<commit_message>
Clase 3: reemplazar diapos de texto por figuras (cuadrantes de Pearson, Spearman con rangos, causalidad, groupby, minimos cuadrados, mal vs buen grafico)
Co-Authored-By: Claude Fable 5 <noreply@anthropic.com>
</commit_message>
<xml_diff>
--- a/presentaciones/clase03_eda_bivariado.pptx
+++ b/presentaciones/clase03_eda_bivariado.pptx
@@ -37,6 +37,9 @@
     <p:sldId id="285" r:id="rId36"/>
     <p:sldId id="286" r:id="rId37"/>
     <p:sldId id="287" r:id="rId38"/>
+    <p:sldId id="288" r:id="rId39"/>
+    <p:sldId id="289" r:id="rId40"/>
+    <p:sldId id="290" r:id="rId41"/>
   </p:sldIdLst>
   <p:sldSz cx="9144000" cy="5138928" type="screen4x3"/>
   <p:notesSz cx="6858000" cy="9144000"/>
@@ -3454,114 +3457,35 @@
                 </a:solidFill>
                 <a:latin typeface="Fira Sans"/>
               </a:rPr>
-              <a:t>La correlación en Pandas</a:t>
-            </a:r>
-          </a:p>
-        </p:txBody>
-      </p:sp>
-      <p:sp>
-        <p:nvSpPr>
-          <p:cNvPr id="4" name="Rectangle 3"/>
-          <p:cNvSpPr/>
-          <p:nvPr/>
-        </p:nvSpPr>
-        <p:spPr>
-          <a:xfrm>
-            <a:off x="704088" y="1280160"/>
-            <a:ext cx="7744968" cy="2880360"/>
-          </a:xfrm>
-          <a:prstGeom prst="rect">
-            <a:avLst/>
-          </a:prstGeom>
-          <a:solidFill>
-            <a:srgbClr val="F0F2F5"/>
-          </a:solidFill>
-          <a:ln>
-            <a:solidFill>
-              <a:srgbClr val="D8DDE3"/>
-            </a:solidFill>
-          </a:ln>
-          <a:effectLst/>
-        </p:spPr>
-        <p:style>
-          <a:lnRef idx="1">
-            <a:schemeClr val="accent1"/>
-          </a:lnRef>
-          <a:fillRef idx="3">
-            <a:schemeClr val="accent1"/>
-          </a:fillRef>
-          <a:effectRef idx="2">
-            <a:schemeClr val="accent1"/>
-          </a:effectRef>
-          <a:fontRef idx="minor">
-            <a:schemeClr val="lt1"/>
-          </a:fontRef>
-        </p:style>
-        <p:txBody>
-          <a:bodyPr rtlCol="0" anchor="ctr" wrap="square" lIns="228600" tIns="137160"/>
-          <a:lstStyle/>
-          <a:p>
-            <a:pPr/>
-            <a:r>
-              <a:rPr sz="1500" b="0">
-                <a:solidFill>
-                  <a:srgbClr val="1D3557"/>
-                </a:solidFill>
-                <a:latin typeface="Menlo"/>
-              </a:rPr>
-              <a:t># Entre dos columnas</a:t>
-            </a:r>
-          </a:p>
-          <a:p>
-            <a:pPr/>
-            <a:r>
-              <a:rPr sz="1500" b="0">
-                <a:solidFill>
-                  <a:srgbClr val="1D3557"/>
-                </a:solidFill>
-                <a:latin typeface="Menlo"/>
-              </a:rPr>
-              <a:t>iris_df["petal length (cm)"].corr(iris_df["petal width (cm)"])</a:t>
-            </a:r>
-          </a:p>
-          <a:p>
-            <a:pPr/>
-            <a:r>
-              <a:rPr sz="1500" b="0">
-                <a:solidFill>
-                  <a:srgbClr val="1D3557"/>
-                </a:solidFill>
-                <a:latin typeface="Menlo"/>
-              </a:rPr>
-              <a:t/>
-            </a:r>
-          </a:p>
-          <a:p>
-            <a:pPr/>
-            <a:r>
-              <a:rPr sz="1500" b="0">
-                <a:solidFill>
-                  <a:srgbClr val="1D3557"/>
-                </a:solidFill>
-                <a:latin typeface="Menlo"/>
-              </a:rPr>
-              <a:t># Todas contra todas: la matriz de correlación</a:t>
-            </a:r>
-          </a:p>
-          <a:p>
-            <a:pPr/>
-            <a:r>
-              <a:rPr sz="1500" b="0">
-                <a:solidFill>
-                  <a:srgbClr val="1D3557"/>
-                </a:solidFill>
-                <a:latin typeface="Menlo"/>
-              </a:rPr>
-              <a:t>iris_df.drop(columns="species").corr()</a:t>
-            </a:r>
-          </a:p>
-        </p:txBody>
-      </p:sp>
+              <a:t>La escala de r</a:t>
+            </a:r>
+          </a:p>
+        </p:txBody>
+      </p:sp>
+      <p:pic>
+        <p:nvPicPr>
+          <p:cNvPr id="4" name="Picture 3" descr="c3_04_escala_r.png"/>
+          <p:cNvPicPr>
+            <a:picLocks noChangeAspect="1"/>
+          </p:cNvPicPr>
+          <p:nvPr/>
+        </p:nvPicPr>
+        <p:blipFill>
+          <a:blip r:embed="rId2"/>
+          <a:stretch>
+            <a:fillRect/>
+          </a:stretch>
+        </p:blipFill>
+        <p:spPr>
+          <a:xfrm>
+            <a:off x="1417319" y="1143000"/>
+            <a:ext cx="6309360" cy="1572703"/>
+          </a:xfrm>
+          <a:prstGeom prst="rect">
+            <a:avLst/>
+          </a:prstGeom>
+        </p:spPr>
+      </p:pic>
       <p:sp>
         <p:nvSpPr>
           <p:cNvPr id="5" name="TextBox 4"/>
@@ -3570,8 +3494,8 @@
         </p:nvSpPr>
         <p:spPr>
           <a:xfrm>
-            <a:off x="704088" y="4389120"/>
-            <a:ext cx="7744968" cy="1097280"/>
+            <a:off x="704088" y="4434840"/>
+            <a:ext cx="7744968" cy="457200"/>
           </a:xfrm>
           <a:prstGeom prst="rect">
             <a:avLst/>
@@ -3584,31 +3508,14 @@
           </a:bodyPr>
           <a:lstStyle/>
           <a:p>
-            <a:pPr>
-              <a:lnSpc>
-                <a:spcPct val="112000"/>
-              </a:lnSpc>
-              <a:spcAft>
-                <a:spcPts val="900"/>
-              </a:spcAft>
-            </a:pPr>
-            <a:r>
-              <a:rPr sz="1600" b="1">
-                <a:solidFill>
-                  <a:srgbClr val="E0A437"/>
-                </a:solidFill>
-                <a:latin typeface="Fira Sans"/>
-              </a:rPr>
-              <a:t>▸ </a:t>
-            </a:r>
-            <a:r>
-              <a:rPr sz="1600" b="0">
-                <a:solidFill>
-                  <a:srgbClr val="000000"/>
-                </a:solidFill>
-                <a:latin typeface="Fira Sans"/>
-              </a:rPr>
-              <a:t>corr() usa Pearson por defecto. En iris, largo y ancho del pétalo correlacionan 0,96.</a:t>
+            <a:r>
+              <a:rPr sz="1300" b="0">
+                <a:solidFill>
+                  <a:srgbClr val="333333"/>
+                </a:solidFill>
+                <a:latin typeface="Fira Sans"/>
+              </a:rPr>
+              <a:t>r = 1 y r = −1 son rectas perfectas; r = 0, ausencia de relación lineal. En datos reales, los valores intermedios son la norma.</a:t>
             </a:r>
           </a:p>
         </p:txBody>
@@ -3704,35 +3611,114 @@
                 </a:solidFill>
                 <a:latin typeface="Fira Sans"/>
               </a:rPr>
-              <a:t>La matriz de correlación</a:t>
-            </a:r>
-          </a:p>
-        </p:txBody>
-      </p:sp>
-      <p:pic>
-        <p:nvPicPr>
-          <p:cNvPr id="4" name="Picture 3" descr="c3_06_matriz_iris.png"/>
-          <p:cNvPicPr>
-            <a:picLocks noChangeAspect="1"/>
-          </p:cNvPicPr>
-          <p:nvPr/>
-        </p:nvPicPr>
-        <p:blipFill>
-          <a:blip r:embed="rId2"/>
-          <a:stretch>
-            <a:fillRect/>
-          </a:stretch>
-        </p:blipFill>
-        <p:spPr>
-          <a:xfrm>
-            <a:off x="2744763" y="1143000"/>
-            <a:ext cx="3654473" cy="3154679"/>
-          </a:xfrm>
-          <a:prstGeom prst="rect">
-            <a:avLst/>
-          </a:prstGeom>
-        </p:spPr>
-      </p:pic>
+              <a:t>La correlación en Pandas</a:t>
+            </a:r>
+          </a:p>
+        </p:txBody>
+      </p:sp>
+      <p:sp>
+        <p:nvSpPr>
+          <p:cNvPr id="4" name="Rectangle 3"/>
+          <p:cNvSpPr/>
+          <p:nvPr/>
+        </p:nvSpPr>
+        <p:spPr>
+          <a:xfrm>
+            <a:off x="704088" y="1280160"/>
+            <a:ext cx="7744968" cy="2880360"/>
+          </a:xfrm>
+          <a:prstGeom prst="rect">
+            <a:avLst/>
+          </a:prstGeom>
+          <a:solidFill>
+            <a:srgbClr val="F0F2F5"/>
+          </a:solidFill>
+          <a:ln>
+            <a:solidFill>
+              <a:srgbClr val="D8DDE3"/>
+            </a:solidFill>
+          </a:ln>
+          <a:effectLst/>
+        </p:spPr>
+        <p:style>
+          <a:lnRef idx="1">
+            <a:schemeClr val="accent1"/>
+          </a:lnRef>
+          <a:fillRef idx="3">
+            <a:schemeClr val="accent1"/>
+          </a:fillRef>
+          <a:effectRef idx="2">
+            <a:schemeClr val="accent1"/>
+          </a:effectRef>
+          <a:fontRef idx="minor">
+            <a:schemeClr val="lt1"/>
+          </a:fontRef>
+        </p:style>
+        <p:txBody>
+          <a:bodyPr rtlCol="0" anchor="ctr" wrap="square" lIns="228600" tIns="137160"/>
+          <a:lstStyle/>
+          <a:p>
+            <a:pPr/>
+            <a:r>
+              <a:rPr sz="1500" b="0">
+                <a:solidFill>
+                  <a:srgbClr val="1D3557"/>
+                </a:solidFill>
+                <a:latin typeface="Menlo"/>
+              </a:rPr>
+              <a:t># Entre dos columnas</a:t>
+            </a:r>
+          </a:p>
+          <a:p>
+            <a:pPr/>
+            <a:r>
+              <a:rPr sz="1500" b="0">
+                <a:solidFill>
+                  <a:srgbClr val="1D3557"/>
+                </a:solidFill>
+                <a:latin typeface="Menlo"/>
+              </a:rPr>
+              <a:t>iris_df["petal length (cm)"].corr(iris_df["petal width (cm)"])</a:t>
+            </a:r>
+          </a:p>
+          <a:p>
+            <a:pPr/>
+            <a:r>
+              <a:rPr sz="1500" b="0">
+                <a:solidFill>
+                  <a:srgbClr val="1D3557"/>
+                </a:solidFill>
+                <a:latin typeface="Menlo"/>
+              </a:rPr>
+              <a:t/>
+            </a:r>
+          </a:p>
+          <a:p>
+            <a:pPr/>
+            <a:r>
+              <a:rPr sz="1500" b="0">
+                <a:solidFill>
+                  <a:srgbClr val="1D3557"/>
+                </a:solidFill>
+                <a:latin typeface="Menlo"/>
+              </a:rPr>
+              <a:t># Todas contra todas: la matriz de correlación</a:t>
+            </a:r>
+          </a:p>
+          <a:p>
+            <a:pPr/>
+            <a:r>
+              <a:rPr sz="1500" b="0">
+                <a:solidFill>
+                  <a:srgbClr val="1D3557"/>
+                </a:solidFill>
+                <a:latin typeface="Menlo"/>
+              </a:rPr>
+              <a:t>iris_df.drop(columns="species").corr()</a:t>
+            </a:r>
+          </a:p>
+        </p:txBody>
+      </p:sp>
       <p:sp>
         <p:nvSpPr>
           <p:cNvPr id="5" name="TextBox 4"/>
@@ -3741,8 +3727,8 @@
         </p:nvSpPr>
         <p:spPr>
           <a:xfrm>
-            <a:off x="704088" y="4434840"/>
-            <a:ext cx="7744968" cy="457200"/>
+            <a:off x="704088" y="4389120"/>
+            <a:ext cx="7744968" cy="1097280"/>
           </a:xfrm>
           <a:prstGeom prst="rect">
             <a:avLst/>
@@ -3755,14 +3741,31 @@
           </a:bodyPr>
           <a:lstStyle/>
           <a:p>
-            <a:r>
-              <a:rPr sz="1300" b="0">
-                <a:solidFill>
-                  <a:srgbClr val="333333"/>
-                </a:solidFill>
-                <a:latin typeface="Fira Sans"/>
-              </a:rPr>
-              <a:t>Todos los pares de una vez: diagonal en 1 y matriz simétrica. El 0,96 entre largo y ancho del pétalo dice que son casi redundantes: evidencia para decidir qué variables conservar en un proyecto.</a:t>
+            <a:pPr>
+              <a:lnSpc>
+                <a:spcPct val="112000"/>
+              </a:lnSpc>
+              <a:spcAft>
+                <a:spcPts val="900"/>
+              </a:spcAft>
+            </a:pPr>
+            <a:r>
+              <a:rPr sz="1600" b="1">
+                <a:solidFill>
+                  <a:srgbClr val="E0A437"/>
+                </a:solidFill>
+                <a:latin typeface="Fira Sans"/>
+              </a:rPr>
+              <a:t>▸ </a:t>
+            </a:r>
+            <a:r>
+              <a:rPr sz="1600" b="0">
+                <a:solidFill>
+                  <a:srgbClr val="000000"/>
+                </a:solidFill>
+                <a:latin typeface="Fira Sans"/>
+              </a:rPr>
+              <a:t>corr() usa Pearson por defecto. En iris, largo y ancho del pétalo correlacionan 0,96.</a:t>
             </a:r>
           </a:p>
         </p:txBody>
@@ -3858,14 +3861,14 @@
                 </a:solidFill>
                 <a:latin typeface="Fira Sans"/>
               </a:rPr>
-              <a:t>Siempre graficar: el cuarteto de Anscombe</a:t>
+              <a:t>La matriz de correlación</a:t>
             </a:r>
           </a:p>
         </p:txBody>
       </p:sp>
       <p:pic>
         <p:nvPicPr>
-          <p:cNvPr id="4" name="Picture 3" descr="c3_05_anscombe.png"/>
+          <p:cNvPr id="4" name="Picture 3" descr="c3_06_matriz_iris.png"/>
           <p:cNvPicPr>
             <a:picLocks noChangeAspect="1"/>
           </p:cNvPicPr>
@@ -3879,8 +3882,8 @@
         </p:blipFill>
         <p:spPr>
           <a:xfrm>
-            <a:off x="2079880" y="1143000"/>
-            <a:ext cx="4984239" cy="3154680"/>
+            <a:off x="2744763" y="1143000"/>
+            <a:ext cx="3654473" cy="3154679"/>
           </a:xfrm>
           <a:prstGeom prst="rect">
             <a:avLst/>
@@ -3916,7 +3919,7 @@
                 </a:solidFill>
                 <a:latin typeface="Fira Sans"/>
               </a:rPr>
-              <a:t>Los cuatro conjuntos comparten medias, correlación y recta, y solo el primero es lo que el número sugiere. El resumen no reemplaza al gráfico.</a:t>
+              <a:t>Todos los pares de una vez: diagonal en 1 y matriz simétrica. El 0,96 entre largo y ancho del pétalo dice que son casi redundantes: evidencia para decidir qué variables conservar en un proyecto.</a:t>
             </a:r>
           </a:p>
         </p:txBody>
@@ -4012,14 +4015,14 @@
                 </a:solidFill>
                 <a:latin typeface="Fira Sans"/>
               </a:rPr>
-              <a:t>El impacto de una sola fila</a:t>
+              <a:t>Siempre graficar: el cuarteto de Anscombe</a:t>
             </a:r>
           </a:p>
         </p:txBody>
       </p:sp>
       <p:pic>
         <p:nvPicPr>
-          <p:cNvPr id="4" name="Picture 3" descr="c3_07_punto_extremo.png"/>
+          <p:cNvPr id="4" name="Picture 3" descr="c3_05_anscombe.png"/>
           <p:cNvPicPr>
             <a:picLocks noChangeAspect="1"/>
           </p:cNvPicPr>
@@ -4033,8 +4036,8 @@
         </p:blipFill>
         <p:spPr>
           <a:xfrm>
-            <a:off x="1417319" y="1143000"/>
-            <a:ext cx="6309360" cy="2628900"/>
+            <a:off x="2079880" y="1143000"/>
+            <a:ext cx="4984239" cy="3154680"/>
           </a:xfrm>
           <a:prstGeom prst="rect">
             <a:avLst/>
@@ -4070,7 +4073,7 @@
                 </a:solidFill>
                 <a:latin typeface="Fira Sans"/>
               </a:rPr>
-              <a:t>Cuarenta puntos sin relación (r = 0,05) y un solo punto extremo fabrican r = 0,72. La correlación de Pearson es tan sensible a los atípicos como la media.</a:t>
+              <a:t>Los cuatro conjuntos comparten medias, correlación y recta, y solo el primero es lo que el número sugiere. El resumen no reemplaza al gráfico.</a:t>
             </a:r>
           </a:p>
         </p:txBody>
@@ -4166,21 +4169,45 @@
                 </a:solidFill>
                 <a:latin typeface="Fira Sans"/>
               </a:rPr>
-              <a:t>Spearman: la correlación robusta</a:t>
-            </a:r>
-          </a:p>
-        </p:txBody>
-      </p:sp>
-      <p:sp>
-        <p:nvSpPr>
-          <p:cNvPr id="4" name="TextBox 3"/>
+              <a:t>El impacto de una sola fila</a:t>
+            </a:r>
+          </a:p>
+        </p:txBody>
+      </p:sp>
+      <p:pic>
+        <p:nvPicPr>
+          <p:cNvPr id="4" name="Picture 3" descr="c3_07_punto_extremo.png"/>
+          <p:cNvPicPr>
+            <a:picLocks noChangeAspect="1"/>
+          </p:cNvPicPr>
+          <p:nvPr/>
+        </p:nvPicPr>
+        <p:blipFill>
+          <a:blip r:embed="rId2"/>
+          <a:stretch>
+            <a:fillRect/>
+          </a:stretch>
+        </p:blipFill>
+        <p:spPr>
+          <a:xfrm>
+            <a:off x="1417319" y="1143000"/>
+            <a:ext cx="6309360" cy="2628900"/>
+          </a:xfrm>
+          <a:prstGeom prst="rect">
+            <a:avLst/>
+          </a:prstGeom>
+        </p:spPr>
+      </p:pic>
+      <p:sp>
+        <p:nvSpPr>
+          <p:cNvPr id="5" name="TextBox 4"/>
           <p:cNvSpPr txBox="1"/>
           <p:nvPr/>
         </p:nvSpPr>
         <p:spPr>
           <a:xfrm>
-            <a:off x="704088" y="1353312"/>
-            <a:ext cx="7744968" cy="3300984"/>
+            <a:off x="704088" y="4434840"/>
+            <a:ext cx="7744968" cy="457200"/>
           </a:xfrm>
           <a:prstGeom prst="rect">
             <a:avLst/>
@@ -4193,115 +4220,14 @@
           </a:bodyPr>
           <a:lstStyle/>
           <a:p>
-            <a:pPr>
-              <a:lnSpc>
-                <a:spcPct val="112000"/>
-              </a:lnSpc>
-              <a:spcAft>
-                <a:spcPts val="900"/>
-              </a:spcAft>
-            </a:pPr>
-            <a:r>
-              <a:rPr sz="1800" b="1">
-                <a:solidFill>
-                  <a:srgbClr val="E0A437"/>
-                </a:solidFill>
-                <a:latin typeface="Fira Sans"/>
-              </a:rPr>
-              <a:t>▸ </a:t>
-            </a:r>
-            <a:r>
-              <a:rPr sz="1800" b="1">
-                <a:solidFill>
-                  <a:srgbClr val="1D3557"/>
-                </a:solidFill>
-                <a:latin typeface="Fira Sans"/>
-              </a:rPr>
-              <a:t>Spearman calcula el Pearson de los rangos: reemplaza cada valor por su posición en el orden (1°, 2°, 3°...).</a:t>
-            </a:r>
-          </a:p>
-          <a:p>
-            <a:pPr>
-              <a:lnSpc>
-                <a:spcPct val="112000"/>
-              </a:lnSpc>
-              <a:spcAft>
-                <a:spcPts val="900"/>
-              </a:spcAft>
-            </a:pPr>
-            <a:r>
-              <a:rPr sz="1800" b="1">
-                <a:solidFill>
-                  <a:srgbClr val="E0A437"/>
-                </a:solidFill>
-                <a:latin typeface="Fira Sans"/>
-              </a:rPr>
-              <a:t>▸ </a:t>
-            </a:r>
-            <a:r>
-              <a:rPr sz="1800" b="0">
-                <a:solidFill>
-                  <a:srgbClr val="000000"/>
-                </a:solidFill>
-                <a:latin typeface="Fira Sans"/>
-              </a:rPr>
-              <a:t>Por eso resiste atípicos y captura relaciones monótonas aunque no sean rectas.</a:t>
-            </a:r>
-          </a:p>
-          <a:p>
-            <a:pPr>
-              <a:lnSpc>
-                <a:spcPct val="112000"/>
-              </a:lnSpc>
-              <a:spcAft>
-                <a:spcPts val="900"/>
-              </a:spcAft>
-            </a:pPr>
-            <a:r>
-              <a:rPr sz="1800" b="1">
-                <a:solidFill>
-                  <a:srgbClr val="E0A437"/>
-                </a:solidFill>
-                <a:latin typeface="Fira Sans"/>
-              </a:rPr>
-              <a:t>▸ </a:t>
-            </a:r>
-            <a:r>
-              <a:rPr sz="1800" b="0">
-                <a:solidFill>
-                  <a:srgbClr val="000000"/>
-                </a:solidFill>
-                <a:latin typeface="Fira Sans"/>
-              </a:rPr>
-              <a:t>En Pandas: corr(method="spearman").</a:t>
-            </a:r>
-          </a:p>
-          <a:p>
-            <a:pPr>
-              <a:lnSpc>
-                <a:spcPct val="112000"/>
-              </a:lnSpc>
-              <a:spcAft>
-                <a:spcPts val="900"/>
-              </a:spcAft>
-            </a:pPr>
-            <a:r>
-              <a:rPr sz="1800" b="1">
-                <a:solidFill>
-                  <a:srgbClr val="E0A437"/>
-                </a:solidFill>
-                <a:latin typeface="Fira Sans"/>
-              </a:rPr>
-              <a:t>▸ </a:t>
-            </a:r>
-            <a:r>
-              <a:rPr sz="1800" b="0">
-                <a:solidFill>
-                  <a:srgbClr val="000000"/>
-                </a:solidFill>
-                <a:latin typeface="Fira Sans"/>
-              </a:rPr>
-              <a:t>En la EOD: distancia y duración dan 0,54 con Pearson y 0,70 con Spearman. La diferencia delata atípicos y curvatura: hay que mirar el gráfico.</a:t>
+            <a:r>
+              <a:rPr sz="1300" b="0">
+                <a:solidFill>
+                  <a:srgbClr val="333333"/>
+                </a:solidFill>
+                <a:latin typeface="Fira Sans"/>
+              </a:rPr>
+              <a:t>Cuarenta puntos sin relación (r = 0,05) y un solo punto extremo fabrican r = 0,72. La correlación de Pearson es tan sensible a los atípicos como la media.</a:t>
             </a:r>
           </a:p>
         </p:txBody>
@@ -4397,21 +4323,45 @@
                 </a:solidFill>
                 <a:latin typeface="Fira Sans"/>
               </a:rPr>
-              <a:t>Correlación no es causalidad</a:t>
-            </a:r>
-          </a:p>
-        </p:txBody>
-      </p:sp>
-      <p:sp>
-        <p:nvSpPr>
-          <p:cNvPr id="4" name="TextBox 3"/>
+              <a:t>Spearman: la correlación de los rangos</a:t>
+            </a:r>
+          </a:p>
+        </p:txBody>
+      </p:sp>
+      <p:pic>
+        <p:nvPicPr>
+          <p:cNvPr id="4" name="Picture 3" descr="c3_12_spearman_rangos.png"/>
+          <p:cNvPicPr>
+            <a:picLocks noChangeAspect="1"/>
+          </p:cNvPicPr>
+          <p:nvPr/>
+        </p:nvPicPr>
+        <p:blipFill>
+          <a:blip r:embed="rId2"/>
+          <a:stretch>
+            <a:fillRect/>
+          </a:stretch>
+        </p:blipFill>
+        <p:spPr>
+          <a:xfrm>
+            <a:off x="1417319" y="1143000"/>
+            <a:ext cx="6309360" cy="2733680"/>
+          </a:xfrm>
+          <a:prstGeom prst="rect">
+            <a:avLst/>
+          </a:prstGeom>
+        </p:spPr>
+      </p:pic>
+      <p:sp>
+        <p:nvSpPr>
+          <p:cNvPr id="5" name="TextBox 4"/>
           <p:cNvSpPr txBox="1"/>
           <p:nvPr/>
         </p:nvSpPr>
         <p:spPr>
           <a:xfrm>
-            <a:off x="704088" y="1353312"/>
-            <a:ext cx="7744968" cy="3300984"/>
+            <a:off x="704088" y="4434840"/>
+            <a:ext cx="7744968" cy="457200"/>
           </a:xfrm>
           <a:prstGeom prst="rect">
             <a:avLst/>
@@ -4424,115 +4374,14 @@
           </a:bodyPr>
           <a:lstStyle/>
           <a:p>
-            <a:pPr>
-              <a:lnSpc>
-                <a:spcPct val="112000"/>
-              </a:lnSpc>
-              <a:spcAft>
-                <a:spcPts val="900"/>
-              </a:spcAft>
-            </a:pPr>
-            <a:r>
-              <a:rPr sz="1800" b="1">
-                <a:solidFill>
-                  <a:srgbClr val="E0A437"/>
-                </a:solidFill>
-                <a:latin typeface="Fira Sans"/>
-              </a:rPr>
-              <a:t>▸ </a:t>
-            </a:r>
-            <a:r>
-              <a:rPr sz="1800" b="1">
-                <a:solidFill>
-                  <a:srgbClr val="1D3557"/>
-                </a:solidFill>
-                <a:latin typeface="Fira Sans"/>
-              </a:rPr>
-              <a:t>Que dos variables se muevan juntas no dice que una cause a la otra.</a:t>
-            </a:r>
-          </a:p>
-          <a:p>
-            <a:pPr>
-              <a:lnSpc>
-                <a:spcPct val="112000"/>
-              </a:lnSpc>
-              <a:spcAft>
-                <a:spcPts val="900"/>
-              </a:spcAft>
-            </a:pPr>
-            <a:r>
-              <a:rPr sz="1800" b="1">
-                <a:solidFill>
-                  <a:srgbClr val="E0A437"/>
-                </a:solidFill>
-                <a:latin typeface="Fira Sans"/>
-              </a:rPr>
-              <a:t>▸ </a:t>
-            </a:r>
-            <a:r>
-              <a:rPr sz="1800" b="0">
-                <a:solidFill>
-                  <a:srgbClr val="000000"/>
-                </a:solidFill>
-                <a:latin typeface="Fira Sans"/>
-              </a:rPr>
-              <a:t>Puede haber una tercera variable moviendo a ambas: los meses de calor suben los helados y los ahogados, sin que uno cause el otro.</a:t>
-            </a:r>
-          </a:p>
-          <a:p>
-            <a:pPr>
-              <a:lnSpc>
-                <a:spcPct val="112000"/>
-              </a:lnSpc>
-              <a:spcAft>
-                <a:spcPts val="900"/>
-              </a:spcAft>
-            </a:pPr>
-            <a:r>
-              <a:rPr sz="1800" b="1">
-                <a:solidFill>
-                  <a:srgbClr val="E0A437"/>
-                </a:solidFill>
-                <a:latin typeface="Fira Sans"/>
-              </a:rPr>
-              <a:t>▸ </a:t>
-            </a:r>
-            <a:r>
-              <a:rPr sz="1800" b="0">
-                <a:solidFill>
-                  <a:srgbClr val="000000"/>
-                </a:solidFill>
-                <a:latin typeface="Fira Sans"/>
-              </a:rPr>
-              <a:t>Puede ser al revés de lo que se piensa, o pura coincidencia.</a:t>
-            </a:r>
-          </a:p>
-          <a:p>
-            <a:pPr>
-              <a:lnSpc>
-                <a:spcPct val="112000"/>
-              </a:lnSpc>
-              <a:spcAft>
-                <a:spcPts val="900"/>
-              </a:spcAft>
-            </a:pPr>
-            <a:r>
-              <a:rPr sz="1800" b="1">
-                <a:solidFill>
-                  <a:srgbClr val="E0A437"/>
-                </a:solidFill>
-                <a:latin typeface="Fira Sans"/>
-              </a:rPr>
-              <a:t>▸ </a:t>
-            </a:r>
-            <a:r>
-              <a:rPr sz="1800" b="0">
-                <a:solidFill>
-                  <a:srgbClr val="000000"/>
-                </a:solidFill>
-                <a:latin typeface="Fira Sans"/>
-              </a:rPr>
-              <a:t>Con datos observacionales reportamos asociación; el lenguaje causal exige diseños que este módulo no cubre (recuerden la tabla de preguntas reparadas de la clase 2).</a:t>
+            <a:r>
+              <a:rPr sz="1300" b="0">
+                <a:solidFill>
+                  <a:srgbClr val="333333"/>
+                </a:solidFill>
+                <a:latin typeface="Fira Sans"/>
+              </a:rPr>
+              <a:t>Reemplazar cada valor por su posición en el orden endereza las curvas monótonas y desarma los atípicos. En Pandas: corr(method="spearman"). En la EOD, distancia y duración dan 0,54 con Pearson y 0,70 con Spearman: la diferencia delata curvatura y atípicos.</a:t>
             </a:r>
           </a:p>
         </p:txBody>
@@ -4570,7 +4419,7 @@
             <a:avLst/>
           </a:prstGeom>
           <a:solidFill>
-            <a:srgbClr val="1D3557"/>
+            <a:srgbClr val="FAFBFC"/>
           </a:solidFill>
           <a:ln>
             <a:noFill/>
@@ -4607,8 +4456,8 @@
         </p:nvSpPr>
         <p:spPr>
           <a:xfrm>
-            <a:off x="603504" y="1847088"/>
-            <a:ext cx="7946136" cy="1399032"/>
+            <a:off x="402336" y="301752"/>
+            <a:ext cx="8348472" cy="795528"/>
           </a:xfrm>
           <a:prstGeom prst="rect">
             <a:avLst/>
@@ -4622,24 +4471,71 @@
           <a:lstStyle/>
           <a:p>
             <a:r>
-              <a:rPr sz="3400" b="1">
-                <a:solidFill>
-                  <a:srgbClr val="FFFFFF"/>
-                </a:solidFill>
-                <a:latin typeface="Fira Sans"/>
-              </a:rPr>
-              <a:t>Recreo</a:t>
-            </a:r>
-          </a:p>
-          <a:p>
-            <a:r>
-              <a:rPr sz="1800" b="0">
-                <a:solidFill>
-                  <a:srgbClr val="E0A437"/>
-                </a:solidFill>
-                <a:latin typeface="Fira Sans"/>
-              </a:rPr>
-              <a:t>10 minutos</a:t>
+              <a:rPr sz="2800" b="1">
+                <a:solidFill>
+                  <a:srgbClr val="0F0F0F"/>
+                </a:solidFill>
+                <a:latin typeface="Fira Sans"/>
+              </a:rPr>
+              <a:t>Correlación no es causalidad</a:t>
+            </a:r>
+          </a:p>
+        </p:txBody>
+      </p:sp>
+      <p:pic>
+        <p:nvPicPr>
+          <p:cNvPr id="4" name="Picture 3" descr="c3_13_causalidad.png"/>
+          <p:cNvPicPr>
+            <a:picLocks noChangeAspect="1"/>
+          </p:cNvPicPr>
+          <p:nvPr/>
+        </p:nvPicPr>
+        <p:blipFill>
+          <a:blip r:embed="rId2"/>
+          <a:stretch>
+            <a:fillRect/>
+          </a:stretch>
+        </p:blipFill>
+        <p:spPr>
+          <a:xfrm>
+            <a:off x="1417319" y="1143000"/>
+            <a:ext cx="6309360" cy="2884949"/>
+          </a:xfrm>
+          <a:prstGeom prst="rect">
+            <a:avLst/>
+          </a:prstGeom>
+        </p:spPr>
+      </p:pic>
+      <p:sp>
+        <p:nvSpPr>
+          <p:cNvPr id="5" name="TextBox 4"/>
+          <p:cNvSpPr txBox="1"/>
+          <p:nvPr/>
+        </p:nvSpPr>
+        <p:spPr>
+          <a:xfrm>
+            <a:off x="704088" y="4434840"/>
+            <a:ext cx="7744968" cy="457200"/>
+          </a:xfrm>
+          <a:prstGeom prst="rect">
+            <a:avLst/>
+          </a:prstGeom>
+          <a:noFill/>
+        </p:spPr>
+        <p:txBody>
+          <a:bodyPr wrap="square">
+            <a:spAutoFit/>
+          </a:bodyPr>
+          <a:lstStyle/>
+          <a:p>
+            <a:r>
+              <a:rPr sz="1300" b="0">
+                <a:solidFill>
+                  <a:srgbClr val="333333"/>
+                </a:solidFill>
+                <a:latin typeface="Fira Sans"/>
+              </a:rPr>
+              <a:t>Que dos variables se muevan juntas no dice que una cause a la otra: puede haber una tercera moviendo a ambas. Con datos observacionales reportamos asociación (recuerden las preguntas reparadas de la clase 2).</a:t>
             </a:r>
           </a:p>
         </p:txBody>
@@ -4735,7 +4631,7 @@
                 </a:solidFill>
                 <a:latin typeface="Fira Sans"/>
               </a:rPr>
-              <a:t>La EOD: distancia y duración</a:t>
+              <a:t>Recreo</a:t>
             </a:r>
           </a:p>
           <a:p>
@@ -4746,7 +4642,7 @@
                 </a:solidFill>
                 <a:latin typeface="Fira Sans"/>
               </a:rPr>
-              <a:t>Calcular una variable nueva y cruzarla</a:t>
+              <a:t>10 minutos</a:t>
             </a:r>
           </a:p>
         </p:txBody>
@@ -4784,7 +4680,7 @@
             <a:avLst/>
           </a:prstGeom>
           <a:solidFill>
-            <a:srgbClr val="FAFBFC"/>
+            <a:srgbClr val="1D3557"/>
           </a:solidFill>
           <a:ln>
             <a:noFill/>
@@ -4821,8 +4717,8 @@
         </p:nvSpPr>
         <p:spPr>
           <a:xfrm>
-            <a:off x="402336" y="301752"/>
-            <a:ext cx="8348472" cy="795528"/>
+            <a:off x="603504" y="1847088"/>
+            <a:ext cx="7946136" cy="1399032"/>
           </a:xfrm>
           <a:prstGeom prst="rect">
             <a:avLst/>
@@ -4836,167 +4732,24 @@
           <a:lstStyle/>
           <a:p>
             <a:r>
-              <a:rPr sz="2800" b="1">
-                <a:solidFill>
-                  <a:srgbClr val="0F0F0F"/>
-                </a:solidFill>
-                <a:latin typeface="Fira Sans"/>
-              </a:rPr>
-              <a:t>La distancia de cada viaje</a:t>
-            </a:r>
-          </a:p>
-        </p:txBody>
-      </p:sp>
-      <p:sp>
-        <p:nvSpPr>
-          <p:cNvPr id="4" name="Rectangle 3"/>
-          <p:cNvSpPr/>
-          <p:nvPr/>
-        </p:nvSpPr>
-        <p:spPr>
-          <a:xfrm>
-            <a:off x="704088" y="1280160"/>
-            <a:ext cx="7744968" cy="2880360"/>
-          </a:xfrm>
-          <a:prstGeom prst="rect">
-            <a:avLst/>
-          </a:prstGeom>
-          <a:solidFill>
-            <a:srgbClr val="F0F2F5"/>
-          </a:solidFill>
-          <a:ln>
-            <a:solidFill>
-              <a:srgbClr val="D8DDE3"/>
-            </a:solidFill>
-          </a:ln>
-          <a:effectLst/>
-        </p:spPr>
-        <p:style>
-          <a:lnRef idx="1">
-            <a:schemeClr val="accent1"/>
-          </a:lnRef>
-          <a:fillRef idx="3">
-            <a:schemeClr val="accent1"/>
-          </a:fillRef>
-          <a:effectRef idx="2">
-            <a:schemeClr val="accent1"/>
-          </a:effectRef>
-          <a:fontRef idx="minor">
-            <a:schemeClr val="lt1"/>
-          </a:fontRef>
-        </p:style>
-        <p:txBody>
-          <a:bodyPr rtlCol="0" anchor="ctr" wrap="square" lIns="228600" tIns="137160"/>
-          <a:lstStyle/>
-          <a:p>
-            <a:pPr/>
-            <a:r>
-              <a:rPr sz="1500" b="0">
-                <a:solidFill>
-                  <a:srgbClr val="1D3557"/>
-                </a:solidFill>
-                <a:latin typeface="Menlo"/>
-              </a:rPr>
-              <a:t>dx = viajes["DestinoCoordX"] - viajes["OrigenCoordX"]</a:t>
-            </a:r>
-          </a:p>
-          <a:p>
-            <a:pPr/>
-            <a:r>
-              <a:rPr sz="1500" b="0">
-                <a:solidFill>
-                  <a:srgbClr val="1D3557"/>
-                </a:solidFill>
-                <a:latin typeface="Menlo"/>
-              </a:rPr>
-              <a:t>dy = viajes["DestinoCoordY"] - viajes["OrigenCoordY"]</a:t>
-            </a:r>
-          </a:p>
-          <a:p>
-            <a:pPr/>
-            <a:r>
-              <a:rPr sz="1500" b="0">
-                <a:solidFill>
-                  <a:srgbClr val="1D3557"/>
-                </a:solidFill>
-                <a:latin typeface="Menlo"/>
-              </a:rPr>
-              <a:t/>
-            </a:r>
-          </a:p>
-          <a:p>
-            <a:pPr/>
-            <a:r>
-              <a:rPr sz="1500" b="0">
-                <a:solidFill>
-                  <a:srgbClr val="1D3557"/>
-                </a:solidFill>
-                <a:latin typeface="Menlo"/>
-              </a:rPr>
-              <a:t># Pitágoras, vectorizado: 90 mil distancias de una vez</a:t>
-            </a:r>
-          </a:p>
-          <a:p>
-            <a:pPr/>
-            <a:r>
-              <a:rPr sz="1500" b="0">
-                <a:solidFill>
-                  <a:srgbClr val="1D3557"/>
-                </a:solidFill>
-                <a:latin typeface="Menlo"/>
-              </a:rPr>
-              <a:t>viajes["DistKm"] = np.sqrt(dx**2 + dy**2) / 1000</a:t>
-            </a:r>
-          </a:p>
-        </p:txBody>
-      </p:sp>
-      <p:sp>
-        <p:nvSpPr>
-          <p:cNvPr id="5" name="TextBox 4"/>
-          <p:cNvSpPr txBox="1"/>
-          <p:nvPr/>
-        </p:nvSpPr>
-        <p:spPr>
-          <a:xfrm>
-            <a:off x="704088" y="4389120"/>
-            <a:ext cx="7744968" cy="1097280"/>
-          </a:xfrm>
-          <a:prstGeom prst="rect">
-            <a:avLst/>
-          </a:prstGeom>
-          <a:noFill/>
-        </p:spPr>
-        <p:txBody>
-          <a:bodyPr wrap="square">
-            <a:spAutoFit/>
-          </a:bodyPr>
-          <a:lstStyle/>
-          <a:p>
-            <a:pPr>
-              <a:lnSpc>
-                <a:spcPct val="112000"/>
-              </a:lnSpc>
-              <a:spcAft>
-                <a:spcPts val="900"/>
-              </a:spcAft>
-            </a:pPr>
-            <a:r>
-              <a:rPr sz="1600" b="1">
+              <a:rPr sz="3400" b="1">
+                <a:solidFill>
+                  <a:srgbClr val="FFFFFF"/>
+                </a:solidFill>
+                <a:latin typeface="Fira Sans"/>
+              </a:rPr>
+              <a:t>La EOD: distancia y duración</a:t>
+            </a:r>
+          </a:p>
+          <a:p>
+            <a:r>
+              <a:rPr sz="1800" b="0">
                 <a:solidFill>
                   <a:srgbClr val="E0A437"/>
                 </a:solidFill>
                 <a:latin typeface="Fira Sans"/>
               </a:rPr>
-              <a:t>▸ </a:t>
-            </a:r>
-            <a:r>
-              <a:rPr sz="1600" b="0">
-                <a:solidFill>
-                  <a:srgbClr val="000000"/>
-                </a:solidFill>
-                <a:latin typeface="Fira Sans"/>
-              </a:rPr>
-              <a:t>Distancia en línea recta entre origen y destino (las coordenadas vienen en metros). Antes hay que filtrar 4.122 filas con coordenada 0: faltantes disfrazados, como los códigos 999 de la clase 2.</a:t>
+              <a:t>Calcular una variable nueva y cruzarla</a:t>
             </a:r>
           </a:p>
         </p:txBody>
@@ -5092,35 +4845,114 @@
                 </a:solidFill>
                 <a:latin typeface="Fira Sans"/>
               </a:rPr>
-              <a:t>Graficar 90 mil puntos: overplotting</a:t>
-            </a:r>
-          </a:p>
-        </p:txBody>
-      </p:sp>
-      <p:pic>
-        <p:nvPicPr>
-          <p:cNvPr id="4" name="Picture 3" descr="c3_08_overplotting.png"/>
-          <p:cNvPicPr>
-            <a:picLocks noChangeAspect="1"/>
-          </p:cNvPicPr>
-          <p:nvPr/>
-        </p:nvPicPr>
-        <p:blipFill>
-          <a:blip r:embed="rId2"/>
-          <a:stretch>
-            <a:fillRect/>
-          </a:stretch>
-        </p:blipFill>
-        <p:spPr>
-          <a:xfrm>
-            <a:off x="1417319" y="1143000"/>
-            <a:ext cx="6309360" cy="1913950"/>
-          </a:xfrm>
-          <a:prstGeom prst="rect">
-            <a:avLst/>
-          </a:prstGeom>
-        </p:spPr>
-      </p:pic>
+              <a:t>La distancia de cada viaje</a:t>
+            </a:r>
+          </a:p>
+        </p:txBody>
+      </p:sp>
+      <p:sp>
+        <p:nvSpPr>
+          <p:cNvPr id="4" name="Rectangle 3"/>
+          <p:cNvSpPr/>
+          <p:nvPr/>
+        </p:nvSpPr>
+        <p:spPr>
+          <a:xfrm>
+            <a:off x="704088" y="1280160"/>
+            <a:ext cx="7744968" cy="2880360"/>
+          </a:xfrm>
+          <a:prstGeom prst="rect">
+            <a:avLst/>
+          </a:prstGeom>
+          <a:solidFill>
+            <a:srgbClr val="F0F2F5"/>
+          </a:solidFill>
+          <a:ln>
+            <a:solidFill>
+              <a:srgbClr val="D8DDE3"/>
+            </a:solidFill>
+          </a:ln>
+          <a:effectLst/>
+        </p:spPr>
+        <p:style>
+          <a:lnRef idx="1">
+            <a:schemeClr val="accent1"/>
+          </a:lnRef>
+          <a:fillRef idx="3">
+            <a:schemeClr val="accent1"/>
+          </a:fillRef>
+          <a:effectRef idx="2">
+            <a:schemeClr val="accent1"/>
+          </a:effectRef>
+          <a:fontRef idx="minor">
+            <a:schemeClr val="lt1"/>
+          </a:fontRef>
+        </p:style>
+        <p:txBody>
+          <a:bodyPr rtlCol="0" anchor="ctr" wrap="square" lIns="228600" tIns="137160"/>
+          <a:lstStyle/>
+          <a:p>
+            <a:pPr/>
+            <a:r>
+              <a:rPr sz="1500" b="0">
+                <a:solidFill>
+                  <a:srgbClr val="1D3557"/>
+                </a:solidFill>
+                <a:latin typeface="Menlo"/>
+              </a:rPr>
+              <a:t>dx = viajes["DestinoCoordX"] - viajes["OrigenCoordX"]</a:t>
+            </a:r>
+          </a:p>
+          <a:p>
+            <a:pPr/>
+            <a:r>
+              <a:rPr sz="1500" b="0">
+                <a:solidFill>
+                  <a:srgbClr val="1D3557"/>
+                </a:solidFill>
+                <a:latin typeface="Menlo"/>
+              </a:rPr>
+              <a:t>dy = viajes["DestinoCoordY"] - viajes["OrigenCoordY"]</a:t>
+            </a:r>
+          </a:p>
+          <a:p>
+            <a:pPr/>
+            <a:r>
+              <a:rPr sz="1500" b="0">
+                <a:solidFill>
+                  <a:srgbClr val="1D3557"/>
+                </a:solidFill>
+                <a:latin typeface="Menlo"/>
+              </a:rPr>
+              <a:t/>
+            </a:r>
+          </a:p>
+          <a:p>
+            <a:pPr/>
+            <a:r>
+              <a:rPr sz="1500" b="0">
+                <a:solidFill>
+                  <a:srgbClr val="1D3557"/>
+                </a:solidFill>
+                <a:latin typeface="Menlo"/>
+              </a:rPr>
+              <a:t># Pitágoras, vectorizado: 90 mil distancias de una vez</a:t>
+            </a:r>
+          </a:p>
+          <a:p>
+            <a:pPr/>
+            <a:r>
+              <a:rPr sz="1500" b="0">
+                <a:solidFill>
+                  <a:srgbClr val="1D3557"/>
+                </a:solidFill>
+                <a:latin typeface="Menlo"/>
+              </a:rPr>
+              <a:t>viajes["DistKm"] = np.sqrt(dx**2 + dy**2) / 1000</a:t>
+            </a:r>
+          </a:p>
+        </p:txBody>
+      </p:sp>
       <p:sp>
         <p:nvSpPr>
           <p:cNvPr id="5" name="TextBox 4"/>
@@ -5129,8 +4961,8 @@
         </p:nvSpPr>
         <p:spPr>
           <a:xfrm>
-            <a:off x="704088" y="4434840"/>
-            <a:ext cx="7744968" cy="457200"/>
+            <a:off x="704088" y="4389120"/>
+            <a:ext cx="7744968" cy="1097280"/>
           </a:xfrm>
           <a:prstGeom prst="rect">
             <a:avLst/>
@@ -5143,14 +4975,31 @@
           </a:bodyPr>
           <a:lstStyle/>
           <a:p>
-            <a:r>
-              <a:rPr sz="1300" b="0">
-                <a:solidFill>
-                  <a:srgbClr val="333333"/>
-                </a:solidFill>
-                <a:latin typeface="Fira Sans"/>
-              </a:rPr>
-              <a:t>Con todos los puntos sólidos, el scatter se satura y miente. Los remedios: transparencia (alpha), muestreo, o hexbin, donde el color cuenta los viajes.</a:t>
+            <a:pPr>
+              <a:lnSpc>
+                <a:spcPct val="112000"/>
+              </a:lnSpc>
+              <a:spcAft>
+                <a:spcPts val="900"/>
+              </a:spcAft>
+            </a:pPr>
+            <a:r>
+              <a:rPr sz="1600" b="1">
+                <a:solidFill>
+                  <a:srgbClr val="E0A437"/>
+                </a:solidFill>
+                <a:latin typeface="Fira Sans"/>
+              </a:rPr>
+              <a:t>▸ </a:t>
+            </a:r>
+            <a:r>
+              <a:rPr sz="1600" b="0">
+                <a:solidFill>
+                  <a:srgbClr val="000000"/>
+                </a:solidFill>
+                <a:latin typeface="Fira Sans"/>
+              </a:rPr>
+              <a:t>Distancia en línea recta entre origen y destino (las coordenadas vienen en metros). Antes hay que filtrar 4.122 filas con coordenada 0: faltantes disfrazados, como los códigos 999 de la clase 2.</a:t>
             </a:r>
           </a:p>
         </p:txBody>
@@ -5475,7 +5324,7 @@
             <a:avLst/>
           </a:prstGeom>
           <a:solidFill>
-            <a:srgbClr val="1D3557"/>
+            <a:srgbClr val="FAFBFC"/>
           </a:solidFill>
           <a:ln>
             <a:noFill/>
@@ -5512,8 +5361,8 @@
         </p:nvSpPr>
         <p:spPr>
           <a:xfrm>
-            <a:off x="603504" y="1847088"/>
-            <a:ext cx="7946136" cy="1399032"/>
+            <a:off x="402336" y="301752"/>
+            <a:ext cx="8348472" cy="795528"/>
           </a:xfrm>
           <a:prstGeom prst="rect">
             <a:avLst/>
@@ -5527,24 +5376,71 @@
           <a:lstStyle/>
           <a:p>
             <a:r>
-              <a:rPr sz="3400" b="1">
-                <a:solidFill>
-                  <a:srgbClr val="FFFFFF"/>
-                </a:solidFill>
-                <a:latin typeface="Fira Sans"/>
-              </a:rPr>
-              <a:t>Grupos y tablas de contingencia</a:t>
-            </a:r>
-          </a:p>
-          <a:p>
-            <a:r>
-              <a:rPr sz="1800" b="0">
-                <a:solidFill>
-                  <a:srgbClr val="E0A437"/>
-                </a:solidFill>
-                <a:latin typeface="Fira Sans"/>
-              </a:rPr>
-              <a:t>Cuando una de las dos variables es categórica</a:t>
+              <a:rPr sz="2800" b="1">
+                <a:solidFill>
+                  <a:srgbClr val="0F0F0F"/>
+                </a:solidFill>
+                <a:latin typeface="Fira Sans"/>
+              </a:rPr>
+              <a:t>Graficar 90 mil puntos: overplotting</a:t>
+            </a:r>
+          </a:p>
+        </p:txBody>
+      </p:sp>
+      <p:pic>
+        <p:nvPicPr>
+          <p:cNvPr id="4" name="Picture 3" descr="c3_08_overplotting.png"/>
+          <p:cNvPicPr>
+            <a:picLocks noChangeAspect="1"/>
+          </p:cNvPicPr>
+          <p:nvPr/>
+        </p:nvPicPr>
+        <p:blipFill>
+          <a:blip r:embed="rId2"/>
+          <a:stretch>
+            <a:fillRect/>
+          </a:stretch>
+        </p:blipFill>
+        <p:spPr>
+          <a:xfrm>
+            <a:off x="1417319" y="1143000"/>
+            <a:ext cx="6309360" cy="1913950"/>
+          </a:xfrm>
+          <a:prstGeom prst="rect">
+            <a:avLst/>
+          </a:prstGeom>
+        </p:spPr>
+      </p:pic>
+      <p:sp>
+        <p:nvSpPr>
+          <p:cNvPr id="5" name="TextBox 4"/>
+          <p:cNvSpPr txBox="1"/>
+          <p:nvPr/>
+        </p:nvSpPr>
+        <p:spPr>
+          <a:xfrm>
+            <a:off x="704088" y="4434840"/>
+            <a:ext cx="7744968" cy="457200"/>
+          </a:xfrm>
+          <a:prstGeom prst="rect">
+            <a:avLst/>
+          </a:prstGeom>
+          <a:noFill/>
+        </p:spPr>
+        <p:txBody>
+          <a:bodyPr wrap="square">
+            <a:spAutoFit/>
+          </a:bodyPr>
+          <a:lstStyle/>
+          <a:p>
+            <a:r>
+              <a:rPr sz="1300" b="0">
+                <a:solidFill>
+                  <a:srgbClr val="333333"/>
+                </a:solidFill>
+                <a:latin typeface="Fira Sans"/>
+              </a:rPr>
+              <a:t>Con todos los puntos sólidos, el scatter se satura y miente. Los remedios: transparencia (alpha), muestreo, o hexbin, donde el color cuenta los viajes.</a:t>
             </a:r>
           </a:p>
         </p:txBody>
@@ -5582,7 +5478,7 @@
             <a:avLst/>
           </a:prstGeom>
           <a:solidFill>
-            <a:srgbClr val="FAFBFC"/>
+            <a:srgbClr val="1D3557"/>
           </a:solidFill>
           <a:ln>
             <a:noFill/>
@@ -5619,8 +5515,8 @@
         </p:nvSpPr>
         <p:spPr>
           <a:xfrm>
-            <a:off x="402336" y="301752"/>
-            <a:ext cx="8348472" cy="795528"/>
+            <a:off x="603504" y="1847088"/>
+            <a:ext cx="7946136" cy="1399032"/>
           </a:xfrm>
           <a:prstGeom prst="rect">
             <a:avLst/>
@@ -5634,155 +5530,24 @@
           <a:lstStyle/>
           <a:p>
             <a:r>
-              <a:rPr sz="2800" b="1">
-                <a:solidFill>
-                  <a:srgbClr val="0F0F0F"/>
-                </a:solidFill>
-                <a:latin typeface="Fira Sans"/>
-              </a:rPr>
-              <a:t>La media por grupo: groupby</a:t>
-            </a:r>
-          </a:p>
-        </p:txBody>
-      </p:sp>
-      <p:sp>
-        <p:nvSpPr>
-          <p:cNvPr id="4" name="Rectangle 3"/>
-          <p:cNvSpPr/>
-          <p:nvPr/>
-        </p:nvSpPr>
-        <p:spPr>
-          <a:xfrm>
-            <a:off x="704088" y="1280160"/>
-            <a:ext cx="7744968" cy="2377440"/>
-          </a:xfrm>
-          <a:prstGeom prst="rect">
-            <a:avLst/>
-          </a:prstGeom>
-          <a:solidFill>
-            <a:srgbClr val="F0F2F5"/>
-          </a:solidFill>
-          <a:ln>
-            <a:solidFill>
-              <a:srgbClr val="D8DDE3"/>
-            </a:solidFill>
-          </a:ln>
-          <a:effectLst/>
-        </p:spPr>
-        <p:style>
-          <a:lnRef idx="1">
-            <a:schemeClr val="accent1"/>
-          </a:lnRef>
-          <a:fillRef idx="3">
-            <a:schemeClr val="accent1"/>
-          </a:fillRef>
-          <a:effectRef idx="2">
-            <a:schemeClr val="accent1"/>
-          </a:effectRef>
-          <a:fontRef idx="minor">
-            <a:schemeClr val="lt1"/>
-          </a:fontRef>
-        </p:style>
-        <p:txBody>
-          <a:bodyPr rtlCol="0" anchor="ctr" wrap="square" lIns="228600" tIns="137160"/>
-          <a:lstStyle/>
-          <a:p>
-            <a:pPr/>
-            <a:r>
-              <a:rPr sz="1500" b="0">
-                <a:solidFill>
-                  <a:srgbClr val="1D3557"/>
-                </a:solidFill>
-                <a:latin typeface="Menlo"/>
-              </a:rPr>
-              <a:t>iris_df.groupby("species")["petal length (cm)"].mean()</a:t>
-            </a:r>
-          </a:p>
-          <a:p>
-            <a:pPr/>
-            <a:r>
-              <a:rPr sz="1500" b="0">
-                <a:solidFill>
-                  <a:srgbClr val="1D3557"/>
-                </a:solidFill>
-                <a:latin typeface="Menlo"/>
-              </a:rPr>
-              <a:t/>
-            </a:r>
-          </a:p>
-          <a:p>
-            <a:pPr/>
-            <a:r>
-              <a:rPr sz="1500" b="0">
-                <a:solidFill>
-                  <a:srgbClr val="1D3557"/>
-                </a:solidFill>
-                <a:latin typeface="Menlo"/>
-              </a:rPr>
-              <a:t># El mismo resumen que construimos a mano con loc y el for,</a:t>
-            </a:r>
-          </a:p>
-          <a:p>
-            <a:pPr/>
-            <a:r>
-              <a:rPr sz="1500" b="0">
-                <a:solidFill>
-                  <a:srgbClr val="1D3557"/>
-                </a:solidFill>
-                <a:latin typeface="Menlo"/>
-              </a:rPr>
-              <a:t># ahora en una línea</a:t>
-            </a:r>
-          </a:p>
-        </p:txBody>
-      </p:sp>
-      <p:sp>
-        <p:nvSpPr>
-          <p:cNvPr id="5" name="TextBox 4"/>
-          <p:cNvSpPr txBox="1"/>
-          <p:nvPr/>
-        </p:nvSpPr>
-        <p:spPr>
-          <a:xfrm>
-            <a:off x="704088" y="3886200"/>
-            <a:ext cx="7744968" cy="1097280"/>
-          </a:xfrm>
-          <a:prstGeom prst="rect">
-            <a:avLst/>
-          </a:prstGeom>
-          <a:noFill/>
-        </p:spPr>
-        <p:txBody>
-          <a:bodyPr wrap="square">
-            <a:spAutoFit/>
-          </a:bodyPr>
-          <a:lstStyle/>
-          <a:p>
-            <a:pPr>
-              <a:lnSpc>
-                <a:spcPct val="112000"/>
-              </a:lnSpc>
-              <a:spcAft>
-                <a:spcPts val="900"/>
-              </a:spcAft>
-            </a:pPr>
-            <a:r>
-              <a:rPr sz="1600" b="1">
+              <a:rPr sz="3400" b="1">
+                <a:solidFill>
+                  <a:srgbClr val="FFFFFF"/>
+                </a:solidFill>
+                <a:latin typeface="Fira Sans"/>
+              </a:rPr>
+              <a:t>Grupos y tablas de contingencia</a:t>
+            </a:r>
+          </a:p>
+          <a:p>
+            <a:r>
+              <a:rPr sz="1800" b="0">
                 <a:solidFill>
                   <a:srgbClr val="E0A437"/>
                 </a:solidFill>
                 <a:latin typeface="Fira Sans"/>
               </a:rPr>
-              <a:t>▸ </a:t>
-            </a:r>
-            <a:r>
-              <a:rPr sz="1600" b="0">
-                <a:solidFill>
-                  <a:srgbClr val="000000"/>
-                </a:solidFill>
-                <a:latin typeface="Fira Sans"/>
-              </a:rPr>
-              <a:t>groupby parte la tabla por categoría, aplica el resumen a cada parte y junta los resultados: 1,46 / 4,26 / 5,55 cm. Es la versión numérica del boxplot por grupo.</a:t>
+              <a:t>Cuando una de las dos variables es categórica</a:t>
             </a:r>
           </a:p>
         </p:txBody>
@@ -5878,114 +5643,35 @@
                 </a:solidFill>
                 <a:latin typeface="Fira Sans"/>
               </a:rPr>
-              <a:t>Dos categóricas: la tabla de contingencia</a:t>
-            </a:r>
-          </a:p>
-        </p:txBody>
-      </p:sp>
-      <p:sp>
-        <p:nvSpPr>
-          <p:cNvPr id="4" name="Rectangle 3"/>
-          <p:cNvSpPr/>
-          <p:nvPr/>
-        </p:nvSpPr>
-        <p:spPr>
-          <a:xfrm>
-            <a:off x="704088" y="1280160"/>
-            <a:ext cx="7744968" cy="2880360"/>
-          </a:xfrm>
-          <a:prstGeom prst="rect">
-            <a:avLst/>
-          </a:prstGeom>
-          <a:solidFill>
-            <a:srgbClr val="F0F2F5"/>
-          </a:solidFill>
-          <a:ln>
-            <a:solidFill>
-              <a:srgbClr val="D8DDE3"/>
-            </a:solidFill>
-          </a:ln>
-          <a:effectLst/>
-        </p:spPr>
-        <p:style>
-          <a:lnRef idx="1">
-            <a:schemeClr val="accent1"/>
-          </a:lnRef>
-          <a:fillRef idx="3">
-            <a:schemeClr val="accent1"/>
-          </a:fillRef>
-          <a:effectRef idx="2">
-            <a:schemeClr val="accent1"/>
-          </a:effectRef>
-          <a:fontRef idx="minor">
-            <a:schemeClr val="lt1"/>
-          </a:fontRef>
-        </p:style>
-        <p:txBody>
-          <a:bodyPr rtlCol="0" anchor="ctr" wrap="square" lIns="228600" tIns="137160"/>
-          <a:lstStyle/>
-          <a:p>
-            <a:pPr/>
-            <a:r>
-              <a:rPr sz="1500" b="0">
-                <a:solidFill>
-                  <a:srgbClr val="1D3557"/>
-                </a:solidFill>
-                <a:latin typeface="Menlo"/>
-              </a:rPr>
-              <a:t>pd.crosstab(datos["Sexo"], datos["ModoAgrupado"],</a:t>
-            </a:r>
-          </a:p>
-          <a:p>
-            <a:pPr/>
-            <a:r>
-              <a:rPr sz="1500" b="0">
-                <a:solidFill>
-                  <a:srgbClr val="1D3557"/>
-                </a:solidFill>
-                <a:latin typeface="Menlo"/>
-              </a:rPr>
-              <a:t>            normalize="index")</a:t>
-            </a:r>
-          </a:p>
-          <a:p>
-            <a:pPr/>
-            <a:r>
-              <a:rPr sz="1500" b="0">
-                <a:solidFill>
-                  <a:srgbClr val="1D3557"/>
-                </a:solidFill>
-                <a:latin typeface="Menlo"/>
-              </a:rPr>
-              <a:t># Para la ciudad: sumar factores en vez de contar viajes</a:t>
-            </a:r>
-          </a:p>
-          <a:p>
-            <a:pPr/>
-            <a:r>
-              <a:rPr sz="1500" b="0">
-                <a:solidFill>
-                  <a:srgbClr val="1D3557"/>
-                </a:solidFill>
-                <a:latin typeface="Menlo"/>
-              </a:rPr>
-              <a:t>datos.pivot_table(values="Factor", index="Sexo",</a:t>
-            </a:r>
-          </a:p>
-          <a:p>
-            <a:pPr/>
-            <a:r>
-              <a:rPr sz="1500" b="0">
-                <a:solidFill>
-                  <a:srgbClr val="1D3557"/>
-                </a:solidFill>
-                <a:latin typeface="Menlo"/>
-              </a:rPr>
-              <a:t>                  columns="ModoAgrupado", aggfunc="sum")</a:t>
-            </a:r>
-          </a:p>
-        </p:txBody>
-      </p:sp>
+              <a:t>groupby: partir, aplicar, juntar</a:t>
+            </a:r>
+          </a:p>
+        </p:txBody>
+      </p:sp>
+      <p:pic>
+        <p:nvPicPr>
+          <p:cNvPr id="4" name="Picture 3" descr="c3_14_groupby.png"/>
+          <p:cNvPicPr>
+            <a:picLocks noChangeAspect="1"/>
+          </p:cNvPicPr>
+          <p:nvPr/>
+        </p:nvPicPr>
+        <p:blipFill>
+          <a:blip r:embed="rId2"/>
+          <a:stretch>
+            <a:fillRect/>
+          </a:stretch>
+        </p:blipFill>
+        <p:spPr>
+          <a:xfrm>
+            <a:off x="1417319" y="1143000"/>
+            <a:ext cx="6309360" cy="2480026"/>
+          </a:xfrm>
+          <a:prstGeom prst="rect">
+            <a:avLst/>
+          </a:prstGeom>
+        </p:spPr>
+      </p:pic>
       <p:sp>
         <p:nvSpPr>
           <p:cNvPr id="5" name="TextBox 4"/>
@@ -5994,8 +5680,8 @@
         </p:nvSpPr>
         <p:spPr>
           <a:xfrm>
-            <a:off x="704088" y="4389120"/>
-            <a:ext cx="7744968" cy="1097280"/>
+            <a:off x="704088" y="4434840"/>
+            <a:ext cx="7744968" cy="457200"/>
           </a:xfrm>
           <a:prstGeom prst="rect">
             <a:avLst/>
@@ -6008,31 +5694,14 @@
           </a:bodyPr>
           <a:lstStyle/>
           <a:p>
-            <a:pPr>
-              <a:lnSpc>
-                <a:spcPct val="112000"/>
-              </a:lnSpc>
-              <a:spcAft>
-                <a:spcPts val="900"/>
-              </a:spcAft>
-            </a:pPr>
-            <a:r>
-              <a:rPr sz="1600" b="1">
-                <a:solidFill>
-                  <a:srgbClr val="E0A437"/>
-                </a:solidFill>
-                <a:latin typeface="Fira Sans"/>
-              </a:rPr>
-              <a:t>▸ </a:t>
-            </a:r>
-            <a:r>
-              <a:rPr sz="1600" b="0">
-                <a:solidFill>
-                  <a:srgbClr val="000000"/>
-                </a:solidFill>
-                <a:latin typeface="Fira Sans"/>
-              </a:rPr>
-              <a:t>Ponderado por factor, en día laboral: las mujeres caminan más (40% contra 27%) y los hombres usan más el auto (28% contra 19%).</a:t>
+            <a:r>
+              <a:rPr sz="1300" b="0">
+                <a:solidFill>
+                  <a:srgbClr val="333333"/>
+                </a:solidFill>
+                <a:latin typeface="Fira Sans"/>
+              </a:rPr>
+              <a:t>La versión numérica del boxplot por grupo: la tabla se parte por categoría, cada parte recibe el resumen y los resultados se juntan.</a:t>
             </a:r>
           </a:p>
         </p:txBody>
@@ -6070,7 +5739,7 @@
             <a:avLst/>
           </a:prstGeom>
           <a:solidFill>
-            <a:srgbClr val="1D3557"/>
+            <a:srgbClr val="FAFBFC"/>
           </a:solidFill>
           <a:ln>
             <a:noFill/>
@@ -6107,8 +5776,8 @@
         </p:nvSpPr>
         <p:spPr>
           <a:xfrm>
-            <a:off x="603504" y="1847088"/>
-            <a:ext cx="7946136" cy="1399032"/>
+            <a:off x="402336" y="301752"/>
+            <a:ext cx="8348472" cy="795528"/>
           </a:xfrm>
           <a:prstGeom prst="rect">
             <a:avLst/>
@@ -6122,24 +5791,155 @@
           <a:lstStyle/>
           <a:p>
             <a:r>
-              <a:rPr sz="3400" b="1">
-                <a:solidFill>
-                  <a:srgbClr val="FFFFFF"/>
-                </a:solidFill>
-                <a:latin typeface="Fira Sans"/>
-              </a:rPr>
-              <a:t>La primera regresión</a:t>
-            </a:r>
-          </a:p>
-          <a:p>
-            <a:r>
-              <a:rPr sz="1800" b="0">
+              <a:rPr sz="2800" b="1">
+                <a:solidFill>
+                  <a:srgbClr val="0F0F0F"/>
+                </a:solidFill>
+                <a:latin typeface="Fira Sans"/>
+              </a:rPr>
+              <a:t>La media por grupo: groupby</a:t>
+            </a:r>
+          </a:p>
+        </p:txBody>
+      </p:sp>
+      <p:sp>
+        <p:nvSpPr>
+          <p:cNvPr id="4" name="Rectangle 3"/>
+          <p:cNvSpPr/>
+          <p:nvPr/>
+        </p:nvSpPr>
+        <p:spPr>
+          <a:xfrm>
+            <a:off x="704088" y="1280160"/>
+            <a:ext cx="7744968" cy="2377440"/>
+          </a:xfrm>
+          <a:prstGeom prst="rect">
+            <a:avLst/>
+          </a:prstGeom>
+          <a:solidFill>
+            <a:srgbClr val="F0F2F5"/>
+          </a:solidFill>
+          <a:ln>
+            <a:solidFill>
+              <a:srgbClr val="D8DDE3"/>
+            </a:solidFill>
+          </a:ln>
+          <a:effectLst/>
+        </p:spPr>
+        <p:style>
+          <a:lnRef idx="1">
+            <a:schemeClr val="accent1"/>
+          </a:lnRef>
+          <a:fillRef idx="3">
+            <a:schemeClr val="accent1"/>
+          </a:fillRef>
+          <a:effectRef idx="2">
+            <a:schemeClr val="accent1"/>
+          </a:effectRef>
+          <a:fontRef idx="minor">
+            <a:schemeClr val="lt1"/>
+          </a:fontRef>
+        </p:style>
+        <p:txBody>
+          <a:bodyPr rtlCol="0" anchor="ctr" wrap="square" lIns="228600" tIns="137160"/>
+          <a:lstStyle/>
+          <a:p>
+            <a:pPr/>
+            <a:r>
+              <a:rPr sz="1500" b="0">
+                <a:solidFill>
+                  <a:srgbClr val="1D3557"/>
+                </a:solidFill>
+                <a:latin typeface="Menlo"/>
+              </a:rPr>
+              <a:t>iris_df.groupby("species")["petal length (cm)"].mean()</a:t>
+            </a:r>
+          </a:p>
+          <a:p>
+            <a:pPr/>
+            <a:r>
+              <a:rPr sz="1500" b="0">
+                <a:solidFill>
+                  <a:srgbClr val="1D3557"/>
+                </a:solidFill>
+                <a:latin typeface="Menlo"/>
+              </a:rPr>
+              <a:t/>
+            </a:r>
+          </a:p>
+          <a:p>
+            <a:pPr/>
+            <a:r>
+              <a:rPr sz="1500" b="0">
+                <a:solidFill>
+                  <a:srgbClr val="1D3557"/>
+                </a:solidFill>
+                <a:latin typeface="Menlo"/>
+              </a:rPr>
+              <a:t># El mismo resumen que construimos a mano con loc y el for,</a:t>
+            </a:r>
+          </a:p>
+          <a:p>
+            <a:pPr/>
+            <a:r>
+              <a:rPr sz="1500" b="0">
+                <a:solidFill>
+                  <a:srgbClr val="1D3557"/>
+                </a:solidFill>
+                <a:latin typeface="Menlo"/>
+              </a:rPr>
+              <a:t># ahora en una línea</a:t>
+            </a:r>
+          </a:p>
+        </p:txBody>
+      </p:sp>
+      <p:sp>
+        <p:nvSpPr>
+          <p:cNvPr id="5" name="TextBox 4"/>
+          <p:cNvSpPr txBox="1"/>
+          <p:nvPr/>
+        </p:nvSpPr>
+        <p:spPr>
+          <a:xfrm>
+            <a:off x="704088" y="3886200"/>
+            <a:ext cx="7744968" cy="1097280"/>
+          </a:xfrm>
+          <a:prstGeom prst="rect">
+            <a:avLst/>
+          </a:prstGeom>
+          <a:noFill/>
+        </p:spPr>
+        <p:txBody>
+          <a:bodyPr wrap="square">
+            <a:spAutoFit/>
+          </a:bodyPr>
+          <a:lstStyle/>
+          <a:p>
+            <a:pPr>
+              <a:lnSpc>
+                <a:spcPct val="112000"/>
+              </a:lnSpc>
+              <a:spcAft>
+                <a:spcPts val="900"/>
+              </a:spcAft>
+            </a:pPr>
+            <a:r>
+              <a:rPr sz="1600" b="1">
                 <a:solidFill>
                   <a:srgbClr val="E0A437"/>
                 </a:solidFill>
                 <a:latin typeface="Fira Sans"/>
               </a:rPr>
-              <a:t>La recta que resume la relación</a:t>
+              <a:t>▸ </a:t>
+            </a:r>
+            <a:r>
+              <a:rPr sz="1600" b="0">
+                <a:solidFill>
+                  <a:srgbClr val="000000"/>
+                </a:solidFill>
+                <a:latin typeface="Fira Sans"/>
+              </a:rPr>
+              <a:t>groupby parte la tabla por categoría, aplica el resumen a cada parte y junta los resultados: 1,46 / 4,26 / 5,55 cm. Es la versión numérica del boxplot por grupo.</a:t>
             </a:r>
           </a:p>
         </p:txBody>
@@ -6235,21 +6035,124 @@
                 </a:solidFill>
                 <a:latin typeface="Fira Sans"/>
               </a:rPr>
-              <a:t>De la correlación a la recta</a:t>
-            </a:r>
-          </a:p>
-        </p:txBody>
-      </p:sp>
-      <p:sp>
-        <p:nvSpPr>
-          <p:cNvPr id="4" name="TextBox 3"/>
+              <a:t>Dos categóricas: la tabla de contingencia</a:t>
+            </a:r>
+          </a:p>
+        </p:txBody>
+      </p:sp>
+      <p:sp>
+        <p:nvSpPr>
+          <p:cNvPr id="4" name="Rectangle 3"/>
+          <p:cNvSpPr/>
+          <p:nvPr/>
+        </p:nvSpPr>
+        <p:spPr>
+          <a:xfrm>
+            <a:off x="704088" y="1280160"/>
+            <a:ext cx="7744968" cy="2880360"/>
+          </a:xfrm>
+          <a:prstGeom prst="rect">
+            <a:avLst/>
+          </a:prstGeom>
+          <a:solidFill>
+            <a:srgbClr val="F0F2F5"/>
+          </a:solidFill>
+          <a:ln>
+            <a:solidFill>
+              <a:srgbClr val="D8DDE3"/>
+            </a:solidFill>
+          </a:ln>
+          <a:effectLst/>
+        </p:spPr>
+        <p:style>
+          <a:lnRef idx="1">
+            <a:schemeClr val="accent1"/>
+          </a:lnRef>
+          <a:fillRef idx="3">
+            <a:schemeClr val="accent1"/>
+          </a:fillRef>
+          <a:effectRef idx="2">
+            <a:schemeClr val="accent1"/>
+          </a:effectRef>
+          <a:fontRef idx="minor">
+            <a:schemeClr val="lt1"/>
+          </a:fontRef>
+        </p:style>
+        <p:txBody>
+          <a:bodyPr rtlCol="0" anchor="ctr" wrap="square" lIns="228600" tIns="137160"/>
+          <a:lstStyle/>
+          <a:p>
+            <a:pPr/>
+            <a:r>
+              <a:rPr sz="1500" b="0">
+                <a:solidFill>
+                  <a:srgbClr val="1D3557"/>
+                </a:solidFill>
+                <a:latin typeface="Menlo"/>
+              </a:rPr>
+              <a:t>pd.crosstab(datos["Sexo"], datos["ModoAgrupado"],</a:t>
+            </a:r>
+          </a:p>
+          <a:p>
+            <a:pPr/>
+            <a:r>
+              <a:rPr sz="1500" b="0">
+                <a:solidFill>
+                  <a:srgbClr val="1D3557"/>
+                </a:solidFill>
+                <a:latin typeface="Menlo"/>
+              </a:rPr>
+              <a:t>            normalize="index")</a:t>
+            </a:r>
+          </a:p>
+          <a:p>
+            <a:pPr/>
+            <a:r>
+              <a:rPr sz="1500" b="0">
+                <a:solidFill>
+                  <a:srgbClr val="1D3557"/>
+                </a:solidFill>
+                <a:latin typeface="Menlo"/>
+              </a:rPr>
+              <a:t># Para la ciudad: sumar factores en vez de contar viajes</a:t>
+            </a:r>
+          </a:p>
+          <a:p>
+            <a:pPr/>
+            <a:r>
+              <a:rPr sz="1500" b="0">
+                <a:solidFill>
+                  <a:srgbClr val="1D3557"/>
+                </a:solidFill>
+                <a:latin typeface="Menlo"/>
+              </a:rPr>
+              <a:t>datos.pivot_table(values="Factor", index="Sexo",</a:t>
+            </a:r>
+          </a:p>
+          <a:p>
+            <a:pPr/>
+            <a:r>
+              <a:rPr sz="1500" b="0">
+                <a:solidFill>
+                  <a:srgbClr val="1D3557"/>
+                </a:solidFill>
+                <a:latin typeface="Menlo"/>
+              </a:rPr>
+              <a:t>                  columns="ModoAgrupado", aggfunc="sum")</a:t>
+            </a:r>
+          </a:p>
+        </p:txBody>
+      </p:sp>
+      <p:sp>
+        <p:nvSpPr>
+          <p:cNvPr id="5" name="TextBox 4"/>
           <p:cNvSpPr txBox="1"/>
           <p:nvPr/>
         </p:nvSpPr>
         <p:spPr>
           <a:xfrm>
-            <a:off x="704088" y="1353312"/>
-            <a:ext cx="7744968" cy="3300984"/>
+            <a:off x="704088" y="4389120"/>
+            <a:ext cx="7744968" cy="1097280"/>
           </a:xfrm>
           <a:prstGeom prst="rect">
             <a:avLst/>
@@ -6271,7 +6174,7 @@
               </a:spcAft>
             </a:pPr>
             <a:r>
-              <a:rPr sz="1800" b="1">
+              <a:rPr sz="1600" b="1">
                 <a:solidFill>
                   <a:srgbClr val="E0A437"/>
                 </a:solidFill>
@@ -6280,97 +6183,13 @@
               <a:t>▸ </a:t>
             </a:r>
             <a:r>
-              <a:rPr sz="1800" b="1">
-                <a:solidFill>
-                  <a:srgbClr val="1D3557"/>
-                </a:solidFill>
-                <a:latin typeface="Fira Sans"/>
-              </a:rPr>
-              <a:t>La correlación dice cuánto se asocian dos variables; la regresión dibuja la recta que mejor resume esa asociación.</a:t>
-            </a:r>
-          </a:p>
-          <a:p>
-            <a:pPr>
-              <a:lnSpc>
-                <a:spcPct val="112000"/>
-              </a:lnSpc>
-              <a:spcAft>
-                <a:spcPts val="900"/>
-              </a:spcAft>
-            </a:pPr>
-            <a:r>
-              <a:rPr sz="1800" b="1">
-                <a:solidFill>
-                  <a:srgbClr val="E0A437"/>
-                </a:solidFill>
-                <a:latin typeface="Fira Sans"/>
-              </a:rPr>
-              <a:t>▸ </a:t>
-            </a:r>
-            <a:r>
-              <a:rPr sz="1800" b="0">
+              <a:rPr sz="1600" b="0">
                 <a:solidFill>
                   <a:srgbClr val="000000"/>
                 </a:solidFill>
                 <a:latin typeface="Fira Sans"/>
               </a:rPr>
-              <a:t>"Mejor" tiene definición: la recta de mínimos cuadrados, la que deja la menor suma de errores al cuadrado.</a:t>
-            </a:r>
-          </a:p>
-          <a:p>
-            <a:pPr>
-              <a:lnSpc>
-                <a:spcPct val="112000"/>
-              </a:lnSpc>
-              <a:spcAft>
-                <a:spcPts val="900"/>
-              </a:spcAft>
-            </a:pPr>
-            <a:r>
-              <a:rPr sz="1800" b="1">
-                <a:solidFill>
-                  <a:srgbClr val="E0A437"/>
-                </a:solidFill>
-                <a:latin typeface="Fira Sans"/>
-              </a:rPr>
-              <a:t>▸ </a:t>
-            </a:r>
-            <a:r>
-              <a:rPr sz="1800" b="0">
-                <a:solidFill>
-                  <a:srgbClr val="000000"/>
-                </a:solidFill>
-                <a:latin typeface="Fira Sans"/>
-              </a:rPr>
-              <a:t>Sus dos números se interpretan: la pendiente (cuánto cambia y por cada unidad de x) y el intercepto (el valor de y cuando x es 0).</a:t>
-            </a:r>
-          </a:p>
-          <a:p>
-            <a:pPr>
-              <a:lnSpc>
-                <a:spcPct val="112000"/>
-              </a:lnSpc>
-              <a:spcAft>
-                <a:spcPts val="900"/>
-              </a:spcAft>
-            </a:pPr>
-            <a:r>
-              <a:rPr sz="1800" b="1">
-                <a:solidFill>
-                  <a:srgbClr val="E0A437"/>
-                </a:solidFill>
-                <a:latin typeface="Fira Sans"/>
-              </a:rPr>
-              <a:t>▸ </a:t>
-            </a:r>
-            <a:r>
-              <a:rPr sz="1800" b="0">
-                <a:solidFill>
-                  <a:srgbClr val="000000"/>
-                </a:solidFill>
-                <a:latin typeface="Fira Sans"/>
-              </a:rPr>
-              <a:t>Hoy es un primer contacto; en las clases 6 y 7 la profundizamos.</a:t>
+              <a:t>Ponderado por factor, en día laboral: las mujeres caminan más (40% contra 27%) y los hombres usan más el auto (28% contra 19%).</a:t>
             </a:r>
           </a:p>
         </p:txBody>
@@ -6408,7 +6227,7 @@
             <a:avLst/>
           </a:prstGeom>
           <a:solidFill>
-            <a:srgbClr val="FAFBFC"/>
+            <a:srgbClr val="1D3557"/>
           </a:solidFill>
           <a:ln>
             <a:noFill/>
@@ -6445,8 +6264,8 @@
         </p:nvSpPr>
         <p:spPr>
           <a:xfrm>
-            <a:off x="402336" y="301752"/>
-            <a:ext cx="8348472" cy="795528"/>
+            <a:off x="603504" y="1847088"/>
+            <a:ext cx="7946136" cy="1399032"/>
           </a:xfrm>
           <a:prstGeom prst="rect">
             <a:avLst/>
@@ -6460,71 +6279,24 @@
           <a:lstStyle/>
           <a:p>
             <a:r>
-              <a:rPr sz="2800" b="1">
-                <a:solidFill>
-                  <a:srgbClr val="0F0F0F"/>
-                </a:solidFill>
-                <a:latin typeface="Fira Sans"/>
-              </a:rPr>
-              <a:t>La recta en la EOD</a:t>
-            </a:r>
-          </a:p>
-        </p:txBody>
-      </p:sp>
-      <p:pic>
-        <p:nvPicPr>
-          <p:cNvPr id="4" name="Picture 3" descr="c3_09_regresion_eod.png"/>
-          <p:cNvPicPr>
-            <a:picLocks noChangeAspect="1"/>
-          </p:cNvPicPr>
-          <p:nvPr/>
-        </p:nvPicPr>
-        <p:blipFill>
-          <a:blip r:embed="rId2"/>
-          <a:stretch>
-            <a:fillRect/>
-          </a:stretch>
-        </p:blipFill>
-        <p:spPr>
-          <a:xfrm>
-            <a:off x="2132444" y="1143000"/>
-            <a:ext cx="4879110" cy="3154679"/>
-          </a:xfrm>
-          <a:prstGeom prst="rect">
-            <a:avLst/>
-          </a:prstGeom>
-        </p:spPr>
-      </p:pic>
-      <p:sp>
-        <p:nvSpPr>
-          <p:cNvPr id="5" name="TextBox 4"/>
-          <p:cNvSpPr txBox="1"/>
-          <p:nvPr/>
-        </p:nvSpPr>
-        <p:spPr>
-          <a:xfrm>
-            <a:off x="704088" y="4434840"/>
-            <a:ext cx="7744968" cy="457200"/>
-          </a:xfrm>
-          <a:prstGeom prst="rect">
-            <a:avLst/>
-          </a:prstGeom>
-          <a:noFill/>
-        </p:spPr>
-        <p:txBody>
-          <a:bodyPr wrap="square">
-            <a:spAutoFit/>
-          </a:bodyPr>
-          <a:lstStyle/>
-          <a:p>
-            <a:r>
-              <a:rPr sz="1300" b="0">
-                <a:solidFill>
-                  <a:srgbClr val="333333"/>
-                </a:solidFill>
-                <a:latin typeface="Fira Sans"/>
-              </a:rPr>
-              <a:t>tiempo = 25,4 + 2,5 · km: cada kilómetro agrega 2,5 minutos, y el viaje parte costando unos 25 (caminatas, esperas, transbordos).</a:t>
+              <a:rPr sz="3400" b="1">
+                <a:solidFill>
+                  <a:srgbClr val="FFFFFF"/>
+                </a:solidFill>
+                <a:latin typeface="Fira Sans"/>
+              </a:rPr>
+              <a:t>La primera regresión</a:t>
+            </a:r>
+          </a:p>
+          <a:p>
+            <a:r>
+              <a:rPr sz="1800" b="0">
+                <a:solidFill>
+                  <a:srgbClr val="E0A437"/>
+                </a:solidFill>
+                <a:latin typeface="Fira Sans"/>
+              </a:rPr>
+              <a:t>La recta que resume la relación</a:t>
             </a:r>
           </a:p>
         </p:txBody>
@@ -6620,102 +6392,35 @@
                 </a:solidFill>
                 <a:latin typeface="Fira Sans"/>
               </a:rPr>
-              <a:t>La recta en NumPy</a:t>
-            </a:r>
-          </a:p>
-        </p:txBody>
-      </p:sp>
-      <p:sp>
-        <p:nvSpPr>
-          <p:cNvPr id="4" name="Rectangle 3"/>
-          <p:cNvSpPr/>
-          <p:nvPr/>
-        </p:nvSpPr>
-        <p:spPr>
-          <a:xfrm>
-            <a:off x="704088" y="1280160"/>
-            <a:ext cx="7744968" cy="2377440"/>
-          </a:xfrm>
-          <a:prstGeom prst="rect">
-            <a:avLst/>
-          </a:prstGeom>
-          <a:solidFill>
-            <a:srgbClr val="F0F2F5"/>
-          </a:solidFill>
-          <a:ln>
-            <a:solidFill>
-              <a:srgbClr val="D8DDE3"/>
-            </a:solidFill>
-          </a:ln>
-          <a:effectLst/>
-        </p:spPr>
-        <p:style>
-          <a:lnRef idx="1">
-            <a:schemeClr val="accent1"/>
-          </a:lnRef>
-          <a:fillRef idx="3">
-            <a:schemeClr val="accent1"/>
-          </a:fillRef>
-          <a:effectRef idx="2">
-            <a:schemeClr val="accent1"/>
-          </a:effectRef>
-          <a:fontRef idx="minor">
-            <a:schemeClr val="lt1"/>
-          </a:fontRef>
-        </p:style>
-        <p:txBody>
-          <a:bodyPr rtlCol="0" anchor="ctr" wrap="square" lIns="228600" tIns="137160"/>
-          <a:lstStyle/>
-          <a:p>
-            <a:pPr/>
-            <a:r>
-              <a:rPr sz="1500" b="0">
-                <a:solidFill>
-                  <a:srgbClr val="1D3557"/>
-                </a:solidFill>
-                <a:latin typeface="Menlo"/>
-              </a:rPr>
-              <a:t>pendiente, intercepto = np.polyfit(distancia, tiempo, 1)</a:t>
-            </a:r>
-          </a:p>
-          <a:p>
-            <a:pPr/>
-            <a:r>
-              <a:rPr sz="1500" b="0">
-                <a:solidFill>
-                  <a:srgbClr val="1D3557"/>
-                </a:solidFill>
-                <a:latin typeface="Menlo"/>
-              </a:rPr>
-              <a:t/>
-            </a:r>
-          </a:p>
-          <a:p>
-            <a:pPr/>
-            <a:r>
-              <a:rPr sz="1500" b="0">
-                <a:solidFill>
-                  <a:srgbClr val="1D3557"/>
-                </a:solidFill>
-                <a:latin typeface="Menlo"/>
-              </a:rPr>
-              <a:t># La recta evaluada, para dibujarla sobre el scatter</a:t>
-            </a:r>
-          </a:p>
-          <a:p>
-            <a:pPr/>
-            <a:r>
-              <a:rPr sz="1500" b="0">
-                <a:solidFill>
-                  <a:srgbClr val="1D3557"/>
-                </a:solidFill>
-                <a:latin typeface="Menlo"/>
-              </a:rPr>
-              <a:t>ax.plot(x, intercepto + pendiente * x)</a:t>
-            </a:r>
-          </a:p>
-        </p:txBody>
-      </p:sp>
+              <a:t>Mínimos cuadrados</a:t>
+            </a:r>
+          </a:p>
+        </p:txBody>
+      </p:sp>
+      <p:pic>
+        <p:nvPicPr>
+          <p:cNvPr id="4" name="Picture 3" descr="c3_15_residuos.png"/>
+          <p:cNvPicPr>
+            <a:picLocks noChangeAspect="1"/>
+          </p:cNvPicPr>
+          <p:nvPr/>
+        </p:nvPicPr>
+        <p:blipFill>
+          <a:blip r:embed="rId2"/>
+          <a:stretch>
+            <a:fillRect/>
+          </a:stretch>
+        </p:blipFill>
+        <p:spPr>
+          <a:xfrm>
+            <a:off x="1417319" y="1143000"/>
+            <a:ext cx="6309360" cy="2525498"/>
+          </a:xfrm>
+          <a:prstGeom prst="rect">
+            <a:avLst/>
+          </a:prstGeom>
+        </p:spPr>
+      </p:pic>
       <p:sp>
         <p:nvSpPr>
           <p:cNvPr id="5" name="TextBox 4"/>
@@ -6724,8 +6429,8 @@
         </p:nvSpPr>
         <p:spPr>
           <a:xfrm>
-            <a:off x="704088" y="3886200"/>
-            <a:ext cx="7744968" cy="1097280"/>
+            <a:off x="704088" y="4434840"/>
+            <a:ext cx="7744968" cy="457200"/>
           </a:xfrm>
           <a:prstGeom prst="rect">
             <a:avLst/>
@@ -6738,31 +6443,14 @@
           </a:bodyPr>
           <a:lstStyle/>
           <a:p>
-            <a:pPr>
-              <a:lnSpc>
-                <a:spcPct val="112000"/>
-              </a:lnSpc>
-              <a:spcAft>
-                <a:spcPts val="900"/>
-              </a:spcAft>
-            </a:pPr>
-            <a:r>
-              <a:rPr sz="1600" b="1">
-                <a:solidFill>
-                  <a:srgbClr val="E0A437"/>
-                </a:solidFill>
-                <a:latin typeface="Fira Sans"/>
-              </a:rPr>
-              <a:t>▸ </a:t>
-            </a:r>
-            <a:r>
-              <a:rPr sz="1600" b="0">
-                <a:solidFill>
-                  <a:srgbClr val="000000"/>
-                </a:solidFill>
-                <a:latin typeface="Fira Sans"/>
-              </a:rPr>
-              <a:t>polyfit ajusta un polinomio por mínimos cuadrados; el 1 pide grado 1, una recta. En las clases 6 y 7 usaremos herramientas con más diagnósticos.</a:t>
+            <a:r>
+              <a:rPr sz="1300" b="0">
+                <a:solidFill>
+                  <a:srgbClr val="333333"/>
+                </a:solidFill>
+                <a:latin typeface="Fira Sans"/>
+              </a:rPr>
+              <a:t>La correlación mide la asociación; la regresión la dibuja: la recta que deja la menor suma de errores al cuadrado. La pendiente dice cuánto cambia y por cada unidad de x. Hoy es un primer contacto; en las clases 6 y 7 la profundizamos.</a:t>
             </a:r>
           </a:p>
         </p:txBody>
@@ -6800,7 +6488,7 @@
             <a:avLst/>
           </a:prstGeom>
           <a:solidFill>
-            <a:srgbClr val="1D3557"/>
+            <a:srgbClr val="FAFBFC"/>
           </a:solidFill>
           <a:ln>
             <a:noFill/>
@@ -6837,8 +6525,8 @@
         </p:nvSpPr>
         <p:spPr>
           <a:xfrm>
-            <a:off x="603504" y="1847088"/>
-            <a:ext cx="7946136" cy="1399032"/>
+            <a:off x="402336" y="301752"/>
+            <a:ext cx="8348472" cy="795528"/>
           </a:xfrm>
           <a:prstGeom prst="rect">
             <a:avLst/>
@@ -6852,24 +6540,71 @@
           <a:lstStyle/>
           <a:p>
             <a:r>
-              <a:rPr sz="3400" b="1">
-                <a:solidFill>
-                  <a:srgbClr val="FFFFFF"/>
-                </a:solidFill>
-                <a:latin typeface="Fira Sans"/>
-              </a:rPr>
-              <a:t>Buenas prácticas de visualización</a:t>
-            </a:r>
-          </a:p>
-          <a:p>
-            <a:r>
-              <a:rPr sz="1800" b="0">
-                <a:solidFill>
-                  <a:srgbClr val="E0A437"/>
-                </a:solidFill>
-                <a:latin typeface="Fira Sans"/>
-              </a:rPr>
-              <a:t>Que el gráfico diga la verdad y se entienda</a:t>
+              <a:rPr sz="2800" b="1">
+                <a:solidFill>
+                  <a:srgbClr val="0F0F0F"/>
+                </a:solidFill>
+                <a:latin typeface="Fira Sans"/>
+              </a:rPr>
+              <a:t>La recta en la EOD</a:t>
+            </a:r>
+          </a:p>
+        </p:txBody>
+      </p:sp>
+      <p:pic>
+        <p:nvPicPr>
+          <p:cNvPr id="4" name="Picture 3" descr="c3_09_regresion_eod.png"/>
+          <p:cNvPicPr>
+            <a:picLocks noChangeAspect="1"/>
+          </p:cNvPicPr>
+          <p:nvPr/>
+        </p:nvPicPr>
+        <p:blipFill>
+          <a:blip r:embed="rId2"/>
+          <a:stretch>
+            <a:fillRect/>
+          </a:stretch>
+        </p:blipFill>
+        <p:spPr>
+          <a:xfrm>
+            <a:off x="2132444" y="1143000"/>
+            <a:ext cx="4879110" cy="3154679"/>
+          </a:xfrm>
+          <a:prstGeom prst="rect">
+            <a:avLst/>
+          </a:prstGeom>
+        </p:spPr>
+      </p:pic>
+      <p:sp>
+        <p:nvSpPr>
+          <p:cNvPr id="5" name="TextBox 4"/>
+          <p:cNvSpPr txBox="1"/>
+          <p:nvPr/>
+        </p:nvSpPr>
+        <p:spPr>
+          <a:xfrm>
+            <a:off x="704088" y="4434840"/>
+            <a:ext cx="7744968" cy="457200"/>
+          </a:xfrm>
+          <a:prstGeom prst="rect">
+            <a:avLst/>
+          </a:prstGeom>
+          <a:noFill/>
+        </p:spPr>
+        <p:txBody>
+          <a:bodyPr wrap="square">
+            <a:spAutoFit/>
+          </a:bodyPr>
+          <a:lstStyle/>
+          <a:p>
+            <a:r>
+              <a:rPr sz="1300" b="0">
+                <a:solidFill>
+                  <a:srgbClr val="333333"/>
+                </a:solidFill>
+                <a:latin typeface="Fira Sans"/>
+              </a:rPr>
+              <a:t>tiempo = 25,4 + 2,5 · km: cada kilómetro agrega 2,5 minutos, y el viaje parte costando unos 25 (caminatas, esperas, transbordos). De regalo: r al cuadrado (0,54² = 0,29) es la fracción de la variación que la recta captura.</a:t>
             </a:r>
           </a:p>
         </p:txBody>
@@ -6965,35 +6700,102 @@
                 </a:solidFill>
                 <a:latin typeface="Fira Sans"/>
               </a:rPr>
-              <a:t>Cuándo usar escala logarítmica</a:t>
-            </a:r>
-          </a:p>
-        </p:txBody>
-      </p:sp>
-      <p:pic>
-        <p:nvPicPr>
-          <p:cNvPr id="4" name="Picture 3" descr="c3_10_escala_log.png"/>
-          <p:cNvPicPr>
-            <a:picLocks noChangeAspect="1"/>
-          </p:cNvPicPr>
-          <p:nvPr/>
-        </p:nvPicPr>
-        <p:blipFill>
-          <a:blip r:embed="rId2"/>
-          <a:stretch>
-            <a:fillRect/>
-          </a:stretch>
-        </p:blipFill>
-        <p:spPr>
-          <a:xfrm>
-            <a:off x="1417319" y="1143000"/>
-            <a:ext cx="6309360" cy="2432846"/>
-          </a:xfrm>
-          <a:prstGeom prst="rect">
-            <a:avLst/>
-          </a:prstGeom>
-        </p:spPr>
-      </p:pic>
+              <a:t>La recta en NumPy</a:t>
+            </a:r>
+          </a:p>
+        </p:txBody>
+      </p:sp>
+      <p:sp>
+        <p:nvSpPr>
+          <p:cNvPr id="4" name="Rectangle 3"/>
+          <p:cNvSpPr/>
+          <p:nvPr/>
+        </p:nvSpPr>
+        <p:spPr>
+          <a:xfrm>
+            <a:off x="704088" y="1280160"/>
+            <a:ext cx="7744968" cy="2377440"/>
+          </a:xfrm>
+          <a:prstGeom prst="rect">
+            <a:avLst/>
+          </a:prstGeom>
+          <a:solidFill>
+            <a:srgbClr val="F0F2F5"/>
+          </a:solidFill>
+          <a:ln>
+            <a:solidFill>
+              <a:srgbClr val="D8DDE3"/>
+            </a:solidFill>
+          </a:ln>
+          <a:effectLst/>
+        </p:spPr>
+        <p:style>
+          <a:lnRef idx="1">
+            <a:schemeClr val="accent1"/>
+          </a:lnRef>
+          <a:fillRef idx="3">
+            <a:schemeClr val="accent1"/>
+          </a:fillRef>
+          <a:effectRef idx="2">
+            <a:schemeClr val="accent1"/>
+          </a:effectRef>
+          <a:fontRef idx="minor">
+            <a:schemeClr val="lt1"/>
+          </a:fontRef>
+        </p:style>
+        <p:txBody>
+          <a:bodyPr rtlCol="0" anchor="ctr" wrap="square" lIns="228600" tIns="137160"/>
+          <a:lstStyle/>
+          <a:p>
+            <a:pPr/>
+            <a:r>
+              <a:rPr sz="1500" b="0">
+                <a:solidFill>
+                  <a:srgbClr val="1D3557"/>
+                </a:solidFill>
+                <a:latin typeface="Menlo"/>
+              </a:rPr>
+              <a:t>pendiente, intercepto = np.polyfit(distancia, tiempo, 1)</a:t>
+            </a:r>
+          </a:p>
+          <a:p>
+            <a:pPr/>
+            <a:r>
+              <a:rPr sz="1500" b="0">
+                <a:solidFill>
+                  <a:srgbClr val="1D3557"/>
+                </a:solidFill>
+                <a:latin typeface="Menlo"/>
+              </a:rPr>
+              <a:t/>
+            </a:r>
+          </a:p>
+          <a:p>
+            <a:pPr/>
+            <a:r>
+              <a:rPr sz="1500" b="0">
+                <a:solidFill>
+                  <a:srgbClr val="1D3557"/>
+                </a:solidFill>
+                <a:latin typeface="Menlo"/>
+              </a:rPr>
+              <a:t># La recta evaluada, para dibujarla sobre el scatter</a:t>
+            </a:r>
+          </a:p>
+          <a:p>
+            <a:pPr/>
+            <a:r>
+              <a:rPr sz="1500" b="0">
+                <a:solidFill>
+                  <a:srgbClr val="1D3557"/>
+                </a:solidFill>
+                <a:latin typeface="Menlo"/>
+              </a:rPr>
+              <a:t>ax.plot(x, intercepto + pendiente * x)</a:t>
+            </a:r>
+          </a:p>
+        </p:txBody>
+      </p:sp>
       <p:sp>
         <p:nvSpPr>
           <p:cNvPr id="5" name="TextBox 4"/>
@@ -7002,8 +6804,8 @@
         </p:nvSpPr>
         <p:spPr>
           <a:xfrm>
-            <a:off x="704088" y="4434840"/>
-            <a:ext cx="7744968" cy="457200"/>
+            <a:off x="704088" y="3886200"/>
+            <a:ext cx="7744968" cy="1097280"/>
           </a:xfrm>
           <a:prstGeom prst="rect">
             <a:avLst/>
@@ -7016,14 +6818,31 @@
           </a:bodyPr>
           <a:lstStyle/>
           <a:p>
-            <a:r>
-              <a:rPr sz="1300" b="0">
-                <a:solidFill>
-                  <a:srgbClr val="333333"/>
-                </a:solidFill>
-                <a:latin typeface="Fira Sans"/>
-              </a:rPr>
-              <a:t>Con colas largas como el ingreso, la escala lineal aplasta el 99% de los datos contra el borde; la logarítmica reparte el espacio y la forma aparece.</a:t>
+            <a:pPr>
+              <a:lnSpc>
+                <a:spcPct val="112000"/>
+              </a:lnSpc>
+              <a:spcAft>
+                <a:spcPts val="900"/>
+              </a:spcAft>
+            </a:pPr>
+            <a:r>
+              <a:rPr sz="1600" b="1">
+                <a:solidFill>
+                  <a:srgbClr val="E0A437"/>
+                </a:solidFill>
+                <a:latin typeface="Fira Sans"/>
+              </a:rPr>
+              <a:t>▸ </a:t>
+            </a:r>
+            <a:r>
+              <a:rPr sz="1600" b="0">
+                <a:solidFill>
+                  <a:srgbClr val="000000"/>
+                </a:solidFill>
+                <a:latin typeface="Fira Sans"/>
+              </a:rPr>
+              <a:t>polyfit ajusta un polinomio por mínimos cuadrados; el 1 pide grado 1, una recta. En las clases 6 y 7 usaremos herramientas con más diagnósticos.</a:t>
             </a:r>
           </a:p>
         </p:txBody>
@@ -7061,7 +6880,7 @@
             <a:avLst/>
           </a:prstGeom>
           <a:solidFill>
-            <a:srgbClr val="FAFBFC"/>
+            <a:srgbClr val="1D3557"/>
           </a:solidFill>
           <a:ln>
             <a:noFill/>
@@ -7098,8 +6917,8 @@
         </p:nvSpPr>
         <p:spPr>
           <a:xfrm>
-            <a:off x="402336" y="301752"/>
-            <a:ext cx="8348472" cy="795528"/>
+            <a:off x="603504" y="1847088"/>
+            <a:ext cx="7946136" cy="1399032"/>
           </a:xfrm>
           <a:prstGeom prst="rect">
             <a:avLst/>
@@ -7113,176 +6932,24 @@
           <a:lstStyle/>
           <a:p>
             <a:r>
-              <a:rPr sz="2800" b="1">
-                <a:solidFill>
-                  <a:srgbClr val="0F0F0F"/>
-                </a:solidFill>
-                <a:latin typeface="Fira Sans"/>
-              </a:rPr>
-              <a:t>Checklist del buen gráfico</a:t>
-            </a:r>
-          </a:p>
-        </p:txBody>
-      </p:sp>
-      <p:sp>
-        <p:nvSpPr>
-          <p:cNvPr id="4" name="TextBox 3"/>
-          <p:cNvSpPr txBox="1"/>
-          <p:nvPr/>
-        </p:nvSpPr>
-        <p:spPr>
-          <a:xfrm>
-            <a:off x="704088" y="1353312"/>
-            <a:ext cx="7744968" cy="3300984"/>
-          </a:xfrm>
-          <a:prstGeom prst="rect">
-            <a:avLst/>
-          </a:prstGeom>
-          <a:noFill/>
-        </p:spPr>
-        <p:txBody>
-          <a:bodyPr wrap="square">
-            <a:spAutoFit/>
-          </a:bodyPr>
-          <a:lstStyle/>
-          <a:p>
-            <a:pPr>
-              <a:lnSpc>
-                <a:spcPct val="112000"/>
-              </a:lnSpc>
-              <a:spcAft>
-                <a:spcPts val="900"/>
-              </a:spcAft>
-            </a:pPr>
-            <a:r>
-              <a:rPr sz="1800" b="1">
+              <a:rPr sz="3400" b="1">
+                <a:solidFill>
+                  <a:srgbClr val="FFFFFF"/>
+                </a:solidFill>
+                <a:latin typeface="Fira Sans"/>
+              </a:rPr>
+              <a:t>Buenas prácticas de visualización</a:t>
+            </a:r>
+          </a:p>
+          <a:p>
+            <a:r>
+              <a:rPr sz="1800" b="0">
                 <a:solidFill>
                   <a:srgbClr val="E0A437"/>
                 </a:solidFill>
                 <a:latin typeface="Fira Sans"/>
               </a:rPr>
-              <a:t>▸ </a:t>
-            </a:r>
-            <a:r>
-              <a:rPr sz="1800" b="0">
-                <a:solidFill>
-                  <a:srgbClr val="000000"/>
-                </a:solidFill>
-                <a:latin typeface="Fira Sans"/>
-              </a:rPr>
-              <a:t>Título que diga el hallazgo, no solo las variables.</a:t>
-            </a:r>
-          </a:p>
-          <a:p>
-            <a:pPr>
-              <a:lnSpc>
-                <a:spcPct val="112000"/>
-              </a:lnSpc>
-              <a:spcAft>
-                <a:spcPts val="900"/>
-              </a:spcAft>
-            </a:pPr>
-            <a:r>
-              <a:rPr sz="1800" b="1">
-                <a:solidFill>
-                  <a:srgbClr val="E0A437"/>
-                </a:solidFill>
-                <a:latin typeface="Fira Sans"/>
-              </a:rPr>
-              <a:t>▸ </a:t>
-            </a:r>
-            <a:r>
-              <a:rPr sz="1800" b="0">
-                <a:solidFill>
-                  <a:srgbClr val="000000"/>
-                </a:solidFill>
-                <a:latin typeface="Fira Sans"/>
-              </a:rPr>
-              <a:t>Ejes con nombre y unidad; ejes que parten de cero en gráficos de barras.</a:t>
-            </a:r>
-          </a:p>
-          <a:p>
-            <a:pPr>
-              <a:lnSpc>
-                <a:spcPct val="112000"/>
-              </a:lnSpc>
-              <a:spcAft>
-                <a:spcPts val="900"/>
-              </a:spcAft>
-            </a:pPr>
-            <a:r>
-              <a:rPr sz="1800" b="1">
-                <a:solidFill>
-                  <a:srgbClr val="E0A437"/>
-                </a:solidFill>
-                <a:latin typeface="Fira Sans"/>
-              </a:rPr>
-              <a:t>▸ </a:t>
-            </a:r>
-            <a:r>
-              <a:rPr sz="1800" b="0">
-                <a:solidFill>
-                  <a:srgbClr val="000000"/>
-                </a:solidFill>
-                <a:latin typeface="Fira Sans"/>
-              </a:rPr>
-              <a:t>Muchos puntos: alpha, muestreo o hexbin.</a:t>
-            </a:r>
-          </a:p>
-          <a:p>
-            <a:pPr>
-              <a:lnSpc>
-                <a:spcPct val="112000"/>
-              </a:lnSpc>
-              <a:spcAft>
-                <a:spcPts val="900"/>
-              </a:spcAft>
-            </a:pPr>
-            <a:r>
-              <a:rPr sz="1800" b="1">
-                <a:solidFill>
-                  <a:srgbClr val="E0A437"/>
-                </a:solidFill>
-                <a:latin typeface="Fira Sans"/>
-              </a:rPr>
-              <a:t>▸ </a:t>
-            </a:r>
-            <a:r>
-              <a:rPr sz="1800" b="0">
-                <a:solidFill>
-                  <a:srgbClr val="000000"/>
-                </a:solidFill>
-                <a:latin typeface="Fira Sans"/>
-              </a:rPr>
-              <a:t>Colas largas: escala logarítmica o eje recortado, declarándolo.</a:t>
-            </a:r>
-          </a:p>
-          <a:p>
-            <a:pPr>
-              <a:lnSpc>
-                <a:spcPct val="112000"/>
-              </a:lnSpc>
-              <a:spcAft>
-                <a:spcPts val="900"/>
-              </a:spcAft>
-            </a:pPr>
-            <a:r>
-              <a:rPr sz="1800" b="1">
-                <a:solidFill>
-                  <a:srgbClr val="E0A437"/>
-                </a:solidFill>
-                <a:latin typeface="Fira Sans"/>
-              </a:rPr>
-              <a:t>▸ </a:t>
-            </a:r>
-            <a:r>
-              <a:rPr sz="1800" b="1">
-                <a:solidFill>
-                  <a:srgbClr val="1D3557"/>
-                </a:solidFill>
-                <a:latin typeface="Fira Sans"/>
-              </a:rPr>
-              <a:t>El gráfico se corrige igual que el código: se itera hasta que un tercero lo entienda sin explicación oral.</a:t>
+              <a:t>Que el gráfico diga la verdad y se entienda</a:t>
             </a:r>
           </a:p>
         </p:txBody>
@@ -7609,21 +7276,45 @@
                 </a:solidFill>
                 <a:latin typeface="Fira Sans"/>
               </a:rPr>
-              <a:t>Síntesis</a:t>
-            </a:r>
-          </a:p>
-        </p:txBody>
-      </p:sp>
-      <p:sp>
-        <p:nvSpPr>
-          <p:cNvPr id="4" name="TextBox 3"/>
+              <a:t>Cuándo usar escala logarítmica</a:t>
+            </a:r>
+          </a:p>
+        </p:txBody>
+      </p:sp>
+      <p:pic>
+        <p:nvPicPr>
+          <p:cNvPr id="4" name="Picture 3" descr="c3_10_escala_log.png"/>
+          <p:cNvPicPr>
+            <a:picLocks noChangeAspect="1"/>
+          </p:cNvPicPr>
+          <p:nvPr/>
+        </p:nvPicPr>
+        <p:blipFill>
+          <a:blip r:embed="rId2"/>
+          <a:stretch>
+            <a:fillRect/>
+          </a:stretch>
+        </p:blipFill>
+        <p:spPr>
+          <a:xfrm>
+            <a:off x="1417319" y="1143000"/>
+            <a:ext cx="6309360" cy="2432846"/>
+          </a:xfrm>
+          <a:prstGeom prst="rect">
+            <a:avLst/>
+          </a:prstGeom>
+        </p:spPr>
+      </p:pic>
+      <p:sp>
+        <p:nvSpPr>
+          <p:cNvPr id="5" name="TextBox 4"/>
           <p:cNvSpPr txBox="1"/>
           <p:nvPr/>
         </p:nvSpPr>
         <p:spPr>
           <a:xfrm>
-            <a:off x="704088" y="1353312"/>
-            <a:ext cx="7744968" cy="3300984"/>
+            <a:off x="704088" y="4434840"/>
+            <a:ext cx="7744968" cy="457200"/>
           </a:xfrm>
           <a:prstGeom prst="rect">
             <a:avLst/>
@@ -7636,143 +7327,14 @@
           </a:bodyPr>
           <a:lstStyle/>
           <a:p>
-            <a:pPr>
-              <a:lnSpc>
-                <a:spcPct val="112000"/>
-              </a:lnSpc>
-              <a:spcAft>
-                <a:spcPts val="900"/>
-              </a:spcAft>
-            </a:pPr>
-            <a:r>
-              <a:rPr sz="1800" b="1">
-                <a:solidFill>
-                  <a:srgbClr val="E0A437"/>
-                </a:solidFill>
-                <a:latin typeface="Fira Sans"/>
-              </a:rPr>
-              <a:t>▸ </a:t>
-            </a:r>
-            <a:r>
-              <a:rPr sz="1800" b="0">
-                <a:solidFill>
-                  <a:srgbClr val="000000"/>
-                </a:solidFill>
-                <a:latin typeface="Fira Sans"/>
-              </a:rPr>
-              <a:t>El análisis bivariado se elige según el par de tipos: scatter y correlación, groupby y boxplot, o tabla de contingencia.</a:t>
-            </a:r>
-          </a:p>
-          <a:p>
-            <a:pPr>
-              <a:lnSpc>
-                <a:spcPct val="112000"/>
-              </a:lnSpc>
-              <a:spcAft>
-                <a:spcPts val="900"/>
-              </a:spcAft>
-            </a:pPr>
-            <a:r>
-              <a:rPr sz="1800" b="1">
-                <a:solidFill>
-                  <a:srgbClr val="E0A437"/>
-                </a:solidFill>
-                <a:latin typeface="Fira Sans"/>
-              </a:rPr>
-              <a:t>▸ </a:t>
-            </a:r>
-            <a:r>
-              <a:rPr sz="1800" b="0">
-                <a:solidFill>
-                  <a:srgbClr val="000000"/>
-                </a:solidFill>
-                <a:latin typeface="Fira Sans"/>
-              </a:rPr>
-              <a:t>Pearson para relaciones lineales; Spearman cuando hay atípicos o curvas. Y siempre graficar: Anscombe.</a:t>
-            </a:r>
-          </a:p>
-          <a:p>
-            <a:pPr>
-              <a:lnSpc>
-                <a:spcPct val="112000"/>
-              </a:lnSpc>
-              <a:spcAft>
-                <a:spcPts val="900"/>
-              </a:spcAft>
-            </a:pPr>
-            <a:r>
-              <a:rPr sz="1800" b="1">
-                <a:solidFill>
-                  <a:srgbClr val="E0A437"/>
-                </a:solidFill>
-                <a:latin typeface="Fira Sans"/>
-              </a:rPr>
-              <a:t>▸ </a:t>
-            </a:r>
-            <a:r>
-              <a:rPr sz="1800" b="0">
-                <a:solidFill>
-                  <a:srgbClr val="000000"/>
-                </a:solidFill>
-                <a:latin typeface="Fira Sans"/>
-              </a:rPr>
-              <a:t>Correlación no es causalidad: reportamos asociación.</a:t>
-            </a:r>
-          </a:p>
-          <a:p>
-            <a:pPr>
-              <a:lnSpc>
-                <a:spcPct val="112000"/>
-              </a:lnSpc>
-              <a:spcAft>
-                <a:spcPts val="900"/>
-              </a:spcAft>
-            </a:pPr>
-            <a:r>
-              <a:rPr sz="1800" b="1">
-                <a:solidFill>
-                  <a:srgbClr val="E0A437"/>
-                </a:solidFill>
-                <a:latin typeface="Fira Sans"/>
-              </a:rPr>
-              <a:t>▸ </a:t>
-            </a:r>
-            <a:r>
-              <a:rPr sz="1800" b="0">
-                <a:solidFill>
-                  <a:srgbClr val="000000"/>
-                </a:solidFill>
-                <a:latin typeface="Fira Sans"/>
-              </a:rPr>
-              <a:t>La regresión da la recta interpretable: pendiente e intercepto.</a:t>
-            </a:r>
-          </a:p>
-          <a:p>
-            <a:pPr>
-              <a:lnSpc>
-                <a:spcPct val="112000"/>
-              </a:lnSpc>
-              <a:spcAft>
-                <a:spcPts val="900"/>
-              </a:spcAft>
-            </a:pPr>
-            <a:r>
-              <a:rPr sz="1800" b="1">
-                <a:solidFill>
-                  <a:srgbClr val="E0A437"/>
-                </a:solidFill>
-                <a:latin typeface="Fira Sans"/>
-              </a:rPr>
-              <a:t>▸ </a:t>
-            </a:r>
-            <a:r>
-              <a:rPr sz="1800" b="1">
-                <a:solidFill>
-                  <a:srgbClr val="1D3557"/>
-                </a:solidFill>
-                <a:latin typeface="Fira Sans"/>
-              </a:rPr>
-              <a:t>Todo lo de hoy es exactamente lo que el primer EDA del proyecto debe mostrar (entrega: lunes 15).</a:t>
+            <a:r>
+              <a:rPr sz="1300" b="0">
+                <a:solidFill>
+                  <a:srgbClr val="333333"/>
+                </a:solidFill>
+                <a:latin typeface="Fira Sans"/>
+              </a:rPr>
+              <a:t>Con colas largas como el ingreso, la escala lineal aplasta el 99% de los datos contra el borde; la logarítmica reparte el espacio y la forma aparece.</a:t>
             </a:r>
           </a:p>
         </p:txBody>
@@ -7868,21 +7430,45 @@
                 </a:solidFill>
                 <a:latin typeface="Fira Sans"/>
               </a:rPr>
-              <a:t>Próxima clase</a:t>
-            </a:r>
-          </a:p>
-        </p:txBody>
-      </p:sp>
-      <p:sp>
-        <p:nvSpPr>
-          <p:cNvPr id="4" name="TextBox 3"/>
+              <a:t>El mismo gráfico, dos veces</a:t>
+            </a:r>
+          </a:p>
+        </p:txBody>
+      </p:sp>
+      <p:pic>
+        <p:nvPicPr>
+          <p:cNvPr id="4" name="Picture 3" descr="c3_16_mal_buen_grafico.png"/>
+          <p:cNvPicPr>
+            <a:picLocks noChangeAspect="1"/>
+          </p:cNvPicPr>
+          <p:nvPr/>
+        </p:nvPicPr>
+        <p:blipFill>
+          <a:blip r:embed="rId2"/>
+          <a:stretch>
+            <a:fillRect/>
+          </a:stretch>
+        </p:blipFill>
+        <p:spPr>
+          <a:xfrm>
+            <a:off x="1417319" y="1143000"/>
+            <a:ext cx="6309360" cy="2447822"/>
+          </a:xfrm>
+          <a:prstGeom prst="rect">
+            <a:avLst/>
+          </a:prstGeom>
+        </p:spPr>
+      </p:pic>
+      <p:sp>
+        <p:nvSpPr>
+          <p:cNvPr id="5" name="TextBox 4"/>
           <p:cNvSpPr txBox="1"/>
           <p:nvPr/>
         </p:nvSpPr>
         <p:spPr>
           <a:xfrm>
-            <a:off x="704088" y="1353312"/>
-            <a:ext cx="7744968" cy="3300984"/>
+            <a:off x="704088" y="4434840"/>
+            <a:ext cx="7744968" cy="457200"/>
           </a:xfrm>
           <a:prstGeom prst="rect">
             <a:avLst/>
@@ -7895,115 +7481,14 @@
           </a:bodyPr>
           <a:lstStyle/>
           <a:p>
-            <a:pPr>
-              <a:lnSpc>
-                <a:spcPct val="112000"/>
-              </a:lnSpc>
-              <a:spcAft>
-                <a:spcPts val="900"/>
-              </a:spcAft>
-            </a:pPr>
-            <a:r>
-              <a:rPr sz="1800" b="1">
-                <a:solidFill>
-                  <a:srgbClr val="E0A437"/>
-                </a:solidFill>
-                <a:latin typeface="Fira Sans"/>
-              </a:rPr>
-              <a:t>▸ </a:t>
-            </a:r>
-            <a:r>
-              <a:rPr sz="1800" b="1">
-                <a:solidFill>
-                  <a:srgbClr val="1D3557"/>
-                </a:solidFill>
-                <a:latin typeface="Fira Sans"/>
-              </a:rPr>
-              <a:t>Jueves 3 de septiembre: presentaciones breves de las ideas de proyecto (5 minutos por equipo, sin nota).</a:t>
-            </a:r>
-          </a:p>
-          <a:p>
-            <a:pPr>
-              <a:lnSpc>
-                <a:spcPct val="112000"/>
-              </a:lnSpc>
-              <a:spcAft>
-                <a:spcPts val="900"/>
-              </a:spcAft>
-            </a:pPr>
-            <a:r>
-              <a:rPr sz="1800" b="1">
-                <a:solidFill>
-                  <a:srgbClr val="E0A437"/>
-                </a:solidFill>
-                <a:latin typeface="Fira Sans"/>
-              </a:rPr>
-              <a:t>▸ </a:t>
-            </a:r>
-            <a:r>
-              <a:rPr sz="1800" b="0">
-                <a:solidFill>
-                  <a:srgbClr val="000000"/>
-                </a:solidFill>
-                <a:latin typeface="Fira Sans"/>
-              </a:rPr>
-              <a:t>Después: fundamentos de probabilidad, la base para la inferencia de las clases siguientes.</a:t>
-            </a:r>
-          </a:p>
-          <a:p>
-            <a:pPr>
-              <a:lnSpc>
-                <a:spcPct val="112000"/>
-              </a:lnSpc>
-              <a:spcAft>
-                <a:spcPts val="900"/>
-              </a:spcAft>
-            </a:pPr>
-            <a:r>
-              <a:rPr sz="1800" b="1">
-                <a:solidFill>
-                  <a:srgbClr val="E0A437"/>
-                </a:solidFill>
-                <a:latin typeface="Fira Sans"/>
-              </a:rPr>
-              <a:t>▸ </a:t>
-            </a:r>
-            <a:r>
-              <a:rPr sz="1800" b="0">
-                <a:solidFill>
-                  <a:srgbClr val="000000"/>
-                </a:solidFill>
-                <a:latin typeface="Fira Sans"/>
-              </a:rPr>
-              <a:t>Se publica la rúbrica del primer análisis exploratorio.</a:t>
-            </a:r>
-          </a:p>
-          <a:p>
-            <a:pPr>
-              <a:lnSpc>
-                <a:spcPct val="112000"/>
-              </a:lnSpc>
-              <a:spcAft>
-                <a:spcPts val="900"/>
-              </a:spcAft>
-            </a:pPr>
-            <a:r>
-              <a:rPr sz="1800" b="1">
-                <a:solidFill>
-                  <a:srgbClr val="E0A437"/>
-                </a:solidFill>
-                <a:latin typeface="Fira Sans"/>
-              </a:rPr>
-              <a:t>▸ </a:t>
-            </a:r>
-            <a:r>
-              <a:rPr sz="1800" b="0">
-                <a:solidFill>
-                  <a:srgbClr val="000000"/>
-                </a:solidFill>
-                <a:latin typeface="Fira Sans"/>
-              </a:rPr>
-              <a:t>Recuerden: la formulación se entrega el lunes 7 por el aula virtual.</a:t>
+            <a:r>
+              <a:rPr sz="1300" b="0">
+                <a:solidFill>
+                  <a:srgbClr val="333333"/>
+                </a:solidFill>
+                <a:latin typeface="Fira Sans"/>
+              </a:rPr>
+              <a:t>Los mismos 30 mil viajes: sin rotular y saturado, contra rotulado, con transparencia y con el hallazgo en el título.</a:t>
             </a:r>
           </a:p>
         </p:txBody>
@@ -8099,6 +7584,755 @@
                 </a:solidFill>
                 <a:latin typeface="Fira Sans"/>
               </a:rPr>
+              <a:t>Checklist del buen gráfico</a:t>
+            </a:r>
+          </a:p>
+        </p:txBody>
+      </p:sp>
+      <p:sp>
+        <p:nvSpPr>
+          <p:cNvPr id="4" name="TextBox 3"/>
+          <p:cNvSpPr txBox="1"/>
+          <p:nvPr/>
+        </p:nvSpPr>
+        <p:spPr>
+          <a:xfrm>
+            <a:off x="704088" y="1353312"/>
+            <a:ext cx="7744968" cy="3300984"/>
+          </a:xfrm>
+          <a:prstGeom prst="rect">
+            <a:avLst/>
+          </a:prstGeom>
+          <a:noFill/>
+        </p:spPr>
+        <p:txBody>
+          <a:bodyPr wrap="square">
+            <a:spAutoFit/>
+          </a:bodyPr>
+          <a:lstStyle/>
+          <a:p>
+            <a:pPr>
+              <a:lnSpc>
+                <a:spcPct val="112000"/>
+              </a:lnSpc>
+              <a:spcAft>
+                <a:spcPts val="900"/>
+              </a:spcAft>
+            </a:pPr>
+            <a:r>
+              <a:rPr sz="1800" b="1">
+                <a:solidFill>
+                  <a:srgbClr val="E0A437"/>
+                </a:solidFill>
+                <a:latin typeface="Fira Sans"/>
+              </a:rPr>
+              <a:t>▸ </a:t>
+            </a:r>
+            <a:r>
+              <a:rPr sz="1800" b="0">
+                <a:solidFill>
+                  <a:srgbClr val="000000"/>
+                </a:solidFill>
+                <a:latin typeface="Fira Sans"/>
+              </a:rPr>
+              <a:t>Título que diga el hallazgo, no solo las variables.</a:t>
+            </a:r>
+          </a:p>
+          <a:p>
+            <a:pPr>
+              <a:lnSpc>
+                <a:spcPct val="112000"/>
+              </a:lnSpc>
+              <a:spcAft>
+                <a:spcPts val="900"/>
+              </a:spcAft>
+            </a:pPr>
+            <a:r>
+              <a:rPr sz="1800" b="1">
+                <a:solidFill>
+                  <a:srgbClr val="E0A437"/>
+                </a:solidFill>
+                <a:latin typeface="Fira Sans"/>
+              </a:rPr>
+              <a:t>▸ </a:t>
+            </a:r>
+            <a:r>
+              <a:rPr sz="1800" b="0">
+                <a:solidFill>
+                  <a:srgbClr val="000000"/>
+                </a:solidFill>
+                <a:latin typeface="Fira Sans"/>
+              </a:rPr>
+              <a:t>Ejes con nombre y unidad; ejes que parten de cero en gráficos de barras.</a:t>
+            </a:r>
+          </a:p>
+          <a:p>
+            <a:pPr>
+              <a:lnSpc>
+                <a:spcPct val="112000"/>
+              </a:lnSpc>
+              <a:spcAft>
+                <a:spcPts val="900"/>
+              </a:spcAft>
+            </a:pPr>
+            <a:r>
+              <a:rPr sz="1800" b="1">
+                <a:solidFill>
+                  <a:srgbClr val="E0A437"/>
+                </a:solidFill>
+                <a:latin typeface="Fira Sans"/>
+              </a:rPr>
+              <a:t>▸ </a:t>
+            </a:r>
+            <a:r>
+              <a:rPr sz="1800" b="0">
+                <a:solidFill>
+                  <a:srgbClr val="000000"/>
+                </a:solidFill>
+                <a:latin typeface="Fira Sans"/>
+              </a:rPr>
+              <a:t>Muchos puntos: alpha, muestreo o hexbin.</a:t>
+            </a:r>
+          </a:p>
+          <a:p>
+            <a:pPr>
+              <a:lnSpc>
+                <a:spcPct val="112000"/>
+              </a:lnSpc>
+              <a:spcAft>
+                <a:spcPts val="900"/>
+              </a:spcAft>
+            </a:pPr>
+            <a:r>
+              <a:rPr sz="1800" b="1">
+                <a:solidFill>
+                  <a:srgbClr val="E0A437"/>
+                </a:solidFill>
+                <a:latin typeface="Fira Sans"/>
+              </a:rPr>
+              <a:t>▸ </a:t>
+            </a:r>
+            <a:r>
+              <a:rPr sz="1800" b="0">
+                <a:solidFill>
+                  <a:srgbClr val="000000"/>
+                </a:solidFill>
+                <a:latin typeface="Fira Sans"/>
+              </a:rPr>
+              <a:t>Colas largas: escala logarítmica o eje recortado, declarándolo.</a:t>
+            </a:r>
+          </a:p>
+          <a:p>
+            <a:pPr>
+              <a:lnSpc>
+                <a:spcPct val="112000"/>
+              </a:lnSpc>
+              <a:spcAft>
+                <a:spcPts val="900"/>
+              </a:spcAft>
+            </a:pPr>
+            <a:r>
+              <a:rPr sz="1800" b="1">
+                <a:solidFill>
+                  <a:srgbClr val="E0A437"/>
+                </a:solidFill>
+                <a:latin typeface="Fira Sans"/>
+              </a:rPr>
+              <a:t>▸ </a:t>
+            </a:r>
+            <a:r>
+              <a:rPr sz="1800" b="1">
+                <a:solidFill>
+                  <a:srgbClr val="1D3557"/>
+                </a:solidFill>
+                <a:latin typeface="Fira Sans"/>
+              </a:rPr>
+              <a:t>El gráfico se corrige igual que el código: se itera hasta que un tercero lo entienda sin explicación oral.</a:t>
+            </a:r>
+          </a:p>
+        </p:txBody>
+      </p:sp>
+    </p:spTree>
+  </p:cSld>
+  <p:clrMapOvr>
+    <a:masterClrMapping/>
+  </p:clrMapOvr>
+</p:sld>
+</file>
+
+<file path=ppt/slides/slide33.xml><?xml version="1.0" encoding="utf-8"?>
+<p:sld xmlns:a="http://schemas.openxmlformats.org/drawingml/2006/main" xmlns:p="http://schemas.openxmlformats.org/presentationml/2006/main" xmlns:r="http://schemas.openxmlformats.org/officeDocument/2006/relationships">
+  <p:cSld>
+    <p:spTree>
+      <p:nvGrpSpPr>
+        <p:cNvPr id="1" name=""/>
+        <p:cNvGrpSpPr/>
+        <p:nvPr/>
+      </p:nvGrpSpPr>
+      <p:grpSpPr/>
+      <p:sp>
+        <p:nvSpPr>
+          <p:cNvPr id="2" name="Rectangle 1"/>
+          <p:cNvSpPr/>
+          <p:nvPr/>
+        </p:nvSpPr>
+        <p:spPr>
+          <a:xfrm>
+            <a:off x="0" y="0"/>
+            <a:ext cx="9144000" cy="5138928"/>
+          </a:xfrm>
+          <a:prstGeom prst="rect">
+            <a:avLst/>
+          </a:prstGeom>
+          <a:solidFill>
+            <a:srgbClr val="FAFBFC"/>
+          </a:solidFill>
+          <a:ln>
+            <a:noFill/>
+          </a:ln>
+          <a:effectLst/>
+        </p:spPr>
+        <p:style>
+          <a:lnRef idx="1">
+            <a:schemeClr val="accent1"/>
+          </a:lnRef>
+          <a:fillRef idx="3">
+            <a:schemeClr val="accent1"/>
+          </a:fillRef>
+          <a:effectRef idx="2">
+            <a:schemeClr val="accent1"/>
+          </a:effectRef>
+          <a:fontRef idx="minor">
+            <a:schemeClr val="lt1"/>
+          </a:fontRef>
+        </p:style>
+        <p:txBody>
+          <a:bodyPr rtlCol="0" anchor="ctr"/>
+          <a:lstStyle/>
+          <a:p>
+            <a:pPr algn="ctr"/>
+          </a:p>
+        </p:txBody>
+      </p:sp>
+      <p:sp>
+        <p:nvSpPr>
+          <p:cNvPr id="3" name="TextBox 2"/>
+          <p:cNvSpPr txBox="1"/>
+          <p:nvPr/>
+        </p:nvSpPr>
+        <p:spPr>
+          <a:xfrm>
+            <a:off x="402336" y="301752"/>
+            <a:ext cx="8348472" cy="795528"/>
+          </a:xfrm>
+          <a:prstGeom prst="rect">
+            <a:avLst/>
+          </a:prstGeom>
+          <a:noFill/>
+        </p:spPr>
+        <p:txBody>
+          <a:bodyPr wrap="square">
+            <a:spAutoFit/>
+          </a:bodyPr>
+          <a:lstStyle/>
+          <a:p>
+            <a:r>
+              <a:rPr sz="2800" b="1">
+                <a:solidFill>
+                  <a:srgbClr val="0F0F0F"/>
+                </a:solidFill>
+                <a:latin typeface="Fira Sans"/>
+              </a:rPr>
+              <a:t>Síntesis</a:t>
+            </a:r>
+          </a:p>
+        </p:txBody>
+      </p:sp>
+      <p:sp>
+        <p:nvSpPr>
+          <p:cNvPr id="4" name="TextBox 3"/>
+          <p:cNvSpPr txBox="1"/>
+          <p:nvPr/>
+        </p:nvSpPr>
+        <p:spPr>
+          <a:xfrm>
+            <a:off x="704088" y="1353312"/>
+            <a:ext cx="7744968" cy="3300984"/>
+          </a:xfrm>
+          <a:prstGeom prst="rect">
+            <a:avLst/>
+          </a:prstGeom>
+          <a:noFill/>
+        </p:spPr>
+        <p:txBody>
+          <a:bodyPr wrap="square">
+            <a:spAutoFit/>
+          </a:bodyPr>
+          <a:lstStyle/>
+          <a:p>
+            <a:pPr>
+              <a:lnSpc>
+                <a:spcPct val="112000"/>
+              </a:lnSpc>
+              <a:spcAft>
+                <a:spcPts val="900"/>
+              </a:spcAft>
+            </a:pPr>
+            <a:r>
+              <a:rPr sz="1800" b="1">
+                <a:solidFill>
+                  <a:srgbClr val="E0A437"/>
+                </a:solidFill>
+                <a:latin typeface="Fira Sans"/>
+              </a:rPr>
+              <a:t>▸ </a:t>
+            </a:r>
+            <a:r>
+              <a:rPr sz="1800" b="0">
+                <a:solidFill>
+                  <a:srgbClr val="000000"/>
+                </a:solidFill>
+                <a:latin typeface="Fira Sans"/>
+              </a:rPr>
+              <a:t>El análisis bivariado se elige según el par de tipos: scatter y correlación, groupby y boxplot, o tabla de contingencia.</a:t>
+            </a:r>
+          </a:p>
+          <a:p>
+            <a:pPr>
+              <a:lnSpc>
+                <a:spcPct val="112000"/>
+              </a:lnSpc>
+              <a:spcAft>
+                <a:spcPts val="900"/>
+              </a:spcAft>
+            </a:pPr>
+            <a:r>
+              <a:rPr sz="1800" b="1">
+                <a:solidFill>
+                  <a:srgbClr val="E0A437"/>
+                </a:solidFill>
+                <a:latin typeface="Fira Sans"/>
+              </a:rPr>
+              <a:t>▸ </a:t>
+            </a:r>
+            <a:r>
+              <a:rPr sz="1800" b="0">
+                <a:solidFill>
+                  <a:srgbClr val="000000"/>
+                </a:solidFill>
+                <a:latin typeface="Fira Sans"/>
+              </a:rPr>
+              <a:t>Pearson para relaciones lineales; Spearman cuando hay atípicos o curvas. Y siempre graficar: Anscombe.</a:t>
+            </a:r>
+          </a:p>
+          <a:p>
+            <a:pPr>
+              <a:lnSpc>
+                <a:spcPct val="112000"/>
+              </a:lnSpc>
+              <a:spcAft>
+                <a:spcPts val="900"/>
+              </a:spcAft>
+            </a:pPr>
+            <a:r>
+              <a:rPr sz="1800" b="1">
+                <a:solidFill>
+                  <a:srgbClr val="E0A437"/>
+                </a:solidFill>
+                <a:latin typeface="Fira Sans"/>
+              </a:rPr>
+              <a:t>▸ </a:t>
+            </a:r>
+            <a:r>
+              <a:rPr sz="1800" b="0">
+                <a:solidFill>
+                  <a:srgbClr val="000000"/>
+                </a:solidFill>
+                <a:latin typeface="Fira Sans"/>
+              </a:rPr>
+              <a:t>Correlación no es causalidad: reportamos asociación.</a:t>
+            </a:r>
+          </a:p>
+          <a:p>
+            <a:pPr>
+              <a:lnSpc>
+                <a:spcPct val="112000"/>
+              </a:lnSpc>
+              <a:spcAft>
+                <a:spcPts val="900"/>
+              </a:spcAft>
+            </a:pPr>
+            <a:r>
+              <a:rPr sz="1800" b="1">
+                <a:solidFill>
+                  <a:srgbClr val="E0A437"/>
+                </a:solidFill>
+                <a:latin typeface="Fira Sans"/>
+              </a:rPr>
+              <a:t>▸ </a:t>
+            </a:r>
+            <a:r>
+              <a:rPr sz="1800" b="0">
+                <a:solidFill>
+                  <a:srgbClr val="000000"/>
+                </a:solidFill>
+                <a:latin typeface="Fira Sans"/>
+              </a:rPr>
+              <a:t>La regresión da la recta interpretable: pendiente e intercepto.</a:t>
+            </a:r>
+          </a:p>
+          <a:p>
+            <a:pPr>
+              <a:lnSpc>
+                <a:spcPct val="112000"/>
+              </a:lnSpc>
+              <a:spcAft>
+                <a:spcPts val="900"/>
+              </a:spcAft>
+            </a:pPr>
+            <a:r>
+              <a:rPr sz="1800" b="1">
+                <a:solidFill>
+                  <a:srgbClr val="E0A437"/>
+                </a:solidFill>
+                <a:latin typeface="Fira Sans"/>
+              </a:rPr>
+              <a:t>▸ </a:t>
+            </a:r>
+            <a:r>
+              <a:rPr sz="1800" b="1">
+                <a:solidFill>
+                  <a:srgbClr val="1D3557"/>
+                </a:solidFill>
+                <a:latin typeface="Fira Sans"/>
+              </a:rPr>
+              <a:t>Todo lo de hoy es exactamente lo que el primer EDA del proyecto debe mostrar (entrega: lunes 15).</a:t>
+            </a:r>
+          </a:p>
+        </p:txBody>
+      </p:sp>
+    </p:spTree>
+  </p:cSld>
+  <p:clrMapOvr>
+    <a:masterClrMapping/>
+  </p:clrMapOvr>
+</p:sld>
+</file>
+
+<file path=ppt/slides/slide34.xml><?xml version="1.0" encoding="utf-8"?>
+<p:sld xmlns:a="http://schemas.openxmlformats.org/drawingml/2006/main" xmlns:p="http://schemas.openxmlformats.org/presentationml/2006/main" xmlns:r="http://schemas.openxmlformats.org/officeDocument/2006/relationships">
+  <p:cSld>
+    <p:spTree>
+      <p:nvGrpSpPr>
+        <p:cNvPr id="1" name=""/>
+        <p:cNvGrpSpPr/>
+        <p:nvPr/>
+      </p:nvGrpSpPr>
+      <p:grpSpPr/>
+      <p:sp>
+        <p:nvSpPr>
+          <p:cNvPr id="2" name="Rectangle 1"/>
+          <p:cNvSpPr/>
+          <p:nvPr/>
+        </p:nvSpPr>
+        <p:spPr>
+          <a:xfrm>
+            <a:off x="0" y="0"/>
+            <a:ext cx="9144000" cy="5138928"/>
+          </a:xfrm>
+          <a:prstGeom prst="rect">
+            <a:avLst/>
+          </a:prstGeom>
+          <a:solidFill>
+            <a:srgbClr val="FAFBFC"/>
+          </a:solidFill>
+          <a:ln>
+            <a:noFill/>
+          </a:ln>
+          <a:effectLst/>
+        </p:spPr>
+        <p:style>
+          <a:lnRef idx="1">
+            <a:schemeClr val="accent1"/>
+          </a:lnRef>
+          <a:fillRef idx="3">
+            <a:schemeClr val="accent1"/>
+          </a:fillRef>
+          <a:effectRef idx="2">
+            <a:schemeClr val="accent1"/>
+          </a:effectRef>
+          <a:fontRef idx="minor">
+            <a:schemeClr val="lt1"/>
+          </a:fontRef>
+        </p:style>
+        <p:txBody>
+          <a:bodyPr rtlCol="0" anchor="ctr"/>
+          <a:lstStyle/>
+          <a:p>
+            <a:pPr algn="ctr"/>
+          </a:p>
+        </p:txBody>
+      </p:sp>
+      <p:sp>
+        <p:nvSpPr>
+          <p:cNvPr id="3" name="TextBox 2"/>
+          <p:cNvSpPr txBox="1"/>
+          <p:nvPr/>
+        </p:nvSpPr>
+        <p:spPr>
+          <a:xfrm>
+            <a:off x="402336" y="301752"/>
+            <a:ext cx="8348472" cy="795528"/>
+          </a:xfrm>
+          <a:prstGeom prst="rect">
+            <a:avLst/>
+          </a:prstGeom>
+          <a:noFill/>
+        </p:spPr>
+        <p:txBody>
+          <a:bodyPr wrap="square">
+            <a:spAutoFit/>
+          </a:bodyPr>
+          <a:lstStyle/>
+          <a:p>
+            <a:r>
+              <a:rPr sz="2800" b="1">
+                <a:solidFill>
+                  <a:srgbClr val="0F0F0F"/>
+                </a:solidFill>
+                <a:latin typeface="Fira Sans"/>
+              </a:rPr>
+              <a:t>Próxima clase</a:t>
+            </a:r>
+          </a:p>
+        </p:txBody>
+      </p:sp>
+      <p:sp>
+        <p:nvSpPr>
+          <p:cNvPr id="4" name="TextBox 3"/>
+          <p:cNvSpPr txBox="1"/>
+          <p:nvPr/>
+        </p:nvSpPr>
+        <p:spPr>
+          <a:xfrm>
+            <a:off x="704088" y="1353312"/>
+            <a:ext cx="7744968" cy="3300984"/>
+          </a:xfrm>
+          <a:prstGeom prst="rect">
+            <a:avLst/>
+          </a:prstGeom>
+          <a:noFill/>
+        </p:spPr>
+        <p:txBody>
+          <a:bodyPr wrap="square">
+            <a:spAutoFit/>
+          </a:bodyPr>
+          <a:lstStyle/>
+          <a:p>
+            <a:pPr>
+              <a:lnSpc>
+                <a:spcPct val="112000"/>
+              </a:lnSpc>
+              <a:spcAft>
+                <a:spcPts val="900"/>
+              </a:spcAft>
+            </a:pPr>
+            <a:r>
+              <a:rPr sz="1800" b="1">
+                <a:solidFill>
+                  <a:srgbClr val="E0A437"/>
+                </a:solidFill>
+                <a:latin typeface="Fira Sans"/>
+              </a:rPr>
+              <a:t>▸ </a:t>
+            </a:r>
+            <a:r>
+              <a:rPr sz="1800" b="1">
+                <a:solidFill>
+                  <a:srgbClr val="1D3557"/>
+                </a:solidFill>
+                <a:latin typeface="Fira Sans"/>
+              </a:rPr>
+              <a:t>Jueves 3 de septiembre: presentaciones breves de las ideas de proyecto (5 minutos por equipo, sin nota).</a:t>
+            </a:r>
+          </a:p>
+          <a:p>
+            <a:pPr>
+              <a:lnSpc>
+                <a:spcPct val="112000"/>
+              </a:lnSpc>
+              <a:spcAft>
+                <a:spcPts val="900"/>
+              </a:spcAft>
+            </a:pPr>
+            <a:r>
+              <a:rPr sz="1800" b="1">
+                <a:solidFill>
+                  <a:srgbClr val="E0A437"/>
+                </a:solidFill>
+                <a:latin typeface="Fira Sans"/>
+              </a:rPr>
+              <a:t>▸ </a:t>
+            </a:r>
+            <a:r>
+              <a:rPr sz="1800" b="0">
+                <a:solidFill>
+                  <a:srgbClr val="000000"/>
+                </a:solidFill>
+                <a:latin typeface="Fira Sans"/>
+              </a:rPr>
+              <a:t>Después: fundamentos de probabilidad, la base para la inferencia de las clases siguientes.</a:t>
+            </a:r>
+          </a:p>
+          <a:p>
+            <a:pPr>
+              <a:lnSpc>
+                <a:spcPct val="112000"/>
+              </a:lnSpc>
+              <a:spcAft>
+                <a:spcPts val="900"/>
+              </a:spcAft>
+            </a:pPr>
+            <a:r>
+              <a:rPr sz="1800" b="1">
+                <a:solidFill>
+                  <a:srgbClr val="E0A437"/>
+                </a:solidFill>
+                <a:latin typeface="Fira Sans"/>
+              </a:rPr>
+              <a:t>▸ </a:t>
+            </a:r>
+            <a:r>
+              <a:rPr sz="1800" b="0">
+                <a:solidFill>
+                  <a:srgbClr val="000000"/>
+                </a:solidFill>
+                <a:latin typeface="Fira Sans"/>
+              </a:rPr>
+              <a:t>Se publica la rúbrica del primer análisis exploratorio.</a:t>
+            </a:r>
+          </a:p>
+          <a:p>
+            <a:pPr>
+              <a:lnSpc>
+                <a:spcPct val="112000"/>
+              </a:lnSpc>
+              <a:spcAft>
+                <a:spcPts val="900"/>
+              </a:spcAft>
+            </a:pPr>
+            <a:r>
+              <a:rPr sz="1800" b="1">
+                <a:solidFill>
+                  <a:srgbClr val="E0A437"/>
+                </a:solidFill>
+                <a:latin typeface="Fira Sans"/>
+              </a:rPr>
+              <a:t>▸ </a:t>
+            </a:r>
+            <a:r>
+              <a:rPr sz="1800" b="0">
+                <a:solidFill>
+                  <a:srgbClr val="000000"/>
+                </a:solidFill>
+                <a:latin typeface="Fira Sans"/>
+              </a:rPr>
+              <a:t>Recuerden: la formulación se entrega el lunes 7 por el aula virtual.</a:t>
+            </a:r>
+          </a:p>
+        </p:txBody>
+      </p:sp>
+    </p:spTree>
+  </p:cSld>
+  <p:clrMapOvr>
+    <a:masterClrMapping/>
+  </p:clrMapOvr>
+</p:sld>
+</file>
+
+<file path=ppt/slides/slide35.xml><?xml version="1.0" encoding="utf-8"?>
+<p:sld xmlns:a="http://schemas.openxmlformats.org/drawingml/2006/main" xmlns:p="http://schemas.openxmlformats.org/presentationml/2006/main" xmlns:r="http://schemas.openxmlformats.org/officeDocument/2006/relationships">
+  <p:cSld>
+    <p:spTree>
+      <p:nvGrpSpPr>
+        <p:cNvPr id="1" name=""/>
+        <p:cNvGrpSpPr/>
+        <p:nvPr/>
+      </p:nvGrpSpPr>
+      <p:grpSpPr/>
+      <p:sp>
+        <p:nvSpPr>
+          <p:cNvPr id="2" name="Rectangle 1"/>
+          <p:cNvSpPr/>
+          <p:nvPr/>
+        </p:nvSpPr>
+        <p:spPr>
+          <a:xfrm>
+            <a:off x="0" y="0"/>
+            <a:ext cx="9144000" cy="5138928"/>
+          </a:xfrm>
+          <a:prstGeom prst="rect">
+            <a:avLst/>
+          </a:prstGeom>
+          <a:solidFill>
+            <a:srgbClr val="FAFBFC"/>
+          </a:solidFill>
+          <a:ln>
+            <a:noFill/>
+          </a:ln>
+          <a:effectLst/>
+        </p:spPr>
+        <p:style>
+          <a:lnRef idx="1">
+            <a:schemeClr val="accent1"/>
+          </a:lnRef>
+          <a:fillRef idx="3">
+            <a:schemeClr val="accent1"/>
+          </a:fillRef>
+          <a:effectRef idx="2">
+            <a:schemeClr val="accent1"/>
+          </a:effectRef>
+          <a:fontRef idx="minor">
+            <a:schemeClr val="lt1"/>
+          </a:fontRef>
+        </p:style>
+        <p:txBody>
+          <a:bodyPr rtlCol="0" anchor="ctr"/>
+          <a:lstStyle/>
+          <a:p>
+            <a:pPr algn="ctr"/>
+          </a:p>
+        </p:txBody>
+      </p:sp>
+      <p:sp>
+        <p:nvSpPr>
+          <p:cNvPr id="3" name="TextBox 2"/>
+          <p:cNvSpPr txBox="1"/>
+          <p:nvPr/>
+        </p:nvSpPr>
+        <p:spPr>
+          <a:xfrm>
+            <a:off x="402336" y="301752"/>
+            <a:ext cx="8348472" cy="795528"/>
+          </a:xfrm>
+          <a:prstGeom prst="rect">
+            <a:avLst/>
+          </a:prstGeom>
+          <a:noFill/>
+        </p:spPr>
+        <p:txBody>
+          <a:bodyPr wrap="square">
+            <a:spAutoFit/>
+          </a:bodyPr>
+          <a:lstStyle/>
+          <a:p>
+            <a:r>
+              <a:rPr sz="2800" b="1">
+                <a:solidFill>
+                  <a:srgbClr val="0F0F0F"/>
+                </a:solidFill>
+                <a:latin typeface="Fira Sans"/>
+              </a:rPr>
               <a:t>Referencias</a:t>
             </a:r>
           </a:p>
@@ -8989,14 +9223,14 @@
                 </a:solidFill>
                 <a:latin typeface="Fira Sans"/>
               </a:rPr>
-              <a:t>La escala de r</a:t>
+              <a:t>La fórmula, dibujada</a:t>
             </a:r>
           </a:p>
         </p:txBody>
       </p:sp>
       <p:pic>
         <p:nvPicPr>
-          <p:cNvPr id="4" name="Picture 3" descr="c3_04_escala_r.png"/>
+          <p:cNvPr id="4" name="Picture 3" descr="c3_11_cuadrantes_pearson.png"/>
           <p:cNvPicPr>
             <a:picLocks noChangeAspect="1"/>
           </p:cNvPicPr>
@@ -9010,8 +9244,8 @@
         </p:blipFill>
         <p:spPr>
           <a:xfrm>
-            <a:off x="1417319" y="1143000"/>
-            <a:ext cx="6309360" cy="1572703"/>
+            <a:off x="2253945" y="1143000"/>
+            <a:ext cx="4636108" cy="3154680"/>
           </a:xfrm>
           <a:prstGeom prst="rect">
             <a:avLst/>
@@ -9047,7 +9281,7 @@
                 </a:solidFill>
                 <a:latin typeface="Fira Sans"/>
               </a:rPr>
-              <a:t>r = 1 y r = −1 son rectas perfectas; r = 0, ausencia de relación lineal. En datos reales, los valores intermedios son la norma.</a:t>
+              <a:t>Las medias parten el plano en cuatro cuadrantes: los puntos de los cuadrantes verdes empujan r hacia arriba y los de los rojos, hacia abajo. En iris casi todos los aportes son positivos: r = 0,96.</a:t>
             </a:r>
           </a:p>
         </p:txBody>

</xml_diff>

<commit_message>
Clase 3: ingreso vs duracion por comuna como relacion central, tabla de rangos de Spearman, distancia relegada a demo de overplotting
Co-Authored-By: Claude Fable 5 <noreply@anthropic.com>
</commit_message>
<xml_diff>
--- a/presentaciones/clase03_eda_bivariado.pptx
+++ b/presentaciones/clase03_eda_bivariado.pptx
@@ -40,6 +40,8 @@
     <p:sldId id="288" r:id="rId39"/>
     <p:sldId id="289" r:id="rId40"/>
     <p:sldId id="290" r:id="rId41"/>
+    <p:sldId id="291" r:id="rId42"/>
+    <p:sldId id="292" r:id="rId43"/>
   </p:sldIdLst>
   <p:sldSz cx="9144000" cy="5138928" type="screen4x3"/>
   <p:notesSz cx="6858000" cy="9144000"/>
@@ -4323,14 +4325,14 @@
                 </a:solidFill>
                 <a:latin typeface="Fira Sans"/>
               </a:rPr>
-              <a:t>Spearman: la correlación de los rangos</a:t>
+              <a:t>Cómo se calculan los rangos</a:t>
             </a:r>
           </a:p>
         </p:txBody>
       </p:sp>
       <p:pic>
         <p:nvPicPr>
-          <p:cNvPr id="4" name="Picture 3" descr="c3_12_spearman_rangos.png"/>
+          <p:cNvPr id="4" name="Picture 3" descr="c3_19_rangos_tabla.png"/>
           <p:cNvPicPr>
             <a:picLocks noChangeAspect="1"/>
           </p:cNvPicPr>
@@ -4344,8 +4346,8 @@
         </p:blipFill>
         <p:spPr>
           <a:xfrm>
-            <a:off x="1417319" y="1143000"/>
-            <a:ext cx="6309360" cy="2733680"/>
+            <a:off x="1742461" y="1143000"/>
+            <a:ext cx="5659076" cy="3154680"/>
           </a:xfrm>
           <a:prstGeom prst="rect">
             <a:avLst/>
@@ -4381,7 +4383,7 @@
                 </a:solidFill>
                 <a:latin typeface="Fira Sans"/>
               </a:rPr>
-              <a:t>Reemplazar cada valor por su posición en el orden endereza las curvas monótonas y desarma los atípicos. En Pandas: corr(method="spearman"). En la EOD, distancia y duración dan 0,54 con Pearson y 0,70 con Spearman: la diferencia delata curvatura y atípicos.</a:t>
+              <a:t>Cada variable se ordena por separado y cada valor recibe su posición; d compara las posiciones de una misma comuna. Con la fórmula de los rangos, cinco comunas bastan para calcular un Spearman a mano.</a:t>
             </a:r>
           </a:p>
         </p:txBody>
@@ -4477,14 +4479,14 @@
                 </a:solidFill>
                 <a:latin typeface="Fira Sans"/>
               </a:rPr>
-              <a:t>Correlación no es causalidad</a:t>
+              <a:t>Spearman: la correlación de los rangos</a:t>
             </a:r>
           </a:p>
         </p:txBody>
       </p:sp>
       <p:pic>
         <p:nvPicPr>
-          <p:cNvPr id="4" name="Picture 3" descr="c3_13_causalidad.png"/>
+          <p:cNvPr id="4" name="Picture 3" descr="c3_12_spearman_rangos.png"/>
           <p:cNvPicPr>
             <a:picLocks noChangeAspect="1"/>
           </p:cNvPicPr>
@@ -4499,7 +4501,7 @@
         <p:spPr>
           <a:xfrm>
             <a:off x="1417319" y="1143000"/>
-            <a:ext cx="6309360" cy="2884949"/>
+            <a:ext cx="6309360" cy="2733680"/>
           </a:xfrm>
           <a:prstGeom prst="rect">
             <a:avLst/>
@@ -4535,7 +4537,7 @@
                 </a:solidFill>
                 <a:latin typeface="Fira Sans"/>
               </a:rPr>
-              <a:t>Que dos variables se muevan juntas no dice que una cause a la otra: puede haber una tercera moviendo a ambas. Con datos observacionales reportamos asociación (recuerden las preguntas reparadas de la clase 2).</a:t>
+              <a:t>Reemplazar cada valor por su posición en el orden endereza las curvas monótonas y desarma los atípicos. En Pandas: corr(method="spearman"). En la EOD, distancia y duración dan 0,54 con Pearson y 0,70 con Spearman: la diferencia delata curvatura y atípicos.</a:t>
             </a:r>
           </a:p>
         </p:txBody>
@@ -4573,7 +4575,7 @@
             <a:avLst/>
           </a:prstGeom>
           <a:solidFill>
-            <a:srgbClr val="1D3557"/>
+            <a:srgbClr val="FAFBFC"/>
           </a:solidFill>
           <a:ln>
             <a:noFill/>
@@ -4610,8 +4612,8 @@
         </p:nvSpPr>
         <p:spPr>
           <a:xfrm>
-            <a:off x="603504" y="1847088"/>
-            <a:ext cx="7946136" cy="1399032"/>
+            <a:off x="402336" y="301752"/>
+            <a:ext cx="8348472" cy="795528"/>
           </a:xfrm>
           <a:prstGeom prst="rect">
             <a:avLst/>
@@ -4625,24 +4627,71 @@
           <a:lstStyle/>
           <a:p>
             <a:r>
-              <a:rPr sz="3400" b="1">
-                <a:solidFill>
-                  <a:srgbClr val="FFFFFF"/>
-                </a:solidFill>
-                <a:latin typeface="Fira Sans"/>
-              </a:rPr>
-              <a:t>Recreo</a:t>
-            </a:r>
-          </a:p>
-          <a:p>
-            <a:r>
-              <a:rPr sz="1800" b="0">
-                <a:solidFill>
-                  <a:srgbClr val="E0A437"/>
-                </a:solidFill>
-                <a:latin typeface="Fira Sans"/>
-              </a:rPr>
-              <a:t>10 minutos</a:t>
+              <a:rPr sz="2800" b="1">
+                <a:solidFill>
+                  <a:srgbClr val="0F0F0F"/>
+                </a:solidFill>
+                <a:latin typeface="Fira Sans"/>
+              </a:rPr>
+              <a:t>Correlación no es causalidad</a:t>
+            </a:r>
+          </a:p>
+        </p:txBody>
+      </p:sp>
+      <p:pic>
+        <p:nvPicPr>
+          <p:cNvPr id="4" name="Picture 3" descr="c3_13_causalidad.png"/>
+          <p:cNvPicPr>
+            <a:picLocks noChangeAspect="1"/>
+          </p:cNvPicPr>
+          <p:nvPr/>
+        </p:nvPicPr>
+        <p:blipFill>
+          <a:blip r:embed="rId2"/>
+          <a:stretch>
+            <a:fillRect/>
+          </a:stretch>
+        </p:blipFill>
+        <p:spPr>
+          <a:xfrm>
+            <a:off x="1417319" y="1143000"/>
+            <a:ext cx="6309360" cy="2884949"/>
+          </a:xfrm>
+          <a:prstGeom prst="rect">
+            <a:avLst/>
+          </a:prstGeom>
+        </p:spPr>
+      </p:pic>
+      <p:sp>
+        <p:nvSpPr>
+          <p:cNvPr id="5" name="TextBox 4"/>
+          <p:cNvSpPr txBox="1"/>
+          <p:nvPr/>
+        </p:nvSpPr>
+        <p:spPr>
+          <a:xfrm>
+            <a:off x="704088" y="4434840"/>
+            <a:ext cx="7744968" cy="457200"/>
+          </a:xfrm>
+          <a:prstGeom prst="rect">
+            <a:avLst/>
+          </a:prstGeom>
+          <a:noFill/>
+        </p:spPr>
+        <p:txBody>
+          <a:bodyPr wrap="square">
+            <a:spAutoFit/>
+          </a:bodyPr>
+          <a:lstStyle/>
+          <a:p>
+            <a:r>
+              <a:rPr sz="1300" b="0">
+                <a:solidFill>
+                  <a:srgbClr val="333333"/>
+                </a:solidFill>
+                <a:latin typeface="Fira Sans"/>
+              </a:rPr>
+              <a:t>Que dos variables se muevan juntas no dice que una cause a la otra: puede haber una tercera moviendo a ambas. Con datos observacionales reportamos asociación (recuerden las preguntas reparadas de la clase 2).</a:t>
             </a:r>
           </a:p>
         </p:txBody>
@@ -4738,7 +4787,7 @@
                 </a:solidFill>
                 <a:latin typeface="Fira Sans"/>
               </a:rPr>
-              <a:t>La EOD: distancia y duración</a:t>
+              <a:t>Recreo</a:t>
             </a:r>
           </a:p>
           <a:p>
@@ -4749,7 +4798,7 @@
                 </a:solidFill>
                 <a:latin typeface="Fira Sans"/>
               </a:rPr>
-              <a:t>Calcular una variable nueva y cruzarla</a:t>
+              <a:t>10 minutos</a:t>
             </a:r>
           </a:p>
         </p:txBody>
@@ -4787,7 +4836,7 @@
             <a:avLst/>
           </a:prstGeom>
           <a:solidFill>
-            <a:srgbClr val="FAFBFC"/>
+            <a:srgbClr val="1D3557"/>
           </a:solidFill>
           <a:ln>
             <a:noFill/>
@@ -4824,8 +4873,8 @@
         </p:nvSpPr>
         <p:spPr>
           <a:xfrm>
-            <a:off x="402336" y="301752"/>
-            <a:ext cx="8348472" cy="795528"/>
+            <a:off x="603504" y="1847088"/>
+            <a:ext cx="7946136" cy="1399032"/>
           </a:xfrm>
           <a:prstGeom prst="rect">
             <a:avLst/>
@@ -4839,167 +4888,24 @@
           <a:lstStyle/>
           <a:p>
             <a:r>
-              <a:rPr sz="2800" b="1">
-                <a:solidFill>
-                  <a:srgbClr val="0F0F0F"/>
-                </a:solidFill>
-                <a:latin typeface="Fira Sans"/>
-              </a:rPr>
-              <a:t>La distancia de cada viaje</a:t>
-            </a:r>
-          </a:p>
-        </p:txBody>
-      </p:sp>
-      <p:sp>
-        <p:nvSpPr>
-          <p:cNvPr id="4" name="Rectangle 3"/>
-          <p:cNvSpPr/>
-          <p:nvPr/>
-        </p:nvSpPr>
-        <p:spPr>
-          <a:xfrm>
-            <a:off x="704088" y="1280160"/>
-            <a:ext cx="7744968" cy="2880360"/>
-          </a:xfrm>
-          <a:prstGeom prst="rect">
-            <a:avLst/>
-          </a:prstGeom>
-          <a:solidFill>
-            <a:srgbClr val="F0F2F5"/>
-          </a:solidFill>
-          <a:ln>
-            <a:solidFill>
-              <a:srgbClr val="D8DDE3"/>
-            </a:solidFill>
-          </a:ln>
-          <a:effectLst/>
-        </p:spPr>
-        <p:style>
-          <a:lnRef idx="1">
-            <a:schemeClr val="accent1"/>
-          </a:lnRef>
-          <a:fillRef idx="3">
-            <a:schemeClr val="accent1"/>
-          </a:fillRef>
-          <a:effectRef idx="2">
-            <a:schemeClr val="accent1"/>
-          </a:effectRef>
-          <a:fontRef idx="minor">
-            <a:schemeClr val="lt1"/>
-          </a:fontRef>
-        </p:style>
-        <p:txBody>
-          <a:bodyPr rtlCol="0" anchor="ctr" wrap="square" lIns="228600" tIns="137160"/>
-          <a:lstStyle/>
-          <a:p>
-            <a:pPr/>
-            <a:r>
-              <a:rPr sz="1500" b="0">
-                <a:solidFill>
-                  <a:srgbClr val="1D3557"/>
-                </a:solidFill>
-                <a:latin typeface="Menlo"/>
-              </a:rPr>
-              <a:t>dx = viajes["DestinoCoordX"] - viajes["OrigenCoordX"]</a:t>
-            </a:r>
-          </a:p>
-          <a:p>
-            <a:pPr/>
-            <a:r>
-              <a:rPr sz="1500" b="0">
-                <a:solidFill>
-                  <a:srgbClr val="1D3557"/>
-                </a:solidFill>
-                <a:latin typeface="Menlo"/>
-              </a:rPr>
-              <a:t>dy = viajes["DestinoCoordY"] - viajes["OrigenCoordY"]</a:t>
-            </a:r>
-          </a:p>
-          <a:p>
-            <a:pPr/>
-            <a:r>
-              <a:rPr sz="1500" b="0">
-                <a:solidFill>
-                  <a:srgbClr val="1D3557"/>
-                </a:solidFill>
-                <a:latin typeface="Menlo"/>
-              </a:rPr>
-              <a:t/>
-            </a:r>
-          </a:p>
-          <a:p>
-            <a:pPr/>
-            <a:r>
-              <a:rPr sz="1500" b="0">
-                <a:solidFill>
-                  <a:srgbClr val="1D3557"/>
-                </a:solidFill>
-                <a:latin typeface="Menlo"/>
-              </a:rPr>
-              <a:t># Pitágoras, vectorizado: 90 mil distancias de una vez</a:t>
-            </a:r>
-          </a:p>
-          <a:p>
-            <a:pPr/>
-            <a:r>
-              <a:rPr sz="1500" b="0">
-                <a:solidFill>
-                  <a:srgbClr val="1D3557"/>
-                </a:solidFill>
-                <a:latin typeface="Menlo"/>
-              </a:rPr>
-              <a:t>viajes["DistKm"] = np.sqrt(dx**2 + dy**2) / 1000</a:t>
-            </a:r>
-          </a:p>
-        </p:txBody>
-      </p:sp>
-      <p:sp>
-        <p:nvSpPr>
-          <p:cNvPr id="5" name="TextBox 4"/>
-          <p:cNvSpPr txBox="1"/>
-          <p:nvPr/>
-        </p:nvSpPr>
-        <p:spPr>
-          <a:xfrm>
-            <a:off x="704088" y="4389120"/>
-            <a:ext cx="7744968" cy="1097280"/>
-          </a:xfrm>
-          <a:prstGeom prst="rect">
-            <a:avLst/>
-          </a:prstGeom>
-          <a:noFill/>
-        </p:spPr>
-        <p:txBody>
-          <a:bodyPr wrap="square">
-            <a:spAutoFit/>
-          </a:bodyPr>
-          <a:lstStyle/>
-          <a:p>
-            <a:pPr>
-              <a:lnSpc>
-                <a:spcPct val="112000"/>
-              </a:lnSpc>
-              <a:spcAft>
-                <a:spcPts val="900"/>
-              </a:spcAft>
-            </a:pPr>
-            <a:r>
-              <a:rPr sz="1600" b="1">
+              <a:rPr sz="3400" b="1">
+                <a:solidFill>
+                  <a:srgbClr val="FFFFFF"/>
+                </a:solidFill>
+                <a:latin typeface="Fira Sans"/>
+              </a:rPr>
+              <a:t>La EOD: ingreso y duración</a:t>
+            </a:r>
+          </a:p>
+          <a:p>
+            <a:r>
+              <a:rPr sz="1800" b="0">
                 <a:solidFill>
                   <a:srgbClr val="E0A437"/>
                 </a:solidFill>
                 <a:latin typeface="Fira Sans"/>
               </a:rPr>
-              <a:t>▸ </a:t>
-            </a:r>
-            <a:r>
-              <a:rPr sz="1600" b="0">
-                <a:solidFill>
-                  <a:srgbClr val="000000"/>
-                </a:solidFill>
-                <a:latin typeface="Fira Sans"/>
-              </a:rPr>
-              <a:t>Distancia en línea recta entre origen y destino (las coordenadas vienen en metros). Antes hay que filtrar 4.122 filas con coordenada 0: faltantes disfrazados, como los códigos 999 de la clase 2.</a:t>
+              <a:t>¿Los que menos ganan viajan más tiempo?</a:t>
             </a:r>
           </a:p>
         </p:txBody>
@@ -5382,35 +5288,114 @@
                 </a:solidFill>
                 <a:latin typeface="Fira Sans"/>
               </a:rPr>
-              <a:t>Graficar 90 mil puntos: overplotting</a:t>
-            </a:r>
-          </a:p>
-        </p:txBody>
-      </p:sp>
-      <p:pic>
-        <p:nvPicPr>
-          <p:cNvPr id="4" name="Picture 3" descr="c3_08_overplotting.png"/>
-          <p:cNvPicPr>
-            <a:picLocks noChangeAspect="1"/>
-          </p:cNvPicPr>
-          <p:nvPr/>
-        </p:nvPicPr>
-        <p:blipFill>
-          <a:blip r:embed="rId2"/>
-          <a:stretch>
-            <a:fillRect/>
-          </a:stretch>
-        </p:blipFill>
-        <p:spPr>
-          <a:xfrm>
-            <a:off x="1417319" y="1143000"/>
-            <a:ext cx="6309360" cy="1913950"/>
-          </a:xfrm>
-          <a:prstGeom prst="rect">
-            <a:avLst/>
-          </a:prstGeom>
-        </p:spPr>
-      </p:pic>
+              <a:t>La tabla por comuna</a:t>
+            </a:r>
+          </a:p>
+        </p:txBody>
+      </p:sp>
+      <p:sp>
+        <p:nvSpPr>
+          <p:cNvPr id="4" name="Rectangle 3"/>
+          <p:cNvSpPr/>
+          <p:nvPr/>
+        </p:nvSpPr>
+        <p:spPr>
+          <a:xfrm>
+            <a:off x="704088" y="1280160"/>
+            <a:ext cx="7744968" cy="2880360"/>
+          </a:xfrm>
+          <a:prstGeom prst="rect">
+            <a:avLst/>
+          </a:prstGeom>
+          <a:solidFill>
+            <a:srgbClr val="F0F2F5"/>
+          </a:solidFill>
+          <a:ln>
+            <a:solidFill>
+              <a:srgbClr val="D8DDE3"/>
+            </a:solidFill>
+          </a:ln>
+          <a:effectLst/>
+        </p:spPr>
+        <p:style>
+          <a:lnRef idx="1">
+            <a:schemeClr val="accent1"/>
+          </a:lnRef>
+          <a:fillRef idx="3">
+            <a:schemeClr val="accent1"/>
+          </a:fillRef>
+          <a:effectRef idx="2">
+            <a:schemeClr val="accent1"/>
+          </a:effectRef>
+          <a:fontRef idx="minor">
+            <a:schemeClr val="lt1"/>
+          </a:fontRef>
+        </p:style>
+        <p:txBody>
+          <a:bodyPr rtlCol="0" anchor="ctr" wrap="square" lIns="228600" tIns="137160"/>
+          <a:lstStyle/>
+          <a:p>
+            <a:pPr/>
+            <a:r>
+              <a:rPr sz="1500" b="0">
+                <a:solidFill>
+                  <a:srgbClr val="1D3557"/>
+                </a:solidFill>
+                <a:latin typeface="Menlo"/>
+              </a:rPr>
+              <a:t>v = viajes.merge(hogares[["Hogar", "Comuna", "IngresoHogar"]],</a:t>
+            </a:r>
+          </a:p>
+          <a:p>
+            <a:pPr/>
+            <a:r>
+              <a:rPr sz="1500" b="0">
+                <a:solidFill>
+                  <a:srgbClr val="1D3557"/>
+                </a:solidFill>
+                <a:latin typeface="Menlo"/>
+              </a:rPr>
+              <a:t>                on="Hogar")</a:t>
+            </a:r>
+          </a:p>
+          <a:p>
+            <a:pPr/>
+            <a:r>
+              <a:rPr sz="1500" b="0">
+                <a:solidFill>
+                  <a:srgbClr val="1D3557"/>
+                </a:solidFill>
+                <a:latin typeface="Menlo"/>
+              </a:rPr>
+              <a:t>por_comuna = v.groupby("Comuna").agg(</a:t>
+            </a:r>
+          </a:p>
+          <a:p>
+            <a:pPr/>
+            <a:r>
+              <a:rPr sz="1500" b="0">
+                <a:solidFill>
+                  <a:srgbClr val="1D3557"/>
+                </a:solidFill>
+                <a:latin typeface="Menlo"/>
+              </a:rPr>
+              <a:t>    ingreso=("IngresoHogar", "mean"),</a:t>
+            </a:r>
+          </a:p>
+          <a:p>
+            <a:pPr/>
+            <a:r>
+              <a:rPr sz="1500" b="0">
+                <a:solidFill>
+                  <a:srgbClr val="1D3557"/>
+                </a:solidFill>
+                <a:latin typeface="Menlo"/>
+              </a:rPr>
+              <a:t>    duracion=("TiempoViaje", "mean"))</a:t>
+            </a:r>
+          </a:p>
+        </p:txBody>
+      </p:sp>
       <p:sp>
         <p:nvSpPr>
           <p:cNvPr id="5" name="TextBox 4"/>
@@ -5419,8 +5404,8 @@
         </p:nvSpPr>
         <p:spPr>
           <a:xfrm>
-            <a:off x="704088" y="4434840"/>
-            <a:ext cx="7744968" cy="457200"/>
+            <a:off x="704088" y="4389120"/>
+            <a:ext cx="7744968" cy="1097280"/>
           </a:xfrm>
           <a:prstGeom prst="rect">
             <a:avLst/>
@@ -5433,14 +5418,31 @@
           </a:bodyPr>
           <a:lstStyle/>
           <a:p>
-            <a:r>
-              <a:rPr sz="1300" b="0">
-                <a:solidFill>
-                  <a:srgbClr val="333333"/>
-                </a:solidFill>
-                <a:latin typeface="Fira Sans"/>
-              </a:rPr>
-              <a:t>Con todos los puntos sólidos, el scatter se satura y miente. Los remedios: transparencia (alpha), muestreo, o hexbin, donde el color cuenta los viajes.</a:t>
+            <a:pPr>
+              <a:lnSpc>
+                <a:spcPct val="112000"/>
+              </a:lnSpc>
+              <a:spcAft>
+                <a:spcPts val="900"/>
+              </a:spcAft>
+            </a:pPr>
+            <a:r>
+              <a:rPr sz="1600" b="1">
+                <a:solidFill>
+                  <a:srgbClr val="E0A437"/>
+                </a:solidFill>
+                <a:latin typeface="Fira Sans"/>
+              </a:rPr>
+              <a:t>▸ </a:t>
+            </a:r>
+            <a:r>
+              <a:rPr sz="1600" b="0">
+                <a:solidFill>
+                  <a:srgbClr val="000000"/>
+                </a:solidFill>
+                <a:latin typeface="Fira Sans"/>
+              </a:rPr>
+              <a:t>Un merge y un groupby con dos resúmenes a la vez: 45 comunas, cada una con su ingreso medio y su duración media de viaje.</a:t>
             </a:r>
           </a:p>
         </p:txBody>
@@ -5478,7 +5480,7 @@
             <a:avLst/>
           </a:prstGeom>
           <a:solidFill>
-            <a:srgbClr val="1D3557"/>
+            <a:srgbClr val="FAFBFC"/>
           </a:solidFill>
           <a:ln>
             <a:noFill/>
@@ -5515,8 +5517,8 @@
         </p:nvSpPr>
         <p:spPr>
           <a:xfrm>
-            <a:off x="603504" y="1847088"/>
-            <a:ext cx="7946136" cy="1399032"/>
+            <a:off x="402336" y="301752"/>
+            <a:ext cx="8348472" cy="795528"/>
           </a:xfrm>
           <a:prstGeom prst="rect">
             <a:avLst/>
@@ -5530,24 +5532,71 @@
           <a:lstStyle/>
           <a:p>
             <a:r>
-              <a:rPr sz="3400" b="1">
-                <a:solidFill>
-                  <a:srgbClr val="FFFFFF"/>
-                </a:solidFill>
-                <a:latin typeface="Fira Sans"/>
-              </a:rPr>
-              <a:t>Grupos y tablas de contingencia</a:t>
-            </a:r>
-          </a:p>
-          <a:p>
-            <a:r>
-              <a:rPr sz="1800" b="0">
-                <a:solidFill>
-                  <a:srgbClr val="E0A437"/>
-                </a:solidFill>
-                <a:latin typeface="Fira Sans"/>
-              </a:rPr>
-              <a:t>Cuando una de las dos variables es categórica</a:t>
+              <a:rPr sz="2800" b="1">
+                <a:solidFill>
+                  <a:srgbClr val="0F0F0F"/>
+                </a:solidFill>
+                <a:latin typeface="Fira Sans"/>
+              </a:rPr>
+              <a:t>Ingreso y duración, por comuna</a:t>
+            </a:r>
+          </a:p>
+        </p:txBody>
+      </p:sp>
+      <p:pic>
+        <p:nvPicPr>
+          <p:cNvPr id="4" name="Picture 3" descr="c3_17_ingreso_duracion.png"/>
+          <p:cNvPicPr>
+            <a:picLocks noChangeAspect="1"/>
+          </p:cNvPicPr>
+          <p:nvPr/>
+        </p:nvPicPr>
+        <p:blipFill>
+          <a:blip r:embed="rId2"/>
+          <a:stretch>
+            <a:fillRect/>
+          </a:stretch>
+        </p:blipFill>
+        <p:spPr>
+          <a:xfrm>
+            <a:off x="2073847" y="1143000"/>
+            <a:ext cx="4996305" cy="3154680"/>
+          </a:xfrm>
+          <a:prstGeom prst="rect">
+            <a:avLst/>
+          </a:prstGeom>
+        </p:spPr>
+      </p:pic>
+      <p:sp>
+        <p:nvSpPr>
+          <p:cNvPr id="5" name="TextBox 4"/>
+          <p:cNvSpPr txBox="1"/>
+          <p:nvPr/>
+        </p:nvSpPr>
+        <p:spPr>
+          <a:xfrm>
+            <a:off x="704088" y="4434840"/>
+            <a:ext cx="7744968" cy="457200"/>
+          </a:xfrm>
+          <a:prstGeom prst="rect">
+            <a:avLst/>
+          </a:prstGeom>
+          <a:noFill/>
+        </p:spPr>
+        <p:txBody>
+          <a:bodyPr wrap="square">
+            <a:spAutoFit/>
+          </a:bodyPr>
+          <a:lstStyle/>
+          <a:p>
+            <a:r>
+              <a:rPr sz="1300" b="0">
+                <a:solidFill>
+                  <a:srgbClr val="333333"/>
+                </a:solidFill>
+                <a:latin typeface="Fira Sans"/>
+              </a:rPr>
+              <a:t>Cada punto es una comuna. La asociación es negativa (r = −0,37): las comunas de menor ingreso promedian viajes más largos. Vitacura, 28 minutos; Cerro Navia, 37.</a:t>
             </a:r>
           </a:p>
         </p:txBody>
@@ -5585,7 +5634,7 @@
             <a:avLst/>
           </a:prstGeom>
           <a:solidFill>
-            <a:srgbClr val="FAFBFC"/>
+            <a:srgbClr val="1D3557"/>
           </a:solidFill>
           <a:ln>
             <a:noFill/>
@@ -5622,8 +5671,8 @@
         </p:nvSpPr>
         <p:spPr>
           <a:xfrm>
-            <a:off x="402336" y="301752"/>
-            <a:ext cx="8348472" cy="795528"/>
+            <a:off x="603504" y="1847088"/>
+            <a:ext cx="7946136" cy="1399032"/>
           </a:xfrm>
           <a:prstGeom prst="rect">
             <a:avLst/>
@@ -5637,71 +5686,24 @@
           <a:lstStyle/>
           <a:p>
             <a:r>
-              <a:rPr sz="2800" b="1">
-                <a:solidFill>
-                  <a:srgbClr val="0F0F0F"/>
-                </a:solidFill>
-                <a:latin typeface="Fira Sans"/>
-              </a:rPr>
-              <a:t>groupby: partir, aplicar, juntar</a:t>
-            </a:r>
-          </a:p>
-        </p:txBody>
-      </p:sp>
-      <p:pic>
-        <p:nvPicPr>
-          <p:cNvPr id="4" name="Picture 3" descr="c3_14_groupby.png"/>
-          <p:cNvPicPr>
-            <a:picLocks noChangeAspect="1"/>
-          </p:cNvPicPr>
-          <p:nvPr/>
-        </p:nvPicPr>
-        <p:blipFill>
-          <a:blip r:embed="rId2"/>
-          <a:stretch>
-            <a:fillRect/>
-          </a:stretch>
-        </p:blipFill>
-        <p:spPr>
-          <a:xfrm>
-            <a:off x="1417319" y="1143000"/>
-            <a:ext cx="6309360" cy="2480026"/>
-          </a:xfrm>
-          <a:prstGeom prst="rect">
-            <a:avLst/>
-          </a:prstGeom>
-        </p:spPr>
-      </p:pic>
-      <p:sp>
-        <p:nvSpPr>
-          <p:cNvPr id="5" name="TextBox 4"/>
-          <p:cNvSpPr txBox="1"/>
-          <p:nvPr/>
-        </p:nvSpPr>
-        <p:spPr>
-          <a:xfrm>
-            <a:off x="704088" y="4434840"/>
-            <a:ext cx="7744968" cy="457200"/>
-          </a:xfrm>
-          <a:prstGeom prst="rect">
-            <a:avLst/>
-          </a:prstGeom>
-          <a:noFill/>
-        </p:spPr>
-        <p:txBody>
-          <a:bodyPr wrap="square">
-            <a:spAutoFit/>
-          </a:bodyPr>
-          <a:lstStyle/>
-          <a:p>
-            <a:r>
-              <a:rPr sz="1300" b="0">
-                <a:solidFill>
-                  <a:srgbClr val="333333"/>
-                </a:solidFill>
-                <a:latin typeface="Fira Sans"/>
-              </a:rPr>
-              <a:t>La versión numérica del boxplot por grupo: la tabla se parte por categoría, cada parte recibe el resumen y los resultados se juntan.</a:t>
+              <a:rPr sz="3400" b="1">
+                <a:solidFill>
+                  <a:srgbClr val="FFFFFF"/>
+                </a:solidFill>
+                <a:latin typeface="Fira Sans"/>
+              </a:rPr>
+              <a:t>Grupos y tablas de contingencia</a:t>
+            </a:r>
+          </a:p>
+          <a:p>
+            <a:r>
+              <a:rPr sz="1800" b="0">
+                <a:solidFill>
+                  <a:srgbClr val="E0A437"/>
+                </a:solidFill>
+                <a:latin typeface="Fira Sans"/>
+              </a:rPr>
+              <a:t>Cuando una de las dos variables es categórica</a:t>
             </a:r>
           </a:p>
         </p:txBody>
@@ -5797,102 +5799,35 @@
                 </a:solidFill>
                 <a:latin typeface="Fira Sans"/>
               </a:rPr>
-              <a:t>La media por grupo: groupby</a:t>
-            </a:r>
-          </a:p>
-        </p:txBody>
-      </p:sp>
-      <p:sp>
-        <p:nvSpPr>
-          <p:cNvPr id="4" name="Rectangle 3"/>
-          <p:cNvSpPr/>
-          <p:nvPr/>
-        </p:nvSpPr>
-        <p:spPr>
-          <a:xfrm>
-            <a:off x="704088" y="1280160"/>
-            <a:ext cx="7744968" cy="2377440"/>
-          </a:xfrm>
-          <a:prstGeom prst="rect">
-            <a:avLst/>
-          </a:prstGeom>
-          <a:solidFill>
-            <a:srgbClr val="F0F2F5"/>
-          </a:solidFill>
-          <a:ln>
-            <a:solidFill>
-              <a:srgbClr val="D8DDE3"/>
-            </a:solidFill>
-          </a:ln>
-          <a:effectLst/>
-        </p:spPr>
-        <p:style>
-          <a:lnRef idx="1">
-            <a:schemeClr val="accent1"/>
-          </a:lnRef>
-          <a:fillRef idx="3">
-            <a:schemeClr val="accent1"/>
-          </a:fillRef>
-          <a:effectRef idx="2">
-            <a:schemeClr val="accent1"/>
-          </a:effectRef>
-          <a:fontRef idx="minor">
-            <a:schemeClr val="lt1"/>
-          </a:fontRef>
-        </p:style>
-        <p:txBody>
-          <a:bodyPr rtlCol="0" anchor="ctr" wrap="square" lIns="228600" tIns="137160"/>
-          <a:lstStyle/>
-          <a:p>
-            <a:pPr/>
-            <a:r>
-              <a:rPr sz="1500" b="0">
-                <a:solidFill>
-                  <a:srgbClr val="1D3557"/>
-                </a:solidFill>
-                <a:latin typeface="Menlo"/>
-              </a:rPr>
-              <a:t>iris_df.groupby("species")["petal length (cm)"].mean()</a:t>
-            </a:r>
-          </a:p>
-          <a:p>
-            <a:pPr/>
-            <a:r>
-              <a:rPr sz="1500" b="0">
-                <a:solidFill>
-                  <a:srgbClr val="1D3557"/>
-                </a:solidFill>
-                <a:latin typeface="Menlo"/>
-              </a:rPr>
-              <a:t/>
-            </a:r>
-          </a:p>
-          <a:p>
-            <a:pPr/>
-            <a:r>
-              <a:rPr sz="1500" b="0">
-                <a:solidFill>
-                  <a:srgbClr val="1D3557"/>
-                </a:solidFill>
-                <a:latin typeface="Menlo"/>
-              </a:rPr>
-              <a:t># El mismo resumen que construimos a mano con loc y el for,</a:t>
-            </a:r>
-          </a:p>
-          <a:p>
-            <a:pPr/>
-            <a:r>
-              <a:rPr sz="1500" b="0">
-                <a:solidFill>
-                  <a:srgbClr val="1D3557"/>
-                </a:solidFill>
-                <a:latin typeface="Menlo"/>
-              </a:rPr>
-              <a:t># ahora en una línea</a:t>
-            </a:r>
-          </a:p>
-        </p:txBody>
-      </p:sp>
+              <a:t>groupby: partir, aplicar, juntar</a:t>
+            </a:r>
+          </a:p>
+        </p:txBody>
+      </p:sp>
+      <p:pic>
+        <p:nvPicPr>
+          <p:cNvPr id="4" name="Picture 3" descr="c3_14_groupby.png"/>
+          <p:cNvPicPr>
+            <a:picLocks noChangeAspect="1"/>
+          </p:cNvPicPr>
+          <p:nvPr/>
+        </p:nvPicPr>
+        <p:blipFill>
+          <a:blip r:embed="rId2"/>
+          <a:stretch>
+            <a:fillRect/>
+          </a:stretch>
+        </p:blipFill>
+        <p:spPr>
+          <a:xfrm>
+            <a:off x="1417319" y="1143000"/>
+            <a:ext cx="6309360" cy="2480026"/>
+          </a:xfrm>
+          <a:prstGeom prst="rect">
+            <a:avLst/>
+          </a:prstGeom>
+        </p:spPr>
+      </p:pic>
       <p:sp>
         <p:nvSpPr>
           <p:cNvPr id="5" name="TextBox 4"/>
@@ -5901,8 +5836,8 @@
         </p:nvSpPr>
         <p:spPr>
           <a:xfrm>
-            <a:off x="704088" y="3886200"/>
-            <a:ext cx="7744968" cy="1097280"/>
+            <a:off x="704088" y="4434840"/>
+            <a:ext cx="7744968" cy="457200"/>
           </a:xfrm>
           <a:prstGeom prst="rect">
             <a:avLst/>
@@ -5915,31 +5850,14 @@
           </a:bodyPr>
           <a:lstStyle/>
           <a:p>
-            <a:pPr>
-              <a:lnSpc>
-                <a:spcPct val="112000"/>
-              </a:lnSpc>
-              <a:spcAft>
-                <a:spcPts val="900"/>
-              </a:spcAft>
-            </a:pPr>
-            <a:r>
-              <a:rPr sz="1600" b="1">
-                <a:solidFill>
-                  <a:srgbClr val="E0A437"/>
-                </a:solidFill>
-                <a:latin typeface="Fira Sans"/>
-              </a:rPr>
-              <a:t>▸ </a:t>
-            </a:r>
-            <a:r>
-              <a:rPr sz="1600" b="0">
-                <a:solidFill>
-                  <a:srgbClr val="000000"/>
-                </a:solidFill>
-                <a:latin typeface="Fira Sans"/>
-              </a:rPr>
-              <a:t>groupby parte la tabla por categoría, aplica el resumen a cada parte y junta los resultados: 1,46 / 4,26 / 5,55 cm. Es la versión numérica del boxplot por grupo.</a:t>
+            <a:r>
+              <a:rPr sz="1300" b="0">
+                <a:solidFill>
+                  <a:srgbClr val="333333"/>
+                </a:solidFill>
+                <a:latin typeface="Fira Sans"/>
+              </a:rPr>
+              <a:t>La versión numérica del boxplot por grupo: la tabla se parte por categoría, cada parte recibe el resumen y los resultados se juntan.</a:t>
             </a:r>
           </a:p>
         </p:txBody>
@@ -6035,7 +5953,7 @@
                 </a:solidFill>
                 <a:latin typeface="Fira Sans"/>
               </a:rPr>
-              <a:t>Dos categóricas: la tabla de contingencia</a:t>
+              <a:t>La media por grupo: groupby</a:t>
             </a:r>
           </a:p>
         </p:txBody>
@@ -6049,7 +5967,7 @@
         <p:spPr>
           <a:xfrm>
             <a:off x="704088" y="1280160"/>
-            <a:ext cx="7744968" cy="2880360"/>
+            <a:ext cx="7744968" cy="2377440"/>
           </a:xfrm>
           <a:prstGeom prst="rect">
             <a:avLst/>
@@ -6090,7 +6008,7 @@
                 </a:solidFill>
                 <a:latin typeface="Menlo"/>
               </a:rPr>
-              <a:t>pd.crosstab(datos["Sexo"], datos["ModoAgrupado"],</a:t>
+              <a:t>iris_df.groupby("species")["petal length (cm)"].mean()</a:t>
             </a:r>
           </a:p>
           <a:p>
@@ -6102,7 +6020,7 @@
                 </a:solidFill>
                 <a:latin typeface="Menlo"/>
               </a:rPr>
-              <a:t>            normalize="index")</a:t>
+              <a:t/>
             </a:r>
           </a:p>
           <a:p>
@@ -6114,7 +6032,7 @@
                 </a:solidFill>
                 <a:latin typeface="Menlo"/>
               </a:rPr>
-              <a:t># Para la ciudad: sumar factores en vez de contar viajes</a:t>
+              <a:t># El mismo resumen que construimos a mano con loc y el for,</a:t>
             </a:r>
           </a:p>
           <a:p>
@@ -6126,19 +6044,7 @@
                 </a:solidFill>
                 <a:latin typeface="Menlo"/>
               </a:rPr>
-              <a:t>datos.pivot_table(values="Factor", index="Sexo",</a:t>
-            </a:r>
-          </a:p>
-          <a:p>
-            <a:pPr/>
-            <a:r>
-              <a:rPr sz="1500" b="0">
-                <a:solidFill>
-                  <a:srgbClr val="1D3557"/>
-                </a:solidFill>
-                <a:latin typeface="Menlo"/>
-              </a:rPr>
-              <a:t>                  columns="ModoAgrupado", aggfunc="sum")</a:t>
+              <a:t># ahora en una línea</a:t>
             </a:r>
           </a:p>
         </p:txBody>
@@ -6151,7 +6057,7 @@
         </p:nvSpPr>
         <p:spPr>
           <a:xfrm>
-            <a:off x="704088" y="4389120"/>
+            <a:off x="704088" y="3886200"/>
             <a:ext cx="7744968" cy="1097280"/>
           </a:xfrm>
           <a:prstGeom prst="rect">
@@ -6189,7 +6095,7 @@
                 </a:solidFill>
                 <a:latin typeface="Fira Sans"/>
               </a:rPr>
-              <a:t>Ponderado por factor, en día laboral: las mujeres caminan más (40% contra 27%) y los hombres usan más el auto (28% contra 19%).</a:t>
+              <a:t>groupby parte la tabla por categoría, aplica el resumen a cada parte y junta los resultados: 1,46 / 4,26 / 5,55 cm. Es la versión numérica del boxplot por grupo.</a:t>
             </a:r>
           </a:p>
         </p:txBody>
@@ -6227,7 +6133,7 @@
             <a:avLst/>
           </a:prstGeom>
           <a:solidFill>
-            <a:srgbClr val="1D3557"/>
+            <a:srgbClr val="FAFBFC"/>
           </a:solidFill>
           <a:ln>
             <a:noFill/>
@@ -6264,8 +6170,8 @@
         </p:nvSpPr>
         <p:spPr>
           <a:xfrm>
-            <a:off x="603504" y="1847088"/>
-            <a:ext cx="7946136" cy="1399032"/>
+            <a:off x="402336" y="301752"/>
+            <a:ext cx="8348472" cy="795528"/>
           </a:xfrm>
           <a:prstGeom prst="rect">
             <a:avLst/>
@@ -6279,24 +6185,167 @@
           <a:lstStyle/>
           <a:p>
             <a:r>
-              <a:rPr sz="3400" b="1">
-                <a:solidFill>
-                  <a:srgbClr val="FFFFFF"/>
-                </a:solidFill>
-                <a:latin typeface="Fira Sans"/>
-              </a:rPr>
-              <a:t>La primera regresión</a:t>
-            </a:r>
-          </a:p>
-          <a:p>
-            <a:r>
-              <a:rPr sz="1800" b="0">
+              <a:rPr sz="2800" b="1">
+                <a:solidFill>
+                  <a:srgbClr val="0F0F0F"/>
+                </a:solidFill>
+                <a:latin typeface="Fira Sans"/>
+              </a:rPr>
+              <a:t>Dos categóricas: la tabla de contingencia</a:t>
+            </a:r>
+          </a:p>
+        </p:txBody>
+      </p:sp>
+      <p:sp>
+        <p:nvSpPr>
+          <p:cNvPr id="4" name="Rectangle 3"/>
+          <p:cNvSpPr/>
+          <p:nvPr/>
+        </p:nvSpPr>
+        <p:spPr>
+          <a:xfrm>
+            <a:off x="704088" y="1280160"/>
+            <a:ext cx="7744968" cy="2880360"/>
+          </a:xfrm>
+          <a:prstGeom prst="rect">
+            <a:avLst/>
+          </a:prstGeom>
+          <a:solidFill>
+            <a:srgbClr val="F0F2F5"/>
+          </a:solidFill>
+          <a:ln>
+            <a:solidFill>
+              <a:srgbClr val="D8DDE3"/>
+            </a:solidFill>
+          </a:ln>
+          <a:effectLst/>
+        </p:spPr>
+        <p:style>
+          <a:lnRef idx="1">
+            <a:schemeClr val="accent1"/>
+          </a:lnRef>
+          <a:fillRef idx="3">
+            <a:schemeClr val="accent1"/>
+          </a:fillRef>
+          <a:effectRef idx="2">
+            <a:schemeClr val="accent1"/>
+          </a:effectRef>
+          <a:fontRef idx="minor">
+            <a:schemeClr val="lt1"/>
+          </a:fontRef>
+        </p:style>
+        <p:txBody>
+          <a:bodyPr rtlCol="0" anchor="ctr" wrap="square" lIns="228600" tIns="137160"/>
+          <a:lstStyle/>
+          <a:p>
+            <a:pPr/>
+            <a:r>
+              <a:rPr sz="1500" b="0">
+                <a:solidFill>
+                  <a:srgbClr val="1D3557"/>
+                </a:solidFill>
+                <a:latin typeface="Menlo"/>
+              </a:rPr>
+              <a:t>pd.crosstab(datos["Sexo"], datos["ModoAgrupado"],</a:t>
+            </a:r>
+          </a:p>
+          <a:p>
+            <a:pPr/>
+            <a:r>
+              <a:rPr sz="1500" b="0">
+                <a:solidFill>
+                  <a:srgbClr val="1D3557"/>
+                </a:solidFill>
+                <a:latin typeface="Menlo"/>
+              </a:rPr>
+              <a:t>            normalize="index")</a:t>
+            </a:r>
+          </a:p>
+          <a:p>
+            <a:pPr/>
+            <a:r>
+              <a:rPr sz="1500" b="0">
+                <a:solidFill>
+                  <a:srgbClr val="1D3557"/>
+                </a:solidFill>
+                <a:latin typeface="Menlo"/>
+              </a:rPr>
+              <a:t># Para la ciudad: sumar factores en vez de contar viajes</a:t>
+            </a:r>
+          </a:p>
+          <a:p>
+            <a:pPr/>
+            <a:r>
+              <a:rPr sz="1500" b="0">
+                <a:solidFill>
+                  <a:srgbClr val="1D3557"/>
+                </a:solidFill>
+                <a:latin typeface="Menlo"/>
+              </a:rPr>
+              <a:t>datos.pivot_table(values="Factor", index="Sexo",</a:t>
+            </a:r>
+          </a:p>
+          <a:p>
+            <a:pPr/>
+            <a:r>
+              <a:rPr sz="1500" b="0">
+                <a:solidFill>
+                  <a:srgbClr val="1D3557"/>
+                </a:solidFill>
+                <a:latin typeface="Menlo"/>
+              </a:rPr>
+              <a:t>                  columns="ModoAgrupado", aggfunc="sum")</a:t>
+            </a:r>
+          </a:p>
+        </p:txBody>
+      </p:sp>
+      <p:sp>
+        <p:nvSpPr>
+          <p:cNvPr id="5" name="TextBox 4"/>
+          <p:cNvSpPr txBox="1"/>
+          <p:nvPr/>
+        </p:nvSpPr>
+        <p:spPr>
+          <a:xfrm>
+            <a:off x="704088" y="4389120"/>
+            <a:ext cx="7744968" cy="1097280"/>
+          </a:xfrm>
+          <a:prstGeom prst="rect">
+            <a:avLst/>
+          </a:prstGeom>
+          <a:noFill/>
+        </p:spPr>
+        <p:txBody>
+          <a:bodyPr wrap="square">
+            <a:spAutoFit/>
+          </a:bodyPr>
+          <a:lstStyle/>
+          <a:p>
+            <a:pPr>
+              <a:lnSpc>
+                <a:spcPct val="112000"/>
+              </a:lnSpc>
+              <a:spcAft>
+                <a:spcPts val="900"/>
+              </a:spcAft>
+            </a:pPr>
+            <a:r>
+              <a:rPr sz="1600" b="1">
                 <a:solidFill>
                   <a:srgbClr val="E0A437"/>
                 </a:solidFill>
                 <a:latin typeface="Fira Sans"/>
               </a:rPr>
-              <a:t>La recta que resume la relación</a:t>
+              <a:t>▸ </a:t>
+            </a:r>
+            <a:r>
+              <a:rPr sz="1600" b="0">
+                <a:solidFill>
+                  <a:srgbClr val="000000"/>
+                </a:solidFill>
+                <a:latin typeface="Fira Sans"/>
+              </a:rPr>
+              <a:t>Ponderado por factor, en día laboral: las mujeres caminan más (40% contra 27%) y los hombres usan más el auto (28% contra 19%).</a:t>
             </a:r>
           </a:p>
         </p:txBody>
@@ -6334,7 +6383,7 @@
             <a:avLst/>
           </a:prstGeom>
           <a:solidFill>
-            <a:srgbClr val="FAFBFC"/>
+            <a:srgbClr val="1D3557"/>
           </a:solidFill>
           <a:ln>
             <a:noFill/>
@@ -6371,8 +6420,8 @@
         </p:nvSpPr>
         <p:spPr>
           <a:xfrm>
-            <a:off x="402336" y="301752"/>
-            <a:ext cx="8348472" cy="795528"/>
+            <a:off x="603504" y="1847088"/>
+            <a:ext cx="7946136" cy="1399032"/>
           </a:xfrm>
           <a:prstGeom prst="rect">
             <a:avLst/>
@@ -6386,71 +6435,24 @@
           <a:lstStyle/>
           <a:p>
             <a:r>
-              <a:rPr sz="2800" b="1">
-                <a:solidFill>
-                  <a:srgbClr val="0F0F0F"/>
-                </a:solidFill>
-                <a:latin typeface="Fira Sans"/>
-              </a:rPr>
-              <a:t>Mínimos cuadrados</a:t>
-            </a:r>
-          </a:p>
-        </p:txBody>
-      </p:sp>
-      <p:pic>
-        <p:nvPicPr>
-          <p:cNvPr id="4" name="Picture 3" descr="c3_15_residuos.png"/>
-          <p:cNvPicPr>
-            <a:picLocks noChangeAspect="1"/>
-          </p:cNvPicPr>
-          <p:nvPr/>
-        </p:nvPicPr>
-        <p:blipFill>
-          <a:blip r:embed="rId2"/>
-          <a:stretch>
-            <a:fillRect/>
-          </a:stretch>
-        </p:blipFill>
-        <p:spPr>
-          <a:xfrm>
-            <a:off x="1417319" y="1143000"/>
-            <a:ext cx="6309360" cy="2525498"/>
-          </a:xfrm>
-          <a:prstGeom prst="rect">
-            <a:avLst/>
-          </a:prstGeom>
-        </p:spPr>
-      </p:pic>
-      <p:sp>
-        <p:nvSpPr>
-          <p:cNvPr id="5" name="TextBox 4"/>
-          <p:cNvSpPr txBox="1"/>
-          <p:nvPr/>
-        </p:nvSpPr>
-        <p:spPr>
-          <a:xfrm>
-            <a:off x="704088" y="4434840"/>
-            <a:ext cx="7744968" cy="457200"/>
-          </a:xfrm>
-          <a:prstGeom prst="rect">
-            <a:avLst/>
-          </a:prstGeom>
-          <a:noFill/>
-        </p:spPr>
-        <p:txBody>
-          <a:bodyPr wrap="square">
-            <a:spAutoFit/>
-          </a:bodyPr>
-          <a:lstStyle/>
-          <a:p>
-            <a:r>
-              <a:rPr sz="1300" b="0">
-                <a:solidFill>
-                  <a:srgbClr val="333333"/>
-                </a:solidFill>
-                <a:latin typeface="Fira Sans"/>
-              </a:rPr>
-              <a:t>La correlación mide la asociación; la regresión la dibuja: la recta que deja la menor suma de errores al cuadrado. La pendiente dice cuánto cambia y por cada unidad de x. Hoy es un primer contacto; en las clases 6 y 7 la profundizamos.</a:t>
+              <a:rPr sz="3400" b="1">
+                <a:solidFill>
+                  <a:srgbClr val="FFFFFF"/>
+                </a:solidFill>
+                <a:latin typeface="Fira Sans"/>
+              </a:rPr>
+              <a:t>La primera regresión</a:t>
+            </a:r>
+          </a:p>
+          <a:p>
+            <a:r>
+              <a:rPr sz="1800" b="0">
+                <a:solidFill>
+                  <a:srgbClr val="E0A437"/>
+                </a:solidFill>
+                <a:latin typeface="Fira Sans"/>
+              </a:rPr>
+              <a:t>La recta que resume la relación</a:t>
             </a:r>
           </a:p>
         </p:txBody>
@@ -6546,14 +6548,14 @@
                 </a:solidFill>
                 <a:latin typeface="Fira Sans"/>
               </a:rPr>
-              <a:t>La recta en la EOD</a:t>
+              <a:t>Mínimos cuadrados</a:t>
             </a:r>
           </a:p>
         </p:txBody>
       </p:sp>
       <p:pic>
         <p:nvPicPr>
-          <p:cNvPr id="4" name="Picture 3" descr="c3_09_regresion_eod.png"/>
+          <p:cNvPr id="4" name="Picture 3" descr="c3_15_residuos.png"/>
           <p:cNvPicPr>
             <a:picLocks noChangeAspect="1"/>
           </p:cNvPicPr>
@@ -6567,8 +6569,8 @@
         </p:blipFill>
         <p:spPr>
           <a:xfrm>
-            <a:off x="2132444" y="1143000"/>
-            <a:ext cx="4879110" cy="3154679"/>
+            <a:off x="1417319" y="1143000"/>
+            <a:ext cx="6309360" cy="2525498"/>
           </a:xfrm>
           <a:prstGeom prst="rect">
             <a:avLst/>
@@ -6604,7 +6606,7 @@
                 </a:solidFill>
                 <a:latin typeface="Fira Sans"/>
               </a:rPr>
-              <a:t>tiempo = 25,4 + 2,5 · km: cada kilómetro agrega 2,5 minutos, y el viaje parte costando unos 25 (caminatas, esperas, transbordos). De regalo: r al cuadrado (0,54² = 0,29) es la fracción de la variación que la recta captura.</a:t>
+              <a:t>La correlación mide la asociación; la regresión la dibuja: la recta que deja la menor suma de errores al cuadrado. La pendiente dice cuánto cambia y por cada unidad de x. Hoy es un primer contacto; en las clases 6 y 7 la profundizamos.</a:t>
             </a:r>
           </a:p>
         </p:txBody>
@@ -6700,102 +6702,35 @@
                 </a:solidFill>
                 <a:latin typeface="Fira Sans"/>
               </a:rPr>
-              <a:t>La recta en NumPy</a:t>
-            </a:r>
-          </a:p>
-        </p:txBody>
-      </p:sp>
-      <p:sp>
-        <p:nvSpPr>
-          <p:cNvPr id="4" name="Rectangle 3"/>
-          <p:cNvSpPr/>
-          <p:nvPr/>
-        </p:nvSpPr>
-        <p:spPr>
-          <a:xfrm>
-            <a:off x="704088" y="1280160"/>
-            <a:ext cx="7744968" cy="2377440"/>
-          </a:xfrm>
-          <a:prstGeom prst="rect">
-            <a:avLst/>
-          </a:prstGeom>
-          <a:solidFill>
-            <a:srgbClr val="F0F2F5"/>
-          </a:solidFill>
-          <a:ln>
-            <a:solidFill>
-              <a:srgbClr val="D8DDE3"/>
-            </a:solidFill>
-          </a:ln>
-          <a:effectLst/>
-        </p:spPr>
-        <p:style>
-          <a:lnRef idx="1">
-            <a:schemeClr val="accent1"/>
-          </a:lnRef>
-          <a:fillRef idx="3">
-            <a:schemeClr val="accent1"/>
-          </a:fillRef>
-          <a:effectRef idx="2">
-            <a:schemeClr val="accent1"/>
-          </a:effectRef>
-          <a:fontRef idx="minor">
-            <a:schemeClr val="lt1"/>
-          </a:fontRef>
-        </p:style>
-        <p:txBody>
-          <a:bodyPr rtlCol="0" anchor="ctr" wrap="square" lIns="228600" tIns="137160"/>
-          <a:lstStyle/>
-          <a:p>
-            <a:pPr/>
-            <a:r>
-              <a:rPr sz="1500" b="0">
-                <a:solidFill>
-                  <a:srgbClr val="1D3557"/>
-                </a:solidFill>
-                <a:latin typeface="Menlo"/>
-              </a:rPr>
-              <a:t>pendiente, intercepto = np.polyfit(distancia, tiempo, 1)</a:t>
-            </a:r>
-          </a:p>
-          <a:p>
-            <a:pPr/>
-            <a:r>
-              <a:rPr sz="1500" b="0">
-                <a:solidFill>
-                  <a:srgbClr val="1D3557"/>
-                </a:solidFill>
-                <a:latin typeface="Menlo"/>
-              </a:rPr>
-              <a:t/>
-            </a:r>
-          </a:p>
-          <a:p>
-            <a:pPr/>
-            <a:r>
-              <a:rPr sz="1500" b="0">
-                <a:solidFill>
-                  <a:srgbClr val="1D3557"/>
-                </a:solidFill>
-                <a:latin typeface="Menlo"/>
-              </a:rPr>
-              <a:t># La recta evaluada, para dibujarla sobre el scatter</a:t>
-            </a:r>
-          </a:p>
-          <a:p>
-            <a:pPr/>
-            <a:r>
-              <a:rPr sz="1500" b="0">
-                <a:solidFill>
-                  <a:srgbClr val="1D3557"/>
-                </a:solidFill>
-                <a:latin typeface="Menlo"/>
-              </a:rPr>
-              <a:t>ax.plot(x, intercepto + pendiente * x)</a:t>
-            </a:r>
-          </a:p>
-        </p:txBody>
-      </p:sp>
+              <a:t>La recta: ingreso y duración</a:t>
+            </a:r>
+          </a:p>
+        </p:txBody>
+      </p:sp>
+      <p:pic>
+        <p:nvPicPr>
+          <p:cNvPr id="4" name="Picture 3" descr="c3_18_ingreso_duracion_recta.png"/>
+          <p:cNvPicPr>
+            <a:picLocks noChangeAspect="1"/>
+          </p:cNvPicPr>
+          <p:nvPr/>
+        </p:nvPicPr>
+        <p:blipFill>
+          <a:blip r:embed="rId2"/>
+          <a:stretch>
+            <a:fillRect/>
+          </a:stretch>
+        </p:blipFill>
+        <p:spPr>
+          <a:xfrm>
+            <a:off x="2120485" y="1143000"/>
+            <a:ext cx="4903028" cy="3154680"/>
+          </a:xfrm>
+          <a:prstGeom prst="rect">
+            <a:avLst/>
+          </a:prstGeom>
+        </p:spPr>
+      </p:pic>
       <p:sp>
         <p:nvSpPr>
           <p:cNvPr id="5" name="TextBox 4"/>
@@ -6804,8 +6739,8 @@
         </p:nvSpPr>
         <p:spPr>
           <a:xfrm>
-            <a:off x="704088" y="3886200"/>
-            <a:ext cx="7744968" cy="1097280"/>
+            <a:off x="704088" y="4434840"/>
+            <a:ext cx="7744968" cy="457200"/>
           </a:xfrm>
           <a:prstGeom prst="rect">
             <a:avLst/>
@@ -6818,31 +6753,14 @@
           </a:bodyPr>
           <a:lstStyle/>
           <a:p>
-            <a:pPr>
-              <a:lnSpc>
-                <a:spcPct val="112000"/>
-              </a:lnSpc>
-              <a:spcAft>
-                <a:spcPts val="900"/>
-              </a:spcAft>
-            </a:pPr>
-            <a:r>
-              <a:rPr sz="1600" b="1">
-                <a:solidFill>
-                  <a:srgbClr val="E0A437"/>
-                </a:solidFill>
-                <a:latin typeface="Fira Sans"/>
-              </a:rPr>
-              <a:t>▸ </a:t>
-            </a:r>
-            <a:r>
-              <a:rPr sz="1600" b="0">
-                <a:solidFill>
-                  <a:srgbClr val="000000"/>
-                </a:solidFill>
-                <a:latin typeface="Fira Sans"/>
-              </a:rPr>
-              <a:t>polyfit ajusta un polinomio por mínimos cuadrados; el 1 pide grado 1, una recta. En las clases 6 y 7 usaremos herramientas con más diagnósticos.</a:t>
+            <a:r>
+              <a:rPr sz="1300" b="0">
+                <a:solidFill>
+                  <a:srgbClr val="333333"/>
+                </a:solidFill>
+                <a:latin typeface="Fira Sans"/>
+              </a:rPr>
+              <a:t>duración = 41,1 − 5,8 · ingreso: por cada millón adicional de ingreso medio, la duración media baja casi 6 minutos. Y r² = 0,14: la recta captura el 14% de la variación; la asociación es real pero moderada, y así se reporta.</a:t>
             </a:r>
           </a:p>
         </p:txBody>
@@ -6880,7 +6798,7 @@
             <a:avLst/>
           </a:prstGeom>
           <a:solidFill>
-            <a:srgbClr val="1D3557"/>
+            <a:srgbClr val="FAFBFC"/>
           </a:solidFill>
           <a:ln>
             <a:noFill/>
@@ -6917,8 +6835,8 @@
         </p:nvSpPr>
         <p:spPr>
           <a:xfrm>
-            <a:off x="603504" y="1847088"/>
-            <a:ext cx="7946136" cy="1399032"/>
+            <a:off x="402336" y="301752"/>
+            <a:ext cx="8348472" cy="795528"/>
           </a:xfrm>
           <a:prstGeom prst="rect">
             <a:avLst/>
@@ -6932,24 +6850,167 @@
           <a:lstStyle/>
           <a:p>
             <a:r>
-              <a:rPr sz="3400" b="1">
-                <a:solidFill>
-                  <a:srgbClr val="FFFFFF"/>
-                </a:solidFill>
-                <a:latin typeface="Fira Sans"/>
-              </a:rPr>
-              <a:t>Buenas prácticas de visualización</a:t>
-            </a:r>
-          </a:p>
-          <a:p>
-            <a:r>
-              <a:rPr sz="1800" b="0">
+              <a:rPr sz="2800" b="1">
+                <a:solidFill>
+                  <a:srgbClr val="0F0F0F"/>
+                </a:solidFill>
+                <a:latin typeface="Fira Sans"/>
+              </a:rPr>
+              <a:t>La recta en NumPy</a:t>
+            </a:r>
+          </a:p>
+        </p:txBody>
+      </p:sp>
+      <p:sp>
+        <p:nvSpPr>
+          <p:cNvPr id="4" name="Rectangle 3"/>
+          <p:cNvSpPr/>
+          <p:nvPr/>
+        </p:nvSpPr>
+        <p:spPr>
+          <a:xfrm>
+            <a:off x="704088" y="1280160"/>
+            <a:ext cx="7744968" cy="2880360"/>
+          </a:xfrm>
+          <a:prstGeom prst="rect">
+            <a:avLst/>
+          </a:prstGeom>
+          <a:solidFill>
+            <a:srgbClr val="F0F2F5"/>
+          </a:solidFill>
+          <a:ln>
+            <a:solidFill>
+              <a:srgbClr val="D8DDE3"/>
+            </a:solidFill>
+          </a:ln>
+          <a:effectLst/>
+        </p:spPr>
+        <p:style>
+          <a:lnRef idx="1">
+            <a:schemeClr val="accent1"/>
+          </a:lnRef>
+          <a:fillRef idx="3">
+            <a:schemeClr val="accent1"/>
+          </a:fillRef>
+          <a:effectRef idx="2">
+            <a:schemeClr val="accent1"/>
+          </a:effectRef>
+          <a:fontRef idx="minor">
+            <a:schemeClr val="lt1"/>
+          </a:fontRef>
+        </p:style>
+        <p:txBody>
+          <a:bodyPr rtlCol="0" anchor="ctr" wrap="square" lIns="228600" tIns="137160"/>
+          <a:lstStyle/>
+          <a:p>
+            <a:pPr/>
+            <a:r>
+              <a:rPr sz="1500" b="0">
+                <a:solidFill>
+                  <a:srgbClr val="1D3557"/>
+                </a:solidFill>
+                <a:latin typeface="Menlo"/>
+              </a:rPr>
+              <a:t>pendiente, intercepto = np.polyfit(por_comuna["ingreso"],</a:t>
+            </a:r>
+          </a:p>
+          <a:p>
+            <a:pPr/>
+            <a:r>
+              <a:rPr sz="1500" b="0">
+                <a:solidFill>
+                  <a:srgbClr val="1D3557"/>
+                </a:solidFill>
+                <a:latin typeface="Menlo"/>
+              </a:rPr>
+              <a:t>                                   por_comuna["duracion"], 1)</a:t>
+            </a:r>
+          </a:p>
+          <a:p>
+            <a:pPr/>
+            <a:r>
+              <a:rPr sz="1500" b="0">
+                <a:solidFill>
+                  <a:srgbClr val="1D3557"/>
+                </a:solidFill>
+                <a:latin typeface="Menlo"/>
+              </a:rPr>
+              <a:t/>
+            </a:r>
+          </a:p>
+          <a:p>
+            <a:pPr/>
+            <a:r>
+              <a:rPr sz="1500" b="0">
+                <a:solidFill>
+                  <a:srgbClr val="1D3557"/>
+                </a:solidFill>
+                <a:latin typeface="Menlo"/>
+              </a:rPr>
+              <a:t># La recta evaluada, para dibujarla sobre el scatter</a:t>
+            </a:r>
+          </a:p>
+          <a:p>
+            <a:pPr/>
+            <a:r>
+              <a:rPr sz="1500" b="0">
+                <a:solidFill>
+                  <a:srgbClr val="1D3557"/>
+                </a:solidFill>
+                <a:latin typeface="Menlo"/>
+              </a:rPr>
+              <a:t>ax.plot(x, intercepto + pendiente * x)</a:t>
+            </a:r>
+          </a:p>
+        </p:txBody>
+      </p:sp>
+      <p:sp>
+        <p:nvSpPr>
+          <p:cNvPr id="5" name="TextBox 4"/>
+          <p:cNvSpPr txBox="1"/>
+          <p:nvPr/>
+        </p:nvSpPr>
+        <p:spPr>
+          <a:xfrm>
+            <a:off x="704088" y="4389120"/>
+            <a:ext cx="7744968" cy="1097280"/>
+          </a:xfrm>
+          <a:prstGeom prst="rect">
+            <a:avLst/>
+          </a:prstGeom>
+          <a:noFill/>
+        </p:spPr>
+        <p:txBody>
+          <a:bodyPr wrap="square">
+            <a:spAutoFit/>
+          </a:bodyPr>
+          <a:lstStyle/>
+          <a:p>
+            <a:pPr>
+              <a:lnSpc>
+                <a:spcPct val="112000"/>
+              </a:lnSpc>
+              <a:spcAft>
+                <a:spcPts val="900"/>
+              </a:spcAft>
+            </a:pPr>
+            <a:r>
+              <a:rPr sz="1600" b="1">
                 <a:solidFill>
                   <a:srgbClr val="E0A437"/>
                 </a:solidFill>
                 <a:latin typeface="Fira Sans"/>
               </a:rPr>
-              <a:t>Que el gráfico diga la verdad y se entienda</a:t>
+              <a:t>▸ </a:t>
+            </a:r>
+            <a:r>
+              <a:rPr sz="1600" b="0">
+                <a:solidFill>
+                  <a:srgbClr val="000000"/>
+                </a:solidFill>
+                <a:latin typeface="Fira Sans"/>
+              </a:rPr>
+              <a:t>polyfit ajusta un polinomio por mínimos cuadrados; el 1 pide grado 1, una recta. En las clases 6 y 7 usaremos herramientas con más diagnósticos.</a:t>
             </a:r>
           </a:p>
         </p:txBody>
@@ -7218,7 +7279,7 @@
             <a:avLst/>
           </a:prstGeom>
           <a:solidFill>
-            <a:srgbClr val="FAFBFC"/>
+            <a:srgbClr val="1D3557"/>
           </a:solidFill>
           <a:ln>
             <a:noFill/>
@@ -7255,8 +7316,8 @@
         </p:nvSpPr>
         <p:spPr>
           <a:xfrm>
-            <a:off x="402336" y="301752"/>
-            <a:ext cx="8348472" cy="795528"/>
+            <a:off x="603504" y="1847088"/>
+            <a:ext cx="7946136" cy="1399032"/>
           </a:xfrm>
           <a:prstGeom prst="rect">
             <a:avLst/>
@@ -7270,71 +7331,24 @@
           <a:lstStyle/>
           <a:p>
             <a:r>
-              <a:rPr sz="2800" b="1">
-                <a:solidFill>
-                  <a:srgbClr val="0F0F0F"/>
-                </a:solidFill>
-                <a:latin typeface="Fira Sans"/>
-              </a:rPr>
-              <a:t>Cuándo usar escala logarítmica</a:t>
-            </a:r>
-          </a:p>
-        </p:txBody>
-      </p:sp>
-      <p:pic>
-        <p:nvPicPr>
-          <p:cNvPr id="4" name="Picture 3" descr="c3_10_escala_log.png"/>
-          <p:cNvPicPr>
-            <a:picLocks noChangeAspect="1"/>
-          </p:cNvPicPr>
-          <p:nvPr/>
-        </p:nvPicPr>
-        <p:blipFill>
-          <a:blip r:embed="rId2"/>
-          <a:stretch>
-            <a:fillRect/>
-          </a:stretch>
-        </p:blipFill>
-        <p:spPr>
-          <a:xfrm>
-            <a:off x="1417319" y="1143000"/>
-            <a:ext cx="6309360" cy="2432846"/>
-          </a:xfrm>
-          <a:prstGeom prst="rect">
-            <a:avLst/>
-          </a:prstGeom>
-        </p:spPr>
-      </p:pic>
-      <p:sp>
-        <p:nvSpPr>
-          <p:cNvPr id="5" name="TextBox 4"/>
-          <p:cNvSpPr txBox="1"/>
-          <p:nvPr/>
-        </p:nvSpPr>
-        <p:spPr>
-          <a:xfrm>
-            <a:off x="704088" y="4434840"/>
-            <a:ext cx="7744968" cy="457200"/>
-          </a:xfrm>
-          <a:prstGeom prst="rect">
-            <a:avLst/>
-          </a:prstGeom>
-          <a:noFill/>
-        </p:spPr>
-        <p:txBody>
-          <a:bodyPr wrap="square">
-            <a:spAutoFit/>
-          </a:bodyPr>
-          <a:lstStyle/>
-          <a:p>
-            <a:r>
-              <a:rPr sz="1300" b="0">
-                <a:solidFill>
-                  <a:srgbClr val="333333"/>
-                </a:solidFill>
-                <a:latin typeface="Fira Sans"/>
-              </a:rPr>
-              <a:t>Con colas largas como el ingreso, la escala lineal aplasta el 99% de los datos contra el borde; la logarítmica reparte el espacio y la forma aparece.</a:t>
+              <a:rPr sz="3400" b="1">
+                <a:solidFill>
+                  <a:srgbClr val="FFFFFF"/>
+                </a:solidFill>
+                <a:latin typeface="Fira Sans"/>
+              </a:rPr>
+              <a:t>Buenas prácticas de visualización</a:t>
+            </a:r>
+          </a:p>
+          <a:p>
+            <a:r>
+              <a:rPr sz="1800" b="0">
+                <a:solidFill>
+                  <a:srgbClr val="E0A437"/>
+                </a:solidFill>
+                <a:latin typeface="Fira Sans"/>
+              </a:rPr>
+              <a:t>Que el gráfico diga la verdad y se entienda</a:t>
             </a:r>
           </a:p>
         </p:txBody>
@@ -7430,14 +7444,14 @@
                 </a:solidFill>
                 <a:latin typeface="Fira Sans"/>
               </a:rPr>
-              <a:t>El mismo gráfico, dos veces</a:t>
+              <a:t>Graficar 90 mil puntos: overplotting</a:t>
             </a:r>
           </a:p>
         </p:txBody>
       </p:sp>
       <p:pic>
         <p:nvPicPr>
-          <p:cNvPr id="4" name="Picture 3" descr="c3_16_mal_buen_grafico.png"/>
+          <p:cNvPr id="4" name="Picture 3" descr="c3_08_overplotting.png"/>
           <p:cNvPicPr>
             <a:picLocks noChangeAspect="1"/>
           </p:cNvPicPr>
@@ -7452,7 +7466,7 @@
         <p:spPr>
           <a:xfrm>
             <a:off x="1417319" y="1143000"/>
-            <a:ext cx="6309360" cy="2447822"/>
+            <a:ext cx="6309360" cy="1913950"/>
           </a:xfrm>
           <a:prstGeom prst="rect">
             <a:avLst/>
@@ -7488,7 +7502,7 @@
                 </a:solidFill>
                 <a:latin typeface="Fira Sans"/>
               </a:rPr>
-              <a:t>Los mismos 30 mil viajes: sin rotular y saturado, contra rotulado, con transparencia y con el hallazgo en el título.</a:t>
+              <a:t>Con todos los puntos sólidos, el scatter se satura y miente. Los remedios: transparencia (alpha), muestreo, o hexbin, donde el color cuenta los viajes (la distancia se calcula con las coordenadas; el notebook muestra el cálculo).</a:t>
             </a:r>
           </a:p>
         </p:txBody>
@@ -7584,21 +7598,45 @@
                 </a:solidFill>
                 <a:latin typeface="Fira Sans"/>
               </a:rPr>
-              <a:t>Checklist del buen gráfico</a:t>
-            </a:r>
-          </a:p>
-        </p:txBody>
-      </p:sp>
-      <p:sp>
-        <p:nvSpPr>
-          <p:cNvPr id="4" name="TextBox 3"/>
+              <a:t>Cuándo usar escala logarítmica</a:t>
+            </a:r>
+          </a:p>
+        </p:txBody>
+      </p:sp>
+      <p:pic>
+        <p:nvPicPr>
+          <p:cNvPr id="4" name="Picture 3" descr="c3_10_escala_log.png"/>
+          <p:cNvPicPr>
+            <a:picLocks noChangeAspect="1"/>
+          </p:cNvPicPr>
+          <p:nvPr/>
+        </p:nvPicPr>
+        <p:blipFill>
+          <a:blip r:embed="rId2"/>
+          <a:stretch>
+            <a:fillRect/>
+          </a:stretch>
+        </p:blipFill>
+        <p:spPr>
+          <a:xfrm>
+            <a:off x="1417319" y="1143000"/>
+            <a:ext cx="6309360" cy="2432846"/>
+          </a:xfrm>
+          <a:prstGeom prst="rect">
+            <a:avLst/>
+          </a:prstGeom>
+        </p:spPr>
+      </p:pic>
+      <p:sp>
+        <p:nvSpPr>
+          <p:cNvPr id="5" name="TextBox 4"/>
           <p:cNvSpPr txBox="1"/>
           <p:nvPr/>
         </p:nvSpPr>
         <p:spPr>
           <a:xfrm>
-            <a:off x="704088" y="1353312"/>
-            <a:ext cx="7744968" cy="3300984"/>
+            <a:off x="704088" y="4434840"/>
+            <a:ext cx="7744968" cy="457200"/>
           </a:xfrm>
           <a:prstGeom prst="rect">
             <a:avLst/>
@@ -7611,143 +7649,14 @@
           </a:bodyPr>
           <a:lstStyle/>
           <a:p>
-            <a:pPr>
-              <a:lnSpc>
-                <a:spcPct val="112000"/>
-              </a:lnSpc>
-              <a:spcAft>
-                <a:spcPts val="900"/>
-              </a:spcAft>
-            </a:pPr>
-            <a:r>
-              <a:rPr sz="1800" b="1">
-                <a:solidFill>
-                  <a:srgbClr val="E0A437"/>
-                </a:solidFill>
-                <a:latin typeface="Fira Sans"/>
-              </a:rPr>
-              <a:t>▸ </a:t>
-            </a:r>
-            <a:r>
-              <a:rPr sz="1800" b="0">
-                <a:solidFill>
-                  <a:srgbClr val="000000"/>
-                </a:solidFill>
-                <a:latin typeface="Fira Sans"/>
-              </a:rPr>
-              <a:t>Título que diga el hallazgo, no solo las variables.</a:t>
-            </a:r>
-          </a:p>
-          <a:p>
-            <a:pPr>
-              <a:lnSpc>
-                <a:spcPct val="112000"/>
-              </a:lnSpc>
-              <a:spcAft>
-                <a:spcPts val="900"/>
-              </a:spcAft>
-            </a:pPr>
-            <a:r>
-              <a:rPr sz="1800" b="1">
-                <a:solidFill>
-                  <a:srgbClr val="E0A437"/>
-                </a:solidFill>
-                <a:latin typeface="Fira Sans"/>
-              </a:rPr>
-              <a:t>▸ </a:t>
-            </a:r>
-            <a:r>
-              <a:rPr sz="1800" b="0">
-                <a:solidFill>
-                  <a:srgbClr val="000000"/>
-                </a:solidFill>
-                <a:latin typeface="Fira Sans"/>
-              </a:rPr>
-              <a:t>Ejes con nombre y unidad; ejes que parten de cero en gráficos de barras.</a:t>
-            </a:r>
-          </a:p>
-          <a:p>
-            <a:pPr>
-              <a:lnSpc>
-                <a:spcPct val="112000"/>
-              </a:lnSpc>
-              <a:spcAft>
-                <a:spcPts val="900"/>
-              </a:spcAft>
-            </a:pPr>
-            <a:r>
-              <a:rPr sz="1800" b="1">
-                <a:solidFill>
-                  <a:srgbClr val="E0A437"/>
-                </a:solidFill>
-                <a:latin typeface="Fira Sans"/>
-              </a:rPr>
-              <a:t>▸ </a:t>
-            </a:r>
-            <a:r>
-              <a:rPr sz="1800" b="0">
-                <a:solidFill>
-                  <a:srgbClr val="000000"/>
-                </a:solidFill>
-                <a:latin typeface="Fira Sans"/>
-              </a:rPr>
-              <a:t>Muchos puntos: alpha, muestreo o hexbin.</a:t>
-            </a:r>
-          </a:p>
-          <a:p>
-            <a:pPr>
-              <a:lnSpc>
-                <a:spcPct val="112000"/>
-              </a:lnSpc>
-              <a:spcAft>
-                <a:spcPts val="900"/>
-              </a:spcAft>
-            </a:pPr>
-            <a:r>
-              <a:rPr sz="1800" b="1">
-                <a:solidFill>
-                  <a:srgbClr val="E0A437"/>
-                </a:solidFill>
-                <a:latin typeface="Fira Sans"/>
-              </a:rPr>
-              <a:t>▸ </a:t>
-            </a:r>
-            <a:r>
-              <a:rPr sz="1800" b="0">
-                <a:solidFill>
-                  <a:srgbClr val="000000"/>
-                </a:solidFill>
-                <a:latin typeface="Fira Sans"/>
-              </a:rPr>
-              <a:t>Colas largas: escala logarítmica o eje recortado, declarándolo.</a:t>
-            </a:r>
-          </a:p>
-          <a:p>
-            <a:pPr>
-              <a:lnSpc>
-                <a:spcPct val="112000"/>
-              </a:lnSpc>
-              <a:spcAft>
-                <a:spcPts val="900"/>
-              </a:spcAft>
-            </a:pPr>
-            <a:r>
-              <a:rPr sz="1800" b="1">
-                <a:solidFill>
-                  <a:srgbClr val="E0A437"/>
-                </a:solidFill>
-                <a:latin typeface="Fira Sans"/>
-              </a:rPr>
-              <a:t>▸ </a:t>
-            </a:r>
-            <a:r>
-              <a:rPr sz="1800" b="1">
-                <a:solidFill>
-                  <a:srgbClr val="1D3557"/>
-                </a:solidFill>
-                <a:latin typeface="Fira Sans"/>
-              </a:rPr>
-              <a:t>El gráfico se corrige igual que el código: se itera hasta que un tercero lo entienda sin explicación oral.</a:t>
+            <a:r>
+              <a:rPr sz="1300" b="0">
+                <a:solidFill>
+                  <a:srgbClr val="333333"/>
+                </a:solidFill>
+                <a:latin typeface="Fira Sans"/>
+              </a:rPr>
+              <a:t>Con colas largas como el ingreso, la escala lineal aplasta el 99% de los datos contra el borde; la logarítmica reparte el espacio y la forma aparece.</a:t>
             </a:r>
           </a:p>
         </p:txBody>
@@ -7843,21 +7752,45 @@
                 </a:solidFill>
                 <a:latin typeface="Fira Sans"/>
               </a:rPr>
-              <a:t>Síntesis</a:t>
-            </a:r>
-          </a:p>
-        </p:txBody>
-      </p:sp>
-      <p:sp>
-        <p:nvSpPr>
-          <p:cNvPr id="4" name="TextBox 3"/>
+              <a:t>El mismo gráfico, dos veces</a:t>
+            </a:r>
+          </a:p>
+        </p:txBody>
+      </p:sp>
+      <p:pic>
+        <p:nvPicPr>
+          <p:cNvPr id="4" name="Picture 3" descr="c3_16_mal_buen_grafico.png"/>
+          <p:cNvPicPr>
+            <a:picLocks noChangeAspect="1"/>
+          </p:cNvPicPr>
+          <p:nvPr/>
+        </p:nvPicPr>
+        <p:blipFill>
+          <a:blip r:embed="rId2"/>
+          <a:stretch>
+            <a:fillRect/>
+          </a:stretch>
+        </p:blipFill>
+        <p:spPr>
+          <a:xfrm>
+            <a:off x="1417319" y="1143000"/>
+            <a:ext cx="6309360" cy="2447822"/>
+          </a:xfrm>
+          <a:prstGeom prst="rect">
+            <a:avLst/>
+          </a:prstGeom>
+        </p:spPr>
+      </p:pic>
+      <p:sp>
+        <p:nvSpPr>
+          <p:cNvPr id="5" name="TextBox 4"/>
           <p:cNvSpPr txBox="1"/>
           <p:nvPr/>
         </p:nvSpPr>
         <p:spPr>
           <a:xfrm>
-            <a:off x="704088" y="1353312"/>
-            <a:ext cx="7744968" cy="3300984"/>
+            <a:off x="704088" y="4434840"/>
+            <a:ext cx="7744968" cy="457200"/>
           </a:xfrm>
           <a:prstGeom prst="rect">
             <a:avLst/>
@@ -7870,143 +7803,14 @@
           </a:bodyPr>
           <a:lstStyle/>
           <a:p>
-            <a:pPr>
-              <a:lnSpc>
-                <a:spcPct val="112000"/>
-              </a:lnSpc>
-              <a:spcAft>
-                <a:spcPts val="900"/>
-              </a:spcAft>
-            </a:pPr>
-            <a:r>
-              <a:rPr sz="1800" b="1">
-                <a:solidFill>
-                  <a:srgbClr val="E0A437"/>
-                </a:solidFill>
-                <a:latin typeface="Fira Sans"/>
-              </a:rPr>
-              <a:t>▸ </a:t>
-            </a:r>
-            <a:r>
-              <a:rPr sz="1800" b="0">
-                <a:solidFill>
-                  <a:srgbClr val="000000"/>
-                </a:solidFill>
-                <a:latin typeface="Fira Sans"/>
-              </a:rPr>
-              <a:t>El análisis bivariado se elige según el par de tipos: scatter y correlación, groupby y boxplot, o tabla de contingencia.</a:t>
-            </a:r>
-          </a:p>
-          <a:p>
-            <a:pPr>
-              <a:lnSpc>
-                <a:spcPct val="112000"/>
-              </a:lnSpc>
-              <a:spcAft>
-                <a:spcPts val="900"/>
-              </a:spcAft>
-            </a:pPr>
-            <a:r>
-              <a:rPr sz="1800" b="1">
-                <a:solidFill>
-                  <a:srgbClr val="E0A437"/>
-                </a:solidFill>
-                <a:latin typeface="Fira Sans"/>
-              </a:rPr>
-              <a:t>▸ </a:t>
-            </a:r>
-            <a:r>
-              <a:rPr sz="1800" b="0">
-                <a:solidFill>
-                  <a:srgbClr val="000000"/>
-                </a:solidFill>
-                <a:latin typeface="Fira Sans"/>
-              </a:rPr>
-              <a:t>Pearson para relaciones lineales; Spearman cuando hay atípicos o curvas. Y siempre graficar: Anscombe.</a:t>
-            </a:r>
-          </a:p>
-          <a:p>
-            <a:pPr>
-              <a:lnSpc>
-                <a:spcPct val="112000"/>
-              </a:lnSpc>
-              <a:spcAft>
-                <a:spcPts val="900"/>
-              </a:spcAft>
-            </a:pPr>
-            <a:r>
-              <a:rPr sz="1800" b="1">
-                <a:solidFill>
-                  <a:srgbClr val="E0A437"/>
-                </a:solidFill>
-                <a:latin typeface="Fira Sans"/>
-              </a:rPr>
-              <a:t>▸ </a:t>
-            </a:r>
-            <a:r>
-              <a:rPr sz="1800" b="0">
-                <a:solidFill>
-                  <a:srgbClr val="000000"/>
-                </a:solidFill>
-                <a:latin typeface="Fira Sans"/>
-              </a:rPr>
-              <a:t>Correlación no es causalidad: reportamos asociación.</a:t>
-            </a:r>
-          </a:p>
-          <a:p>
-            <a:pPr>
-              <a:lnSpc>
-                <a:spcPct val="112000"/>
-              </a:lnSpc>
-              <a:spcAft>
-                <a:spcPts val="900"/>
-              </a:spcAft>
-            </a:pPr>
-            <a:r>
-              <a:rPr sz="1800" b="1">
-                <a:solidFill>
-                  <a:srgbClr val="E0A437"/>
-                </a:solidFill>
-                <a:latin typeface="Fira Sans"/>
-              </a:rPr>
-              <a:t>▸ </a:t>
-            </a:r>
-            <a:r>
-              <a:rPr sz="1800" b="0">
-                <a:solidFill>
-                  <a:srgbClr val="000000"/>
-                </a:solidFill>
-                <a:latin typeface="Fira Sans"/>
-              </a:rPr>
-              <a:t>La regresión da la recta interpretable: pendiente e intercepto.</a:t>
-            </a:r>
-          </a:p>
-          <a:p>
-            <a:pPr>
-              <a:lnSpc>
-                <a:spcPct val="112000"/>
-              </a:lnSpc>
-              <a:spcAft>
-                <a:spcPts val="900"/>
-              </a:spcAft>
-            </a:pPr>
-            <a:r>
-              <a:rPr sz="1800" b="1">
-                <a:solidFill>
-                  <a:srgbClr val="E0A437"/>
-                </a:solidFill>
-                <a:latin typeface="Fira Sans"/>
-              </a:rPr>
-              <a:t>▸ </a:t>
-            </a:r>
-            <a:r>
-              <a:rPr sz="1800" b="1">
-                <a:solidFill>
-                  <a:srgbClr val="1D3557"/>
-                </a:solidFill>
-                <a:latin typeface="Fira Sans"/>
-              </a:rPr>
-              <a:t>Todo lo de hoy es exactamente lo que el primer EDA del proyecto debe mostrar (entrega: lunes 15).</a:t>
+            <a:r>
+              <a:rPr sz="1300" b="0">
+                <a:solidFill>
+                  <a:srgbClr val="333333"/>
+                </a:solidFill>
+                <a:latin typeface="Fira Sans"/>
+              </a:rPr>
+              <a:t>Los mismos 30 mil viajes: sin rotular y saturado, contra rotulado, con transparencia y con el hallazgo en el título.</a:t>
             </a:r>
           </a:p>
         </p:txBody>
@@ -8102,7 +7906,7 @@
                 </a:solidFill>
                 <a:latin typeface="Fira Sans"/>
               </a:rPr>
-              <a:t>Próxima clase</a:t>
+              <a:t>Checklist del buen gráfico</a:t>
             </a:r>
           </a:p>
         </p:txBody>
@@ -8147,13 +7951,13 @@
               <a:t>▸ </a:t>
             </a:r>
             <a:r>
-              <a:rPr sz="1800" b="1">
-                <a:solidFill>
-                  <a:srgbClr val="1D3557"/>
-                </a:solidFill>
-                <a:latin typeface="Fira Sans"/>
-              </a:rPr>
-              <a:t>Jueves 3 de septiembre: presentaciones breves de las ideas de proyecto (5 minutos por equipo, sin nota).</a:t>
+              <a:rPr sz="1800" b="0">
+                <a:solidFill>
+                  <a:srgbClr val="000000"/>
+                </a:solidFill>
+                <a:latin typeface="Fira Sans"/>
+              </a:rPr>
+              <a:t>Título que diga el hallazgo, no solo las variables.</a:t>
             </a:r>
           </a:p>
           <a:p>
@@ -8181,7 +7985,7 @@
                 </a:solidFill>
                 <a:latin typeface="Fira Sans"/>
               </a:rPr>
-              <a:t>Después: fundamentos de probabilidad, la base para la inferencia de las clases siguientes.</a:t>
+              <a:t>Ejes con nombre y unidad; ejes que parten de cero en gráficos de barras.</a:t>
             </a:r>
           </a:p>
           <a:p>
@@ -8209,7 +8013,7 @@
                 </a:solidFill>
                 <a:latin typeface="Fira Sans"/>
               </a:rPr>
-              <a:t>Se publica la rúbrica del primer análisis exploratorio.</a:t>
+              <a:t>Muchos puntos: alpha, muestreo o hexbin.</a:t>
             </a:r>
           </a:p>
           <a:p>
@@ -8237,7 +8041,35 @@
                 </a:solidFill>
                 <a:latin typeface="Fira Sans"/>
               </a:rPr>
-              <a:t>Recuerden: la formulación se entrega el lunes 7 por el aula virtual.</a:t>
+              <a:t>Colas largas: escala logarítmica o eje recortado, declarándolo.</a:t>
+            </a:r>
+          </a:p>
+          <a:p>
+            <a:pPr>
+              <a:lnSpc>
+                <a:spcPct val="112000"/>
+              </a:lnSpc>
+              <a:spcAft>
+                <a:spcPts val="900"/>
+              </a:spcAft>
+            </a:pPr>
+            <a:r>
+              <a:rPr sz="1800" b="1">
+                <a:solidFill>
+                  <a:srgbClr val="E0A437"/>
+                </a:solidFill>
+                <a:latin typeface="Fira Sans"/>
+              </a:rPr>
+              <a:t>▸ </a:t>
+            </a:r>
+            <a:r>
+              <a:rPr sz="1800" b="1">
+                <a:solidFill>
+                  <a:srgbClr val="1D3557"/>
+                </a:solidFill>
+                <a:latin typeface="Fira Sans"/>
+              </a:rPr>
+              <a:t>El gráfico se corrige igual que el código: se itera hasta que un tercero lo entienda sin explicación oral.</a:t>
             </a:r>
           </a:p>
         </p:txBody>
@@ -8251,6 +8083,496 @@
 </file>
 
 <file path=ppt/slides/slide35.xml><?xml version="1.0" encoding="utf-8"?>
+<p:sld xmlns:a="http://schemas.openxmlformats.org/drawingml/2006/main" xmlns:p="http://schemas.openxmlformats.org/presentationml/2006/main" xmlns:r="http://schemas.openxmlformats.org/officeDocument/2006/relationships">
+  <p:cSld>
+    <p:spTree>
+      <p:nvGrpSpPr>
+        <p:cNvPr id="1" name=""/>
+        <p:cNvGrpSpPr/>
+        <p:nvPr/>
+      </p:nvGrpSpPr>
+      <p:grpSpPr/>
+      <p:sp>
+        <p:nvSpPr>
+          <p:cNvPr id="2" name="Rectangle 1"/>
+          <p:cNvSpPr/>
+          <p:nvPr/>
+        </p:nvSpPr>
+        <p:spPr>
+          <a:xfrm>
+            <a:off x="0" y="0"/>
+            <a:ext cx="9144000" cy="5138928"/>
+          </a:xfrm>
+          <a:prstGeom prst="rect">
+            <a:avLst/>
+          </a:prstGeom>
+          <a:solidFill>
+            <a:srgbClr val="FAFBFC"/>
+          </a:solidFill>
+          <a:ln>
+            <a:noFill/>
+          </a:ln>
+          <a:effectLst/>
+        </p:spPr>
+        <p:style>
+          <a:lnRef idx="1">
+            <a:schemeClr val="accent1"/>
+          </a:lnRef>
+          <a:fillRef idx="3">
+            <a:schemeClr val="accent1"/>
+          </a:fillRef>
+          <a:effectRef idx="2">
+            <a:schemeClr val="accent1"/>
+          </a:effectRef>
+          <a:fontRef idx="minor">
+            <a:schemeClr val="lt1"/>
+          </a:fontRef>
+        </p:style>
+        <p:txBody>
+          <a:bodyPr rtlCol="0" anchor="ctr"/>
+          <a:lstStyle/>
+          <a:p>
+            <a:pPr algn="ctr"/>
+          </a:p>
+        </p:txBody>
+      </p:sp>
+      <p:sp>
+        <p:nvSpPr>
+          <p:cNvPr id="3" name="TextBox 2"/>
+          <p:cNvSpPr txBox="1"/>
+          <p:nvPr/>
+        </p:nvSpPr>
+        <p:spPr>
+          <a:xfrm>
+            <a:off x="402336" y="301752"/>
+            <a:ext cx="8348472" cy="795528"/>
+          </a:xfrm>
+          <a:prstGeom prst="rect">
+            <a:avLst/>
+          </a:prstGeom>
+          <a:noFill/>
+        </p:spPr>
+        <p:txBody>
+          <a:bodyPr wrap="square">
+            <a:spAutoFit/>
+          </a:bodyPr>
+          <a:lstStyle/>
+          <a:p>
+            <a:r>
+              <a:rPr sz="2800" b="1">
+                <a:solidFill>
+                  <a:srgbClr val="0F0F0F"/>
+                </a:solidFill>
+                <a:latin typeface="Fira Sans"/>
+              </a:rPr>
+              <a:t>Síntesis</a:t>
+            </a:r>
+          </a:p>
+        </p:txBody>
+      </p:sp>
+      <p:sp>
+        <p:nvSpPr>
+          <p:cNvPr id="4" name="TextBox 3"/>
+          <p:cNvSpPr txBox="1"/>
+          <p:nvPr/>
+        </p:nvSpPr>
+        <p:spPr>
+          <a:xfrm>
+            <a:off x="704088" y="1353312"/>
+            <a:ext cx="7744968" cy="3300984"/>
+          </a:xfrm>
+          <a:prstGeom prst="rect">
+            <a:avLst/>
+          </a:prstGeom>
+          <a:noFill/>
+        </p:spPr>
+        <p:txBody>
+          <a:bodyPr wrap="square">
+            <a:spAutoFit/>
+          </a:bodyPr>
+          <a:lstStyle/>
+          <a:p>
+            <a:pPr>
+              <a:lnSpc>
+                <a:spcPct val="112000"/>
+              </a:lnSpc>
+              <a:spcAft>
+                <a:spcPts val="900"/>
+              </a:spcAft>
+            </a:pPr>
+            <a:r>
+              <a:rPr sz="1800" b="1">
+                <a:solidFill>
+                  <a:srgbClr val="E0A437"/>
+                </a:solidFill>
+                <a:latin typeface="Fira Sans"/>
+              </a:rPr>
+              <a:t>▸ </a:t>
+            </a:r>
+            <a:r>
+              <a:rPr sz="1800" b="0">
+                <a:solidFill>
+                  <a:srgbClr val="000000"/>
+                </a:solidFill>
+                <a:latin typeface="Fira Sans"/>
+              </a:rPr>
+              <a:t>El análisis bivariado se elige según el par de tipos: scatter y correlación, groupby y boxplot, o tabla de contingencia.</a:t>
+            </a:r>
+          </a:p>
+          <a:p>
+            <a:pPr>
+              <a:lnSpc>
+                <a:spcPct val="112000"/>
+              </a:lnSpc>
+              <a:spcAft>
+                <a:spcPts val="900"/>
+              </a:spcAft>
+            </a:pPr>
+            <a:r>
+              <a:rPr sz="1800" b="1">
+                <a:solidFill>
+                  <a:srgbClr val="E0A437"/>
+                </a:solidFill>
+                <a:latin typeface="Fira Sans"/>
+              </a:rPr>
+              <a:t>▸ </a:t>
+            </a:r>
+            <a:r>
+              <a:rPr sz="1800" b="0">
+                <a:solidFill>
+                  <a:srgbClr val="000000"/>
+                </a:solidFill>
+                <a:latin typeface="Fira Sans"/>
+              </a:rPr>
+              <a:t>Pearson para relaciones lineales; Spearman cuando hay atípicos o curvas. Y siempre graficar: Anscombe.</a:t>
+            </a:r>
+          </a:p>
+          <a:p>
+            <a:pPr>
+              <a:lnSpc>
+                <a:spcPct val="112000"/>
+              </a:lnSpc>
+              <a:spcAft>
+                <a:spcPts val="900"/>
+              </a:spcAft>
+            </a:pPr>
+            <a:r>
+              <a:rPr sz="1800" b="1">
+                <a:solidFill>
+                  <a:srgbClr val="E0A437"/>
+                </a:solidFill>
+                <a:latin typeface="Fira Sans"/>
+              </a:rPr>
+              <a:t>▸ </a:t>
+            </a:r>
+            <a:r>
+              <a:rPr sz="1800" b="0">
+                <a:solidFill>
+                  <a:srgbClr val="000000"/>
+                </a:solidFill>
+                <a:latin typeface="Fira Sans"/>
+              </a:rPr>
+              <a:t>Correlación no es causalidad: reportamos asociación.</a:t>
+            </a:r>
+          </a:p>
+          <a:p>
+            <a:pPr>
+              <a:lnSpc>
+                <a:spcPct val="112000"/>
+              </a:lnSpc>
+              <a:spcAft>
+                <a:spcPts val="900"/>
+              </a:spcAft>
+            </a:pPr>
+            <a:r>
+              <a:rPr sz="1800" b="1">
+                <a:solidFill>
+                  <a:srgbClr val="E0A437"/>
+                </a:solidFill>
+                <a:latin typeface="Fira Sans"/>
+              </a:rPr>
+              <a:t>▸ </a:t>
+            </a:r>
+            <a:r>
+              <a:rPr sz="1800" b="0">
+                <a:solidFill>
+                  <a:srgbClr val="000000"/>
+                </a:solidFill>
+                <a:latin typeface="Fira Sans"/>
+              </a:rPr>
+              <a:t>La regresión da la recta interpretable: pendiente e intercepto.</a:t>
+            </a:r>
+          </a:p>
+          <a:p>
+            <a:pPr>
+              <a:lnSpc>
+                <a:spcPct val="112000"/>
+              </a:lnSpc>
+              <a:spcAft>
+                <a:spcPts val="900"/>
+              </a:spcAft>
+            </a:pPr>
+            <a:r>
+              <a:rPr sz="1800" b="1">
+                <a:solidFill>
+                  <a:srgbClr val="E0A437"/>
+                </a:solidFill>
+                <a:latin typeface="Fira Sans"/>
+              </a:rPr>
+              <a:t>▸ </a:t>
+            </a:r>
+            <a:r>
+              <a:rPr sz="1800" b="1">
+                <a:solidFill>
+                  <a:srgbClr val="1D3557"/>
+                </a:solidFill>
+                <a:latin typeface="Fira Sans"/>
+              </a:rPr>
+              <a:t>Todo lo de hoy es exactamente lo que el primer EDA del proyecto debe mostrar (entrega: lunes 15).</a:t>
+            </a:r>
+          </a:p>
+        </p:txBody>
+      </p:sp>
+    </p:spTree>
+  </p:cSld>
+  <p:clrMapOvr>
+    <a:masterClrMapping/>
+  </p:clrMapOvr>
+</p:sld>
+</file>
+
+<file path=ppt/slides/slide36.xml><?xml version="1.0" encoding="utf-8"?>
+<p:sld xmlns:a="http://schemas.openxmlformats.org/drawingml/2006/main" xmlns:p="http://schemas.openxmlformats.org/presentationml/2006/main" xmlns:r="http://schemas.openxmlformats.org/officeDocument/2006/relationships">
+  <p:cSld>
+    <p:spTree>
+      <p:nvGrpSpPr>
+        <p:cNvPr id="1" name=""/>
+        <p:cNvGrpSpPr/>
+        <p:nvPr/>
+      </p:nvGrpSpPr>
+      <p:grpSpPr/>
+      <p:sp>
+        <p:nvSpPr>
+          <p:cNvPr id="2" name="Rectangle 1"/>
+          <p:cNvSpPr/>
+          <p:nvPr/>
+        </p:nvSpPr>
+        <p:spPr>
+          <a:xfrm>
+            <a:off x="0" y="0"/>
+            <a:ext cx="9144000" cy="5138928"/>
+          </a:xfrm>
+          <a:prstGeom prst="rect">
+            <a:avLst/>
+          </a:prstGeom>
+          <a:solidFill>
+            <a:srgbClr val="FAFBFC"/>
+          </a:solidFill>
+          <a:ln>
+            <a:noFill/>
+          </a:ln>
+          <a:effectLst/>
+        </p:spPr>
+        <p:style>
+          <a:lnRef idx="1">
+            <a:schemeClr val="accent1"/>
+          </a:lnRef>
+          <a:fillRef idx="3">
+            <a:schemeClr val="accent1"/>
+          </a:fillRef>
+          <a:effectRef idx="2">
+            <a:schemeClr val="accent1"/>
+          </a:effectRef>
+          <a:fontRef idx="minor">
+            <a:schemeClr val="lt1"/>
+          </a:fontRef>
+        </p:style>
+        <p:txBody>
+          <a:bodyPr rtlCol="0" anchor="ctr"/>
+          <a:lstStyle/>
+          <a:p>
+            <a:pPr algn="ctr"/>
+          </a:p>
+        </p:txBody>
+      </p:sp>
+      <p:sp>
+        <p:nvSpPr>
+          <p:cNvPr id="3" name="TextBox 2"/>
+          <p:cNvSpPr txBox="1"/>
+          <p:nvPr/>
+        </p:nvSpPr>
+        <p:spPr>
+          <a:xfrm>
+            <a:off x="402336" y="301752"/>
+            <a:ext cx="8348472" cy="795528"/>
+          </a:xfrm>
+          <a:prstGeom prst="rect">
+            <a:avLst/>
+          </a:prstGeom>
+          <a:noFill/>
+        </p:spPr>
+        <p:txBody>
+          <a:bodyPr wrap="square">
+            <a:spAutoFit/>
+          </a:bodyPr>
+          <a:lstStyle/>
+          <a:p>
+            <a:r>
+              <a:rPr sz="2800" b="1">
+                <a:solidFill>
+                  <a:srgbClr val="0F0F0F"/>
+                </a:solidFill>
+                <a:latin typeface="Fira Sans"/>
+              </a:rPr>
+              <a:t>Próxima clase</a:t>
+            </a:r>
+          </a:p>
+        </p:txBody>
+      </p:sp>
+      <p:sp>
+        <p:nvSpPr>
+          <p:cNvPr id="4" name="TextBox 3"/>
+          <p:cNvSpPr txBox="1"/>
+          <p:nvPr/>
+        </p:nvSpPr>
+        <p:spPr>
+          <a:xfrm>
+            <a:off x="704088" y="1353312"/>
+            <a:ext cx="7744968" cy="3300984"/>
+          </a:xfrm>
+          <a:prstGeom prst="rect">
+            <a:avLst/>
+          </a:prstGeom>
+          <a:noFill/>
+        </p:spPr>
+        <p:txBody>
+          <a:bodyPr wrap="square">
+            <a:spAutoFit/>
+          </a:bodyPr>
+          <a:lstStyle/>
+          <a:p>
+            <a:pPr>
+              <a:lnSpc>
+                <a:spcPct val="112000"/>
+              </a:lnSpc>
+              <a:spcAft>
+                <a:spcPts val="900"/>
+              </a:spcAft>
+            </a:pPr>
+            <a:r>
+              <a:rPr sz="1800" b="1">
+                <a:solidFill>
+                  <a:srgbClr val="E0A437"/>
+                </a:solidFill>
+                <a:latin typeface="Fira Sans"/>
+              </a:rPr>
+              <a:t>▸ </a:t>
+            </a:r>
+            <a:r>
+              <a:rPr sz="1800" b="1">
+                <a:solidFill>
+                  <a:srgbClr val="1D3557"/>
+                </a:solidFill>
+                <a:latin typeface="Fira Sans"/>
+              </a:rPr>
+              <a:t>Jueves 3 de septiembre: presentaciones breves de las ideas de proyecto (5 minutos por equipo, sin nota).</a:t>
+            </a:r>
+          </a:p>
+          <a:p>
+            <a:pPr>
+              <a:lnSpc>
+                <a:spcPct val="112000"/>
+              </a:lnSpc>
+              <a:spcAft>
+                <a:spcPts val="900"/>
+              </a:spcAft>
+            </a:pPr>
+            <a:r>
+              <a:rPr sz="1800" b="1">
+                <a:solidFill>
+                  <a:srgbClr val="E0A437"/>
+                </a:solidFill>
+                <a:latin typeface="Fira Sans"/>
+              </a:rPr>
+              <a:t>▸ </a:t>
+            </a:r>
+            <a:r>
+              <a:rPr sz="1800" b="0">
+                <a:solidFill>
+                  <a:srgbClr val="000000"/>
+                </a:solidFill>
+                <a:latin typeface="Fira Sans"/>
+              </a:rPr>
+              <a:t>Después: fundamentos de probabilidad, la base para la inferencia de las clases siguientes.</a:t>
+            </a:r>
+          </a:p>
+          <a:p>
+            <a:pPr>
+              <a:lnSpc>
+                <a:spcPct val="112000"/>
+              </a:lnSpc>
+              <a:spcAft>
+                <a:spcPts val="900"/>
+              </a:spcAft>
+            </a:pPr>
+            <a:r>
+              <a:rPr sz="1800" b="1">
+                <a:solidFill>
+                  <a:srgbClr val="E0A437"/>
+                </a:solidFill>
+                <a:latin typeface="Fira Sans"/>
+              </a:rPr>
+              <a:t>▸ </a:t>
+            </a:r>
+            <a:r>
+              <a:rPr sz="1800" b="0">
+                <a:solidFill>
+                  <a:srgbClr val="000000"/>
+                </a:solidFill>
+                <a:latin typeface="Fira Sans"/>
+              </a:rPr>
+              <a:t>Se publica la rúbrica del primer análisis exploratorio.</a:t>
+            </a:r>
+          </a:p>
+          <a:p>
+            <a:pPr>
+              <a:lnSpc>
+                <a:spcPct val="112000"/>
+              </a:lnSpc>
+              <a:spcAft>
+                <a:spcPts val="900"/>
+              </a:spcAft>
+            </a:pPr>
+            <a:r>
+              <a:rPr sz="1800" b="1">
+                <a:solidFill>
+                  <a:srgbClr val="E0A437"/>
+                </a:solidFill>
+                <a:latin typeface="Fira Sans"/>
+              </a:rPr>
+              <a:t>▸ </a:t>
+            </a:r>
+            <a:r>
+              <a:rPr sz="1800" b="0">
+                <a:solidFill>
+                  <a:srgbClr val="000000"/>
+                </a:solidFill>
+                <a:latin typeface="Fira Sans"/>
+              </a:rPr>
+              <a:t>Recuerden: la formulación se entrega el lunes 7 por el aula virtual.</a:t>
+            </a:r>
+          </a:p>
+        </p:txBody>
+      </p:sp>
+    </p:spTree>
+  </p:cSld>
+  <p:clrMapOvr>
+    <a:masterClrMapping/>
+  </p:clrMapOvr>
+</p:sld>
+</file>
+
+<file path=ppt/slides/slide37.xml><?xml version="1.0" encoding="utf-8"?>
 <p:sld xmlns:a="http://schemas.openxmlformats.org/drawingml/2006/main" xmlns:p="http://schemas.openxmlformats.org/presentationml/2006/main" xmlns:r="http://schemas.openxmlformats.org/officeDocument/2006/relationships">
   <p:cSld>
     <p:spTree>

</xml_diff>

<commit_message>
Clase 3: medir el impacto de sacar una fila sobre varios resumenes a la vez (con y sin Lo Barnechea)
Co-Authored-By: Claude Fable 5 <noreply@anthropic.com>
</commit_message>
<xml_diff>
--- a/presentaciones/clase03_eda_bivariado.pptx
+++ b/presentaciones/clase03_eda_bivariado.pptx
@@ -45,6 +45,7 @@
     <p:sldId id="293" r:id="rId44"/>
     <p:sldId id="294" r:id="rId45"/>
     <p:sldId id="295" r:id="rId46"/>
+    <p:sldId id="296" r:id="rId47"/>
   </p:sldIdLst>
   <p:sldSz cx="9144000" cy="5138928" type="screen4x3"/>
   <p:notesSz cx="6858000" cy="9144000"/>
@@ -7840,7 +7841,7 @@
             <a:avLst/>
           </a:prstGeom>
           <a:solidFill>
-            <a:srgbClr val="1D3557"/>
+            <a:srgbClr val="FAFBFC"/>
           </a:solidFill>
           <a:ln>
             <a:noFill/>
@@ -7877,8 +7878,8 @@
         </p:nvSpPr>
         <p:spPr>
           <a:xfrm>
-            <a:off x="603504" y="1847088"/>
-            <a:ext cx="7946136" cy="1399032"/>
+            <a:off x="402336" y="301752"/>
+            <a:ext cx="8348472" cy="795528"/>
           </a:xfrm>
           <a:prstGeom prst="rect">
             <a:avLst/>
@@ -7892,24 +7893,167 @@
           <a:lstStyle/>
           <a:p>
             <a:r>
-              <a:rPr sz="3400" b="1">
-                <a:solidFill>
-                  <a:srgbClr val="FFFFFF"/>
-                </a:solidFill>
-                <a:latin typeface="Fira Sans"/>
-              </a:rPr>
-              <a:t>Buenas prácticas de visualización</a:t>
-            </a:r>
-          </a:p>
-          <a:p>
-            <a:r>
-              <a:rPr sz="1800" b="0">
+              <a:rPr sz="2800" b="1">
+                <a:solidFill>
+                  <a:srgbClr val="0F0F0F"/>
+                </a:solidFill>
+                <a:latin typeface="Fira Sans"/>
+              </a:rPr>
+              <a:t>El impacto de sacar una fila</a:t>
+            </a:r>
+          </a:p>
+        </p:txBody>
+      </p:sp>
+      <p:sp>
+        <p:nvSpPr>
+          <p:cNvPr id="4" name="Rectangle 3"/>
+          <p:cNvSpPr/>
+          <p:nvPr/>
+        </p:nvSpPr>
+        <p:spPr>
+          <a:xfrm>
+            <a:off x="704088" y="1280160"/>
+            <a:ext cx="7744968" cy="2880360"/>
+          </a:xfrm>
+          <a:prstGeom prst="rect">
+            <a:avLst/>
+          </a:prstGeom>
+          <a:solidFill>
+            <a:srgbClr val="F0F2F5"/>
+          </a:solidFill>
+          <a:ln>
+            <a:solidFill>
+              <a:srgbClr val="D8DDE3"/>
+            </a:solidFill>
+          </a:ln>
+          <a:effectLst/>
+        </p:spPr>
+        <p:style>
+          <a:lnRef idx="1">
+            <a:schemeClr val="accent1"/>
+          </a:lnRef>
+          <a:fillRef idx="3">
+            <a:schemeClr val="accent1"/>
+          </a:fillRef>
+          <a:effectRef idx="2">
+            <a:schemeClr val="accent1"/>
+          </a:effectRef>
+          <a:fontRef idx="minor">
+            <a:schemeClr val="lt1"/>
+          </a:fontRef>
+        </p:style>
+        <p:txBody>
+          <a:bodyPr rtlCol="0" anchor="ctr" wrap="square" lIns="228600" tIns="137160"/>
+          <a:lstStyle/>
+          <a:p>
+            <a:pPr/>
+            <a:r>
+              <a:rPr sz="1500" b="0">
+                <a:solidFill>
+                  <a:srgbClr val="1D3557"/>
+                </a:solidFill>
+                <a:latin typeface="Menlo"/>
+              </a:rPr>
+              <a:t>sin_lb = por_comuna[por_comuna["Comuna"] != "LO BARNECHEA"]</a:t>
+            </a:r>
+          </a:p>
+          <a:p>
+            <a:pPr/>
+            <a:r>
+              <a:rPr sz="1500" b="0">
+                <a:solidFill>
+                  <a:srgbClr val="1D3557"/>
+                </a:solidFill>
+                <a:latin typeface="Menlo"/>
+              </a:rPr>
+              <a:t/>
+            </a:r>
+          </a:p>
+          <a:p>
+            <a:pPr/>
+            <a:r>
+              <a:rPr sz="1500" b="0">
+                <a:solidFill>
+                  <a:srgbClr val="1D3557"/>
+                </a:solidFill>
+                <a:latin typeface="Menlo"/>
+              </a:rPr>
+              <a:t># Todo se recalcula sin la fila, y se compara</a:t>
+            </a:r>
+          </a:p>
+          <a:p>
+            <a:pPr/>
+            <a:r>
+              <a:rPr sz="1500" b="0">
+                <a:solidFill>
+                  <a:srgbClr val="1D3557"/>
+                </a:solidFill>
+                <a:latin typeface="Menlo"/>
+              </a:rPr>
+              <a:t>sin_lb["ingreso"].corr(sin_lb["duracion"])</a:t>
+            </a:r>
+          </a:p>
+          <a:p>
+            <a:pPr/>
+            <a:r>
+              <a:rPr sz="1500" b="0">
+                <a:solidFill>
+                  <a:srgbClr val="1D3557"/>
+                </a:solidFill>
+                <a:latin typeface="Menlo"/>
+              </a:rPr>
+              <a:t>np.polyfit(sin_lb["ingreso"] / 1e6, sin_lb["duracion"], 1)</a:t>
+            </a:r>
+          </a:p>
+        </p:txBody>
+      </p:sp>
+      <p:sp>
+        <p:nvSpPr>
+          <p:cNvPr id="5" name="TextBox 4"/>
+          <p:cNvSpPr txBox="1"/>
+          <p:nvPr/>
+        </p:nvSpPr>
+        <p:spPr>
+          <a:xfrm>
+            <a:off x="704088" y="4389120"/>
+            <a:ext cx="7744968" cy="1097280"/>
+          </a:xfrm>
+          <a:prstGeom prst="rect">
+            <a:avLst/>
+          </a:prstGeom>
+          <a:noFill/>
+        </p:spPr>
+        <p:txBody>
+          <a:bodyPr wrap="square">
+            <a:spAutoFit/>
+          </a:bodyPr>
+          <a:lstStyle/>
+          <a:p>
+            <a:pPr>
+              <a:lnSpc>
+                <a:spcPct val="112000"/>
+              </a:lnSpc>
+              <a:spcAft>
+                <a:spcPts val="900"/>
+              </a:spcAft>
+            </a:pPr>
+            <a:r>
+              <a:rPr sz="1600" b="1">
                 <a:solidFill>
                   <a:srgbClr val="E0A437"/>
                 </a:solidFill>
                 <a:latin typeface="Fira Sans"/>
               </a:rPr>
-              <a:t>Que el gráfico diga la verdad y se entienda</a:t>
+              <a:t>▸ </a:t>
+            </a:r>
+            <a:r>
+              <a:rPr sz="1600" b="0">
+                <a:solidFill>
+                  <a:srgbClr val="000000"/>
+                </a:solidFill>
+                <a:latin typeface="Fira Sans"/>
+              </a:rPr>
+              <a:t>Sacar 1 comuna de 45 casi no mueve r (−0,37 a −0,39) pero cambia la pendiente en un cuarto (−5,8 a −7,3): el impacto se mide con y sin, sobre todos los resúmenes en uso.</a:t>
             </a:r>
           </a:p>
         </p:txBody>
@@ -7947,7 +8091,7 @@
             <a:avLst/>
           </a:prstGeom>
           <a:solidFill>
-            <a:srgbClr val="FAFBFC"/>
+            <a:srgbClr val="1D3557"/>
           </a:solidFill>
           <a:ln>
             <a:noFill/>
@@ -7984,8 +8128,8 @@
         </p:nvSpPr>
         <p:spPr>
           <a:xfrm>
-            <a:off x="402336" y="301752"/>
-            <a:ext cx="8348472" cy="795528"/>
+            <a:off x="603504" y="1847088"/>
+            <a:ext cx="7946136" cy="1399032"/>
           </a:xfrm>
           <a:prstGeom prst="rect">
             <a:avLst/>
@@ -7999,71 +8143,24 @@
           <a:lstStyle/>
           <a:p>
             <a:r>
-              <a:rPr sz="2800" b="1">
-                <a:solidFill>
-                  <a:srgbClr val="0F0F0F"/>
-                </a:solidFill>
-                <a:latin typeface="Fira Sans"/>
-              </a:rPr>
-              <a:t>Graficar 90 mil puntos: overplotting</a:t>
-            </a:r>
-          </a:p>
-        </p:txBody>
-      </p:sp>
-      <p:pic>
-        <p:nvPicPr>
-          <p:cNvPr id="4" name="Picture 3" descr="c3_08_overplotting.png"/>
-          <p:cNvPicPr>
-            <a:picLocks noChangeAspect="1"/>
-          </p:cNvPicPr>
-          <p:nvPr/>
-        </p:nvPicPr>
-        <p:blipFill>
-          <a:blip r:embed="rId2"/>
-          <a:stretch>
-            <a:fillRect/>
-          </a:stretch>
-        </p:blipFill>
-        <p:spPr>
-          <a:xfrm>
-            <a:off x="1417319" y="1143000"/>
-            <a:ext cx="6309360" cy="1913950"/>
-          </a:xfrm>
-          <a:prstGeom prst="rect">
-            <a:avLst/>
-          </a:prstGeom>
-        </p:spPr>
-      </p:pic>
-      <p:sp>
-        <p:nvSpPr>
-          <p:cNvPr id="5" name="TextBox 4"/>
-          <p:cNvSpPr txBox="1"/>
-          <p:nvPr/>
-        </p:nvSpPr>
-        <p:spPr>
-          <a:xfrm>
-            <a:off x="704088" y="4434840"/>
-            <a:ext cx="7744968" cy="457200"/>
-          </a:xfrm>
-          <a:prstGeom prst="rect">
-            <a:avLst/>
-          </a:prstGeom>
-          <a:noFill/>
-        </p:spPr>
-        <p:txBody>
-          <a:bodyPr wrap="square">
-            <a:spAutoFit/>
-          </a:bodyPr>
-          <a:lstStyle/>
-          <a:p>
-            <a:r>
-              <a:rPr sz="1300" b="0">
-                <a:solidFill>
-                  <a:srgbClr val="333333"/>
-                </a:solidFill>
-                <a:latin typeface="Fira Sans"/>
-              </a:rPr>
-              <a:t>Con todos los puntos sólidos, el scatter se satura y miente. Los remedios: transparencia (alpha), muestreo, o hexbin, donde el color cuenta los viajes (la distancia se calcula con las coordenadas; el notebook muestra el cálculo).</a:t>
+              <a:rPr sz="3400" b="1">
+                <a:solidFill>
+                  <a:srgbClr val="FFFFFF"/>
+                </a:solidFill>
+                <a:latin typeface="Fira Sans"/>
+              </a:rPr>
+              <a:t>Buenas prácticas de visualización</a:t>
+            </a:r>
+          </a:p>
+          <a:p>
+            <a:r>
+              <a:rPr sz="1800" b="0">
+                <a:solidFill>
+                  <a:srgbClr val="E0A437"/>
+                </a:solidFill>
+                <a:latin typeface="Fira Sans"/>
+              </a:rPr>
+              <a:t>Que el gráfico diga la verdad y se entienda</a:t>
             </a:r>
           </a:p>
         </p:txBody>
@@ -8159,14 +8256,14 @@
                 </a:solidFill>
                 <a:latin typeface="Fira Sans"/>
               </a:rPr>
-              <a:t>Cuándo usar escala logarítmica</a:t>
+              <a:t>Graficar 90 mil puntos: overplotting</a:t>
             </a:r>
           </a:p>
         </p:txBody>
       </p:sp>
       <p:pic>
         <p:nvPicPr>
-          <p:cNvPr id="4" name="Picture 3" descr="c3_10_escala_log.png"/>
+          <p:cNvPr id="4" name="Picture 3" descr="c3_08_overplotting.png"/>
           <p:cNvPicPr>
             <a:picLocks noChangeAspect="1"/>
           </p:cNvPicPr>
@@ -8181,7 +8278,7 @@
         <p:spPr>
           <a:xfrm>
             <a:off x="1417319" y="1143000"/>
-            <a:ext cx="6309360" cy="2432846"/>
+            <a:ext cx="6309360" cy="1913950"/>
           </a:xfrm>
           <a:prstGeom prst="rect">
             <a:avLst/>
@@ -8217,7 +8314,7 @@
                 </a:solidFill>
                 <a:latin typeface="Fira Sans"/>
               </a:rPr>
-              <a:t>Con colas largas como el ingreso, la escala lineal aplasta el 99% de los datos contra el borde; la logarítmica reparte el espacio y la forma aparece.</a:t>
+              <a:t>Con todos los puntos sólidos, el scatter se satura y miente. Los remedios: transparencia (alpha), muestreo, o hexbin, donde el color cuenta los viajes (la distancia se calcula con las coordenadas; el notebook muestra el cálculo).</a:t>
             </a:r>
           </a:p>
         </p:txBody>
@@ -8313,14 +8410,14 @@
                 </a:solidFill>
                 <a:latin typeface="Fira Sans"/>
               </a:rPr>
-              <a:t>El mismo gráfico, dos veces</a:t>
+              <a:t>Cuándo usar escala logarítmica</a:t>
             </a:r>
           </a:p>
         </p:txBody>
       </p:sp>
       <p:pic>
         <p:nvPicPr>
-          <p:cNvPr id="4" name="Picture 3" descr="c3_16_mal_buen_grafico.png"/>
+          <p:cNvPr id="4" name="Picture 3" descr="c3_10_escala_log.png"/>
           <p:cNvPicPr>
             <a:picLocks noChangeAspect="1"/>
           </p:cNvPicPr>
@@ -8335,7 +8432,7 @@
         <p:spPr>
           <a:xfrm>
             <a:off x="1417319" y="1143000"/>
-            <a:ext cx="6309360" cy="2447822"/>
+            <a:ext cx="6309360" cy="2432846"/>
           </a:xfrm>
           <a:prstGeom prst="rect">
             <a:avLst/>
@@ -8371,7 +8468,7 @@
                 </a:solidFill>
                 <a:latin typeface="Fira Sans"/>
               </a:rPr>
-              <a:t>Los mismos 30 mil viajes: sin rotular y saturado, contra rotulado, con transparencia y con el hallazgo en el título.</a:t>
+              <a:t>Con colas largas como el ingreso, la escala lineal aplasta el 99% de los datos contra el borde; la logarítmica reparte el espacio y la forma aparece.</a:t>
             </a:r>
           </a:p>
         </p:txBody>
@@ -8467,21 +8564,45 @@
                 </a:solidFill>
                 <a:latin typeface="Fira Sans"/>
               </a:rPr>
-              <a:t>Checklist del buen gráfico</a:t>
-            </a:r>
-          </a:p>
-        </p:txBody>
-      </p:sp>
-      <p:sp>
-        <p:nvSpPr>
-          <p:cNvPr id="4" name="TextBox 3"/>
+              <a:t>El mismo gráfico, dos veces</a:t>
+            </a:r>
+          </a:p>
+        </p:txBody>
+      </p:sp>
+      <p:pic>
+        <p:nvPicPr>
+          <p:cNvPr id="4" name="Picture 3" descr="c3_16_mal_buen_grafico.png"/>
+          <p:cNvPicPr>
+            <a:picLocks noChangeAspect="1"/>
+          </p:cNvPicPr>
+          <p:nvPr/>
+        </p:nvPicPr>
+        <p:blipFill>
+          <a:blip r:embed="rId2"/>
+          <a:stretch>
+            <a:fillRect/>
+          </a:stretch>
+        </p:blipFill>
+        <p:spPr>
+          <a:xfrm>
+            <a:off x="1417319" y="1143000"/>
+            <a:ext cx="6309360" cy="2447822"/>
+          </a:xfrm>
+          <a:prstGeom prst="rect">
+            <a:avLst/>
+          </a:prstGeom>
+        </p:spPr>
+      </p:pic>
+      <p:sp>
+        <p:nvSpPr>
+          <p:cNvPr id="5" name="TextBox 4"/>
           <p:cNvSpPr txBox="1"/>
           <p:nvPr/>
         </p:nvSpPr>
         <p:spPr>
           <a:xfrm>
-            <a:off x="704088" y="1353312"/>
-            <a:ext cx="7744968" cy="3300984"/>
+            <a:off x="704088" y="4434840"/>
+            <a:ext cx="7744968" cy="457200"/>
           </a:xfrm>
           <a:prstGeom prst="rect">
             <a:avLst/>
@@ -8494,143 +8615,14 @@
           </a:bodyPr>
           <a:lstStyle/>
           <a:p>
-            <a:pPr>
-              <a:lnSpc>
-                <a:spcPct val="112000"/>
-              </a:lnSpc>
-              <a:spcAft>
-                <a:spcPts val="900"/>
-              </a:spcAft>
-            </a:pPr>
-            <a:r>
-              <a:rPr sz="1800" b="1">
-                <a:solidFill>
-                  <a:srgbClr val="E0A437"/>
-                </a:solidFill>
-                <a:latin typeface="Fira Sans"/>
-              </a:rPr>
-              <a:t>▸ </a:t>
-            </a:r>
-            <a:r>
-              <a:rPr sz="1800" b="0">
-                <a:solidFill>
-                  <a:srgbClr val="000000"/>
-                </a:solidFill>
-                <a:latin typeface="Fira Sans"/>
-              </a:rPr>
-              <a:t>Título que diga el hallazgo, no solo las variables.</a:t>
-            </a:r>
-          </a:p>
-          <a:p>
-            <a:pPr>
-              <a:lnSpc>
-                <a:spcPct val="112000"/>
-              </a:lnSpc>
-              <a:spcAft>
-                <a:spcPts val="900"/>
-              </a:spcAft>
-            </a:pPr>
-            <a:r>
-              <a:rPr sz="1800" b="1">
-                <a:solidFill>
-                  <a:srgbClr val="E0A437"/>
-                </a:solidFill>
-                <a:latin typeface="Fira Sans"/>
-              </a:rPr>
-              <a:t>▸ </a:t>
-            </a:r>
-            <a:r>
-              <a:rPr sz="1800" b="0">
-                <a:solidFill>
-                  <a:srgbClr val="000000"/>
-                </a:solidFill>
-                <a:latin typeface="Fira Sans"/>
-              </a:rPr>
-              <a:t>Ejes con nombre y unidad; ejes que parten de cero en gráficos de barras.</a:t>
-            </a:r>
-          </a:p>
-          <a:p>
-            <a:pPr>
-              <a:lnSpc>
-                <a:spcPct val="112000"/>
-              </a:lnSpc>
-              <a:spcAft>
-                <a:spcPts val="900"/>
-              </a:spcAft>
-            </a:pPr>
-            <a:r>
-              <a:rPr sz="1800" b="1">
-                <a:solidFill>
-                  <a:srgbClr val="E0A437"/>
-                </a:solidFill>
-                <a:latin typeface="Fira Sans"/>
-              </a:rPr>
-              <a:t>▸ </a:t>
-            </a:r>
-            <a:r>
-              <a:rPr sz="1800" b="0">
-                <a:solidFill>
-                  <a:srgbClr val="000000"/>
-                </a:solidFill>
-                <a:latin typeface="Fira Sans"/>
-              </a:rPr>
-              <a:t>Muchos puntos: alpha, muestreo o hexbin.</a:t>
-            </a:r>
-          </a:p>
-          <a:p>
-            <a:pPr>
-              <a:lnSpc>
-                <a:spcPct val="112000"/>
-              </a:lnSpc>
-              <a:spcAft>
-                <a:spcPts val="900"/>
-              </a:spcAft>
-            </a:pPr>
-            <a:r>
-              <a:rPr sz="1800" b="1">
-                <a:solidFill>
-                  <a:srgbClr val="E0A437"/>
-                </a:solidFill>
-                <a:latin typeface="Fira Sans"/>
-              </a:rPr>
-              <a:t>▸ </a:t>
-            </a:r>
-            <a:r>
-              <a:rPr sz="1800" b="0">
-                <a:solidFill>
-                  <a:srgbClr val="000000"/>
-                </a:solidFill>
-                <a:latin typeface="Fira Sans"/>
-              </a:rPr>
-              <a:t>Colas largas: escala logarítmica o eje recortado, declarándolo.</a:t>
-            </a:r>
-          </a:p>
-          <a:p>
-            <a:pPr>
-              <a:lnSpc>
-                <a:spcPct val="112000"/>
-              </a:lnSpc>
-              <a:spcAft>
-                <a:spcPts val="900"/>
-              </a:spcAft>
-            </a:pPr>
-            <a:r>
-              <a:rPr sz="1800" b="1">
-                <a:solidFill>
-                  <a:srgbClr val="E0A437"/>
-                </a:solidFill>
-                <a:latin typeface="Fira Sans"/>
-              </a:rPr>
-              <a:t>▸ </a:t>
-            </a:r>
-            <a:r>
-              <a:rPr sz="1800" b="1">
-                <a:solidFill>
-                  <a:srgbClr val="1D3557"/>
-                </a:solidFill>
-                <a:latin typeface="Fira Sans"/>
-              </a:rPr>
-              <a:t>El gráfico se corrige igual que el código: se itera hasta que un tercero lo entienda sin explicación oral.</a:t>
+            <a:r>
+              <a:rPr sz="1300" b="0">
+                <a:solidFill>
+                  <a:srgbClr val="333333"/>
+                </a:solidFill>
+                <a:latin typeface="Fira Sans"/>
+              </a:rPr>
+              <a:t>Los mismos 30 mil viajes: sin rotular y saturado, contra rotulado, con transparencia y con el hallazgo en el título.</a:t>
             </a:r>
           </a:p>
         </p:txBody>
@@ -8726,7 +8718,7 @@
                 </a:solidFill>
                 <a:latin typeface="Fira Sans"/>
               </a:rPr>
-              <a:t>Síntesis</a:t>
+              <a:t>Checklist del buen gráfico</a:t>
             </a:r>
           </a:p>
         </p:txBody>
@@ -8777,7 +8769,7 @@
                 </a:solidFill>
                 <a:latin typeface="Fira Sans"/>
               </a:rPr>
-              <a:t>El análisis bivariado se elige según el par de tipos: scatter y correlación, groupby y boxplot, o tabla de contingencia.</a:t>
+              <a:t>Título que diga el hallazgo, no solo las variables.</a:t>
             </a:r>
           </a:p>
           <a:p>
@@ -8805,7 +8797,7 @@
                 </a:solidFill>
                 <a:latin typeface="Fira Sans"/>
               </a:rPr>
-              <a:t>Pearson para relaciones lineales; Spearman cuando hay atípicos o curvas. Y siempre graficar: Anscombe.</a:t>
+              <a:t>Ejes con nombre y unidad; ejes que parten de cero en gráficos de barras.</a:t>
             </a:r>
           </a:p>
           <a:p>
@@ -8833,7 +8825,7 @@
                 </a:solidFill>
                 <a:latin typeface="Fira Sans"/>
               </a:rPr>
-              <a:t>Correlación no es causalidad: reportamos asociación.</a:t>
+              <a:t>Muchos puntos: alpha, muestreo o hexbin.</a:t>
             </a:r>
           </a:p>
           <a:p>
@@ -8861,7 +8853,7 @@
                 </a:solidFill>
                 <a:latin typeface="Fira Sans"/>
               </a:rPr>
-              <a:t>La regresión es el primer modelo: una función que resume, predice y deja residuos que diagnostican.</a:t>
+              <a:t>Colas largas: escala logarítmica o eje recortado, declarándolo.</a:t>
             </a:r>
           </a:p>
           <a:p>
@@ -8889,7 +8881,7 @@
                 </a:solidFill>
                 <a:latin typeface="Fira Sans"/>
               </a:rPr>
-              <a:t>Todo lo de hoy es exactamente lo que el primer EDA del proyecto debe mostrar (entrega: lunes 15).</a:t>
+              <a:t>El gráfico se corrige igual que el código: se itera hasta que un tercero lo entienda sin explicación oral.</a:t>
             </a:r>
           </a:p>
         </p:txBody>
@@ -8985,7 +8977,7 @@
                 </a:solidFill>
                 <a:latin typeface="Fira Sans"/>
               </a:rPr>
-              <a:t>Próxima clase</a:t>
+              <a:t>Síntesis</a:t>
             </a:r>
           </a:p>
         </p:txBody>
@@ -9030,13 +9022,13 @@
               <a:t>▸ </a:t>
             </a:r>
             <a:r>
-              <a:rPr sz="1800" b="1">
-                <a:solidFill>
-                  <a:srgbClr val="1D3557"/>
-                </a:solidFill>
-                <a:latin typeface="Fira Sans"/>
-              </a:rPr>
-              <a:t>Jueves 3 de septiembre: presentaciones breves de las ideas de proyecto (5 minutos por equipo, sin nota).</a:t>
+              <a:rPr sz="1800" b="0">
+                <a:solidFill>
+                  <a:srgbClr val="000000"/>
+                </a:solidFill>
+                <a:latin typeface="Fira Sans"/>
+              </a:rPr>
+              <a:t>El análisis bivariado se elige según el par de tipos: scatter y correlación, groupby y boxplot, o tabla de contingencia.</a:t>
             </a:r>
           </a:p>
           <a:p>
@@ -9064,7 +9056,7 @@
                 </a:solidFill>
                 <a:latin typeface="Fira Sans"/>
               </a:rPr>
-              <a:t>Después: fundamentos de probabilidad, la base para la inferencia de las clases siguientes.</a:t>
+              <a:t>Pearson para relaciones lineales; Spearman cuando hay atípicos o curvas. Y siempre graficar: Anscombe.</a:t>
             </a:r>
           </a:p>
           <a:p>
@@ -9092,7 +9084,7 @@
                 </a:solidFill>
                 <a:latin typeface="Fira Sans"/>
               </a:rPr>
-              <a:t>Se publica la rúbrica del primer análisis exploratorio.</a:t>
+              <a:t>Correlación no es causalidad: reportamos asociación.</a:t>
             </a:r>
           </a:p>
           <a:p>
@@ -9120,7 +9112,35 @@
                 </a:solidFill>
                 <a:latin typeface="Fira Sans"/>
               </a:rPr>
-              <a:t>Recuerden: la formulación se entrega el lunes 7 por el aula virtual.</a:t>
+              <a:t>La regresión es el primer modelo: una función que resume, predice y deja residuos que diagnostican.</a:t>
+            </a:r>
+          </a:p>
+          <a:p>
+            <a:pPr>
+              <a:lnSpc>
+                <a:spcPct val="112000"/>
+              </a:lnSpc>
+              <a:spcAft>
+                <a:spcPts val="900"/>
+              </a:spcAft>
+            </a:pPr>
+            <a:r>
+              <a:rPr sz="1800" b="1">
+                <a:solidFill>
+                  <a:srgbClr val="E0A437"/>
+                </a:solidFill>
+                <a:latin typeface="Fira Sans"/>
+              </a:rPr>
+              <a:t>▸ </a:t>
+            </a:r>
+            <a:r>
+              <a:rPr sz="1800" b="1">
+                <a:solidFill>
+                  <a:srgbClr val="1D3557"/>
+                </a:solidFill>
+                <a:latin typeface="Fira Sans"/>
+              </a:rPr>
+              <a:t>Todo lo de hoy es exactamente lo que el primer EDA del proyecto debe mostrar (entrega: lunes 15).</a:t>
             </a:r>
           </a:p>
         </p:txBody>
@@ -9393,6 +9413,237 @@
 </file>
 
 <file path=ppt/slides/slide40.xml><?xml version="1.0" encoding="utf-8"?>
+<p:sld xmlns:a="http://schemas.openxmlformats.org/drawingml/2006/main" xmlns:p="http://schemas.openxmlformats.org/presentationml/2006/main" xmlns:r="http://schemas.openxmlformats.org/officeDocument/2006/relationships">
+  <p:cSld>
+    <p:spTree>
+      <p:nvGrpSpPr>
+        <p:cNvPr id="1" name=""/>
+        <p:cNvGrpSpPr/>
+        <p:nvPr/>
+      </p:nvGrpSpPr>
+      <p:grpSpPr/>
+      <p:sp>
+        <p:nvSpPr>
+          <p:cNvPr id="2" name="Rectangle 1"/>
+          <p:cNvSpPr/>
+          <p:nvPr/>
+        </p:nvSpPr>
+        <p:spPr>
+          <a:xfrm>
+            <a:off x="0" y="0"/>
+            <a:ext cx="9144000" cy="5138928"/>
+          </a:xfrm>
+          <a:prstGeom prst="rect">
+            <a:avLst/>
+          </a:prstGeom>
+          <a:solidFill>
+            <a:srgbClr val="FAFBFC"/>
+          </a:solidFill>
+          <a:ln>
+            <a:noFill/>
+          </a:ln>
+          <a:effectLst/>
+        </p:spPr>
+        <p:style>
+          <a:lnRef idx="1">
+            <a:schemeClr val="accent1"/>
+          </a:lnRef>
+          <a:fillRef idx="3">
+            <a:schemeClr val="accent1"/>
+          </a:fillRef>
+          <a:effectRef idx="2">
+            <a:schemeClr val="accent1"/>
+          </a:effectRef>
+          <a:fontRef idx="minor">
+            <a:schemeClr val="lt1"/>
+          </a:fontRef>
+        </p:style>
+        <p:txBody>
+          <a:bodyPr rtlCol="0" anchor="ctr"/>
+          <a:lstStyle/>
+          <a:p>
+            <a:pPr algn="ctr"/>
+          </a:p>
+        </p:txBody>
+      </p:sp>
+      <p:sp>
+        <p:nvSpPr>
+          <p:cNvPr id="3" name="TextBox 2"/>
+          <p:cNvSpPr txBox="1"/>
+          <p:nvPr/>
+        </p:nvSpPr>
+        <p:spPr>
+          <a:xfrm>
+            <a:off x="402336" y="301752"/>
+            <a:ext cx="8348472" cy="795528"/>
+          </a:xfrm>
+          <a:prstGeom prst="rect">
+            <a:avLst/>
+          </a:prstGeom>
+          <a:noFill/>
+        </p:spPr>
+        <p:txBody>
+          <a:bodyPr wrap="square">
+            <a:spAutoFit/>
+          </a:bodyPr>
+          <a:lstStyle/>
+          <a:p>
+            <a:r>
+              <a:rPr sz="2800" b="1">
+                <a:solidFill>
+                  <a:srgbClr val="0F0F0F"/>
+                </a:solidFill>
+                <a:latin typeface="Fira Sans"/>
+              </a:rPr>
+              <a:t>Próxima clase</a:t>
+            </a:r>
+          </a:p>
+        </p:txBody>
+      </p:sp>
+      <p:sp>
+        <p:nvSpPr>
+          <p:cNvPr id="4" name="TextBox 3"/>
+          <p:cNvSpPr txBox="1"/>
+          <p:nvPr/>
+        </p:nvSpPr>
+        <p:spPr>
+          <a:xfrm>
+            <a:off x="704088" y="1353312"/>
+            <a:ext cx="7744968" cy="3300984"/>
+          </a:xfrm>
+          <a:prstGeom prst="rect">
+            <a:avLst/>
+          </a:prstGeom>
+          <a:noFill/>
+        </p:spPr>
+        <p:txBody>
+          <a:bodyPr wrap="square">
+            <a:spAutoFit/>
+          </a:bodyPr>
+          <a:lstStyle/>
+          <a:p>
+            <a:pPr>
+              <a:lnSpc>
+                <a:spcPct val="112000"/>
+              </a:lnSpc>
+              <a:spcAft>
+                <a:spcPts val="900"/>
+              </a:spcAft>
+            </a:pPr>
+            <a:r>
+              <a:rPr sz="1800" b="1">
+                <a:solidFill>
+                  <a:srgbClr val="E0A437"/>
+                </a:solidFill>
+                <a:latin typeface="Fira Sans"/>
+              </a:rPr>
+              <a:t>▸ </a:t>
+            </a:r>
+            <a:r>
+              <a:rPr sz="1800" b="1">
+                <a:solidFill>
+                  <a:srgbClr val="1D3557"/>
+                </a:solidFill>
+                <a:latin typeface="Fira Sans"/>
+              </a:rPr>
+              <a:t>Jueves 3 de septiembre: presentaciones breves de las ideas de proyecto (5 minutos por equipo, sin nota).</a:t>
+            </a:r>
+          </a:p>
+          <a:p>
+            <a:pPr>
+              <a:lnSpc>
+                <a:spcPct val="112000"/>
+              </a:lnSpc>
+              <a:spcAft>
+                <a:spcPts val="900"/>
+              </a:spcAft>
+            </a:pPr>
+            <a:r>
+              <a:rPr sz="1800" b="1">
+                <a:solidFill>
+                  <a:srgbClr val="E0A437"/>
+                </a:solidFill>
+                <a:latin typeface="Fira Sans"/>
+              </a:rPr>
+              <a:t>▸ </a:t>
+            </a:r>
+            <a:r>
+              <a:rPr sz="1800" b="0">
+                <a:solidFill>
+                  <a:srgbClr val="000000"/>
+                </a:solidFill>
+                <a:latin typeface="Fira Sans"/>
+              </a:rPr>
+              <a:t>Después: fundamentos de probabilidad, la base para la inferencia de las clases siguientes.</a:t>
+            </a:r>
+          </a:p>
+          <a:p>
+            <a:pPr>
+              <a:lnSpc>
+                <a:spcPct val="112000"/>
+              </a:lnSpc>
+              <a:spcAft>
+                <a:spcPts val="900"/>
+              </a:spcAft>
+            </a:pPr>
+            <a:r>
+              <a:rPr sz="1800" b="1">
+                <a:solidFill>
+                  <a:srgbClr val="E0A437"/>
+                </a:solidFill>
+                <a:latin typeface="Fira Sans"/>
+              </a:rPr>
+              <a:t>▸ </a:t>
+            </a:r>
+            <a:r>
+              <a:rPr sz="1800" b="0">
+                <a:solidFill>
+                  <a:srgbClr val="000000"/>
+                </a:solidFill>
+                <a:latin typeface="Fira Sans"/>
+              </a:rPr>
+              <a:t>Se publica la rúbrica del primer análisis exploratorio.</a:t>
+            </a:r>
+          </a:p>
+          <a:p>
+            <a:pPr>
+              <a:lnSpc>
+                <a:spcPct val="112000"/>
+              </a:lnSpc>
+              <a:spcAft>
+                <a:spcPts val="900"/>
+              </a:spcAft>
+            </a:pPr>
+            <a:r>
+              <a:rPr sz="1800" b="1">
+                <a:solidFill>
+                  <a:srgbClr val="E0A437"/>
+                </a:solidFill>
+                <a:latin typeface="Fira Sans"/>
+              </a:rPr>
+              <a:t>▸ </a:t>
+            </a:r>
+            <a:r>
+              <a:rPr sz="1800" b="0">
+                <a:solidFill>
+                  <a:srgbClr val="000000"/>
+                </a:solidFill>
+                <a:latin typeface="Fira Sans"/>
+              </a:rPr>
+              <a:t>Recuerden: la formulación se entrega el lunes 7 por el aula virtual.</a:t>
+            </a:r>
+          </a:p>
+        </p:txBody>
+      </p:sp>
+    </p:spTree>
+  </p:cSld>
+  <p:clrMapOvr>
+    <a:masterClrMapping/>
+  </p:clrMapOvr>
+</p:sld>
+</file>
+
+<file path=ppt/slides/slide41.xml><?xml version="1.0" encoding="utf-8"?>
 <p:sld xmlns:a="http://schemas.openxmlformats.org/drawingml/2006/main" xmlns:p="http://schemas.openxmlformats.org/presentationml/2006/main" xmlns:r="http://schemas.openxmlformats.org/officeDocument/2006/relationships">
   <p:cSld>
     <p:spTree>

</xml_diff>

<commit_message>
Clase 3: modelo de motorizacion del hogar y la trampa de sacar atipicos de la variable objetivo
Co-Authored-By: Claude Fable 5 <noreply@anthropic.com>
</commit_message>
<xml_diff>
--- a/presentaciones/clase03_eda_bivariado.pptx
+++ b/presentaciones/clase03_eda_bivariado.pptx
@@ -46,6 +46,8 @@
     <p:sldId id="294" r:id="rId45"/>
     <p:sldId id="295" r:id="rId46"/>
     <p:sldId id="296" r:id="rId47"/>
+    <p:sldId id="297" r:id="rId48"/>
+    <p:sldId id="298" r:id="rId49"/>
   </p:sldIdLst>
   <p:sldSz cx="9144000" cy="5138928" type="screen4x3"/>
   <p:notesSz cx="6858000" cy="9144000"/>
@@ -8091,7 +8093,7 @@
             <a:avLst/>
           </a:prstGeom>
           <a:solidFill>
-            <a:srgbClr val="1D3557"/>
+            <a:srgbClr val="FAFBFC"/>
           </a:solidFill>
           <a:ln>
             <a:noFill/>
@@ -8128,8 +8130,8 @@
         </p:nvSpPr>
         <p:spPr>
           <a:xfrm>
-            <a:off x="603504" y="1847088"/>
-            <a:ext cx="7946136" cy="1399032"/>
+            <a:off x="402336" y="301752"/>
+            <a:ext cx="8348472" cy="795528"/>
           </a:xfrm>
           <a:prstGeom prst="rect">
             <a:avLst/>
@@ -8143,24 +8145,167 @@
           <a:lstStyle/>
           <a:p>
             <a:r>
-              <a:rPr sz="3400" b="1">
-                <a:solidFill>
-                  <a:srgbClr val="FFFFFF"/>
-                </a:solidFill>
-                <a:latin typeface="Fira Sans"/>
-              </a:rPr>
-              <a:t>Buenas prácticas de visualización</a:t>
-            </a:r>
-          </a:p>
-          <a:p>
-            <a:r>
-              <a:rPr sz="1800" b="0">
+              <a:rPr sz="2800" b="1">
+                <a:solidFill>
+                  <a:srgbClr val="0F0F0F"/>
+                </a:solidFill>
+                <a:latin typeface="Fira Sans"/>
+              </a:rPr>
+              <a:t>Otro modelo: la motorización del hogar</a:t>
+            </a:r>
+          </a:p>
+        </p:txBody>
+      </p:sp>
+      <p:sp>
+        <p:nvSpPr>
+          <p:cNvPr id="4" name="Rectangle 3"/>
+          <p:cNvSpPr/>
+          <p:nvPr/>
+        </p:nvSpPr>
+        <p:spPr>
+          <a:xfrm>
+            <a:off x="704088" y="1280160"/>
+            <a:ext cx="7744968" cy="2880360"/>
+          </a:xfrm>
+          <a:prstGeom prst="rect">
+            <a:avLst/>
+          </a:prstGeom>
+          <a:solidFill>
+            <a:srgbClr val="F0F2F5"/>
+          </a:solidFill>
+          <a:ln>
+            <a:solidFill>
+              <a:srgbClr val="D8DDE3"/>
+            </a:solidFill>
+          </a:ln>
+          <a:effectLst/>
+        </p:spPr>
+        <p:style>
+          <a:lnRef idx="1">
+            <a:schemeClr val="accent1"/>
+          </a:lnRef>
+          <a:fillRef idx="3">
+            <a:schemeClr val="accent1"/>
+          </a:fillRef>
+          <a:effectRef idx="2">
+            <a:schemeClr val="accent1"/>
+          </a:effectRef>
+          <a:fontRef idx="minor">
+            <a:schemeClr val="lt1"/>
+          </a:fontRef>
+        </p:style>
+        <p:txBody>
+          <a:bodyPr rtlCol="0" anchor="ctr" wrap="square" lIns="228600" tIns="137160"/>
+          <a:lstStyle/>
+          <a:p>
+            <a:pPr/>
+            <a:r>
+              <a:rPr sz="1500" b="0">
+                <a:solidFill>
+                  <a:srgbClr val="1D3557"/>
+                </a:solidFill>
+                <a:latin typeface="Menlo"/>
+              </a:rPr>
+              <a:t>h = hogares.dropna(subset=["IngresoHogar", "NumVeh"])</a:t>
+            </a:r>
+          </a:p>
+          <a:p>
+            <a:pPr/>
+            <a:r>
+              <a:rPr sz="1500" b="0">
+                <a:solidFill>
+                  <a:srgbClr val="1D3557"/>
+                </a:solidFill>
+                <a:latin typeface="Menlo"/>
+              </a:rPr>
+              <a:t/>
+            </a:r>
+          </a:p>
+          <a:p>
+            <a:pPr/>
+            <a:r>
+              <a:rPr sz="1500" b="0">
+                <a:solidFill>
+                  <a:srgbClr val="1D3557"/>
+                </a:solidFill>
+                <a:latin typeface="Menlo"/>
+              </a:rPr>
+              <a:t># ¿Cuántos vehículos tendrá un hogar, según su ingreso?</a:t>
+            </a:r>
+          </a:p>
+          <a:p>
+            <a:pPr/>
+            <a:r>
+              <a:rPr sz="1500" b="0">
+                <a:solidFill>
+                  <a:srgbClr val="1D3557"/>
+                </a:solidFill>
+                <a:latin typeface="Menlo"/>
+              </a:rPr>
+              <a:t>pendiente, intercepto = np.polyfit(h["IngresoHogar"] / 1e6,</a:t>
+            </a:r>
+          </a:p>
+          <a:p>
+            <a:pPr/>
+            <a:r>
+              <a:rPr sz="1500" b="0">
+                <a:solidFill>
+                  <a:srgbClr val="1D3557"/>
+                </a:solidFill>
+                <a:latin typeface="Menlo"/>
+              </a:rPr>
+              <a:t>                                   h["NumVeh"], 1)</a:t>
+            </a:r>
+          </a:p>
+        </p:txBody>
+      </p:sp>
+      <p:sp>
+        <p:nvSpPr>
+          <p:cNvPr id="5" name="TextBox 4"/>
+          <p:cNvSpPr txBox="1"/>
+          <p:nvPr/>
+        </p:nvSpPr>
+        <p:spPr>
+          <a:xfrm>
+            <a:off x="704088" y="4389120"/>
+            <a:ext cx="7744968" cy="1097280"/>
+          </a:xfrm>
+          <a:prstGeom prst="rect">
+            <a:avLst/>
+          </a:prstGeom>
+          <a:noFill/>
+        </p:spPr>
+        <p:txBody>
+          <a:bodyPr wrap="square">
+            <a:spAutoFit/>
+          </a:bodyPr>
+          <a:lstStyle/>
+          <a:p>
+            <a:pPr>
+              <a:lnSpc>
+                <a:spcPct val="112000"/>
+              </a:lnSpc>
+              <a:spcAft>
+                <a:spcPts val="900"/>
+              </a:spcAft>
+            </a:pPr>
+            <a:r>
+              <a:rPr sz="1600" b="1">
                 <a:solidFill>
                   <a:srgbClr val="E0A437"/>
                 </a:solidFill>
                 <a:latin typeface="Fira Sans"/>
               </a:rPr>
-              <a:t>Que el gráfico diga la verdad y se entienda</a:t>
+              <a:t>▸ </a:t>
+            </a:r>
+            <a:r>
+              <a:rPr sz="1600" b="0">
+                <a:solidFill>
+                  <a:srgbClr val="000000"/>
+                </a:solidFill>
+                <a:latin typeface="Fira Sans"/>
+              </a:rPr>
+              <a:t>18.264 hogares, cada fila un hogar real: vehículos = 0,18 + 0,45 · ingreso. Casi medio vehículo más por millón (r = 0,47).</a:t>
             </a:r>
           </a:p>
         </p:txBody>
@@ -8256,35 +8401,114 @@
                 </a:solidFill>
                 <a:latin typeface="Fira Sans"/>
               </a:rPr>
-              <a:t>Graficar 90 mil puntos: overplotting</a:t>
-            </a:r>
-          </a:p>
-        </p:txBody>
-      </p:sp>
-      <p:pic>
-        <p:nvPicPr>
-          <p:cNvPr id="4" name="Picture 3" descr="c3_08_overplotting.png"/>
-          <p:cNvPicPr>
-            <a:picLocks noChangeAspect="1"/>
-          </p:cNvPicPr>
-          <p:nvPr/>
-        </p:nvPicPr>
-        <p:blipFill>
-          <a:blip r:embed="rId2"/>
-          <a:stretch>
-            <a:fillRect/>
-          </a:stretch>
-        </p:blipFill>
-        <p:spPr>
-          <a:xfrm>
-            <a:off x="1417319" y="1143000"/>
-            <a:ext cx="6309360" cy="1913950"/>
-          </a:xfrm>
-          <a:prstGeom prst="rect">
-            <a:avLst/>
-          </a:prstGeom>
-        </p:spPr>
-      </p:pic>
+              <a:t>Sacar atípicos de la variable a predecir</a:t>
+            </a:r>
+          </a:p>
+        </p:txBody>
+      </p:sp>
+      <p:sp>
+        <p:nvSpPr>
+          <p:cNvPr id="4" name="Rectangle 3"/>
+          <p:cNvSpPr/>
+          <p:nvPr/>
+        </p:nvSpPr>
+        <p:spPr>
+          <a:xfrm>
+            <a:off x="704088" y="1280160"/>
+            <a:ext cx="7744968" cy="2880360"/>
+          </a:xfrm>
+          <a:prstGeom prst="rect">
+            <a:avLst/>
+          </a:prstGeom>
+          <a:solidFill>
+            <a:srgbClr val="F0F2F5"/>
+          </a:solidFill>
+          <a:ln>
+            <a:solidFill>
+              <a:srgbClr val="D8DDE3"/>
+            </a:solidFill>
+          </a:ln>
+          <a:effectLst/>
+        </p:spPr>
+        <p:style>
+          <a:lnRef idx="1">
+            <a:schemeClr val="accent1"/>
+          </a:lnRef>
+          <a:fillRef idx="3">
+            <a:schemeClr val="accent1"/>
+          </a:fillRef>
+          <a:effectRef idx="2">
+            <a:schemeClr val="accent1"/>
+          </a:effectRef>
+          <a:fontRef idx="minor">
+            <a:schemeClr val="lt1"/>
+          </a:fontRef>
+        </p:style>
+        <p:txBody>
+          <a:bodyPr rtlCol="0" anchor="ctr" wrap="square" lIns="228600" tIns="137160"/>
+          <a:lstStyle/>
+          <a:p>
+            <a:pPr/>
+            <a:r>
+              <a:rPr sz="1500" b="0">
+                <a:solidFill>
+                  <a:srgbClr val="1D3557"/>
+                </a:solidFill>
+                <a:latin typeface="Menlo"/>
+              </a:rPr>
+              <a:t>q1, q3 = h["NumVeh"].quantile([0.25, 0.75])</a:t>
+            </a:r>
+          </a:p>
+          <a:p>
+            <a:pPr/>
+            <a:r>
+              <a:rPr sz="1500" b="0">
+                <a:solidFill>
+                  <a:srgbClr val="1D3557"/>
+                </a:solidFill>
+                <a:latin typeface="Menlo"/>
+              </a:rPr>
+              <a:t>sin_atipicos = h[h["NumVeh"] &lt;= q3 + 1.5 * (q3 - q1)]</a:t>
+            </a:r>
+          </a:p>
+          <a:p>
+            <a:pPr/>
+            <a:r>
+              <a:rPr sz="1500" b="0">
+                <a:solidFill>
+                  <a:srgbClr val="1D3557"/>
+                </a:solidFill>
+                <a:latin typeface="Menlo"/>
+              </a:rPr>
+              <a:t/>
+            </a:r>
+          </a:p>
+          <a:p>
+            <a:pPr/>
+            <a:r>
+              <a:rPr sz="1500" b="0">
+                <a:solidFill>
+                  <a:srgbClr val="1D3557"/>
+                </a:solidFill>
+                <a:latin typeface="Menlo"/>
+              </a:rPr>
+              <a:t># El mismo modelo, sin los hogares de 3 autos o más</a:t>
+            </a:r>
+          </a:p>
+          <a:p>
+            <a:pPr/>
+            <a:r>
+              <a:rPr sz="1500" b="0">
+                <a:solidFill>
+                  <a:srgbClr val="1D3557"/>
+                </a:solidFill>
+                <a:latin typeface="Menlo"/>
+              </a:rPr>
+              <a:t>np.polyfit(sin_atipicos["IngresoHogar"] / 1e6, sin_atipicos["NumVeh"], 1)</a:t>
+            </a:r>
+          </a:p>
+        </p:txBody>
+      </p:sp>
       <p:sp>
         <p:nvSpPr>
           <p:cNvPr id="5" name="TextBox 4"/>
@@ -8293,8 +8517,8 @@
         </p:nvSpPr>
         <p:spPr>
           <a:xfrm>
-            <a:off x="704088" y="4434840"/>
-            <a:ext cx="7744968" cy="457200"/>
+            <a:off x="704088" y="4389120"/>
+            <a:ext cx="7744968" cy="1097280"/>
           </a:xfrm>
           <a:prstGeom prst="rect">
             <a:avLst/>
@@ -8307,14 +8531,31 @@
           </a:bodyPr>
           <a:lstStyle/>
           <a:p>
-            <a:r>
-              <a:rPr sz="1300" b="0">
-                <a:solidFill>
-                  <a:srgbClr val="333333"/>
-                </a:solidFill>
-                <a:latin typeface="Fira Sans"/>
-              </a:rPr>
-              <a:t>Con todos los puntos sólidos, el scatter se satura y miente. Los remedios: transparencia (alpha), muestreo, o hexbin, donde el color cuenta los viajes (la distancia se calcula con las coordenadas; el notebook muestra el cálculo).</a:t>
+            <a:pPr>
+              <a:lnSpc>
+                <a:spcPct val="112000"/>
+              </a:lnSpc>
+              <a:spcAft>
+                <a:spcPts val="900"/>
+              </a:spcAft>
+            </a:pPr>
+            <a:r>
+              <a:rPr sz="1600" b="1">
+                <a:solidFill>
+                  <a:srgbClr val="E0A437"/>
+                </a:solidFill>
+                <a:latin typeface="Fira Sans"/>
+              </a:rPr>
+              <a:t>▸ </a:t>
+            </a:r>
+            <a:r>
+              <a:rPr sz="1600" b="0">
+                <a:solidFill>
+                  <a:srgbClr val="000000"/>
+                </a:solidFill>
+                <a:latin typeface="Fira Sans"/>
+              </a:rPr>
+              <a:t>Sacar 236 hogares aplana la pendiente (0,45 a 0,39): no eran errores, eran la señal. Los atípicos de y se investigan; se eliminan solo por dominio.</a:t>
             </a:r>
           </a:p>
         </p:txBody>
@@ -8352,7 +8593,7 @@
             <a:avLst/>
           </a:prstGeom>
           <a:solidFill>
-            <a:srgbClr val="FAFBFC"/>
+            <a:srgbClr val="1D3557"/>
           </a:solidFill>
           <a:ln>
             <a:noFill/>
@@ -8389,8 +8630,8 @@
         </p:nvSpPr>
         <p:spPr>
           <a:xfrm>
-            <a:off x="402336" y="301752"/>
-            <a:ext cx="8348472" cy="795528"/>
+            <a:off x="603504" y="1847088"/>
+            <a:ext cx="7946136" cy="1399032"/>
           </a:xfrm>
           <a:prstGeom prst="rect">
             <a:avLst/>
@@ -8404,71 +8645,24 @@
           <a:lstStyle/>
           <a:p>
             <a:r>
-              <a:rPr sz="2800" b="1">
-                <a:solidFill>
-                  <a:srgbClr val="0F0F0F"/>
-                </a:solidFill>
-                <a:latin typeface="Fira Sans"/>
-              </a:rPr>
-              <a:t>Cuándo usar escala logarítmica</a:t>
-            </a:r>
-          </a:p>
-        </p:txBody>
-      </p:sp>
-      <p:pic>
-        <p:nvPicPr>
-          <p:cNvPr id="4" name="Picture 3" descr="c3_10_escala_log.png"/>
-          <p:cNvPicPr>
-            <a:picLocks noChangeAspect="1"/>
-          </p:cNvPicPr>
-          <p:nvPr/>
-        </p:nvPicPr>
-        <p:blipFill>
-          <a:blip r:embed="rId2"/>
-          <a:stretch>
-            <a:fillRect/>
-          </a:stretch>
-        </p:blipFill>
-        <p:spPr>
-          <a:xfrm>
-            <a:off x="1417319" y="1143000"/>
-            <a:ext cx="6309360" cy="2432846"/>
-          </a:xfrm>
-          <a:prstGeom prst="rect">
-            <a:avLst/>
-          </a:prstGeom>
-        </p:spPr>
-      </p:pic>
-      <p:sp>
-        <p:nvSpPr>
-          <p:cNvPr id="5" name="TextBox 4"/>
-          <p:cNvSpPr txBox="1"/>
-          <p:nvPr/>
-        </p:nvSpPr>
-        <p:spPr>
-          <a:xfrm>
-            <a:off x="704088" y="4434840"/>
-            <a:ext cx="7744968" cy="457200"/>
-          </a:xfrm>
-          <a:prstGeom prst="rect">
-            <a:avLst/>
-          </a:prstGeom>
-          <a:noFill/>
-        </p:spPr>
-        <p:txBody>
-          <a:bodyPr wrap="square">
-            <a:spAutoFit/>
-          </a:bodyPr>
-          <a:lstStyle/>
-          <a:p>
-            <a:r>
-              <a:rPr sz="1300" b="0">
-                <a:solidFill>
-                  <a:srgbClr val="333333"/>
-                </a:solidFill>
-                <a:latin typeface="Fira Sans"/>
-              </a:rPr>
-              <a:t>Con colas largas como el ingreso, la escala lineal aplasta el 99% de los datos contra el borde; la logarítmica reparte el espacio y la forma aparece.</a:t>
+              <a:rPr sz="3400" b="1">
+                <a:solidFill>
+                  <a:srgbClr val="FFFFFF"/>
+                </a:solidFill>
+                <a:latin typeface="Fira Sans"/>
+              </a:rPr>
+              <a:t>Buenas prácticas de visualización</a:t>
+            </a:r>
+          </a:p>
+          <a:p>
+            <a:r>
+              <a:rPr sz="1800" b="0">
+                <a:solidFill>
+                  <a:srgbClr val="E0A437"/>
+                </a:solidFill>
+                <a:latin typeface="Fira Sans"/>
+              </a:rPr>
+              <a:t>Que el gráfico diga la verdad y se entienda</a:t>
             </a:r>
           </a:p>
         </p:txBody>
@@ -8564,14 +8758,14 @@
                 </a:solidFill>
                 <a:latin typeface="Fira Sans"/>
               </a:rPr>
-              <a:t>El mismo gráfico, dos veces</a:t>
+              <a:t>Graficar 90 mil puntos: overplotting</a:t>
             </a:r>
           </a:p>
         </p:txBody>
       </p:sp>
       <p:pic>
         <p:nvPicPr>
-          <p:cNvPr id="4" name="Picture 3" descr="c3_16_mal_buen_grafico.png"/>
+          <p:cNvPr id="4" name="Picture 3" descr="c3_08_overplotting.png"/>
           <p:cNvPicPr>
             <a:picLocks noChangeAspect="1"/>
           </p:cNvPicPr>
@@ -8586,7 +8780,7 @@
         <p:spPr>
           <a:xfrm>
             <a:off x="1417319" y="1143000"/>
-            <a:ext cx="6309360" cy="2447822"/>
+            <a:ext cx="6309360" cy="1913950"/>
           </a:xfrm>
           <a:prstGeom prst="rect">
             <a:avLst/>
@@ -8622,7 +8816,7 @@
                 </a:solidFill>
                 <a:latin typeface="Fira Sans"/>
               </a:rPr>
-              <a:t>Los mismos 30 mil viajes: sin rotular y saturado, contra rotulado, con transparencia y con el hallazgo en el título.</a:t>
+              <a:t>Con todos los puntos sólidos, el scatter se satura y miente. Los remedios: transparencia (alpha), muestreo, o hexbin, donde el color cuenta los viajes (la distancia se calcula con las coordenadas; el notebook muestra el cálculo).</a:t>
             </a:r>
           </a:p>
         </p:txBody>
@@ -8718,21 +8912,45 @@
                 </a:solidFill>
                 <a:latin typeface="Fira Sans"/>
               </a:rPr>
-              <a:t>Checklist del buen gráfico</a:t>
-            </a:r>
-          </a:p>
-        </p:txBody>
-      </p:sp>
-      <p:sp>
-        <p:nvSpPr>
-          <p:cNvPr id="4" name="TextBox 3"/>
+              <a:t>Cuándo usar escala logarítmica</a:t>
+            </a:r>
+          </a:p>
+        </p:txBody>
+      </p:sp>
+      <p:pic>
+        <p:nvPicPr>
+          <p:cNvPr id="4" name="Picture 3" descr="c3_10_escala_log.png"/>
+          <p:cNvPicPr>
+            <a:picLocks noChangeAspect="1"/>
+          </p:cNvPicPr>
+          <p:nvPr/>
+        </p:nvPicPr>
+        <p:blipFill>
+          <a:blip r:embed="rId2"/>
+          <a:stretch>
+            <a:fillRect/>
+          </a:stretch>
+        </p:blipFill>
+        <p:spPr>
+          <a:xfrm>
+            <a:off x="1417319" y="1143000"/>
+            <a:ext cx="6309360" cy="2432846"/>
+          </a:xfrm>
+          <a:prstGeom prst="rect">
+            <a:avLst/>
+          </a:prstGeom>
+        </p:spPr>
+      </p:pic>
+      <p:sp>
+        <p:nvSpPr>
+          <p:cNvPr id="5" name="TextBox 4"/>
           <p:cNvSpPr txBox="1"/>
           <p:nvPr/>
         </p:nvSpPr>
         <p:spPr>
           <a:xfrm>
-            <a:off x="704088" y="1353312"/>
-            <a:ext cx="7744968" cy="3300984"/>
+            <a:off x="704088" y="4434840"/>
+            <a:ext cx="7744968" cy="457200"/>
           </a:xfrm>
           <a:prstGeom prst="rect">
             <a:avLst/>
@@ -8745,143 +8963,14 @@
           </a:bodyPr>
           <a:lstStyle/>
           <a:p>
-            <a:pPr>
-              <a:lnSpc>
-                <a:spcPct val="112000"/>
-              </a:lnSpc>
-              <a:spcAft>
-                <a:spcPts val="900"/>
-              </a:spcAft>
-            </a:pPr>
-            <a:r>
-              <a:rPr sz="1800" b="1">
-                <a:solidFill>
-                  <a:srgbClr val="E0A437"/>
-                </a:solidFill>
-                <a:latin typeface="Fira Sans"/>
-              </a:rPr>
-              <a:t>▸ </a:t>
-            </a:r>
-            <a:r>
-              <a:rPr sz="1800" b="0">
-                <a:solidFill>
-                  <a:srgbClr val="000000"/>
-                </a:solidFill>
-                <a:latin typeface="Fira Sans"/>
-              </a:rPr>
-              <a:t>Título que diga el hallazgo, no solo las variables.</a:t>
-            </a:r>
-          </a:p>
-          <a:p>
-            <a:pPr>
-              <a:lnSpc>
-                <a:spcPct val="112000"/>
-              </a:lnSpc>
-              <a:spcAft>
-                <a:spcPts val="900"/>
-              </a:spcAft>
-            </a:pPr>
-            <a:r>
-              <a:rPr sz="1800" b="1">
-                <a:solidFill>
-                  <a:srgbClr val="E0A437"/>
-                </a:solidFill>
-                <a:latin typeface="Fira Sans"/>
-              </a:rPr>
-              <a:t>▸ </a:t>
-            </a:r>
-            <a:r>
-              <a:rPr sz="1800" b="0">
-                <a:solidFill>
-                  <a:srgbClr val="000000"/>
-                </a:solidFill>
-                <a:latin typeface="Fira Sans"/>
-              </a:rPr>
-              <a:t>Ejes con nombre y unidad; ejes que parten de cero en gráficos de barras.</a:t>
-            </a:r>
-          </a:p>
-          <a:p>
-            <a:pPr>
-              <a:lnSpc>
-                <a:spcPct val="112000"/>
-              </a:lnSpc>
-              <a:spcAft>
-                <a:spcPts val="900"/>
-              </a:spcAft>
-            </a:pPr>
-            <a:r>
-              <a:rPr sz="1800" b="1">
-                <a:solidFill>
-                  <a:srgbClr val="E0A437"/>
-                </a:solidFill>
-                <a:latin typeface="Fira Sans"/>
-              </a:rPr>
-              <a:t>▸ </a:t>
-            </a:r>
-            <a:r>
-              <a:rPr sz="1800" b="0">
-                <a:solidFill>
-                  <a:srgbClr val="000000"/>
-                </a:solidFill>
-                <a:latin typeface="Fira Sans"/>
-              </a:rPr>
-              <a:t>Muchos puntos: alpha, muestreo o hexbin.</a:t>
-            </a:r>
-          </a:p>
-          <a:p>
-            <a:pPr>
-              <a:lnSpc>
-                <a:spcPct val="112000"/>
-              </a:lnSpc>
-              <a:spcAft>
-                <a:spcPts val="900"/>
-              </a:spcAft>
-            </a:pPr>
-            <a:r>
-              <a:rPr sz="1800" b="1">
-                <a:solidFill>
-                  <a:srgbClr val="E0A437"/>
-                </a:solidFill>
-                <a:latin typeface="Fira Sans"/>
-              </a:rPr>
-              <a:t>▸ </a:t>
-            </a:r>
-            <a:r>
-              <a:rPr sz="1800" b="0">
-                <a:solidFill>
-                  <a:srgbClr val="000000"/>
-                </a:solidFill>
-                <a:latin typeface="Fira Sans"/>
-              </a:rPr>
-              <a:t>Colas largas: escala logarítmica o eje recortado, declarándolo.</a:t>
-            </a:r>
-          </a:p>
-          <a:p>
-            <a:pPr>
-              <a:lnSpc>
-                <a:spcPct val="112000"/>
-              </a:lnSpc>
-              <a:spcAft>
-                <a:spcPts val="900"/>
-              </a:spcAft>
-            </a:pPr>
-            <a:r>
-              <a:rPr sz="1800" b="1">
-                <a:solidFill>
-                  <a:srgbClr val="E0A437"/>
-                </a:solidFill>
-                <a:latin typeface="Fira Sans"/>
-              </a:rPr>
-              <a:t>▸ </a:t>
-            </a:r>
-            <a:r>
-              <a:rPr sz="1800" b="1">
-                <a:solidFill>
-                  <a:srgbClr val="1D3557"/>
-                </a:solidFill>
-                <a:latin typeface="Fira Sans"/>
-              </a:rPr>
-              <a:t>El gráfico se corrige igual que el código: se itera hasta que un tercero lo entienda sin explicación oral.</a:t>
+            <a:r>
+              <a:rPr sz="1300" b="0">
+                <a:solidFill>
+                  <a:srgbClr val="333333"/>
+                </a:solidFill>
+                <a:latin typeface="Fira Sans"/>
+              </a:rPr>
+              <a:t>Con colas largas como el ingreso, la escala lineal aplasta el 99% de los datos contra el borde; la logarítmica reparte el espacio y la forma aparece.</a:t>
             </a:r>
           </a:p>
         </p:txBody>
@@ -8977,21 +9066,45 @@
                 </a:solidFill>
                 <a:latin typeface="Fira Sans"/>
               </a:rPr>
-              <a:t>Síntesis</a:t>
-            </a:r>
-          </a:p>
-        </p:txBody>
-      </p:sp>
-      <p:sp>
-        <p:nvSpPr>
-          <p:cNvPr id="4" name="TextBox 3"/>
+              <a:t>El mismo gráfico, dos veces</a:t>
+            </a:r>
+          </a:p>
+        </p:txBody>
+      </p:sp>
+      <p:pic>
+        <p:nvPicPr>
+          <p:cNvPr id="4" name="Picture 3" descr="c3_16_mal_buen_grafico.png"/>
+          <p:cNvPicPr>
+            <a:picLocks noChangeAspect="1"/>
+          </p:cNvPicPr>
+          <p:nvPr/>
+        </p:nvPicPr>
+        <p:blipFill>
+          <a:blip r:embed="rId2"/>
+          <a:stretch>
+            <a:fillRect/>
+          </a:stretch>
+        </p:blipFill>
+        <p:spPr>
+          <a:xfrm>
+            <a:off x="1417319" y="1143000"/>
+            <a:ext cx="6309360" cy="2447822"/>
+          </a:xfrm>
+          <a:prstGeom prst="rect">
+            <a:avLst/>
+          </a:prstGeom>
+        </p:spPr>
+      </p:pic>
+      <p:sp>
+        <p:nvSpPr>
+          <p:cNvPr id="5" name="TextBox 4"/>
           <p:cNvSpPr txBox="1"/>
           <p:nvPr/>
         </p:nvSpPr>
         <p:spPr>
           <a:xfrm>
-            <a:off x="704088" y="1353312"/>
-            <a:ext cx="7744968" cy="3300984"/>
+            <a:off x="704088" y="4434840"/>
+            <a:ext cx="7744968" cy="457200"/>
           </a:xfrm>
           <a:prstGeom prst="rect">
             <a:avLst/>
@@ -9004,143 +9117,14 @@
           </a:bodyPr>
           <a:lstStyle/>
           <a:p>
-            <a:pPr>
-              <a:lnSpc>
-                <a:spcPct val="112000"/>
-              </a:lnSpc>
-              <a:spcAft>
-                <a:spcPts val="900"/>
-              </a:spcAft>
-            </a:pPr>
-            <a:r>
-              <a:rPr sz="1800" b="1">
-                <a:solidFill>
-                  <a:srgbClr val="E0A437"/>
-                </a:solidFill>
-                <a:latin typeface="Fira Sans"/>
-              </a:rPr>
-              <a:t>▸ </a:t>
-            </a:r>
-            <a:r>
-              <a:rPr sz="1800" b="0">
-                <a:solidFill>
-                  <a:srgbClr val="000000"/>
-                </a:solidFill>
-                <a:latin typeface="Fira Sans"/>
-              </a:rPr>
-              <a:t>El análisis bivariado se elige según el par de tipos: scatter y correlación, groupby y boxplot, o tabla de contingencia.</a:t>
-            </a:r>
-          </a:p>
-          <a:p>
-            <a:pPr>
-              <a:lnSpc>
-                <a:spcPct val="112000"/>
-              </a:lnSpc>
-              <a:spcAft>
-                <a:spcPts val="900"/>
-              </a:spcAft>
-            </a:pPr>
-            <a:r>
-              <a:rPr sz="1800" b="1">
-                <a:solidFill>
-                  <a:srgbClr val="E0A437"/>
-                </a:solidFill>
-                <a:latin typeface="Fira Sans"/>
-              </a:rPr>
-              <a:t>▸ </a:t>
-            </a:r>
-            <a:r>
-              <a:rPr sz="1800" b="0">
-                <a:solidFill>
-                  <a:srgbClr val="000000"/>
-                </a:solidFill>
-                <a:latin typeface="Fira Sans"/>
-              </a:rPr>
-              <a:t>Pearson para relaciones lineales; Spearman cuando hay atípicos o curvas. Y siempre graficar: Anscombe.</a:t>
-            </a:r>
-          </a:p>
-          <a:p>
-            <a:pPr>
-              <a:lnSpc>
-                <a:spcPct val="112000"/>
-              </a:lnSpc>
-              <a:spcAft>
-                <a:spcPts val="900"/>
-              </a:spcAft>
-            </a:pPr>
-            <a:r>
-              <a:rPr sz="1800" b="1">
-                <a:solidFill>
-                  <a:srgbClr val="E0A437"/>
-                </a:solidFill>
-                <a:latin typeface="Fira Sans"/>
-              </a:rPr>
-              <a:t>▸ </a:t>
-            </a:r>
-            <a:r>
-              <a:rPr sz="1800" b="0">
-                <a:solidFill>
-                  <a:srgbClr val="000000"/>
-                </a:solidFill>
-                <a:latin typeface="Fira Sans"/>
-              </a:rPr>
-              <a:t>Correlación no es causalidad: reportamos asociación.</a:t>
-            </a:r>
-          </a:p>
-          <a:p>
-            <a:pPr>
-              <a:lnSpc>
-                <a:spcPct val="112000"/>
-              </a:lnSpc>
-              <a:spcAft>
-                <a:spcPts val="900"/>
-              </a:spcAft>
-            </a:pPr>
-            <a:r>
-              <a:rPr sz="1800" b="1">
-                <a:solidFill>
-                  <a:srgbClr val="E0A437"/>
-                </a:solidFill>
-                <a:latin typeface="Fira Sans"/>
-              </a:rPr>
-              <a:t>▸ </a:t>
-            </a:r>
-            <a:r>
-              <a:rPr sz="1800" b="0">
-                <a:solidFill>
-                  <a:srgbClr val="000000"/>
-                </a:solidFill>
-                <a:latin typeface="Fira Sans"/>
-              </a:rPr>
-              <a:t>La regresión es el primer modelo: una función que resume, predice y deja residuos que diagnostican.</a:t>
-            </a:r>
-          </a:p>
-          <a:p>
-            <a:pPr>
-              <a:lnSpc>
-                <a:spcPct val="112000"/>
-              </a:lnSpc>
-              <a:spcAft>
-                <a:spcPts val="900"/>
-              </a:spcAft>
-            </a:pPr>
-            <a:r>
-              <a:rPr sz="1800" b="1">
-                <a:solidFill>
-                  <a:srgbClr val="E0A437"/>
-                </a:solidFill>
-                <a:latin typeface="Fira Sans"/>
-              </a:rPr>
-              <a:t>▸ </a:t>
-            </a:r>
-            <a:r>
-              <a:rPr sz="1800" b="1">
-                <a:solidFill>
-                  <a:srgbClr val="1D3557"/>
-                </a:solidFill>
-                <a:latin typeface="Fira Sans"/>
-              </a:rPr>
-              <a:t>Todo lo de hoy es exactamente lo que el primer EDA del proyecto debe mostrar (entrega: lunes 15).</a:t>
+            <a:r>
+              <a:rPr sz="1300" b="0">
+                <a:solidFill>
+                  <a:srgbClr val="333333"/>
+                </a:solidFill>
+                <a:latin typeface="Fira Sans"/>
+              </a:rPr>
+              <a:t>Los mismos 30 mil viajes: sin rotular y saturado, contra rotulado, con transparencia y con el hallazgo en el título.</a:t>
             </a:r>
           </a:p>
         </p:txBody>
@@ -9495,7 +9479,7 @@
                 </a:solidFill>
                 <a:latin typeface="Fira Sans"/>
               </a:rPr>
-              <a:t>Próxima clase</a:t>
+              <a:t>Checklist del buen gráfico</a:t>
             </a:r>
           </a:p>
         </p:txBody>
@@ -9540,13 +9524,13 @@
               <a:t>▸ </a:t>
             </a:r>
             <a:r>
-              <a:rPr sz="1800" b="1">
-                <a:solidFill>
-                  <a:srgbClr val="1D3557"/>
-                </a:solidFill>
-                <a:latin typeface="Fira Sans"/>
-              </a:rPr>
-              <a:t>Jueves 3 de septiembre: presentaciones breves de las ideas de proyecto (5 minutos por equipo, sin nota).</a:t>
+              <a:rPr sz="1800" b="0">
+                <a:solidFill>
+                  <a:srgbClr val="000000"/>
+                </a:solidFill>
+                <a:latin typeface="Fira Sans"/>
+              </a:rPr>
+              <a:t>Título que diga el hallazgo, no solo las variables.</a:t>
             </a:r>
           </a:p>
           <a:p>
@@ -9574,7 +9558,7 @@
                 </a:solidFill>
                 <a:latin typeface="Fira Sans"/>
               </a:rPr>
-              <a:t>Después: fundamentos de probabilidad, la base para la inferencia de las clases siguientes.</a:t>
+              <a:t>Ejes con nombre y unidad; ejes que parten de cero en gráficos de barras.</a:t>
             </a:r>
           </a:p>
           <a:p>
@@ -9602,7 +9586,7 @@
                 </a:solidFill>
                 <a:latin typeface="Fira Sans"/>
               </a:rPr>
-              <a:t>Se publica la rúbrica del primer análisis exploratorio.</a:t>
+              <a:t>Muchos puntos: alpha, muestreo o hexbin.</a:t>
             </a:r>
           </a:p>
           <a:p>
@@ -9630,7 +9614,35 @@
                 </a:solidFill>
                 <a:latin typeface="Fira Sans"/>
               </a:rPr>
-              <a:t>Recuerden: la formulación se entrega el lunes 7 por el aula virtual.</a:t>
+              <a:t>Colas largas: escala logarítmica o eje recortado, declarándolo.</a:t>
+            </a:r>
+          </a:p>
+          <a:p>
+            <a:pPr>
+              <a:lnSpc>
+                <a:spcPct val="112000"/>
+              </a:lnSpc>
+              <a:spcAft>
+                <a:spcPts val="900"/>
+              </a:spcAft>
+            </a:pPr>
+            <a:r>
+              <a:rPr sz="1800" b="1">
+                <a:solidFill>
+                  <a:srgbClr val="E0A437"/>
+                </a:solidFill>
+                <a:latin typeface="Fira Sans"/>
+              </a:rPr>
+              <a:t>▸ </a:t>
+            </a:r>
+            <a:r>
+              <a:rPr sz="1800" b="1">
+                <a:solidFill>
+                  <a:srgbClr val="1D3557"/>
+                </a:solidFill>
+                <a:latin typeface="Fira Sans"/>
+              </a:rPr>
+              <a:t>El gráfico se corrige igual que el código: se itera hasta que un tercero lo entienda sin explicación oral.</a:t>
             </a:r>
           </a:p>
         </p:txBody>
@@ -9644,6 +9656,496 @@
 </file>
 
 <file path=ppt/slides/slide41.xml><?xml version="1.0" encoding="utf-8"?>
+<p:sld xmlns:a="http://schemas.openxmlformats.org/drawingml/2006/main" xmlns:p="http://schemas.openxmlformats.org/presentationml/2006/main" xmlns:r="http://schemas.openxmlformats.org/officeDocument/2006/relationships">
+  <p:cSld>
+    <p:spTree>
+      <p:nvGrpSpPr>
+        <p:cNvPr id="1" name=""/>
+        <p:cNvGrpSpPr/>
+        <p:nvPr/>
+      </p:nvGrpSpPr>
+      <p:grpSpPr/>
+      <p:sp>
+        <p:nvSpPr>
+          <p:cNvPr id="2" name="Rectangle 1"/>
+          <p:cNvSpPr/>
+          <p:nvPr/>
+        </p:nvSpPr>
+        <p:spPr>
+          <a:xfrm>
+            <a:off x="0" y="0"/>
+            <a:ext cx="9144000" cy="5138928"/>
+          </a:xfrm>
+          <a:prstGeom prst="rect">
+            <a:avLst/>
+          </a:prstGeom>
+          <a:solidFill>
+            <a:srgbClr val="FAFBFC"/>
+          </a:solidFill>
+          <a:ln>
+            <a:noFill/>
+          </a:ln>
+          <a:effectLst/>
+        </p:spPr>
+        <p:style>
+          <a:lnRef idx="1">
+            <a:schemeClr val="accent1"/>
+          </a:lnRef>
+          <a:fillRef idx="3">
+            <a:schemeClr val="accent1"/>
+          </a:fillRef>
+          <a:effectRef idx="2">
+            <a:schemeClr val="accent1"/>
+          </a:effectRef>
+          <a:fontRef idx="minor">
+            <a:schemeClr val="lt1"/>
+          </a:fontRef>
+        </p:style>
+        <p:txBody>
+          <a:bodyPr rtlCol="0" anchor="ctr"/>
+          <a:lstStyle/>
+          <a:p>
+            <a:pPr algn="ctr"/>
+          </a:p>
+        </p:txBody>
+      </p:sp>
+      <p:sp>
+        <p:nvSpPr>
+          <p:cNvPr id="3" name="TextBox 2"/>
+          <p:cNvSpPr txBox="1"/>
+          <p:nvPr/>
+        </p:nvSpPr>
+        <p:spPr>
+          <a:xfrm>
+            <a:off x="402336" y="301752"/>
+            <a:ext cx="8348472" cy="795528"/>
+          </a:xfrm>
+          <a:prstGeom prst="rect">
+            <a:avLst/>
+          </a:prstGeom>
+          <a:noFill/>
+        </p:spPr>
+        <p:txBody>
+          <a:bodyPr wrap="square">
+            <a:spAutoFit/>
+          </a:bodyPr>
+          <a:lstStyle/>
+          <a:p>
+            <a:r>
+              <a:rPr sz="2800" b="1">
+                <a:solidFill>
+                  <a:srgbClr val="0F0F0F"/>
+                </a:solidFill>
+                <a:latin typeface="Fira Sans"/>
+              </a:rPr>
+              <a:t>Síntesis</a:t>
+            </a:r>
+          </a:p>
+        </p:txBody>
+      </p:sp>
+      <p:sp>
+        <p:nvSpPr>
+          <p:cNvPr id="4" name="TextBox 3"/>
+          <p:cNvSpPr txBox="1"/>
+          <p:nvPr/>
+        </p:nvSpPr>
+        <p:spPr>
+          <a:xfrm>
+            <a:off x="704088" y="1353312"/>
+            <a:ext cx="7744968" cy="3300984"/>
+          </a:xfrm>
+          <a:prstGeom prst="rect">
+            <a:avLst/>
+          </a:prstGeom>
+          <a:noFill/>
+        </p:spPr>
+        <p:txBody>
+          <a:bodyPr wrap="square">
+            <a:spAutoFit/>
+          </a:bodyPr>
+          <a:lstStyle/>
+          <a:p>
+            <a:pPr>
+              <a:lnSpc>
+                <a:spcPct val="112000"/>
+              </a:lnSpc>
+              <a:spcAft>
+                <a:spcPts val="900"/>
+              </a:spcAft>
+            </a:pPr>
+            <a:r>
+              <a:rPr sz="1800" b="1">
+                <a:solidFill>
+                  <a:srgbClr val="E0A437"/>
+                </a:solidFill>
+                <a:latin typeface="Fira Sans"/>
+              </a:rPr>
+              <a:t>▸ </a:t>
+            </a:r>
+            <a:r>
+              <a:rPr sz="1800" b="0">
+                <a:solidFill>
+                  <a:srgbClr val="000000"/>
+                </a:solidFill>
+                <a:latin typeface="Fira Sans"/>
+              </a:rPr>
+              <a:t>El análisis bivariado se elige según el par de tipos: scatter y correlación, groupby y boxplot, o tabla de contingencia.</a:t>
+            </a:r>
+          </a:p>
+          <a:p>
+            <a:pPr>
+              <a:lnSpc>
+                <a:spcPct val="112000"/>
+              </a:lnSpc>
+              <a:spcAft>
+                <a:spcPts val="900"/>
+              </a:spcAft>
+            </a:pPr>
+            <a:r>
+              <a:rPr sz="1800" b="1">
+                <a:solidFill>
+                  <a:srgbClr val="E0A437"/>
+                </a:solidFill>
+                <a:latin typeface="Fira Sans"/>
+              </a:rPr>
+              <a:t>▸ </a:t>
+            </a:r>
+            <a:r>
+              <a:rPr sz="1800" b="0">
+                <a:solidFill>
+                  <a:srgbClr val="000000"/>
+                </a:solidFill>
+                <a:latin typeface="Fira Sans"/>
+              </a:rPr>
+              <a:t>Pearson para relaciones lineales; Spearman cuando hay atípicos o curvas. Y siempre graficar: Anscombe.</a:t>
+            </a:r>
+          </a:p>
+          <a:p>
+            <a:pPr>
+              <a:lnSpc>
+                <a:spcPct val="112000"/>
+              </a:lnSpc>
+              <a:spcAft>
+                <a:spcPts val="900"/>
+              </a:spcAft>
+            </a:pPr>
+            <a:r>
+              <a:rPr sz="1800" b="1">
+                <a:solidFill>
+                  <a:srgbClr val="E0A437"/>
+                </a:solidFill>
+                <a:latin typeface="Fira Sans"/>
+              </a:rPr>
+              <a:t>▸ </a:t>
+            </a:r>
+            <a:r>
+              <a:rPr sz="1800" b="0">
+                <a:solidFill>
+                  <a:srgbClr val="000000"/>
+                </a:solidFill>
+                <a:latin typeface="Fira Sans"/>
+              </a:rPr>
+              <a:t>Correlación no es causalidad: reportamos asociación.</a:t>
+            </a:r>
+          </a:p>
+          <a:p>
+            <a:pPr>
+              <a:lnSpc>
+                <a:spcPct val="112000"/>
+              </a:lnSpc>
+              <a:spcAft>
+                <a:spcPts val="900"/>
+              </a:spcAft>
+            </a:pPr>
+            <a:r>
+              <a:rPr sz="1800" b="1">
+                <a:solidFill>
+                  <a:srgbClr val="E0A437"/>
+                </a:solidFill>
+                <a:latin typeface="Fira Sans"/>
+              </a:rPr>
+              <a:t>▸ </a:t>
+            </a:r>
+            <a:r>
+              <a:rPr sz="1800" b="0">
+                <a:solidFill>
+                  <a:srgbClr val="000000"/>
+                </a:solidFill>
+                <a:latin typeface="Fira Sans"/>
+              </a:rPr>
+              <a:t>La regresión es el primer modelo: una función que resume, predice y deja residuos que diagnostican.</a:t>
+            </a:r>
+          </a:p>
+          <a:p>
+            <a:pPr>
+              <a:lnSpc>
+                <a:spcPct val="112000"/>
+              </a:lnSpc>
+              <a:spcAft>
+                <a:spcPts val="900"/>
+              </a:spcAft>
+            </a:pPr>
+            <a:r>
+              <a:rPr sz="1800" b="1">
+                <a:solidFill>
+                  <a:srgbClr val="E0A437"/>
+                </a:solidFill>
+                <a:latin typeface="Fira Sans"/>
+              </a:rPr>
+              <a:t>▸ </a:t>
+            </a:r>
+            <a:r>
+              <a:rPr sz="1800" b="1">
+                <a:solidFill>
+                  <a:srgbClr val="1D3557"/>
+                </a:solidFill>
+                <a:latin typeface="Fira Sans"/>
+              </a:rPr>
+              <a:t>Todo lo de hoy es exactamente lo que el primer EDA del proyecto debe mostrar (entrega: lunes 15).</a:t>
+            </a:r>
+          </a:p>
+        </p:txBody>
+      </p:sp>
+    </p:spTree>
+  </p:cSld>
+  <p:clrMapOvr>
+    <a:masterClrMapping/>
+  </p:clrMapOvr>
+</p:sld>
+</file>
+
+<file path=ppt/slides/slide42.xml><?xml version="1.0" encoding="utf-8"?>
+<p:sld xmlns:a="http://schemas.openxmlformats.org/drawingml/2006/main" xmlns:p="http://schemas.openxmlformats.org/presentationml/2006/main" xmlns:r="http://schemas.openxmlformats.org/officeDocument/2006/relationships">
+  <p:cSld>
+    <p:spTree>
+      <p:nvGrpSpPr>
+        <p:cNvPr id="1" name=""/>
+        <p:cNvGrpSpPr/>
+        <p:nvPr/>
+      </p:nvGrpSpPr>
+      <p:grpSpPr/>
+      <p:sp>
+        <p:nvSpPr>
+          <p:cNvPr id="2" name="Rectangle 1"/>
+          <p:cNvSpPr/>
+          <p:nvPr/>
+        </p:nvSpPr>
+        <p:spPr>
+          <a:xfrm>
+            <a:off x="0" y="0"/>
+            <a:ext cx="9144000" cy="5138928"/>
+          </a:xfrm>
+          <a:prstGeom prst="rect">
+            <a:avLst/>
+          </a:prstGeom>
+          <a:solidFill>
+            <a:srgbClr val="FAFBFC"/>
+          </a:solidFill>
+          <a:ln>
+            <a:noFill/>
+          </a:ln>
+          <a:effectLst/>
+        </p:spPr>
+        <p:style>
+          <a:lnRef idx="1">
+            <a:schemeClr val="accent1"/>
+          </a:lnRef>
+          <a:fillRef idx="3">
+            <a:schemeClr val="accent1"/>
+          </a:fillRef>
+          <a:effectRef idx="2">
+            <a:schemeClr val="accent1"/>
+          </a:effectRef>
+          <a:fontRef idx="minor">
+            <a:schemeClr val="lt1"/>
+          </a:fontRef>
+        </p:style>
+        <p:txBody>
+          <a:bodyPr rtlCol="0" anchor="ctr"/>
+          <a:lstStyle/>
+          <a:p>
+            <a:pPr algn="ctr"/>
+          </a:p>
+        </p:txBody>
+      </p:sp>
+      <p:sp>
+        <p:nvSpPr>
+          <p:cNvPr id="3" name="TextBox 2"/>
+          <p:cNvSpPr txBox="1"/>
+          <p:nvPr/>
+        </p:nvSpPr>
+        <p:spPr>
+          <a:xfrm>
+            <a:off x="402336" y="301752"/>
+            <a:ext cx="8348472" cy="795528"/>
+          </a:xfrm>
+          <a:prstGeom prst="rect">
+            <a:avLst/>
+          </a:prstGeom>
+          <a:noFill/>
+        </p:spPr>
+        <p:txBody>
+          <a:bodyPr wrap="square">
+            <a:spAutoFit/>
+          </a:bodyPr>
+          <a:lstStyle/>
+          <a:p>
+            <a:r>
+              <a:rPr sz="2800" b="1">
+                <a:solidFill>
+                  <a:srgbClr val="0F0F0F"/>
+                </a:solidFill>
+                <a:latin typeface="Fira Sans"/>
+              </a:rPr>
+              <a:t>Próxima clase</a:t>
+            </a:r>
+          </a:p>
+        </p:txBody>
+      </p:sp>
+      <p:sp>
+        <p:nvSpPr>
+          <p:cNvPr id="4" name="TextBox 3"/>
+          <p:cNvSpPr txBox="1"/>
+          <p:nvPr/>
+        </p:nvSpPr>
+        <p:spPr>
+          <a:xfrm>
+            <a:off x="704088" y="1353312"/>
+            <a:ext cx="7744968" cy="3300984"/>
+          </a:xfrm>
+          <a:prstGeom prst="rect">
+            <a:avLst/>
+          </a:prstGeom>
+          <a:noFill/>
+        </p:spPr>
+        <p:txBody>
+          <a:bodyPr wrap="square">
+            <a:spAutoFit/>
+          </a:bodyPr>
+          <a:lstStyle/>
+          <a:p>
+            <a:pPr>
+              <a:lnSpc>
+                <a:spcPct val="112000"/>
+              </a:lnSpc>
+              <a:spcAft>
+                <a:spcPts val="900"/>
+              </a:spcAft>
+            </a:pPr>
+            <a:r>
+              <a:rPr sz="1800" b="1">
+                <a:solidFill>
+                  <a:srgbClr val="E0A437"/>
+                </a:solidFill>
+                <a:latin typeface="Fira Sans"/>
+              </a:rPr>
+              <a:t>▸ </a:t>
+            </a:r>
+            <a:r>
+              <a:rPr sz="1800" b="1">
+                <a:solidFill>
+                  <a:srgbClr val="1D3557"/>
+                </a:solidFill>
+                <a:latin typeface="Fira Sans"/>
+              </a:rPr>
+              <a:t>Jueves 3 de septiembre: presentaciones breves de las ideas de proyecto (5 minutos por equipo, sin nota).</a:t>
+            </a:r>
+          </a:p>
+          <a:p>
+            <a:pPr>
+              <a:lnSpc>
+                <a:spcPct val="112000"/>
+              </a:lnSpc>
+              <a:spcAft>
+                <a:spcPts val="900"/>
+              </a:spcAft>
+            </a:pPr>
+            <a:r>
+              <a:rPr sz="1800" b="1">
+                <a:solidFill>
+                  <a:srgbClr val="E0A437"/>
+                </a:solidFill>
+                <a:latin typeface="Fira Sans"/>
+              </a:rPr>
+              <a:t>▸ </a:t>
+            </a:r>
+            <a:r>
+              <a:rPr sz="1800" b="0">
+                <a:solidFill>
+                  <a:srgbClr val="000000"/>
+                </a:solidFill>
+                <a:latin typeface="Fira Sans"/>
+              </a:rPr>
+              <a:t>Después: fundamentos de probabilidad, la base para la inferencia de las clases siguientes.</a:t>
+            </a:r>
+          </a:p>
+          <a:p>
+            <a:pPr>
+              <a:lnSpc>
+                <a:spcPct val="112000"/>
+              </a:lnSpc>
+              <a:spcAft>
+                <a:spcPts val="900"/>
+              </a:spcAft>
+            </a:pPr>
+            <a:r>
+              <a:rPr sz="1800" b="1">
+                <a:solidFill>
+                  <a:srgbClr val="E0A437"/>
+                </a:solidFill>
+                <a:latin typeface="Fira Sans"/>
+              </a:rPr>
+              <a:t>▸ </a:t>
+            </a:r>
+            <a:r>
+              <a:rPr sz="1800" b="0">
+                <a:solidFill>
+                  <a:srgbClr val="000000"/>
+                </a:solidFill>
+                <a:latin typeface="Fira Sans"/>
+              </a:rPr>
+              <a:t>Se publica la rúbrica del primer análisis exploratorio.</a:t>
+            </a:r>
+          </a:p>
+          <a:p>
+            <a:pPr>
+              <a:lnSpc>
+                <a:spcPct val="112000"/>
+              </a:lnSpc>
+              <a:spcAft>
+                <a:spcPts val="900"/>
+              </a:spcAft>
+            </a:pPr>
+            <a:r>
+              <a:rPr sz="1800" b="1">
+                <a:solidFill>
+                  <a:srgbClr val="E0A437"/>
+                </a:solidFill>
+                <a:latin typeface="Fira Sans"/>
+              </a:rPr>
+              <a:t>▸ </a:t>
+            </a:r>
+            <a:r>
+              <a:rPr sz="1800" b="0">
+                <a:solidFill>
+                  <a:srgbClr val="000000"/>
+                </a:solidFill>
+                <a:latin typeface="Fira Sans"/>
+              </a:rPr>
+              <a:t>Recuerden: la formulación se entrega el lunes 7 por el aula virtual.</a:t>
+            </a:r>
+          </a:p>
+        </p:txBody>
+      </p:sp>
+    </p:spTree>
+  </p:cSld>
+  <p:clrMapOvr>
+    <a:masterClrMapping/>
+  </p:clrMapOvr>
+</p:sld>
+</file>
+
+<file path=ppt/slides/slide43.xml><?xml version="1.0" encoding="utf-8"?>
 <p:sld xmlns:a="http://schemas.openxmlformats.org/drawingml/2006/main" xmlns:p="http://schemas.openxmlformats.org/presentationml/2006/main" xmlns:r="http://schemas.openxmlformats.org/officeDocument/2006/relationships">
   <p:cSld>
     <p:spTree>

</xml_diff>

<commit_message>
Clase 3: factores de expansion en todos los analisis, formula OLS ponderada, metodo y libreria explicitos
Co-Authored-By: Claude Fable 5 <noreply@anthropic.com>
</commit_message>
<xml_diff>
--- a/presentaciones/clase03_eda_bivariado.pptx
+++ b/presentaciones/clase03_eda_bivariado.pptx
@@ -48,6 +48,7 @@
     <p:sldId id="296" r:id="rId47"/>
     <p:sldId id="297" r:id="rId48"/>
     <p:sldId id="298" r:id="rId49"/>
+    <p:sldId id="299" r:id="rId50"/>
   </p:sldIdLst>
   <p:sldSz cx="9144000" cy="5138928" type="screen4x3"/>
   <p:notesSz cx="6858000" cy="9144000"/>
@@ -5448,7 +5449,7 @@
                 </a:solidFill>
                 <a:latin typeface="Fira Sans"/>
               </a:rPr>
-              <a:t>La tabla por comuna</a:t>
+              <a:t>La tabla por comuna, ponderada</a:t>
             </a:r>
           </a:p>
         </p:txBody>
@@ -5503,7 +5504,7 @@
                 </a:solidFill>
                 <a:latin typeface="Menlo"/>
               </a:rPr>
-              <a:t>v = viajes.merge(hogares[["Hogar", "Comuna", "IngresoHogar"]],</a:t>
+              <a:t>lab["w_ingreso"] = lab["Factor"] * lab["IngresoHogar"]</a:t>
             </a:r>
           </a:p>
           <a:p>
@@ -5515,7 +5516,7 @@
                 </a:solidFill>
                 <a:latin typeface="Menlo"/>
               </a:rPr>
-              <a:t>                on="Hogar")</a:t>
+              <a:t>suma = lab.groupby("Comuna").sum()</a:t>
             </a:r>
           </a:p>
           <a:p>
@@ -5527,7 +5528,7 @@
                 </a:solidFill>
                 <a:latin typeface="Menlo"/>
               </a:rPr>
-              <a:t>por_comuna = v.groupby("Comuna").agg(</a:t>
+              <a:t/>
             </a:r>
           </a:p>
           <a:p>
@@ -5539,7 +5540,7 @@
                 </a:solidFill>
                 <a:latin typeface="Menlo"/>
               </a:rPr>
-              <a:t>    ingreso=("IngresoHogar", "mean"),</a:t>
+              <a:t># La media ponderada de la clase 2, ahora por comuna</a:t>
             </a:r>
           </a:p>
           <a:p>
@@ -5551,7 +5552,7 @@
                 </a:solidFill>
                 <a:latin typeface="Menlo"/>
               </a:rPr>
-              <a:t>    duracion=("TiempoViaje", "mean"))</a:t>
+              <a:t>suma["w_ingreso"] / suma["Factor"]</a:t>
             </a:r>
           </a:p>
         </p:txBody>
@@ -5602,7 +5603,7 @@
                 </a:solidFill>
                 <a:latin typeface="Fira Sans"/>
               </a:rPr>
-              <a:t>Un merge y un groupby con dos resúmenes a la vez: 45 comunas, cada una con su ingreso medio y su duración media de viaje.</a:t>
+              <a:t>Las conclusiones son sobre la ciudad, así que se pondera (clase 2): cada media por comuna es suma de w por x, dividida por suma de w, con el factor del día laboral.</a:t>
             </a:r>
           </a:p>
         </p:txBody>
@@ -5719,8 +5720,8 @@
         </p:blipFill>
         <p:spPr>
           <a:xfrm>
-            <a:off x="2073847" y="1143000"/>
-            <a:ext cx="4996305" cy="3154680"/>
+            <a:off x="2064280" y="1143000"/>
+            <a:ext cx="5015438" cy="3154679"/>
           </a:xfrm>
           <a:prstGeom prst="rect">
             <a:avLst/>
@@ -5756,7 +5757,7 @@
                 </a:solidFill>
                 <a:latin typeface="Fira Sans"/>
               </a:rPr>
-              <a:t>Cada punto es una comuna. La asociación es negativa (r = −0,37): las comunas de menor ingreso promedian viajes más largos. Vitacura, 28 minutos; Cerro Navia, 37.</a:t>
+              <a:t>Cada punto es una comuna (medias ponderadas por factor). La asociación es negativa (r = −0,34): las comunas de menor ingreso promedian viajes más largos. Providencia, 25 minutos; Puente Alto, 40.</a:t>
             </a:r>
           </a:p>
         </p:txBody>
@@ -5910,7 +5911,7 @@
                 </a:solidFill>
                 <a:latin typeface="Fira Sans"/>
               </a:rPr>
-              <a:t>Cuatro variables, seis pares: el ingreso compra autos (0,93), y la sorpresa es que el mejor acompañante de la duración no es el ingreso (−0,37) sino las personas por hogar (0,66).</a:t>
+              <a:t>Cuatro variables, seis pares (todo ponderado): el ingreso compra autos (0,94), y la sorpresa es que el mejor acompañante de la duración no es el ingreso (−0,34) sino las personas por hogar (0,65).</a:t>
             </a:r>
           </a:p>
         </p:txBody>
@@ -7247,14 +7248,14 @@
                 </a:solidFill>
                 <a:latin typeface="Fira Sans"/>
               </a:rPr>
-              <a:t>La recta: ingreso y duración</a:t>
+              <a:t>Las fórmulas de la recta</a:t>
             </a:r>
           </a:p>
         </p:txBody>
       </p:sp>
       <p:pic>
         <p:nvPicPr>
-          <p:cNvPr id="4" name="Picture 3" descr="c3_18_ingreso_duracion_recta.png"/>
+          <p:cNvPr id="4" name="Picture 3" descr="c3_21_formulas_recta.png"/>
           <p:cNvPicPr>
             <a:picLocks noChangeAspect="1"/>
           </p:cNvPicPr>
@@ -7268,8 +7269,8 @@
         </p:blipFill>
         <p:spPr>
           <a:xfrm>
-            <a:off x="2120485" y="1143000"/>
-            <a:ext cx="4903028" cy="3154680"/>
+            <a:off x="1417319" y="1143000"/>
+            <a:ext cx="6309360" cy="2734524"/>
           </a:xfrm>
           <a:prstGeom prst="rect">
             <a:avLst/>
@@ -7305,7 +7306,7 @@
                 </a:solidFill>
                 <a:latin typeface="Fira Sans"/>
               </a:rPr>
-              <a:t>duración = 41,1 − 5,8 · ingreso: por cada millón adicional de ingreso medio, la duración media baja casi 6 minutos. Y r² = 0,14: la recta captura el 14% de la variación; la asociación es real pero moderada, y así se reporta.</a:t>
+              <a:t>El método se llama mínimos cuadrados ordinarios (OLS). Hoy lo calcula NumPy (np.polyfit); en las clases 6 y 7 lo harán scikit-learn y statsmodels, con diagnósticos e inferencia. Con factores de expansión se usa la versión ponderada.</a:t>
             </a:r>
           </a:p>
         </p:txBody>
@@ -7401,114 +7402,35 @@
                 </a:solidFill>
                 <a:latin typeface="Fira Sans"/>
               </a:rPr>
-              <a:t>La recta en NumPy</a:t>
-            </a:r>
-          </a:p>
-        </p:txBody>
-      </p:sp>
-      <p:sp>
-        <p:nvSpPr>
-          <p:cNvPr id="4" name="Rectangle 3"/>
-          <p:cNvSpPr/>
-          <p:nvPr/>
-        </p:nvSpPr>
-        <p:spPr>
-          <a:xfrm>
-            <a:off x="704088" y="1280160"/>
-            <a:ext cx="7744968" cy="2880360"/>
-          </a:xfrm>
-          <a:prstGeom prst="rect">
-            <a:avLst/>
-          </a:prstGeom>
-          <a:solidFill>
-            <a:srgbClr val="F0F2F5"/>
-          </a:solidFill>
-          <a:ln>
-            <a:solidFill>
-              <a:srgbClr val="D8DDE3"/>
-            </a:solidFill>
-          </a:ln>
-          <a:effectLst/>
-        </p:spPr>
-        <p:style>
-          <a:lnRef idx="1">
-            <a:schemeClr val="accent1"/>
-          </a:lnRef>
-          <a:fillRef idx="3">
-            <a:schemeClr val="accent1"/>
-          </a:fillRef>
-          <a:effectRef idx="2">
-            <a:schemeClr val="accent1"/>
-          </a:effectRef>
-          <a:fontRef idx="minor">
-            <a:schemeClr val="lt1"/>
-          </a:fontRef>
-        </p:style>
-        <p:txBody>
-          <a:bodyPr rtlCol="0" anchor="ctr" wrap="square" lIns="228600" tIns="137160"/>
-          <a:lstStyle/>
-          <a:p>
-            <a:pPr/>
-            <a:r>
-              <a:rPr sz="1500" b="0">
-                <a:solidFill>
-                  <a:srgbClr val="1D3557"/>
-                </a:solidFill>
-                <a:latin typeface="Menlo"/>
-              </a:rPr>
-              <a:t>pendiente, intercepto = np.polyfit(por_comuna["ingreso"],</a:t>
-            </a:r>
-          </a:p>
-          <a:p>
-            <a:pPr/>
-            <a:r>
-              <a:rPr sz="1500" b="0">
-                <a:solidFill>
-                  <a:srgbClr val="1D3557"/>
-                </a:solidFill>
-                <a:latin typeface="Menlo"/>
-              </a:rPr>
-              <a:t>                                   por_comuna["duracion"], 1)</a:t>
-            </a:r>
-          </a:p>
-          <a:p>
-            <a:pPr/>
-            <a:r>
-              <a:rPr sz="1500" b="0">
-                <a:solidFill>
-                  <a:srgbClr val="1D3557"/>
-                </a:solidFill>
-                <a:latin typeface="Menlo"/>
-              </a:rPr>
-              <a:t/>
-            </a:r>
-          </a:p>
-          <a:p>
-            <a:pPr/>
-            <a:r>
-              <a:rPr sz="1500" b="0">
-                <a:solidFill>
-                  <a:srgbClr val="1D3557"/>
-                </a:solidFill>
-                <a:latin typeface="Menlo"/>
-              </a:rPr>
-              <a:t># La recta evaluada, para dibujarla sobre el scatter</a:t>
-            </a:r>
-          </a:p>
-          <a:p>
-            <a:pPr/>
-            <a:r>
-              <a:rPr sz="1500" b="0">
-                <a:solidFill>
-                  <a:srgbClr val="1D3557"/>
-                </a:solidFill>
-                <a:latin typeface="Menlo"/>
-              </a:rPr>
-              <a:t>ax.plot(x, intercepto + pendiente * x)</a:t>
-            </a:r>
-          </a:p>
-        </p:txBody>
-      </p:sp>
+              <a:t>La recta: ingreso y duración</a:t>
+            </a:r>
+          </a:p>
+        </p:txBody>
+      </p:sp>
+      <p:pic>
+        <p:nvPicPr>
+          <p:cNvPr id="4" name="Picture 3" descr="c3_18_ingreso_duracion_recta.png"/>
+          <p:cNvPicPr>
+            <a:picLocks noChangeAspect="1"/>
+          </p:cNvPicPr>
+          <p:nvPr/>
+        </p:nvPicPr>
+        <p:blipFill>
+          <a:blip r:embed="rId2"/>
+          <a:stretch>
+            <a:fillRect/>
+          </a:stretch>
+        </p:blipFill>
+        <p:spPr>
+          <a:xfrm>
+            <a:off x="2107331" y="1143000"/>
+            <a:ext cx="4929336" cy="3154679"/>
+          </a:xfrm>
+          <a:prstGeom prst="rect">
+            <a:avLst/>
+          </a:prstGeom>
+        </p:spPr>
+      </p:pic>
       <p:sp>
         <p:nvSpPr>
           <p:cNvPr id="5" name="TextBox 4"/>
@@ -7517,8 +7439,8 @@
         </p:nvSpPr>
         <p:spPr>
           <a:xfrm>
-            <a:off x="704088" y="4389120"/>
-            <a:ext cx="7744968" cy="1097280"/>
+            <a:off x="704088" y="4434840"/>
+            <a:ext cx="7744968" cy="457200"/>
           </a:xfrm>
           <a:prstGeom prst="rect">
             <a:avLst/>
@@ -7531,31 +7453,14 @@
           </a:bodyPr>
           <a:lstStyle/>
           <a:p>
-            <a:pPr>
-              <a:lnSpc>
-                <a:spcPct val="112000"/>
-              </a:lnSpc>
-              <a:spcAft>
-                <a:spcPts val="900"/>
-              </a:spcAft>
-            </a:pPr>
-            <a:r>
-              <a:rPr sz="1600" b="1">
-                <a:solidFill>
-                  <a:srgbClr val="E0A437"/>
-                </a:solidFill>
-                <a:latin typeface="Fira Sans"/>
-              </a:rPr>
-              <a:t>▸ </a:t>
-            </a:r>
-            <a:r>
-              <a:rPr sz="1600" b="0">
-                <a:solidFill>
-                  <a:srgbClr val="000000"/>
-                </a:solidFill>
-                <a:latin typeface="Fira Sans"/>
-              </a:rPr>
-              <a:t>polyfit ajusta un polinomio por mínimos cuadrados; el 1 pide grado 1, una recta. En las clases 6 y 7 usaremos herramientas con más diagnósticos.</a:t>
+            <a:r>
+              <a:rPr sz="1300" b="0">
+                <a:solidFill>
+                  <a:srgbClr val="333333"/>
+                </a:solidFill>
+                <a:latin typeface="Fira Sans"/>
+              </a:rPr>
+              <a:t>duración = 38,3 − 4,8 · ingreso (ponderada por factor): por cada millón adicional, la duración media baja casi 5 minutos. Y r² = 0,12: la recta captura el 12% de la variación; la asociación es real pero moderada, y así se reporta.</a:t>
             </a:r>
           </a:p>
         </p:txBody>
@@ -7651,7 +7556,7 @@
                 </a:solidFill>
                 <a:latin typeface="Fira Sans"/>
               </a:rPr>
-              <a:t>Usar la recta: predecir y medir residuos</a:t>
+              <a:t>La recta en NumPy</a:t>
             </a:r>
           </a:p>
         </p:txBody>
@@ -7706,7 +7611,7 @@
                 </a:solidFill>
                 <a:latin typeface="Menlo"/>
               </a:rPr>
-              <a:t>prediccion = intercepto + pendiente * ingreso</a:t>
+              <a:t>pendiente, intercepto = np.polyfit(por_comuna["ingreso"],</a:t>
             </a:r>
           </a:p>
           <a:p>
@@ -7718,7 +7623,7 @@
                 </a:solidFill>
                 <a:latin typeface="Menlo"/>
               </a:rPr>
-              <a:t>residuo = duracion - prediccion</a:t>
+              <a:t>                                   por_comuna["duracion"], 1)</a:t>
             </a:r>
           </a:p>
           <a:p>
@@ -7742,7 +7647,7 @@
                 </a:solidFill>
                 <a:latin typeface="Menlo"/>
               </a:rPr>
-              <a:t># ¿Qué comunas viajan más de lo que su ingreso predice?</a:t>
+              <a:t># La recta evaluada, para dibujarla sobre el scatter</a:t>
             </a:r>
           </a:p>
           <a:p>
@@ -7754,7 +7659,7 @@
                 </a:solidFill>
                 <a:latin typeface="Menlo"/>
               </a:rPr>
-              <a:t>por_comuna.nlargest(5, "residuo")</a:t>
+              <a:t>ax.plot(x, intercepto + pendiente * x)</a:t>
             </a:r>
           </a:p>
         </p:txBody>
@@ -7805,7 +7710,7 @@
                 </a:solidFill>
                 <a:latin typeface="Fira Sans"/>
               </a:rPr>
-              <a:t>La Pintana viaja 17 minutos más de lo predicho y Santiago 8 menos: el residuo revela periferia y centralidad. ¿Azar? La clase 5 responde.</a:t>
+              <a:t>polyfit ajusta un polinomio por mínimos cuadrados; el 1 pide grado 1, una recta. En las clases 6 y 7 usaremos herramientas con más diagnósticos.</a:t>
             </a:r>
           </a:p>
         </p:txBody>
@@ -7901,7 +7806,7 @@
                 </a:solidFill>
                 <a:latin typeface="Fira Sans"/>
               </a:rPr>
-              <a:t>El impacto de sacar una fila</a:t>
+              <a:t>Usar la recta: predecir y medir residuos</a:t>
             </a:r>
           </a:p>
         </p:txBody>
@@ -7956,7 +7861,7 @@
                 </a:solidFill>
                 <a:latin typeface="Menlo"/>
               </a:rPr>
-              <a:t>sin_lb = por_comuna[por_comuna["Comuna"] != "LO BARNECHEA"]</a:t>
+              <a:t>prediccion = intercepto + pendiente * ingreso</a:t>
             </a:r>
           </a:p>
           <a:p>
@@ -7968,6 +7873,18 @@
                 </a:solidFill>
                 <a:latin typeface="Menlo"/>
               </a:rPr>
+              <a:t>residuo = duracion - prediccion</a:t>
+            </a:r>
+          </a:p>
+          <a:p>
+            <a:pPr/>
+            <a:r>
+              <a:rPr sz="1500" b="0">
+                <a:solidFill>
+                  <a:srgbClr val="1D3557"/>
+                </a:solidFill>
+                <a:latin typeface="Menlo"/>
+              </a:rPr>
               <a:t/>
             </a:r>
           </a:p>
@@ -7980,7 +7897,7 @@
                 </a:solidFill>
                 <a:latin typeface="Menlo"/>
               </a:rPr>
-              <a:t># Todo se recalcula sin la fila, y se compara</a:t>
+              <a:t># ¿Qué comunas viajan más de lo que su ingreso predice?</a:t>
             </a:r>
           </a:p>
           <a:p>
@@ -7992,19 +7909,7 @@
                 </a:solidFill>
                 <a:latin typeface="Menlo"/>
               </a:rPr>
-              <a:t>sin_lb["ingreso"].corr(sin_lb["duracion"])</a:t>
-            </a:r>
-          </a:p>
-          <a:p>
-            <a:pPr/>
-            <a:r>
-              <a:rPr sz="1500" b="0">
-                <a:solidFill>
-                  <a:srgbClr val="1D3557"/>
-                </a:solidFill>
-                <a:latin typeface="Menlo"/>
-              </a:rPr>
-              <a:t>np.polyfit(sin_lb["ingreso"] / 1e6, sin_lb["duracion"], 1)</a:t>
+              <a:t>por_comuna.nlargest(5, "residuo")</a:t>
             </a:r>
           </a:p>
         </p:txBody>
@@ -8055,7 +7960,7 @@
                 </a:solidFill>
                 <a:latin typeface="Fira Sans"/>
               </a:rPr>
-              <a:t>Sacar 1 comuna de 45 casi no mueve r (−0,37 a −0,39) pero cambia la pendiente en un cuarto (−5,8 a −7,3): el impacto se mide con y sin, sobre todos los resúmenes en uso.</a:t>
+              <a:t>La Pintana viaja 13 minutos más de lo predicho y Santiago 7 menos: el residuo revela periferia y centralidad. ¿Azar? La clase 5 responde.</a:t>
             </a:r>
           </a:p>
         </p:txBody>
@@ -8151,7 +8056,7 @@
                 </a:solidFill>
                 <a:latin typeface="Fira Sans"/>
               </a:rPr>
-              <a:t>Otro modelo: la motorización del hogar</a:t>
+              <a:t>El impacto de sacar una fila</a:t>
             </a:r>
           </a:p>
         </p:txBody>
@@ -8206,7 +8111,7 @@
                 </a:solidFill>
                 <a:latin typeface="Menlo"/>
               </a:rPr>
-              <a:t>h = hogares.dropna(subset=["IngresoHogar", "NumVeh"])</a:t>
+              <a:t>sin_lb = por_comuna[por_comuna["Comuna"] != "LO BARNECHEA"]</a:t>
             </a:r>
           </a:p>
           <a:p>
@@ -8230,7 +8135,7 @@
                 </a:solidFill>
                 <a:latin typeface="Menlo"/>
               </a:rPr>
-              <a:t># ¿Cuántos vehículos tendrá un hogar, según su ingreso?</a:t>
+              <a:t># Todo se recalcula sin la fila, y se compara</a:t>
             </a:r>
           </a:p>
           <a:p>
@@ -8242,7 +8147,7 @@
                 </a:solidFill>
                 <a:latin typeface="Menlo"/>
               </a:rPr>
-              <a:t>pendiente, intercepto = np.polyfit(h["IngresoHogar"] / 1e6,</a:t>
+              <a:t>sin_lb["ingreso"].corr(sin_lb["duracion"])</a:t>
             </a:r>
           </a:p>
           <a:p>
@@ -8254,7 +8159,7 @@
                 </a:solidFill>
                 <a:latin typeface="Menlo"/>
               </a:rPr>
-              <a:t>                                   h["NumVeh"], 1)</a:t>
+              <a:t>np.polyfit(sin_lb["ingreso"] / 1e6, sin_lb["duracion"], 1)</a:t>
             </a:r>
           </a:p>
         </p:txBody>
@@ -8305,7 +8210,7 @@
                 </a:solidFill>
                 <a:latin typeface="Fira Sans"/>
               </a:rPr>
-              <a:t>18.264 hogares, cada fila un hogar real: vehículos = 0,18 + 0,45 · ingreso. Casi medio vehículo más por millón (r = 0,47).</a:t>
+              <a:t>Sacar 1 comuna de 45 no mueve r (−0,34) pero cambia la pendiente en un quinto (−4,8 a −5,8): el impacto se mide con y sin, sobre todos los resúmenes en uso.</a:t>
             </a:r>
           </a:p>
         </p:txBody>
@@ -8401,7 +8306,7 @@
                 </a:solidFill>
                 <a:latin typeface="Fira Sans"/>
               </a:rPr>
-              <a:t>Sacar atípicos de la variable a predecir</a:t>
+              <a:t>Otro modelo: la motorización del hogar</a:t>
             </a:r>
           </a:p>
         </p:txBody>
@@ -8456,7 +8361,7 @@
                 </a:solidFill>
                 <a:latin typeface="Menlo"/>
               </a:rPr>
-              <a:t>q1, q3 = h["NumVeh"].quantile([0.25, 0.75])</a:t>
+              <a:t>x = h["IngresoHogar"] / 1e6</a:t>
             </a:r>
           </a:p>
           <a:p>
@@ -8468,7 +8373,7 @@
                 </a:solidFill>
                 <a:latin typeface="Menlo"/>
               </a:rPr>
-              <a:t>sin_atipicos = h[h["NumVeh"] &lt;= q3 + 1.5 * (q3 - q1)]</a:t>
+              <a:t>y, w = h["NumVeh"], h["Factor"]</a:t>
             </a:r>
           </a:p>
           <a:p>
@@ -8492,7 +8397,7 @@
                 </a:solidFill>
                 <a:latin typeface="Menlo"/>
               </a:rPr>
-              <a:t># El mismo modelo, sin los hogares de 3 autos o más</a:t>
+              <a:t># La fórmula de la pendiente ponderada, tal cual</a:t>
             </a:r>
           </a:p>
           <a:p>
@@ -8504,7 +8409,7 @@
                 </a:solidFill>
                 <a:latin typeface="Menlo"/>
               </a:rPr>
-              <a:t>np.polyfit(sin_atipicos["IngresoHogar"] / 1e6, sin_atipicos["NumVeh"], 1)</a:t>
+              <a:t>b = (w*(x - xw)*(y - yw)).sum() / (w*(x - xw)**2).sum()</a:t>
             </a:r>
           </a:p>
         </p:txBody>
@@ -8555,7 +8460,7 @@
                 </a:solidFill>
                 <a:latin typeface="Fira Sans"/>
               </a:rPr>
-              <a:t>Sacar 236 hogares aplana la pendiente (0,45 a 0,39): no eran errores, eran la señal. Los atípicos de y se investigan; se eliminan solo por dominio.</a:t>
+              <a:t>18.264 hogares reales, ponderados por su factor: vehículos = 0,20 + 0,50 · ingreso. Medio vehículo más por cada millón.</a:t>
             </a:r>
           </a:p>
         </p:txBody>
@@ -8593,7 +8498,7 @@
             <a:avLst/>
           </a:prstGeom>
           <a:solidFill>
-            <a:srgbClr val="1D3557"/>
+            <a:srgbClr val="FAFBFC"/>
           </a:solidFill>
           <a:ln>
             <a:noFill/>
@@ -8630,8 +8535,8 @@
         </p:nvSpPr>
         <p:spPr>
           <a:xfrm>
-            <a:off x="603504" y="1847088"/>
-            <a:ext cx="7946136" cy="1399032"/>
+            <a:off x="402336" y="301752"/>
+            <a:ext cx="8348472" cy="795528"/>
           </a:xfrm>
           <a:prstGeom prst="rect">
             <a:avLst/>
@@ -8645,24 +8550,167 @@
           <a:lstStyle/>
           <a:p>
             <a:r>
-              <a:rPr sz="3400" b="1">
-                <a:solidFill>
-                  <a:srgbClr val="FFFFFF"/>
-                </a:solidFill>
-                <a:latin typeface="Fira Sans"/>
-              </a:rPr>
-              <a:t>Buenas prácticas de visualización</a:t>
-            </a:r>
-          </a:p>
-          <a:p>
-            <a:r>
-              <a:rPr sz="1800" b="0">
+              <a:rPr sz="2800" b="1">
+                <a:solidFill>
+                  <a:srgbClr val="0F0F0F"/>
+                </a:solidFill>
+                <a:latin typeface="Fira Sans"/>
+              </a:rPr>
+              <a:t>Sacar atípicos de la variable a predecir</a:t>
+            </a:r>
+          </a:p>
+        </p:txBody>
+      </p:sp>
+      <p:sp>
+        <p:nvSpPr>
+          <p:cNvPr id="4" name="Rectangle 3"/>
+          <p:cNvSpPr/>
+          <p:nvPr/>
+        </p:nvSpPr>
+        <p:spPr>
+          <a:xfrm>
+            <a:off x="704088" y="1280160"/>
+            <a:ext cx="7744968" cy="2880360"/>
+          </a:xfrm>
+          <a:prstGeom prst="rect">
+            <a:avLst/>
+          </a:prstGeom>
+          <a:solidFill>
+            <a:srgbClr val="F0F2F5"/>
+          </a:solidFill>
+          <a:ln>
+            <a:solidFill>
+              <a:srgbClr val="D8DDE3"/>
+            </a:solidFill>
+          </a:ln>
+          <a:effectLst/>
+        </p:spPr>
+        <p:style>
+          <a:lnRef idx="1">
+            <a:schemeClr val="accent1"/>
+          </a:lnRef>
+          <a:fillRef idx="3">
+            <a:schemeClr val="accent1"/>
+          </a:fillRef>
+          <a:effectRef idx="2">
+            <a:schemeClr val="accent1"/>
+          </a:effectRef>
+          <a:fontRef idx="minor">
+            <a:schemeClr val="lt1"/>
+          </a:fontRef>
+        </p:style>
+        <p:txBody>
+          <a:bodyPr rtlCol="0" anchor="ctr" wrap="square" lIns="228600" tIns="137160"/>
+          <a:lstStyle/>
+          <a:p>
+            <a:pPr/>
+            <a:r>
+              <a:rPr sz="1500" b="0">
+                <a:solidFill>
+                  <a:srgbClr val="1D3557"/>
+                </a:solidFill>
+                <a:latin typeface="Menlo"/>
+              </a:rPr>
+              <a:t>q1, q3 = h["NumVeh"].quantile([0.25, 0.75])</a:t>
+            </a:r>
+          </a:p>
+          <a:p>
+            <a:pPr/>
+            <a:r>
+              <a:rPr sz="1500" b="0">
+                <a:solidFill>
+                  <a:srgbClr val="1D3557"/>
+                </a:solidFill>
+                <a:latin typeface="Menlo"/>
+              </a:rPr>
+              <a:t>sin_atipicos = h[h["NumVeh"] &lt;= q3 + 1.5 * (q3 - q1)]</a:t>
+            </a:r>
+          </a:p>
+          <a:p>
+            <a:pPr/>
+            <a:r>
+              <a:rPr sz="1500" b="0">
+                <a:solidFill>
+                  <a:srgbClr val="1D3557"/>
+                </a:solidFill>
+                <a:latin typeface="Menlo"/>
+              </a:rPr>
+              <a:t/>
+            </a:r>
+          </a:p>
+          <a:p>
+            <a:pPr/>
+            <a:r>
+              <a:rPr sz="1500" b="0">
+                <a:solidFill>
+                  <a:srgbClr val="1D3557"/>
+                </a:solidFill>
+                <a:latin typeface="Menlo"/>
+              </a:rPr>
+              <a:t># El mismo modelo, sin los hogares de 3 autos o más</a:t>
+            </a:r>
+          </a:p>
+          <a:p>
+            <a:pPr/>
+            <a:r>
+              <a:rPr sz="1500" b="0">
+                <a:solidFill>
+                  <a:srgbClr val="1D3557"/>
+                </a:solidFill>
+                <a:latin typeface="Menlo"/>
+              </a:rPr>
+              <a:t>np.polyfit(sin_atipicos["IngresoHogar"] / 1e6, sin_atipicos["NumVeh"], 1)</a:t>
+            </a:r>
+          </a:p>
+        </p:txBody>
+      </p:sp>
+      <p:sp>
+        <p:nvSpPr>
+          <p:cNvPr id="5" name="TextBox 4"/>
+          <p:cNvSpPr txBox="1"/>
+          <p:nvPr/>
+        </p:nvSpPr>
+        <p:spPr>
+          <a:xfrm>
+            <a:off x="704088" y="4389120"/>
+            <a:ext cx="7744968" cy="1097280"/>
+          </a:xfrm>
+          <a:prstGeom prst="rect">
+            <a:avLst/>
+          </a:prstGeom>
+          <a:noFill/>
+        </p:spPr>
+        <p:txBody>
+          <a:bodyPr wrap="square">
+            <a:spAutoFit/>
+          </a:bodyPr>
+          <a:lstStyle/>
+          <a:p>
+            <a:pPr>
+              <a:lnSpc>
+                <a:spcPct val="112000"/>
+              </a:lnSpc>
+              <a:spcAft>
+                <a:spcPts val="900"/>
+              </a:spcAft>
+            </a:pPr>
+            <a:r>
+              <a:rPr sz="1600" b="1">
                 <a:solidFill>
                   <a:srgbClr val="E0A437"/>
                 </a:solidFill>
                 <a:latin typeface="Fira Sans"/>
               </a:rPr>
-              <a:t>Que el gráfico diga la verdad y se entienda</a:t>
+              <a:t>▸ </a:t>
+            </a:r>
+            <a:r>
+              <a:rPr sz="1600" b="0">
+                <a:solidFill>
+                  <a:srgbClr val="000000"/>
+                </a:solidFill>
+                <a:latin typeface="Fira Sans"/>
+              </a:rPr>
+              <a:t>Sacar 236 hogares aplana la pendiente ponderada (0,50 a 0,44): no eran errores, eran la señal. Los atípicos de y se investigan; se eliminan solo por dominio.</a:t>
             </a:r>
           </a:p>
         </p:txBody>
@@ -8700,7 +8748,7 @@
             <a:avLst/>
           </a:prstGeom>
           <a:solidFill>
-            <a:srgbClr val="FAFBFC"/>
+            <a:srgbClr val="1D3557"/>
           </a:solidFill>
           <a:ln>
             <a:noFill/>
@@ -8737,8 +8785,8 @@
         </p:nvSpPr>
         <p:spPr>
           <a:xfrm>
-            <a:off x="402336" y="301752"/>
-            <a:ext cx="8348472" cy="795528"/>
+            <a:off x="603504" y="1847088"/>
+            <a:ext cx="7946136" cy="1399032"/>
           </a:xfrm>
           <a:prstGeom prst="rect">
             <a:avLst/>
@@ -8752,71 +8800,24 @@
           <a:lstStyle/>
           <a:p>
             <a:r>
-              <a:rPr sz="2800" b="1">
-                <a:solidFill>
-                  <a:srgbClr val="0F0F0F"/>
-                </a:solidFill>
-                <a:latin typeface="Fira Sans"/>
-              </a:rPr>
-              <a:t>Graficar 90 mil puntos: overplotting</a:t>
-            </a:r>
-          </a:p>
-        </p:txBody>
-      </p:sp>
-      <p:pic>
-        <p:nvPicPr>
-          <p:cNvPr id="4" name="Picture 3" descr="c3_08_overplotting.png"/>
-          <p:cNvPicPr>
-            <a:picLocks noChangeAspect="1"/>
-          </p:cNvPicPr>
-          <p:nvPr/>
-        </p:nvPicPr>
-        <p:blipFill>
-          <a:blip r:embed="rId2"/>
-          <a:stretch>
-            <a:fillRect/>
-          </a:stretch>
-        </p:blipFill>
-        <p:spPr>
-          <a:xfrm>
-            <a:off x="1417319" y="1143000"/>
-            <a:ext cx="6309360" cy="1913950"/>
-          </a:xfrm>
-          <a:prstGeom prst="rect">
-            <a:avLst/>
-          </a:prstGeom>
-        </p:spPr>
-      </p:pic>
-      <p:sp>
-        <p:nvSpPr>
-          <p:cNvPr id="5" name="TextBox 4"/>
-          <p:cNvSpPr txBox="1"/>
-          <p:nvPr/>
-        </p:nvSpPr>
-        <p:spPr>
-          <a:xfrm>
-            <a:off x="704088" y="4434840"/>
-            <a:ext cx="7744968" cy="457200"/>
-          </a:xfrm>
-          <a:prstGeom prst="rect">
-            <a:avLst/>
-          </a:prstGeom>
-          <a:noFill/>
-        </p:spPr>
-        <p:txBody>
-          <a:bodyPr wrap="square">
-            <a:spAutoFit/>
-          </a:bodyPr>
-          <a:lstStyle/>
-          <a:p>
-            <a:r>
-              <a:rPr sz="1300" b="0">
-                <a:solidFill>
-                  <a:srgbClr val="333333"/>
-                </a:solidFill>
-                <a:latin typeface="Fira Sans"/>
-              </a:rPr>
-              <a:t>Con todos los puntos sólidos, el scatter se satura y miente. Los remedios: transparencia (alpha), muestreo, o hexbin, donde el color cuenta los viajes (la distancia se calcula con las coordenadas; el notebook muestra el cálculo).</a:t>
+              <a:rPr sz="3400" b="1">
+                <a:solidFill>
+                  <a:srgbClr val="FFFFFF"/>
+                </a:solidFill>
+                <a:latin typeface="Fira Sans"/>
+              </a:rPr>
+              <a:t>Buenas prácticas de visualización</a:t>
+            </a:r>
+          </a:p>
+          <a:p>
+            <a:r>
+              <a:rPr sz="1800" b="0">
+                <a:solidFill>
+                  <a:srgbClr val="E0A437"/>
+                </a:solidFill>
+                <a:latin typeface="Fira Sans"/>
+              </a:rPr>
+              <a:t>Que el gráfico diga la verdad y se entienda</a:t>
             </a:r>
           </a:p>
         </p:txBody>
@@ -8912,14 +8913,14 @@
                 </a:solidFill>
                 <a:latin typeface="Fira Sans"/>
               </a:rPr>
-              <a:t>Cuándo usar escala logarítmica</a:t>
+              <a:t>Graficar 90 mil puntos: overplotting</a:t>
             </a:r>
           </a:p>
         </p:txBody>
       </p:sp>
       <p:pic>
         <p:nvPicPr>
-          <p:cNvPr id="4" name="Picture 3" descr="c3_10_escala_log.png"/>
+          <p:cNvPr id="4" name="Picture 3" descr="c3_08_overplotting.png"/>
           <p:cNvPicPr>
             <a:picLocks noChangeAspect="1"/>
           </p:cNvPicPr>
@@ -8934,7 +8935,7 @@
         <p:spPr>
           <a:xfrm>
             <a:off x="1417319" y="1143000"/>
-            <a:ext cx="6309360" cy="2432846"/>
+            <a:ext cx="6309360" cy="1913950"/>
           </a:xfrm>
           <a:prstGeom prst="rect">
             <a:avLst/>
@@ -8970,7 +8971,7 @@
                 </a:solidFill>
                 <a:latin typeface="Fira Sans"/>
               </a:rPr>
-              <a:t>Con colas largas como el ingreso, la escala lineal aplasta el 99% de los datos contra el borde; la logarítmica reparte el espacio y la forma aparece.</a:t>
+              <a:t>Con todos los puntos sólidos, el scatter se satura y miente. Los remedios: transparencia (alpha), muestreo, o hexbin, donde el color cuenta los viajes (la distancia se calcula con las coordenadas; el notebook muestra el cálculo).</a:t>
             </a:r>
           </a:p>
         </p:txBody>
@@ -9066,14 +9067,14 @@
                 </a:solidFill>
                 <a:latin typeface="Fira Sans"/>
               </a:rPr>
-              <a:t>El mismo gráfico, dos veces</a:t>
+              <a:t>Cuándo usar escala logarítmica</a:t>
             </a:r>
           </a:p>
         </p:txBody>
       </p:sp>
       <p:pic>
         <p:nvPicPr>
-          <p:cNvPr id="4" name="Picture 3" descr="c3_16_mal_buen_grafico.png"/>
+          <p:cNvPr id="4" name="Picture 3" descr="c3_10_escala_log.png"/>
           <p:cNvPicPr>
             <a:picLocks noChangeAspect="1"/>
           </p:cNvPicPr>
@@ -9088,7 +9089,7 @@
         <p:spPr>
           <a:xfrm>
             <a:off x="1417319" y="1143000"/>
-            <a:ext cx="6309360" cy="2447822"/>
+            <a:ext cx="6309360" cy="2432846"/>
           </a:xfrm>
           <a:prstGeom prst="rect">
             <a:avLst/>
@@ -9124,7 +9125,7 @@
                 </a:solidFill>
                 <a:latin typeface="Fira Sans"/>
               </a:rPr>
-              <a:t>Los mismos 30 mil viajes: sin rotular y saturado, contra rotulado, con transparencia y con el hallazgo en el título.</a:t>
+              <a:t>Con colas largas como el ingreso, la escala lineal aplasta el 99% de los datos contra el borde; la logarítmica reparte el espacio y la forma aparece.</a:t>
             </a:r>
           </a:p>
         </p:txBody>
@@ -9479,21 +9480,45 @@
                 </a:solidFill>
                 <a:latin typeface="Fira Sans"/>
               </a:rPr>
-              <a:t>Checklist del buen gráfico</a:t>
-            </a:r>
-          </a:p>
-        </p:txBody>
-      </p:sp>
-      <p:sp>
-        <p:nvSpPr>
-          <p:cNvPr id="4" name="TextBox 3"/>
+              <a:t>El mismo gráfico, dos veces</a:t>
+            </a:r>
+          </a:p>
+        </p:txBody>
+      </p:sp>
+      <p:pic>
+        <p:nvPicPr>
+          <p:cNvPr id="4" name="Picture 3" descr="c3_16_mal_buen_grafico.png"/>
+          <p:cNvPicPr>
+            <a:picLocks noChangeAspect="1"/>
+          </p:cNvPicPr>
+          <p:nvPr/>
+        </p:nvPicPr>
+        <p:blipFill>
+          <a:blip r:embed="rId2"/>
+          <a:stretch>
+            <a:fillRect/>
+          </a:stretch>
+        </p:blipFill>
+        <p:spPr>
+          <a:xfrm>
+            <a:off x="1417319" y="1143000"/>
+            <a:ext cx="6309360" cy="2447822"/>
+          </a:xfrm>
+          <a:prstGeom prst="rect">
+            <a:avLst/>
+          </a:prstGeom>
+        </p:spPr>
+      </p:pic>
+      <p:sp>
+        <p:nvSpPr>
+          <p:cNvPr id="5" name="TextBox 4"/>
           <p:cNvSpPr txBox="1"/>
           <p:nvPr/>
         </p:nvSpPr>
         <p:spPr>
           <a:xfrm>
-            <a:off x="704088" y="1353312"/>
-            <a:ext cx="7744968" cy="3300984"/>
+            <a:off x="704088" y="4434840"/>
+            <a:ext cx="7744968" cy="457200"/>
           </a:xfrm>
           <a:prstGeom prst="rect">
             <a:avLst/>
@@ -9506,143 +9531,14 @@
           </a:bodyPr>
           <a:lstStyle/>
           <a:p>
-            <a:pPr>
-              <a:lnSpc>
-                <a:spcPct val="112000"/>
-              </a:lnSpc>
-              <a:spcAft>
-                <a:spcPts val="900"/>
-              </a:spcAft>
-            </a:pPr>
-            <a:r>
-              <a:rPr sz="1800" b="1">
-                <a:solidFill>
-                  <a:srgbClr val="E0A437"/>
-                </a:solidFill>
-                <a:latin typeface="Fira Sans"/>
-              </a:rPr>
-              <a:t>▸ </a:t>
-            </a:r>
-            <a:r>
-              <a:rPr sz="1800" b="0">
-                <a:solidFill>
-                  <a:srgbClr val="000000"/>
-                </a:solidFill>
-                <a:latin typeface="Fira Sans"/>
-              </a:rPr>
-              <a:t>Título que diga el hallazgo, no solo las variables.</a:t>
-            </a:r>
-          </a:p>
-          <a:p>
-            <a:pPr>
-              <a:lnSpc>
-                <a:spcPct val="112000"/>
-              </a:lnSpc>
-              <a:spcAft>
-                <a:spcPts val="900"/>
-              </a:spcAft>
-            </a:pPr>
-            <a:r>
-              <a:rPr sz="1800" b="1">
-                <a:solidFill>
-                  <a:srgbClr val="E0A437"/>
-                </a:solidFill>
-                <a:latin typeface="Fira Sans"/>
-              </a:rPr>
-              <a:t>▸ </a:t>
-            </a:r>
-            <a:r>
-              <a:rPr sz="1800" b="0">
-                <a:solidFill>
-                  <a:srgbClr val="000000"/>
-                </a:solidFill>
-                <a:latin typeface="Fira Sans"/>
-              </a:rPr>
-              <a:t>Ejes con nombre y unidad; ejes que parten de cero en gráficos de barras.</a:t>
-            </a:r>
-          </a:p>
-          <a:p>
-            <a:pPr>
-              <a:lnSpc>
-                <a:spcPct val="112000"/>
-              </a:lnSpc>
-              <a:spcAft>
-                <a:spcPts val="900"/>
-              </a:spcAft>
-            </a:pPr>
-            <a:r>
-              <a:rPr sz="1800" b="1">
-                <a:solidFill>
-                  <a:srgbClr val="E0A437"/>
-                </a:solidFill>
-                <a:latin typeface="Fira Sans"/>
-              </a:rPr>
-              <a:t>▸ </a:t>
-            </a:r>
-            <a:r>
-              <a:rPr sz="1800" b="0">
-                <a:solidFill>
-                  <a:srgbClr val="000000"/>
-                </a:solidFill>
-                <a:latin typeface="Fira Sans"/>
-              </a:rPr>
-              <a:t>Muchos puntos: alpha, muestreo o hexbin.</a:t>
-            </a:r>
-          </a:p>
-          <a:p>
-            <a:pPr>
-              <a:lnSpc>
-                <a:spcPct val="112000"/>
-              </a:lnSpc>
-              <a:spcAft>
-                <a:spcPts val="900"/>
-              </a:spcAft>
-            </a:pPr>
-            <a:r>
-              <a:rPr sz="1800" b="1">
-                <a:solidFill>
-                  <a:srgbClr val="E0A437"/>
-                </a:solidFill>
-                <a:latin typeface="Fira Sans"/>
-              </a:rPr>
-              <a:t>▸ </a:t>
-            </a:r>
-            <a:r>
-              <a:rPr sz="1800" b="0">
-                <a:solidFill>
-                  <a:srgbClr val="000000"/>
-                </a:solidFill>
-                <a:latin typeface="Fira Sans"/>
-              </a:rPr>
-              <a:t>Colas largas: escala logarítmica o eje recortado, declarándolo.</a:t>
-            </a:r>
-          </a:p>
-          <a:p>
-            <a:pPr>
-              <a:lnSpc>
-                <a:spcPct val="112000"/>
-              </a:lnSpc>
-              <a:spcAft>
-                <a:spcPts val="900"/>
-              </a:spcAft>
-            </a:pPr>
-            <a:r>
-              <a:rPr sz="1800" b="1">
-                <a:solidFill>
-                  <a:srgbClr val="E0A437"/>
-                </a:solidFill>
-                <a:latin typeface="Fira Sans"/>
-              </a:rPr>
-              <a:t>▸ </a:t>
-            </a:r>
-            <a:r>
-              <a:rPr sz="1800" b="1">
-                <a:solidFill>
-                  <a:srgbClr val="1D3557"/>
-                </a:solidFill>
-                <a:latin typeface="Fira Sans"/>
-              </a:rPr>
-              <a:t>El gráfico se corrige igual que el código: se itera hasta que un tercero lo entienda sin explicación oral.</a:t>
+            <a:r>
+              <a:rPr sz="1300" b="0">
+                <a:solidFill>
+                  <a:srgbClr val="333333"/>
+                </a:solidFill>
+                <a:latin typeface="Fira Sans"/>
+              </a:rPr>
+              <a:t>Los mismos 30 mil viajes: sin rotular y saturado, contra rotulado, con transparencia y con el hallazgo en el título.</a:t>
             </a:r>
           </a:p>
         </p:txBody>
@@ -9738,7 +9634,7 @@
                 </a:solidFill>
                 <a:latin typeface="Fira Sans"/>
               </a:rPr>
-              <a:t>Síntesis</a:t>
+              <a:t>Checklist del buen gráfico</a:t>
             </a:r>
           </a:p>
         </p:txBody>
@@ -9789,7 +9685,7 @@
                 </a:solidFill>
                 <a:latin typeface="Fira Sans"/>
               </a:rPr>
-              <a:t>El análisis bivariado se elige según el par de tipos: scatter y correlación, groupby y boxplot, o tabla de contingencia.</a:t>
+              <a:t>Título que diga el hallazgo, no solo las variables.</a:t>
             </a:r>
           </a:p>
           <a:p>
@@ -9817,7 +9713,7 @@
                 </a:solidFill>
                 <a:latin typeface="Fira Sans"/>
               </a:rPr>
-              <a:t>Pearson para relaciones lineales; Spearman cuando hay atípicos o curvas. Y siempre graficar: Anscombe.</a:t>
+              <a:t>Ejes con nombre y unidad; ejes que parten de cero en gráficos de barras.</a:t>
             </a:r>
           </a:p>
           <a:p>
@@ -9845,7 +9741,7 @@
                 </a:solidFill>
                 <a:latin typeface="Fira Sans"/>
               </a:rPr>
-              <a:t>Correlación no es causalidad: reportamos asociación.</a:t>
+              <a:t>Muchos puntos: alpha, muestreo o hexbin.</a:t>
             </a:r>
           </a:p>
           <a:p>
@@ -9873,7 +9769,7 @@
                 </a:solidFill>
                 <a:latin typeface="Fira Sans"/>
               </a:rPr>
-              <a:t>La regresión es el primer modelo: una función que resume, predice y deja residuos que diagnostican.</a:t>
+              <a:t>Colas largas: escala logarítmica o eje recortado, declarándolo.</a:t>
             </a:r>
           </a:p>
           <a:p>
@@ -9901,7 +9797,7 @@
                 </a:solidFill>
                 <a:latin typeface="Fira Sans"/>
               </a:rPr>
-              <a:t>Todo lo de hoy es exactamente lo que el primer EDA del proyecto debe mostrar (entrega: lunes 15).</a:t>
+              <a:t>El gráfico se corrige igual que el código: se itera hasta que un tercero lo entienda sin explicación oral.</a:t>
             </a:r>
           </a:p>
         </p:txBody>
@@ -9997,7 +9893,7 @@
                 </a:solidFill>
                 <a:latin typeface="Fira Sans"/>
               </a:rPr>
-              <a:t>Próxima clase</a:t>
+              <a:t>Síntesis</a:t>
             </a:r>
           </a:p>
         </p:txBody>
@@ -10042,13 +9938,13 @@
               <a:t>▸ </a:t>
             </a:r>
             <a:r>
-              <a:rPr sz="1800" b="1">
-                <a:solidFill>
-                  <a:srgbClr val="1D3557"/>
-                </a:solidFill>
-                <a:latin typeface="Fira Sans"/>
-              </a:rPr>
-              <a:t>Jueves 3 de septiembre: presentaciones breves de las ideas de proyecto (5 minutos por equipo, sin nota).</a:t>
+              <a:rPr sz="1800" b="0">
+                <a:solidFill>
+                  <a:srgbClr val="000000"/>
+                </a:solidFill>
+                <a:latin typeface="Fira Sans"/>
+              </a:rPr>
+              <a:t>El análisis bivariado se elige según el par de tipos: scatter y correlación, groupby y boxplot, o tabla de contingencia.</a:t>
             </a:r>
           </a:p>
           <a:p>
@@ -10076,7 +9972,7 @@
                 </a:solidFill>
                 <a:latin typeface="Fira Sans"/>
               </a:rPr>
-              <a:t>Después: fundamentos de probabilidad, la base para la inferencia de las clases siguientes.</a:t>
+              <a:t>Pearson para relaciones lineales; Spearman cuando hay atípicos o curvas. Y siempre graficar: Anscombe.</a:t>
             </a:r>
           </a:p>
           <a:p>
@@ -10104,7 +10000,7 @@
                 </a:solidFill>
                 <a:latin typeface="Fira Sans"/>
               </a:rPr>
-              <a:t>Se publica la rúbrica del primer análisis exploratorio.</a:t>
+              <a:t>Correlación no es causalidad: reportamos asociación.</a:t>
             </a:r>
           </a:p>
           <a:p>
@@ -10132,7 +10028,35 @@
                 </a:solidFill>
                 <a:latin typeface="Fira Sans"/>
               </a:rPr>
-              <a:t>Recuerden: la formulación se entrega el lunes 7 por el aula virtual.</a:t>
+              <a:t>La regresión es el primer modelo: una función que resume, predice y deja residuos que diagnostican.</a:t>
+            </a:r>
+          </a:p>
+          <a:p>
+            <a:pPr>
+              <a:lnSpc>
+                <a:spcPct val="112000"/>
+              </a:lnSpc>
+              <a:spcAft>
+                <a:spcPts val="900"/>
+              </a:spcAft>
+            </a:pPr>
+            <a:r>
+              <a:rPr sz="1800" b="1">
+                <a:solidFill>
+                  <a:srgbClr val="E0A437"/>
+                </a:solidFill>
+                <a:latin typeface="Fira Sans"/>
+              </a:rPr>
+              <a:t>▸ </a:t>
+            </a:r>
+            <a:r>
+              <a:rPr sz="1800" b="1">
+                <a:solidFill>
+                  <a:srgbClr val="1D3557"/>
+                </a:solidFill>
+                <a:latin typeface="Fira Sans"/>
+              </a:rPr>
+              <a:t>Todo lo de hoy es exactamente lo que el primer EDA del proyecto debe mostrar (entrega: lunes 15).</a:t>
             </a:r>
           </a:p>
         </p:txBody>
@@ -10146,6 +10070,237 @@
 </file>
 
 <file path=ppt/slides/slide43.xml><?xml version="1.0" encoding="utf-8"?>
+<p:sld xmlns:a="http://schemas.openxmlformats.org/drawingml/2006/main" xmlns:p="http://schemas.openxmlformats.org/presentationml/2006/main" xmlns:r="http://schemas.openxmlformats.org/officeDocument/2006/relationships">
+  <p:cSld>
+    <p:spTree>
+      <p:nvGrpSpPr>
+        <p:cNvPr id="1" name=""/>
+        <p:cNvGrpSpPr/>
+        <p:nvPr/>
+      </p:nvGrpSpPr>
+      <p:grpSpPr/>
+      <p:sp>
+        <p:nvSpPr>
+          <p:cNvPr id="2" name="Rectangle 1"/>
+          <p:cNvSpPr/>
+          <p:nvPr/>
+        </p:nvSpPr>
+        <p:spPr>
+          <a:xfrm>
+            <a:off x="0" y="0"/>
+            <a:ext cx="9144000" cy="5138928"/>
+          </a:xfrm>
+          <a:prstGeom prst="rect">
+            <a:avLst/>
+          </a:prstGeom>
+          <a:solidFill>
+            <a:srgbClr val="FAFBFC"/>
+          </a:solidFill>
+          <a:ln>
+            <a:noFill/>
+          </a:ln>
+          <a:effectLst/>
+        </p:spPr>
+        <p:style>
+          <a:lnRef idx="1">
+            <a:schemeClr val="accent1"/>
+          </a:lnRef>
+          <a:fillRef idx="3">
+            <a:schemeClr val="accent1"/>
+          </a:fillRef>
+          <a:effectRef idx="2">
+            <a:schemeClr val="accent1"/>
+          </a:effectRef>
+          <a:fontRef idx="minor">
+            <a:schemeClr val="lt1"/>
+          </a:fontRef>
+        </p:style>
+        <p:txBody>
+          <a:bodyPr rtlCol="0" anchor="ctr"/>
+          <a:lstStyle/>
+          <a:p>
+            <a:pPr algn="ctr"/>
+          </a:p>
+        </p:txBody>
+      </p:sp>
+      <p:sp>
+        <p:nvSpPr>
+          <p:cNvPr id="3" name="TextBox 2"/>
+          <p:cNvSpPr txBox="1"/>
+          <p:nvPr/>
+        </p:nvSpPr>
+        <p:spPr>
+          <a:xfrm>
+            <a:off x="402336" y="301752"/>
+            <a:ext cx="8348472" cy="795528"/>
+          </a:xfrm>
+          <a:prstGeom prst="rect">
+            <a:avLst/>
+          </a:prstGeom>
+          <a:noFill/>
+        </p:spPr>
+        <p:txBody>
+          <a:bodyPr wrap="square">
+            <a:spAutoFit/>
+          </a:bodyPr>
+          <a:lstStyle/>
+          <a:p>
+            <a:r>
+              <a:rPr sz="2800" b="1">
+                <a:solidFill>
+                  <a:srgbClr val="0F0F0F"/>
+                </a:solidFill>
+                <a:latin typeface="Fira Sans"/>
+              </a:rPr>
+              <a:t>Próxima clase</a:t>
+            </a:r>
+          </a:p>
+        </p:txBody>
+      </p:sp>
+      <p:sp>
+        <p:nvSpPr>
+          <p:cNvPr id="4" name="TextBox 3"/>
+          <p:cNvSpPr txBox="1"/>
+          <p:nvPr/>
+        </p:nvSpPr>
+        <p:spPr>
+          <a:xfrm>
+            <a:off x="704088" y="1353312"/>
+            <a:ext cx="7744968" cy="3300984"/>
+          </a:xfrm>
+          <a:prstGeom prst="rect">
+            <a:avLst/>
+          </a:prstGeom>
+          <a:noFill/>
+        </p:spPr>
+        <p:txBody>
+          <a:bodyPr wrap="square">
+            <a:spAutoFit/>
+          </a:bodyPr>
+          <a:lstStyle/>
+          <a:p>
+            <a:pPr>
+              <a:lnSpc>
+                <a:spcPct val="112000"/>
+              </a:lnSpc>
+              <a:spcAft>
+                <a:spcPts val="900"/>
+              </a:spcAft>
+            </a:pPr>
+            <a:r>
+              <a:rPr sz="1800" b="1">
+                <a:solidFill>
+                  <a:srgbClr val="E0A437"/>
+                </a:solidFill>
+                <a:latin typeface="Fira Sans"/>
+              </a:rPr>
+              <a:t>▸ </a:t>
+            </a:r>
+            <a:r>
+              <a:rPr sz="1800" b="1">
+                <a:solidFill>
+                  <a:srgbClr val="1D3557"/>
+                </a:solidFill>
+                <a:latin typeface="Fira Sans"/>
+              </a:rPr>
+              <a:t>Jueves 3 de septiembre: presentaciones breves de las ideas de proyecto (5 minutos por equipo, sin nota).</a:t>
+            </a:r>
+          </a:p>
+          <a:p>
+            <a:pPr>
+              <a:lnSpc>
+                <a:spcPct val="112000"/>
+              </a:lnSpc>
+              <a:spcAft>
+                <a:spcPts val="900"/>
+              </a:spcAft>
+            </a:pPr>
+            <a:r>
+              <a:rPr sz="1800" b="1">
+                <a:solidFill>
+                  <a:srgbClr val="E0A437"/>
+                </a:solidFill>
+                <a:latin typeface="Fira Sans"/>
+              </a:rPr>
+              <a:t>▸ </a:t>
+            </a:r>
+            <a:r>
+              <a:rPr sz="1800" b="0">
+                <a:solidFill>
+                  <a:srgbClr val="000000"/>
+                </a:solidFill>
+                <a:latin typeface="Fira Sans"/>
+              </a:rPr>
+              <a:t>Después: fundamentos de probabilidad, la base para la inferencia de las clases siguientes.</a:t>
+            </a:r>
+          </a:p>
+          <a:p>
+            <a:pPr>
+              <a:lnSpc>
+                <a:spcPct val="112000"/>
+              </a:lnSpc>
+              <a:spcAft>
+                <a:spcPts val="900"/>
+              </a:spcAft>
+            </a:pPr>
+            <a:r>
+              <a:rPr sz="1800" b="1">
+                <a:solidFill>
+                  <a:srgbClr val="E0A437"/>
+                </a:solidFill>
+                <a:latin typeface="Fira Sans"/>
+              </a:rPr>
+              <a:t>▸ </a:t>
+            </a:r>
+            <a:r>
+              <a:rPr sz="1800" b="0">
+                <a:solidFill>
+                  <a:srgbClr val="000000"/>
+                </a:solidFill>
+                <a:latin typeface="Fira Sans"/>
+              </a:rPr>
+              <a:t>Se publica la rúbrica del primer análisis exploratorio.</a:t>
+            </a:r>
+          </a:p>
+          <a:p>
+            <a:pPr>
+              <a:lnSpc>
+                <a:spcPct val="112000"/>
+              </a:lnSpc>
+              <a:spcAft>
+                <a:spcPts val="900"/>
+              </a:spcAft>
+            </a:pPr>
+            <a:r>
+              <a:rPr sz="1800" b="1">
+                <a:solidFill>
+                  <a:srgbClr val="E0A437"/>
+                </a:solidFill>
+                <a:latin typeface="Fira Sans"/>
+              </a:rPr>
+              <a:t>▸ </a:t>
+            </a:r>
+            <a:r>
+              <a:rPr sz="1800" b="0">
+                <a:solidFill>
+                  <a:srgbClr val="000000"/>
+                </a:solidFill>
+                <a:latin typeface="Fira Sans"/>
+              </a:rPr>
+              <a:t>Recuerden: la formulación se entrega el lunes 7 por el aula virtual.</a:t>
+            </a:r>
+          </a:p>
+        </p:txBody>
+      </p:sp>
+    </p:spTree>
+  </p:cSld>
+  <p:clrMapOvr>
+    <a:masterClrMapping/>
+  </p:clrMapOvr>
+</p:sld>
+</file>
+
+<file path=ppt/slides/slide44.xml><?xml version="1.0" encoding="utf-8"?>
 <p:sld xmlns:a="http://schemas.openxmlformats.org/drawingml/2006/main" xmlns:p="http://schemas.openxmlformats.org/presentationml/2006/main" xmlns:r="http://schemas.openxmlformats.org/officeDocument/2006/relationships">
   <p:cSld>
     <p:spTree>

</xml_diff>

<commit_message>
Clase 3: formulas OLS y ponderada separadas y en orden, diagrama de pendiente e intercepto en deck y notebook
Co-Authored-By: Claude Fable 5 <noreply@anthropic.com>
</commit_message>
<xml_diff>
--- a/presentaciones/clase03_eda_bivariado.pptx
+++ b/presentaciones/clase03_eda_bivariado.pptx
@@ -49,6 +49,8 @@
     <p:sldId id="297" r:id="rId48"/>
     <p:sldId id="298" r:id="rId49"/>
     <p:sldId id="299" r:id="rId50"/>
+    <p:sldId id="300" r:id="rId51"/>
+    <p:sldId id="301" r:id="rId52"/>
   </p:sldIdLst>
   <p:sldSz cx="9144000" cy="5138928" type="screen4x3"/>
   <p:notesSz cx="6858000" cy="9144000"/>
@@ -7270,7 +7272,7 @@
         <p:spPr>
           <a:xfrm>
             <a:off x="1417319" y="1143000"/>
-            <a:ext cx="6309360" cy="2734524"/>
+            <a:ext cx="6309360" cy="2245514"/>
           </a:xfrm>
           <a:prstGeom prst="rect">
             <a:avLst/>
@@ -7306,7 +7308,7 @@
                 </a:solidFill>
                 <a:latin typeface="Fira Sans"/>
               </a:rPr>
-              <a:t>El método se llama mínimos cuadrados ordinarios (OLS). Hoy lo calcula NumPy (np.polyfit); en las clases 6 y 7 lo harán scikit-learn y statsmodels, con diagnósticos e inferencia. Con factores de expansión se usa la versión ponderada.</a:t>
+              <a:t>El método se llama mínimos cuadrados ordinarios (OLS): np.polyfit implementa exactamente esta fórmula. En las clases 6 y 7 lo harán scikit-learn y statsmodels, con diagnósticos e inferencia.</a:t>
             </a:r>
           </a:p>
         </p:txBody>
@@ -7402,14 +7404,14 @@
                 </a:solidFill>
                 <a:latin typeface="Fira Sans"/>
               </a:rPr>
-              <a:t>La recta: ingreso y duración</a:t>
+              <a:t>Pendiente e intercepto, dibujados</a:t>
             </a:r>
           </a:p>
         </p:txBody>
       </p:sp>
       <p:pic>
         <p:nvPicPr>
-          <p:cNvPr id="4" name="Picture 3" descr="c3_18_ingreso_duracion_recta.png"/>
+          <p:cNvPr id="4" name="Picture 3" descr="c3_23_pendiente_intercepto.png"/>
           <p:cNvPicPr>
             <a:picLocks noChangeAspect="1"/>
           </p:cNvPicPr>
@@ -7423,8 +7425,8 @@
         </p:blipFill>
         <p:spPr>
           <a:xfrm>
-            <a:off x="2107331" y="1143000"/>
-            <a:ext cx="4929336" cy="3154679"/>
+            <a:off x="1715735" y="1143000"/>
+            <a:ext cx="5712528" cy="3154680"/>
           </a:xfrm>
           <a:prstGeom prst="rect">
             <a:avLst/>
@@ -7460,7 +7462,7 @@
                 </a:solidFill>
                 <a:latin typeface="Fira Sans"/>
               </a:rPr>
-              <a:t>duración = 38,3 − 4,8 · ingreso (ponderada por factor): por cada millón adicional, la duración media baja casi 5 minutos. Y r² = 0,12: la recta captura el 12% de la variación; la asociación es real pero moderada, y así se reporta.</a:t>
+              <a:t>El intercepto es donde la recta corta el eje: el valor de y cuando x es 0. La pendiente es cuánto sube y por cada unidad de x. En nuestra recta: 38,3 minutos de base y −4,8 por cada millón de ingreso.</a:t>
             </a:r>
           </a:p>
         </p:txBody>
@@ -7556,114 +7558,35 @@
                 </a:solidFill>
                 <a:latin typeface="Fira Sans"/>
               </a:rPr>
-              <a:t>La recta en NumPy</a:t>
-            </a:r>
-          </a:p>
-        </p:txBody>
-      </p:sp>
-      <p:sp>
-        <p:nvSpPr>
-          <p:cNvPr id="4" name="Rectangle 3"/>
-          <p:cNvSpPr/>
-          <p:nvPr/>
-        </p:nvSpPr>
-        <p:spPr>
-          <a:xfrm>
-            <a:off x="704088" y="1280160"/>
-            <a:ext cx="7744968" cy="2880360"/>
-          </a:xfrm>
-          <a:prstGeom prst="rect">
-            <a:avLst/>
-          </a:prstGeom>
-          <a:solidFill>
-            <a:srgbClr val="F0F2F5"/>
-          </a:solidFill>
-          <a:ln>
-            <a:solidFill>
-              <a:srgbClr val="D8DDE3"/>
-            </a:solidFill>
-          </a:ln>
-          <a:effectLst/>
-        </p:spPr>
-        <p:style>
-          <a:lnRef idx="1">
-            <a:schemeClr val="accent1"/>
-          </a:lnRef>
-          <a:fillRef idx="3">
-            <a:schemeClr val="accent1"/>
-          </a:fillRef>
-          <a:effectRef idx="2">
-            <a:schemeClr val="accent1"/>
-          </a:effectRef>
-          <a:fontRef idx="minor">
-            <a:schemeClr val="lt1"/>
-          </a:fontRef>
-        </p:style>
-        <p:txBody>
-          <a:bodyPr rtlCol="0" anchor="ctr" wrap="square" lIns="228600" tIns="137160"/>
-          <a:lstStyle/>
-          <a:p>
-            <a:pPr/>
-            <a:r>
-              <a:rPr sz="1500" b="0">
-                <a:solidFill>
-                  <a:srgbClr val="1D3557"/>
-                </a:solidFill>
-                <a:latin typeface="Menlo"/>
-              </a:rPr>
-              <a:t>pendiente, intercepto = np.polyfit(por_comuna["ingreso"],</a:t>
-            </a:r>
-          </a:p>
-          <a:p>
-            <a:pPr/>
-            <a:r>
-              <a:rPr sz="1500" b="0">
-                <a:solidFill>
-                  <a:srgbClr val="1D3557"/>
-                </a:solidFill>
-                <a:latin typeface="Menlo"/>
-              </a:rPr>
-              <a:t>                                   por_comuna["duracion"], 1)</a:t>
-            </a:r>
-          </a:p>
-          <a:p>
-            <a:pPr/>
-            <a:r>
-              <a:rPr sz="1500" b="0">
-                <a:solidFill>
-                  <a:srgbClr val="1D3557"/>
-                </a:solidFill>
-                <a:latin typeface="Menlo"/>
-              </a:rPr>
-              <a:t/>
-            </a:r>
-          </a:p>
-          <a:p>
-            <a:pPr/>
-            <a:r>
-              <a:rPr sz="1500" b="0">
-                <a:solidFill>
-                  <a:srgbClr val="1D3557"/>
-                </a:solidFill>
-                <a:latin typeface="Menlo"/>
-              </a:rPr>
-              <a:t># La recta evaluada, para dibujarla sobre el scatter</a:t>
-            </a:r>
-          </a:p>
-          <a:p>
-            <a:pPr/>
-            <a:r>
-              <a:rPr sz="1500" b="0">
-                <a:solidFill>
-                  <a:srgbClr val="1D3557"/>
-                </a:solidFill>
-                <a:latin typeface="Menlo"/>
-              </a:rPr>
-              <a:t>ax.plot(x, intercepto + pendiente * x)</a:t>
-            </a:r>
-          </a:p>
-        </p:txBody>
-      </p:sp>
+              <a:t>La recta: ingreso y duración</a:t>
+            </a:r>
+          </a:p>
+        </p:txBody>
+      </p:sp>
+      <p:pic>
+        <p:nvPicPr>
+          <p:cNvPr id="4" name="Picture 3" descr="c3_18_ingreso_duracion_recta.png"/>
+          <p:cNvPicPr>
+            <a:picLocks noChangeAspect="1"/>
+          </p:cNvPicPr>
+          <p:nvPr/>
+        </p:nvPicPr>
+        <p:blipFill>
+          <a:blip r:embed="rId2"/>
+          <a:stretch>
+            <a:fillRect/>
+          </a:stretch>
+        </p:blipFill>
+        <p:spPr>
+          <a:xfrm>
+            <a:off x="2107331" y="1143000"/>
+            <a:ext cx="4929336" cy="3154679"/>
+          </a:xfrm>
+          <a:prstGeom prst="rect">
+            <a:avLst/>
+          </a:prstGeom>
+        </p:spPr>
+      </p:pic>
       <p:sp>
         <p:nvSpPr>
           <p:cNvPr id="5" name="TextBox 4"/>
@@ -7672,8 +7595,8 @@
         </p:nvSpPr>
         <p:spPr>
           <a:xfrm>
-            <a:off x="704088" y="4389120"/>
-            <a:ext cx="7744968" cy="1097280"/>
+            <a:off x="704088" y="4434840"/>
+            <a:ext cx="7744968" cy="457200"/>
           </a:xfrm>
           <a:prstGeom prst="rect">
             <a:avLst/>
@@ -7686,31 +7609,14 @@
           </a:bodyPr>
           <a:lstStyle/>
           <a:p>
-            <a:pPr>
-              <a:lnSpc>
-                <a:spcPct val="112000"/>
-              </a:lnSpc>
-              <a:spcAft>
-                <a:spcPts val="900"/>
-              </a:spcAft>
-            </a:pPr>
-            <a:r>
-              <a:rPr sz="1600" b="1">
-                <a:solidFill>
-                  <a:srgbClr val="E0A437"/>
-                </a:solidFill>
-                <a:latin typeface="Fira Sans"/>
-              </a:rPr>
-              <a:t>▸ </a:t>
-            </a:r>
-            <a:r>
-              <a:rPr sz="1600" b="0">
-                <a:solidFill>
-                  <a:srgbClr val="000000"/>
-                </a:solidFill>
-                <a:latin typeface="Fira Sans"/>
-              </a:rPr>
-              <a:t>polyfit ajusta un polinomio por mínimos cuadrados; el 1 pide grado 1, una recta. En las clases 6 y 7 usaremos herramientas con más diagnósticos.</a:t>
+            <a:r>
+              <a:rPr sz="1300" b="0">
+                <a:solidFill>
+                  <a:srgbClr val="333333"/>
+                </a:solidFill>
+                <a:latin typeface="Fira Sans"/>
+              </a:rPr>
+              <a:t>duración = 38,3 − 4,8 · ingreso (ponderada por factor): por cada millón adicional, la duración media baja casi 5 minutos. Y r² = 0,12: la recta captura el 12% de la variación; la asociación es real pero moderada, y así se reporta.</a:t>
             </a:r>
           </a:p>
         </p:txBody>
@@ -7806,7 +7712,7 @@
                 </a:solidFill>
                 <a:latin typeface="Fira Sans"/>
               </a:rPr>
-              <a:t>Usar la recta: predecir y medir residuos</a:t>
+              <a:t>La recta en NumPy</a:t>
             </a:r>
           </a:p>
         </p:txBody>
@@ -7861,7 +7767,7 @@
                 </a:solidFill>
                 <a:latin typeface="Menlo"/>
               </a:rPr>
-              <a:t>prediccion = intercepto + pendiente * ingreso</a:t>
+              <a:t>pendiente, intercepto = np.polyfit(por_comuna["ingreso"],</a:t>
             </a:r>
           </a:p>
           <a:p>
@@ -7873,7 +7779,7 @@
                 </a:solidFill>
                 <a:latin typeface="Menlo"/>
               </a:rPr>
-              <a:t>residuo = duracion - prediccion</a:t>
+              <a:t>                                   por_comuna["duracion"], 1)</a:t>
             </a:r>
           </a:p>
           <a:p>
@@ -7897,7 +7803,7 @@
                 </a:solidFill>
                 <a:latin typeface="Menlo"/>
               </a:rPr>
-              <a:t># ¿Qué comunas viajan más de lo que su ingreso predice?</a:t>
+              <a:t># La recta evaluada, para dibujarla sobre el scatter</a:t>
             </a:r>
           </a:p>
           <a:p>
@@ -7909,7 +7815,7 @@
                 </a:solidFill>
                 <a:latin typeface="Menlo"/>
               </a:rPr>
-              <a:t>por_comuna.nlargest(5, "residuo")</a:t>
+              <a:t>ax.plot(x, intercepto + pendiente * x)</a:t>
             </a:r>
           </a:p>
         </p:txBody>
@@ -7960,7 +7866,7 @@
                 </a:solidFill>
                 <a:latin typeface="Fira Sans"/>
               </a:rPr>
-              <a:t>La Pintana viaja 13 minutos más de lo predicho y Santiago 7 menos: el residuo revela periferia y centralidad. ¿Azar? La clase 5 responde.</a:t>
+              <a:t>polyfit ajusta un polinomio por mínimos cuadrados; el 1 pide grado 1, una recta. En las clases 6 y 7 usaremos herramientas con más diagnósticos.</a:t>
             </a:r>
           </a:p>
         </p:txBody>
@@ -8056,7 +7962,7 @@
                 </a:solidFill>
                 <a:latin typeface="Fira Sans"/>
               </a:rPr>
-              <a:t>El impacto de sacar una fila</a:t>
+              <a:t>Usar la recta: predecir y medir residuos</a:t>
             </a:r>
           </a:p>
         </p:txBody>
@@ -8111,7 +8017,7 @@
                 </a:solidFill>
                 <a:latin typeface="Menlo"/>
               </a:rPr>
-              <a:t>sin_lb = por_comuna[por_comuna["Comuna"] != "LO BARNECHEA"]</a:t>
+              <a:t>prediccion = intercepto + pendiente * ingreso</a:t>
             </a:r>
           </a:p>
           <a:p>
@@ -8123,6 +8029,18 @@
                 </a:solidFill>
                 <a:latin typeface="Menlo"/>
               </a:rPr>
+              <a:t>residuo = duracion - prediccion</a:t>
+            </a:r>
+          </a:p>
+          <a:p>
+            <a:pPr/>
+            <a:r>
+              <a:rPr sz="1500" b="0">
+                <a:solidFill>
+                  <a:srgbClr val="1D3557"/>
+                </a:solidFill>
+                <a:latin typeface="Menlo"/>
+              </a:rPr>
               <a:t/>
             </a:r>
           </a:p>
@@ -8135,7 +8053,7 @@
                 </a:solidFill>
                 <a:latin typeface="Menlo"/>
               </a:rPr>
-              <a:t># Todo se recalcula sin la fila, y se compara</a:t>
+              <a:t># ¿Qué comunas viajan más de lo que su ingreso predice?</a:t>
             </a:r>
           </a:p>
           <a:p>
@@ -8147,19 +8065,7 @@
                 </a:solidFill>
                 <a:latin typeface="Menlo"/>
               </a:rPr>
-              <a:t>sin_lb["ingreso"].corr(sin_lb["duracion"])</a:t>
-            </a:r>
-          </a:p>
-          <a:p>
-            <a:pPr/>
-            <a:r>
-              <a:rPr sz="1500" b="0">
-                <a:solidFill>
-                  <a:srgbClr val="1D3557"/>
-                </a:solidFill>
-                <a:latin typeface="Menlo"/>
-              </a:rPr>
-              <a:t>np.polyfit(sin_lb["ingreso"] / 1e6, sin_lb["duracion"], 1)</a:t>
+              <a:t>por_comuna.nlargest(5, "residuo")</a:t>
             </a:r>
           </a:p>
         </p:txBody>
@@ -8210,7 +8116,7 @@
                 </a:solidFill>
                 <a:latin typeface="Fira Sans"/>
               </a:rPr>
-              <a:t>Sacar 1 comuna de 45 no mueve r (−0,34) pero cambia la pendiente en un quinto (−4,8 a −5,8): el impacto se mide con y sin, sobre todos los resúmenes en uso.</a:t>
+              <a:t>La Pintana viaja 13 minutos más de lo predicho y Santiago 7 menos: el residuo revela periferia y centralidad. ¿Azar? La clase 5 responde.</a:t>
             </a:r>
           </a:p>
         </p:txBody>
@@ -8306,7 +8212,7 @@
                 </a:solidFill>
                 <a:latin typeface="Fira Sans"/>
               </a:rPr>
-              <a:t>Otro modelo: la motorización del hogar</a:t>
+              <a:t>El impacto de sacar una fila</a:t>
             </a:r>
           </a:p>
         </p:txBody>
@@ -8361,7 +8267,7 @@
                 </a:solidFill>
                 <a:latin typeface="Menlo"/>
               </a:rPr>
-              <a:t>x = h["IngresoHogar"] / 1e6</a:t>
+              <a:t>sin_lb = por_comuna[por_comuna["Comuna"] != "LO BARNECHEA"]</a:t>
             </a:r>
           </a:p>
           <a:p>
@@ -8373,7 +8279,7 @@
                 </a:solidFill>
                 <a:latin typeface="Menlo"/>
               </a:rPr>
-              <a:t>y, w = h["NumVeh"], h["Factor"]</a:t>
+              <a:t/>
             </a:r>
           </a:p>
           <a:p>
@@ -8385,7 +8291,7 @@
                 </a:solidFill>
                 <a:latin typeface="Menlo"/>
               </a:rPr>
-              <a:t/>
+              <a:t># Todo se recalcula sin la fila, y se compara</a:t>
             </a:r>
           </a:p>
           <a:p>
@@ -8397,7 +8303,7 @@
                 </a:solidFill>
                 <a:latin typeface="Menlo"/>
               </a:rPr>
-              <a:t># La fórmula de la pendiente ponderada, tal cual</a:t>
+              <a:t>sin_lb["ingreso"].corr(sin_lb["duracion"])</a:t>
             </a:r>
           </a:p>
           <a:p>
@@ -8409,7 +8315,7 @@
                 </a:solidFill>
                 <a:latin typeface="Menlo"/>
               </a:rPr>
-              <a:t>b = (w*(x - xw)*(y - yw)).sum() / (w*(x - xw)**2).sum()</a:t>
+              <a:t>np.polyfit(sin_lb["ingreso"] / 1e6, sin_lb["duracion"], 1)</a:t>
             </a:r>
           </a:p>
         </p:txBody>
@@ -8460,7 +8366,7 @@
                 </a:solidFill>
                 <a:latin typeface="Fira Sans"/>
               </a:rPr>
-              <a:t>18.264 hogares reales, ponderados por su factor: vehículos = 0,20 + 0,50 · ingreso. Medio vehículo más por cada millón.</a:t>
+              <a:t>Sacar 1 comuna de 45 no mueve r (−0,34) pero cambia la pendiente en un quinto (−4,8 a −5,8): el impacto se mide con y sin, sobre todos los resúmenes en uso.</a:t>
             </a:r>
           </a:p>
         </p:txBody>
@@ -8556,114 +8462,35 @@
                 </a:solidFill>
                 <a:latin typeface="Fira Sans"/>
               </a:rPr>
-              <a:t>Sacar atípicos de la variable a predecir</a:t>
-            </a:r>
-          </a:p>
-        </p:txBody>
-      </p:sp>
-      <p:sp>
-        <p:nvSpPr>
-          <p:cNvPr id="4" name="Rectangle 3"/>
-          <p:cNvSpPr/>
-          <p:nvPr/>
-        </p:nvSpPr>
-        <p:spPr>
-          <a:xfrm>
-            <a:off x="704088" y="1280160"/>
-            <a:ext cx="7744968" cy="2880360"/>
-          </a:xfrm>
-          <a:prstGeom prst="rect">
-            <a:avLst/>
-          </a:prstGeom>
-          <a:solidFill>
-            <a:srgbClr val="F0F2F5"/>
-          </a:solidFill>
-          <a:ln>
-            <a:solidFill>
-              <a:srgbClr val="D8DDE3"/>
-            </a:solidFill>
-          </a:ln>
-          <a:effectLst/>
-        </p:spPr>
-        <p:style>
-          <a:lnRef idx="1">
-            <a:schemeClr val="accent1"/>
-          </a:lnRef>
-          <a:fillRef idx="3">
-            <a:schemeClr val="accent1"/>
-          </a:fillRef>
-          <a:effectRef idx="2">
-            <a:schemeClr val="accent1"/>
-          </a:effectRef>
-          <a:fontRef idx="minor">
-            <a:schemeClr val="lt1"/>
-          </a:fontRef>
-        </p:style>
-        <p:txBody>
-          <a:bodyPr rtlCol="0" anchor="ctr" wrap="square" lIns="228600" tIns="137160"/>
-          <a:lstStyle/>
-          <a:p>
-            <a:pPr/>
-            <a:r>
-              <a:rPr sz="1500" b="0">
-                <a:solidFill>
-                  <a:srgbClr val="1D3557"/>
-                </a:solidFill>
-                <a:latin typeface="Menlo"/>
-              </a:rPr>
-              <a:t>q1, q3 = h["NumVeh"].quantile([0.25, 0.75])</a:t>
-            </a:r>
-          </a:p>
-          <a:p>
-            <a:pPr/>
-            <a:r>
-              <a:rPr sz="1500" b="0">
-                <a:solidFill>
-                  <a:srgbClr val="1D3557"/>
-                </a:solidFill>
-                <a:latin typeface="Menlo"/>
-              </a:rPr>
-              <a:t>sin_atipicos = h[h["NumVeh"] &lt;= q3 + 1.5 * (q3 - q1)]</a:t>
-            </a:r>
-          </a:p>
-          <a:p>
-            <a:pPr/>
-            <a:r>
-              <a:rPr sz="1500" b="0">
-                <a:solidFill>
-                  <a:srgbClr val="1D3557"/>
-                </a:solidFill>
-                <a:latin typeface="Menlo"/>
-              </a:rPr>
-              <a:t/>
-            </a:r>
-          </a:p>
-          <a:p>
-            <a:pPr/>
-            <a:r>
-              <a:rPr sz="1500" b="0">
-                <a:solidFill>
-                  <a:srgbClr val="1D3557"/>
-                </a:solidFill>
-                <a:latin typeface="Menlo"/>
-              </a:rPr>
-              <a:t># El mismo modelo, sin los hogares de 3 autos o más</a:t>
-            </a:r>
-          </a:p>
-          <a:p>
-            <a:pPr/>
-            <a:r>
-              <a:rPr sz="1500" b="0">
-                <a:solidFill>
-                  <a:srgbClr val="1D3557"/>
-                </a:solidFill>
-                <a:latin typeface="Menlo"/>
-              </a:rPr>
-              <a:t>np.polyfit(sin_atipicos["IngresoHogar"] / 1e6, sin_atipicos["NumVeh"], 1)</a:t>
-            </a:r>
-          </a:p>
-        </p:txBody>
-      </p:sp>
+              <a:t>Las fórmulas, con factor de expansión</a:t>
+            </a:r>
+          </a:p>
+        </p:txBody>
+      </p:sp>
+      <p:pic>
+        <p:nvPicPr>
+          <p:cNvPr id="4" name="Picture 3" descr="c3_22_formulas_ponderada.png"/>
+          <p:cNvPicPr>
+            <a:picLocks noChangeAspect="1"/>
+          </p:cNvPicPr>
+          <p:nvPr/>
+        </p:nvPicPr>
+        <p:blipFill>
+          <a:blip r:embed="rId2"/>
+          <a:stretch>
+            <a:fillRect/>
+          </a:stretch>
+        </p:blipFill>
+        <p:spPr>
+          <a:xfrm>
+            <a:off x="1417319" y="1143000"/>
+            <a:ext cx="6309360" cy="2245514"/>
+          </a:xfrm>
+          <a:prstGeom prst="rect">
+            <a:avLst/>
+          </a:prstGeom>
+        </p:spPr>
+      </p:pic>
       <p:sp>
         <p:nvSpPr>
           <p:cNvPr id="5" name="TextBox 4"/>
@@ -8672,8 +8499,8 @@
         </p:nvSpPr>
         <p:spPr>
           <a:xfrm>
-            <a:off x="704088" y="4389120"/>
-            <a:ext cx="7744968" cy="1097280"/>
+            <a:off x="704088" y="4434840"/>
+            <a:ext cx="7744968" cy="457200"/>
           </a:xfrm>
           <a:prstGeom prst="rect">
             <a:avLst/>
@@ -8686,31 +8513,14 @@
           </a:bodyPr>
           <a:lstStyle/>
           <a:p>
-            <a:pPr>
-              <a:lnSpc>
-                <a:spcPct val="112000"/>
-              </a:lnSpc>
-              <a:spcAft>
-                <a:spcPts val="900"/>
-              </a:spcAft>
-            </a:pPr>
-            <a:r>
-              <a:rPr sz="1600" b="1">
-                <a:solidFill>
-                  <a:srgbClr val="E0A437"/>
-                </a:solidFill>
-                <a:latin typeface="Fira Sans"/>
-              </a:rPr>
-              <a:t>▸ </a:t>
-            </a:r>
-            <a:r>
-              <a:rPr sz="1600" b="0">
-                <a:solidFill>
-                  <a:srgbClr val="000000"/>
-                </a:solidFill>
-                <a:latin typeface="Fira Sans"/>
-              </a:rPr>
-              <a:t>Sacar 236 hogares aplana la pendiente ponderada (0,50 a 0,44): no eran errores, eran la señal. Los atípicos de y se investigan; se eliminan solo por dominio.</a:t>
+            <a:r>
+              <a:rPr sz="1300" b="0">
+                <a:solidFill>
+                  <a:srgbClr val="333333"/>
+                </a:solidFill>
+                <a:latin typeface="Fira Sans"/>
+              </a:rPr>
+              <a:t>La misma recta de mínimos cuadrados, con cada término pesado por su factor: es la que usa el modelo que sigue, y en statsmodels se llama WLS (weighted least squares).</a:t>
             </a:r>
           </a:p>
         </p:txBody>
@@ -8748,7 +8558,7 @@
             <a:avLst/>
           </a:prstGeom>
           <a:solidFill>
-            <a:srgbClr val="1D3557"/>
+            <a:srgbClr val="FAFBFC"/>
           </a:solidFill>
           <a:ln>
             <a:noFill/>
@@ -8785,8 +8595,8 @@
         </p:nvSpPr>
         <p:spPr>
           <a:xfrm>
-            <a:off x="603504" y="1847088"/>
-            <a:ext cx="7946136" cy="1399032"/>
+            <a:off x="402336" y="301752"/>
+            <a:ext cx="8348472" cy="795528"/>
           </a:xfrm>
           <a:prstGeom prst="rect">
             <a:avLst/>
@@ -8800,24 +8610,167 @@
           <a:lstStyle/>
           <a:p>
             <a:r>
-              <a:rPr sz="3400" b="1">
-                <a:solidFill>
-                  <a:srgbClr val="FFFFFF"/>
-                </a:solidFill>
-                <a:latin typeface="Fira Sans"/>
-              </a:rPr>
-              <a:t>Buenas prácticas de visualización</a:t>
-            </a:r>
-          </a:p>
-          <a:p>
-            <a:r>
-              <a:rPr sz="1800" b="0">
+              <a:rPr sz="2800" b="1">
+                <a:solidFill>
+                  <a:srgbClr val="0F0F0F"/>
+                </a:solidFill>
+                <a:latin typeface="Fira Sans"/>
+              </a:rPr>
+              <a:t>Otro modelo: la motorización del hogar</a:t>
+            </a:r>
+          </a:p>
+        </p:txBody>
+      </p:sp>
+      <p:sp>
+        <p:nvSpPr>
+          <p:cNvPr id="4" name="Rectangle 3"/>
+          <p:cNvSpPr/>
+          <p:nvPr/>
+        </p:nvSpPr>
+        <p:spPr>
+          <a:xfrm>
+            <a:off x="704088" y="1280160"/>
+            <a:ext cx="7744968" cy="2880360"/>
+          </a:xfrm>
+          <a:prstGeom prst="rect">
+            <a:avLst/>
+          </a:prstGeom>
+          <a:solidFill>
+            <a:srgbClr val="F0F2F5"/>
+          </a:solidFill>
+          <a:ln>
+            <a:solidFill>
+              <a:srgbClr val="D8DDE3"/>
+            </a:solidFill>
+          </a:ln>
+          <a:effectLst/>
+        </p:spPr>
+        <p:style>
+          <a:lnRef idx="1">
+            <a:schemeClr val="accent1"/>
+          </a:lnRef>
+          <a:fillRef idx="3">
+            <a:schemeClr val="accent1"/>
+          </a:fillRef>
+          <a:effectRef idx="2">
+            <a:schemeClr val="accent1"/>
+          </a:effectRef>
+          <a:fontRef idx="minor">
+            <a:schemeClr val="lt1"/>
+          </a:fontRef>
+        </p:style>
+        <p:txBody>
+          <a:bodyPr rtlCol="0" anchor="ctr" wrap="square" lIns="228600" tIns="137160"/>
+          <a:lstStyle/>
+          <a:p>
+            <a:pPr/>
+            <a:r>
+              <a:rPr sz="1500" b="0">
+                <a:solidFill>
+                  <a:srgbClr val="1D3557"/>
+                </a:solidFill>
+                <a:latin typeface="Menlo"/>
+              </a:rPr>
+              <a:t>x = h["IngresoHogar"] / 1e6</a:t>
+            </a:r>
+          </a:p>
+          <a:p>
+            <a:pPr/>
+            <a:r>
+              <a:rPr sz="1500" b="0">
+                <a:solidFill>
+                  <a:srgbClr val="1D3557"/>
+                </a:solidFill>
+                <a:latin typeface="Menlo"/>
+              </a:rPr>
+              <a:t>y, w = h["NumVeh"], h["Factor"]</a:t>
+            </a:r>
+          </a:p>
+          <a:p>
+            <a:pPr/>
+            <a:r>
+              <a:rPr sz="1500" b="0">
+                <a:solidFill>
+                  <a:srgbClr val="1D3557"/>
+                </a:solidFill>
+                <a:latin typeface="Menlo"/>
+              </a:rPr>
+              <a:t/>
+            </a:r>
+          </a:p>
+          <a:p>
+            <a:pPr/>
+            <a:r>
+              <a:rPr sz="1500" b="0">
+                <a:solidFill>
+                  <a:srgbClr val="1D3557"/>
+                </a:solidFill>
+                <a:latin typeface="Menlo"/>
+              </a:rPr>
+              <a:t># La fórmula de la pendiente ponderada, tal cual</a:t>
+            </a:r>
+          </a:p>
+          <a:p>
+            <a:pPr/>
+            <a:r>
+              <a:rPr sz="1500" b="0">
+                <a:solidFill>
+                  <a:srgbClr val="1D3557"/>
+                </a:solidFill>
+                <a:latin typeface="Menlo"/>
+              </a:rPr>
+              <a:t>b = (w*(x - xw)*(y - yw)).sum() / (w*(x - xw)**2).sum()</a:t>
+            </a:r>
+          </a:p>
+        </p:txBody>
+      </p:sp>
+      <p:sp>
+        <p:nvSpPr>
+          <p:cNvPr id="5" name="TextBox 4"/>
+          <p:cNvSpPr txBox="1"/>
+          <p:nvPr/>
+        </p:nvSpPr>
+        <p:spPr>
+          <a:xfrm>
+            <a:off x="704088" y="4389120"/>
+            <a:ext cx="7744968" cy="1097280"/>
+          </a:xfrm>
+          <a:prstGeom prst="rect">
+            <a:avLst/>
+          </a:prstGeom>
+          <a:noFill/>
+        </p:spPr>
+        <p:txBody>
+          <a:bodyPr wrap="square">
+            <a:spAutoFit/>
+          </a:bodyPr>
+          <a:lstStyle/>
+          <a:p>
+            <a:pPr>
+              <a:lnSpc>
+                <a:spcPct val="112000"/>
+              </a:lnSpc>
+              <a:spcAft>
+                <a:spcPts val="900"/>
+              </a:spcAft>
+            </a:pPr>
+            <a:r>
+              <a:rPr sz="1600" b="1">
                 <a:solidFill>
                   <a:srgbClr val="E0A437"/>
                 </a:solidFill>
                 <a:latin typeface="Fira Sans"/>
               </a:rPr>
-              <a:t>Que el gráfico diga la verdad y se entienda</a:t>
+              <a:t>▸ </a:t>
+            </a:r>
+            <a:r>
+              <a:rPr sz="1600" b="0">
+                <a:solidFill>
+                  <a:srgbClr val="000000"/>
+                </a:solidFill>
+                <a:latin typeface="Fira Sans"/>
+              </a:rPr>
+              <a:t>18.264 hogares reales, ponderados por su factor: vehículos = 0,20 + 0,50 · ingreso. Medio vehículo más por cada millón.</a:t>
             </a:r>
           </a:p>
         </p:txBody>
@@ -8913,35 +8866,114 @@
                 </a:solidFill>
                 <a:latin typeface="Fira Sans"/>
               </a:rPr>
-              <a:t>Graficar 90 mil puntos: overplotting</a:t>
-            </a:r>
-          </a:p>
-        </p:txBody>
-      </p:sp>
-      <p:pic>
-        <p:nvPicPr>
-          <p:cNvPr id="4" name="Picture 3" descr="c3_08_overplotting.png"/>
-          <p:cNvPicPr>
-            <a:picLocks noChangeAspect="1"/>
-          </p:cNvPicPr>
-          <p:nvPr/>
-        </p:nvPicPr>
-        <p:blipFill>
-          <a:blip r:embed="rId2"/>
-          <a:stretch>
-            <a:fillRect/>
-          </a:stretch>
-        </p:blipFill>
-        <p:spPr>
-          <a:xfrm>
-            <a:off x="1417319" y="1143000"/>
-            <a:ext cx="6309360" cy="1913950"/>
-          </a:xfrm>
-          <a:prstGeom prst="rect">
-            <a:avLst/>
-          </a:prstGeom>
-        </p:spPr>
-      </p:pic>
+              <a:t>Sacar atípicos de la variable a predecir</a:t>
+            </a:r>
+          </a:p>
+        </p:txBody>
+      </p:sp>
+      <p:sp>
+        <p:nvSpPr>
+          <p:cNvPr id="4" name="Rectangle 3"/>
+          <p:cNvSpPr/>
+          <p:nvPr/>
+        </p:nvSpPr>
+        <p:spPr>
+          <a:xfrm>
+            <a:off x="704088" y="1280160"/>
+            <a:ext cx="7744968" cy="2880360"/>
+          </a:xfrm>
+          <a:prstGeom prst="rect">
+            <a:avLst/>
+          </a:prstGeom>
+          <a:solidFill>
+            <a:srgbClr val="F0F2F5"/>
+          </a:solidFill>
+          <a:ln>
+            <a:solidFill>
+              <a:srgbClr val="D8DDE3"/>
+            </a:solidFill>
+          </a:ln>
+          <a:effectLst/>
+        </p:spPr>
+        <p:style>
+          <a:lnRef idx="1">
+            <a:schemeClr val="accent1"/>
+          </a:lnRef>
+          <a:fillRef idx="3">
+            <a:schemeClr val="accent1"/>
+          </a:fillRef>
+          <a:effectRef idx="2">
+            <a:schemeClr val="accent1"/>
+          </a:effectRef>
+          <a:fontRef idx="minor">
+            <a:schemeClr val="lt1"/>
+          </a:fontRef>
+        </p:style>
+        <p:txBody>
+          <a:bodyPr rtlCol="0" anchor="ctr" wrap="square" lIns="228600" tIns="137160"/>
+          <a:lstStyle/>
+          <a:p>
+            <a:pPr/>
+            <a:r>
+              <a:rPr sz="1500" b="0">
+                <a:solidFill>
+                  <a:srgbClr val="1D3557"/>
+                </a:solidFill>
+                <a:latin typeface="Menlo"/>
+              </a:rPr>
+              <a:t>q1, q3 = h["NumVeh"].quantile([0.25, 0.75])</a:t>
+            </a:r>
+          </a:p>
+          <a:p>
+            <a:pPr/>
+            <a:r>
+              <a:rPr sz="1500" b="0">
+                <a:solidFill>
+                  <a:srgbClr val="1D3557"/>
+                </a:solidFill>
+                <a:latin typeface="Menlo"/>
+              </a:rPr>
+              <a:t>sin_atipicos = h[h["NumVeh"] &lt;= q3 + 1.5 * (q3 - q1)]</a:t>
+            </a:r>
+          </a:p>
+          <a:p>
+            <a:pPr/>
+            <a:r>
+              <a:rPr sz="1500" b="0">
+                <a:solidFill>
+                  <a:srgbClr val="1D3557"/>
+                </a:solidFill>
+                <a:latin typeface="Menlo"/>
+              </a:rPr>
+              <a:t/>
+            </a:r>
+          </a:p>
+          <a:p>
+            <a:pPr/>
+            <a:r>
+              <a:rPr sz="1500" b="0">
+                <a:solidFill>
+                  <a:srgbClr val="1D3557"/>
+                </a:solidFill>
+                <a:latin typeface="Menlo"/>
+              </a:rPr>
+              <a:t># El mismo modelo, sin los hogares de 3 autos o más</a:t>
+            </a:r>
+          </a:p>
+          <a:p>
+            <a:pPr/>
+            <a:r>
+              <a:rPr sz="1500" b="0">
+                <a:solidFill>
+                  <a:srgbClr val="1D3557"/>
+                </a:solidFill>
+                <a:latin typeface="Menlo"/>
+              </a:rPr>
+              <a:t>np.polyfit(sin_atipicos["IngresoHogar"] / 1e6, sin_atipicos["NumVeh"], 1)</a:t>
+            </a:r>
+          </a:p>
+        </p:txBody>
+      </p:sp>
       <p:sp>
         <p:nvSpPr>
           <p:cNvPr id="5" name="TextBox 4"/>
@@ -8950,8 +8982,8 @@
         </p:nvSpPr>
         <p:spPr>
           <a:xfrm>
-            <a:off x="704088" y="4434840"/>
-            <a:ext cx="7744968" cy="457200"/>
+            <a:off x="704088" y="4389120"/>
+            <a:ext cx="7744968" cy="1097280"/>
           </a:xfrm>
           <a:prstGeom prst="rect">
             <a:avLst/>
@@ -8964,14 +8996,31 @@
           </a:bodyPr>
           <a:lstStyle/>
           <a:p>
-            <a:r>
-              <a:rPr sz="1300" b="0">
-                <a:solidFill>
-                  <a:srgbClr val="333333"/>
-                </a:solidFill>
-                <a:latin typeface="Fira Sans"/>
-              </a:rPr>
-              <a:t>Con todos los puntos sólidos, el scatter se satura y miente. Los remedios: transparencia (alpha), muestreo, o hexbin, donde el color cuenta los viajes (la distancia se calcula con las coordenadas; el notebook muestra el cálculo).</a:t>
+            <a:pPr>
+              <a:lnSpc>
+                <a:spcPct val="112000"/>
+              </a:lnSpc>
+              <a:spcAft>
+                <a:spcPts val="900"/>
+              </a:spcAft>
+            </a:pPr>
+            <a:r>
+              <a:rPr sz="1600" b="1">
+                <a:solidFill>
+                  <a:srgbClr val="E0A437"/>
+                </a:solidFill>
+                <a:latin typeface="Fira Sans"/>
+              </a:rPr>
+              <a:t>▸ </a:t>
+            </a:r>
+            <a:r>
+              <a:rPr sz="1600" b="0">
+                <a:solidFill>
+                  <a:srgbClr val="000000"/>
+                </a:solidFill>
+                <a:latin typeface="Fira Sans"/>
+              </a:rPr>
+              <a:t>Sacar 236 hogares aplana la pendiente ponderada (0,50 a 0,44): no eran errores, eran la señal. Los atípicos de y se investigan; se eliminan solo por dominio.</a:t>
             </a:r>
           </a:p>
         </p:txBody>
@@ -9009,7 +9058,7 @@
             <a:avLst/>
           </a:prstGeom>
           <a:solidFill>
-            <a:srgbClr val="FAFBFC"/>
+            <a:srgbClr val="1D3557"/>
           </a:solidFill>
           <a:ln>
             <a:noFill/>
@@ -9046,8 +9095,8 @@
         </p:nvSpPr>
         <p:spPr>
           <a:xfrm>
-            <a:off x="402336" y="301752"/>
-            <a:ext cx="8348472" cy="795528"/>
+            <a:off x="603504" y="1847088"/>
+            <a:ext cx="7946136" cy="1399032"/>
           </a:xfrm>
           <a:prstGeom prst="rect">
             <a:avLst/>
@@ -9061,71 +9110,24 @@
           <a:lstStyle/>
           <a:p>
             <a:r>
-              <a:rPr sz="2800" b="1">
-                <a:solidFill>
-                  <a:srgbClr val="0F0F0F"/>
-                </a:solidFill>
-                <a:latin typeface="Fira Sans"/>
-              </a:rPr>
-              <a:t>Cuándo usar escala logarítmica</a:t>
-            </a:r>
-          </a:p>
-        </p:txBody>
-      </p:sp>
-      <p:pic>
-        <p:nvPicPr>
-          <p:cNvPr id="4" name="Picture 3" descr="c3_10_escala_log.png"/>
-          <p:cNvPicPr>
-            <a:picLocks noChangeAspect="1"/>
-          </p:cNvPicPr>
-          <p:nvPr/>
-        </p:nvPicPr>
-        <p:blipFill>
-          <a:blip r:embed="rId2"/>
-          <a:stretch>
-            <a:fillRect/>
-          </a:stretch>
-        </p:blipFill>
-        <p:spPr>
-          <a:xfrm>
-            <a:off x="1417319" y="1143000"/>
-            <a:ext cx="6309360" cy="2432846"/>
-          </a:xfrm>
-          <a:prstGeom prst="rect">
-            <a:avLst/>
-          </a:prstGeom>
-        </p:spPr>
-      </p:pic>
-      <p:sp>
-        <p:nvSpPr>
-          <p:cNvPr id="5" name="TextBox 4"/>
-          <p:cNvSpPr txBox="1"/>
-          <p:nvPr/>
-        </p:nvSpPr>
-        <p:spPr>
-          <a:xfrm>
-            <a:off x="704088" y="4434840"/>
-            <a:ext cx="7744968" cy="457200"/>
-          </a:xfrm>
-          <a:prstGeom prst="rect">
-            <a:avLst/>
-          </a:prstGeom>
-          <a:noFill/>
-        </p:spPr>
-        <p:txBody>
-          <a:bodyPr wrap="square">
-            <a:spAutoFit/>
-          </a:bodyPr>
-          <a:lstStyle/>
-          <a:p>
-            <a:r>
-              <a:rPr sz="1300" b="0">
-                <a:solidFill>
-                  <a:srgbClr val="333333"/>
-                </a:solidFill>
-                <a:latin typeface="Fira Sans"/>
-              </a:rPr>
-              <a:t>Con colas largas como el ingreso, la escala lineal aplasta el 99% de los datos contra el borde; la logarítmica reparte el espacio y la forma aparece.</a:t>
+              <a:rPr sz="3400" b="1">
+                <a:solidFill>
+                  <a:srgbClr val="FFFFFF"/>
+                </a:solidFill>
+                <a:latin typeface="Fira Sans"/>
+              </a:rPr>
+              <a:t>Buenas prácticas de visualización</a:t>
+            </a:r>
+          </a:p>
+          <a:p>
+            <a:r>
+              <a:rPr sz="1800" b="0">
+                <a:solidFill>
+                  <a:srgbClr val="E0A437"/>
+                </a:solidFill>
+                <a:latin typeface="Fira Sans"/>
+              </a:rPr>
+              <a:t>Que el gráfico diga la verdad y se entienda</a:t>
             </a:r>
           </a:p>
         </p:txBody>
@@ -9480,14 +9482,14 @@
                 </a:solidFill>
                 <a:latin typeface="Fira Sans"/>
               </a:rPr>
-              <a:t>El mismo gráfico, dos veces</a:t>
+              <a:t>Graficar 90 mil puntos: overplotting</a:t>
             </a:r>
           </a:p>
         </p:txBody>
       </p:sp>
       <p:pic>
         <p:nvPicPr>
-          <p:cNvPr id="4" name="Picture 3" descr="c3_16_mal_buen_grafico.png"/>
+          <p:cNvPr id="4" name="Picture 3" descr="c3_08_overplotting.png"/>
           <p:cNvPicPr>
             <a:picLocks noChangeAspect="1"/>
           </p:cNvPicPr>
@@ -9502,7 +9504,7 @@
         <p:spPr>
           <a:xfrm>
             <a:off x="1417319" y="1143000"/>
-            <a:ext cx="6309360" cy="2447822"/>
+            <a:ext cx="6309360" cy="1913950"/>
           </a:xfrm>
           <a:prstGeom prst="rect">
             <a:avLst/>
@@ -9538,7 +9540,7 @@
                 </a:solidFill>
                 <a:latin typeface="Fira Sans"/>
               </a:rPr>
-              <a:t>Los mismos 30 mil viajes: sin rotular y saturado, contra rotulado, con transparencia y con el hallazgo en el título.</a:t>
+              <a:t>Con todos los puntos sólidos, el scatter se satura y miente. Los remedios: transparencia (alpha), muestreo, o hexbin, donde el color cuenta los viajes (la distancia se calcula con las coordenadas; el notebook muestra el cálculo).</a:t>
             </a:r>
           </a:p>
         </p:txBody>
@@ -9634,21 +9636,45 @@
                 </a:solidFill>
                 <a:latin typeface="Fira Sans"/>
               </a:rPr>
-              <a:t>Checklist del buen gráfico</a:t>
-            </a:r>
-          </a:p>
-        </p:txBody>
-      </p:sp>
-      <p:sp>
-        <p:nvSpPr>
-          <p:cNvPr id="4" name="TextBox 3"/>
+              <a:t>Cuándo usar escala logarítmica</a:t>
+            </a:r>
+          </a:p>
+        </p:txBody>
+      </p:sp>
+      <p:pic>
+        <p:nvPicPr>
+          <p:cNvPr id="4" name="Picture 3" descr="c3_10_escala_log.png"/>
+          <p:cNvPicPr>
+            <a:picLocks noChangeAspect="1"/>
+          </p:cNvPicPr>
+          <p:nvPr/>
+        </p:nvPicPr>
+        <p:blipFill>
+          <a:blip r:embed="rId2"/>
+          <a:stretch>
+            <a:fillRect/>
+          </a:stretch>
+        </p:blipFill>
+        <p:spPr>
+          <a:xfrm>
+            <a:off x="1417319" y="1143000"/>
+            <a:ext cx="6309360" cy="2432846"/>
+          </a:xfrm>
+          <a:prstGeom prst="rect">
+            <a:avLst/>
+          </a:prstGeom>
+        </p:spPr>
+      </p:pic>
+      <p:sp>
+        <p:nvSpPr>
+          <p:cNvPr id="5" name="TextBox 4"/>
           <p:cNvSpPr txBox="1"/>
           <p:nvPr/>
         </p:nvSpPr>
         <p:spPr>
           <a:xfrm>
-            <a:off x="704088" y="1353312"/>
-            <a:ext cx="7744968" cy="3300984"/>
+            <a:off x="704088" y="4434840"/>
+            <a:ext cx="7744968" cy="457200"/>
           </a:xfrm>
           <a:prstGeom prst="rect">
             <a:avLst/>
@@ -9661,143 +9687,14 @@
           </a:bodyPr>
           <a:lstStyle/>
           <a:p>
-            <a:pPr>
-              <a:lnSpc>
-                <a:spcPct val="112000"/>
-              </a:lnSpc>
-              <a:spcAft>
-                <a:spcPts val="900"/>
-              </a:spcAft>
-            </a:pPr>
-            <a:r>
-              <a:rPr sz="1800" b="1">
-                <a:solidFill>
-                  <a:srgbClr val="E0A437"/>
-                </a:solidFill>
-                <a:latin typeface="Fira Sans"/>
-              </a:rPr>
-              <a:t>▸ </a:t>
-            </a:r>
-            <a:r>
-              <a:rPr sz="1800" b="0">
-                <a:solidFill>
-                  <a:srgbClr val="000000"/>
-                </a:solidFill>
-                <a:latin typeface="Fira Sans"/>
-              </a:rPr>
-              <a:t>Título que diga el hallazgo, no solo las variables.</a:t>
-            </a:r>
-          </a:p>
-          <a:p>
-            <a:pPr>
-              <a:lnSpc>
-                <a:spcPct val="112000"/>
-              </a:lnSpc>
-              <a:spcAft>
-                <a:spcPts val="900"/>
-              </a:spcAft>
-            </a:pPr>
-            <a:r>
-              <a:rPr sz="1800" b="1">
-                <a:solidFill>
-                  <a:srgbClr val="E0A437"/>
-                </a:solidFill>
-                <a:latin typeface="Fira Sans"/>
-              </a:rPr>
-              <a:t>▸ </a:t>
-            </a:r>
-            <a:r>
-              <a:rPr sz="1800" b="0">
-                <a:solidFill>
-                  <a:srgbClr val="000000"/>
-                </a:solidFill>
-                <a:latin typeface="Fira Sans"/>
-              </a:rPr>
-              <a:t>Ejes con nombre y unidad; ejes que parten de cero en gráficos de barras.</a:t>
-            </a:r>
-          </a:p>
-          <a:p>
-            <a:pPr>
-              <a:lnSpc>
-                <a:spcPct val="112000"/>
-              </a:lnSpc>
-              <a:spcAft>
-                <a:spcPts val="900"/>
-              </a:spcAft>
-            </a:pPr>
-            <a:r>
-              <a:rPr sz="1800" b="1">
-                <a:solidFill>
-                  <a:srgbClr val="E0A437"/>
-                </a:solidFill>
-                <a:latin typeface="Fira Sans"/>
-              </a:rPr>
-              <a:t>▸ </a:t>
-            </a:r>
-            <a:r>
-              <a:rPr sz="1800" b="0">
-                <a:solidFill>
-                  <a:srgbClr val="000000"/>
-                </a:solidFill>
-                <a:latin typeface="Fira Sans"/>
-              </a:rPr>
-              <a:t>Muchos puntos: alpha, muestreo o hexbin.</a:t>
-            </a:r>
-          </a:p>
-          <a:p>
-            <a:pPr>
-              <a:lnSpc>
-                <a:spcPct val="112000"/>
-              </a:lnSpc>
-              <a:spcAft>
-                <a:spcPts val="900"/>
-              </a:spcAft>
-            </a:pPr>
-            <a:r>
-              <a:rPr sz="1800" b="1">
-                <a:solidFill>
-                  <a:srgbClr val="E0A437"/>
-                </a:solidFill>
-                <a:latin typeface="Fira Sans"/>
-              </a:rPr>
-              <a:t>▸ </a:t>
-            </a:r>
-            <a:r>
-              <a:rPr sz="1800" b="0">
-                <a:solidFill>
-                  <a:srgbClr val="000000"/>
-                </a:solidFill>
-                <a:latin typeface="Fira Sans"/>
-              </a:rPr>
-              <a:t>Colas largas: escala logarítmica o eje recortado, declarándolo.</a:t>
-            </a:r>
-          </a:p>
-          <a:p>
-            <a:pPr>
-              <a:lnSpc>
-                <a:spcPct val="112000"/>
-              </a:lnSpc>
-              <a:spcAft>
-                <a:spcPts val="900"/>
-              </a:spcAft>
-            </a:pPr>
-            <a:r>
-              <a:rPr sz="1800" b="1">
-                <a:solidFill>
-                  <a:srgbClr val="E0A437"/>
-                </a:solidFill>
-                <a:latin typeface="Fira Sans"/>
-              </a:rPr>
-              <a:t>▸ </a:t>
-            </a:r>
-            <a:r>
-              <a:rPr sz="1800" b="1">
-                <a:solidFill>
-                  <a:srgbClr val="1D3557"/>
-                </a:solidFill>
-                <a:latin typeface="Fira Sans"/>
-              </a:rPr>
-              <a:t>El gráfico se corrige igual que el código: se itera hasta que un tercero lo entienda sin explicación oral.</a:t>
+            <a:r>
+              <a:rPr sz="1300" b="0">
+                <a:solidFill>
+                  <a:srgbClr val="333333"/>
+                </a:solidFill>
+                <a:latin typeface="Fira Sans"/>
+              </a:rPr>
+              <a:t>Con colas largas como el ingreso, la escala lineal aplasta el 99% de los datos contra el borde; la logarítmica reparte el espacio y la forma aparece.</a:t>
             </a:r>
           </a:p>
         </p:txBody>
@@ -9893,21 +9790,45 @@
                 </a:solidFill>
                 <a:latin typeface="Fira Sans"/>
               </a:rPr>
-              <a:t>Síntesis</a:t>
-            </a:r>
-          </a:p>
-        </p:txBody>
-      </p:sp>
-      <p:sp>
-        <p:nvSpPr>
-          <p:cNvPr id="4" name="TextBox 3"/>
+              <a:t>El mismo gráfico, dos veces</a:t>
+            </a:r>
+          </a:p>
+        </p:txBody>
+      </p:sp>
+      <p:pic>
+        <p:nvPicPr>
+          <p:cNvPr id="4" name="Picture 3" descr="c3_16_mal_buen_grafico.png"/>
+          <p:cNvPicPr>
+            <a:picLocks noChangeAspect="1"/>
+          </p:cNvPicPr>
+          <p:nvPr/>
+        </p:nvPicPr>
+        <p:blipFill>
+          <a:blip r:embed="rId2"/>
+          <a:stretch>
+            <a:fillRect/>
+          </a:stretch>
+        </p:blipFill>
+        <p:spPr>
+          <a:xfrm>
+            <a:off x="1417319" y="1143000"/>
+            <a:ext cx="6309360" cy="2447822"/>
+          </a:xfrm>
+          <a:prstGeom prst="rect">
+            <a:avLst/>
+          </a:prstGeom>
+        </p:spPr>
+      </p:pic>
+      <p:sp>
+        <p:nvSpPr>
+          <p:cNvPr id="5" name="TextBox 4"/>
           <p:cNvSpPr txBox="1"/>
           <p:nvPr/>
         </p:nvSpPr>
         <p:spPr>
           <a:xfrm>
-            <a:off x="704088" y="1353312"/>
-            <a:ext cx="7744968" cy="3300984"/>
+            <a:off x="704088" y="4434840"/>
+            <a:ext cx="7744968" cy="457200"/>
           </a:xfrm>
           <a:prstGeom prst="rect">
             <a:avLst/>
@@ -9920,143 +9841,14 @@
           </a:bodyPr>
           <a:lstStyle/>
           <a:p>
-            <a:pPr>
-              <a:lnSpc>
-                <a:spcPct val="112000"/>
-              </a:lnSpc>
-              <a:spcAft>
-                <a:spcPts val="900"/>
-              </a:spcAft>
-            </a:pPr>
-            <a:r>
-              <a:rPr sz="1800" b="1">
-                <a:solidFill>
-                  <a:srgbClr val="E0A437"/>
-                </a:solidFill>
-                <a:latin typeface="Fira Sans"/>
-              </a:rPr>
-              <a:t>▸ </a:t>
-            </a:r>
-            <a:r>
-              <a:rPr sz="1800" b="0">
-                <a:solidFill>
-                  <a:srgbClr val="000000"/>
-                </a:solidFill>
-                <a:latin typeface="Fira Sans"/>
-              </a:rPr>
-              <a:t>El análisis bivariado se elige según el par de tipos: scatter y correlación, groupby y boxplot, o tabla de contingencia.</a:t>
-            </a:r>
-          </a:p>
-          <a:p>
-            <a:pPr>
-              <a:lnSpc>
-                <a:spcPct val="112000"/>
-              </a:lnSpc>
-              <a:spcAft>
-                <a:spcPts val="900"/>
-              </a:spcAft>
-            </a:pPr>
-            <a:r>
-              <a:rPr sz="1800" b="1">
-                <a:solidFill>
-                  <a:srgbClr val="E0A437"/>
-                </a:solidFill>
-                <a:latin typeface="Fira Sans"/>
-              </a:rPr>
-              <a:t>▸ </a:t>
-            </a:r>
-            <a:r>
-              <a:rPr sz="1800" b="0">
-                <a:solidFill>
-                  <a:srgbClr val="000000"/>
-                </a:solidFill>
-                <a:latin typeface="Fira Sans"/>
-              </a:rPr>
-              <a:t>Pearson para relaciones lineales; Spearman cuando hay atípicos o curvas. Y siempre graficar: Anscombe.</a:t>
-            </a:r>
-          </a:p>
-          <a:p>
-            <a:pPr>
-              <a:lnSpc>
-                <a:spcPct val="112000"/>
-              </a:lnSpc>
-              <a:spcAft>
-                <a:spcPts val="900"/>
-              </a:spcAft>
-            </a:pPr>
-            <a:r>
-              <a:rPr sz="1800" b="1">
-                <a:solidFill>
-                  <a:srgbClr val="E0A437"/>
-                </a:solidFill>
-                <a:latin typeface="Fira Sans"/>
-              </a:rPr>
-              <a:t>▸ </a:t>
-            </a:r>
-            <a:r>
-              <a:rPr sz="1800" b="0">
-                <a:solidFill>
-                  <a:srgbClr val="000000"/>
-                </a:solidFill>
-                <a:latin typeface="Fira Sans"/>
-              </a:rPr>
-              <a:t>Correlación no es causalidad: reportamos asociación.</a:t>
-            </a:r>
-          </a:p>
-          <a:p>
-            <a:pPr>
-              <a:lnSpc>
-                <a:spcPct val="112000"/>
-              </a:lnSpc>
-              <a:spcAft>
-                <a:spcPts val="900"/>
-              </a:spcAft>
-            </a:pPr>
-            <a:r>
-              <a:rPr sz="1800" b="1">
-                <a:solidFill>
-                  <a:srgbClr val="E0A437"/>
-                </a:solidFill>
-                <a:latin typeface="Fira Sans"/>
-              </a:rPr>
-              <a:t>▸ </a:t>
-            </a:r>
-            <a:r>
-              <a:rPr sz="1800" b="0">
-                <a:solidFill>
-                  <a:srgbClr val="000000"/>
-                </a:solidFill>
-                <a:latin typeface="Fira Sans"/>
-              </a:rPr>
-              <a:t>La regresión es el primer modelo: una función que resume, predice y deja residuos que diagnostican.</a:t>
-            </a:r>
-          </a:p>
-          <a:p>
-            <a:pPr>
-              <a:lnSpc>
-                <a:spcPct val="112000"/>
-              </a:lnSpc>
-              <a:spcAft>
-                <a:spcPts val="900"/>
-              </a:spcAft>
-            </a:pPr>
-            <a:r>
-              <a:rPr sz="1800" b="1">
-                <a:solidFill>
-                  <a:srgbClr val="E0A437"/>
-                </a:solidFill>
-                <a:latin typeface="Fira Sans"/>
-              </a:rPr>
-              <a:t>▸ </a:t>
-            </a:r>
-            <a:r>
-              <a:rPr sz="1800" b="1">
-                <a:solidFill>
-                  <a:srgbClr val="1D3557"/>
-                </a:solidFill>
-                <a:latin typeface="Fira Sans"/>
-              </a:rPr>
-              <a:t>Todo lo de hoy es exactamente lo que el primer EDA del proyecto debe mostrar (entrega: lunes 15).</a:t>
+            <a:r>
+              <a:rPr sz="1300" b="0">
+                <a:solidFill>
+                  <a:srgbClr val="333333"/>
+                </a:solidFill>
+                <a:latin typeface="Fira Sans"/>
+              </a:rPr>
+              <a:t>Los mismos 30 mil viajes: sin rotular y saturado, contra rotulado, con transparencia y con el hallazgo en el título.</a:t>
             </a:r>
           </a:p>
         </p:txBody>
@@ -10152,7 +9944,7 @@
                 </a:solidFill>
                 <a:latin typeface="Fira Sans"/>
               </a:rPr>
-              <a:t>Próxima clase</a:t>
+              <a:t>Checklist del buen gráfico</a:t>
             </a:r>
           </a:p>
         </p:txBody>
@@ -10197,13 +9989,13 @@
               <a:t>▸ </a:t>
             </a:r>
             <a:r>
-              <a:rPr sz="1800" b="1">
-                <a:solidFill>
-                  <a:srgbClr val="1D3557"/>
-                </a:solidFill>
-                <a:latin typeface="Fira Sans"/>
-              </a:rPr>
-              <a:t>Jueves 3 de septiembre: presentaciones breves de las ideas de proyecto (5 minutos por equipo, sin nota).</a:t>
+              <a:rPr sz="1800" b="0">
+                <a:solidFill>
+                  <a:srgbClr val="000000"/>
+                </a:solidFill>
+                <a:latin typeface="Fira Sans"/>
+              </a:rPr>
+              <a:t>Título que diga el hallazgo, no solo las variables.</a:t>
             </a:r>
           </a:p>
           <a:p>
@@ -10231,7 +10023,7 @@
                 </a:solidFill>
                 <a:latin typeface="Fira Sans"/>
               </a:rPr>
-              <a:t>Después: fundamentos de probabilidad, la base para la inferencia de las clases siguientes.</a:t>
+              <a:t>Ejes con nombre y unidad; ejes que parten de cero en gráficos de barras.</a:t>
             </a:r>
           </a:p>
           <a:p>
@@ -10259,7 +10051,7 @@
                 </a:solidFill>
                 <a:latin typeface="Fira Sans"/>
               </a:rPr>
-              <a:t>Se publica la rúbrica del primer análisis exploratorio.</a:t>
+              <a:t>Muchos puntos: alpha, muestreo o hexbin.</a:t>
             </a:r>
           </a:p>
           <a:p>
@@ -10287,7 +10079,35 @@
                 </a:solidFill>
                 <a:latin typeface="Fira Sans"/>
               </a:rPr>
-              <a:t>Recuerden: la formulación se entrega el lunes 7 por el aula virtual.</a:t>
+              <a:t>Colas largas: escala logarítmica o eje recortado, declarándolo.</a:t>
+            </a:r>
+          </a:p>
+          <a:p>
+            <a:pPr>
+              <a:lnSpc>
+                <a:spcPct val="112000"/>
+              </a:lnSpc>
+              <a:spcAft>
+                <a:spcPts val="900"/>
+              </a:spcAft>
+            </a:pPr>
+            <a:r>
+              <a:rPr sz="1800" b="1">
+                <a:solidFill>
+                  <a:srgbClr val="E0A437"/>
+                </a:solidFill>
+                <a:latin typeface="Fira Sans"/>
+              </a:rPr>
+              <a:t>▸ </a:t>
+            </a:r>
+            <a:r>
+              <a:rPr sz="1800" b="1">
+                <a:solidFill>
+                  <a:srgbClr val="1D3557"/>
+                </a:solidFill>
+                <a:latin typeface="Fira Sans"/>
+              </a:rPr>
+              <a:t>El gráfico se corrige igual que el código: se itera hasta que un tercero lo entienda sin explicación oral.</a:t>
             </a:r>
           </a:p>
         </p:txBody>
@@ -10301,6 +10121,496 @@
 </file>
 
 <file path=ppt/slides/slide44.xml><?xml version="1.0" encoding="utf-8"?>
+<p:sld xmlns:a="http://schemas.openxmlformats.org/drawingml/2006/main" xmlns:p="http://schemas.openxmlformats.org/presentationml/2006/main" xmlns:r="http://schemas.openxmlformats.org/officeDocument/2006/relationships">
+  <p:cSld>
+    <p:spTree>
+      <p:nvGrpSpPr>
+        <p:cNvPr id="1" name=""/>
+        <p:cNvGrpSpPr/>
+        <p:nvPr/>
+      </p:nvGrpSpPr>
+      <p:grpSpPr/>
+      <p:sp>
+        <p:nvSpPr>
+          <p:cNvPr id="2" name="Rectangle 1"/>
+          <p:cNvSpPr/>
+          <p:nvPr/>
+        </p:nvSpPr>
+        <p:spPr>
+          <a:xfrm>
+            <a:off x="0" y="0"/>
+            <a:ext cx="9144000" cy="5138928"/>
+          </a:xfrm>
+          <a:prstGeom prst="rect">
+            <a:avLst/>
+          </a:prstGeom>
+          <a:solidFill>
+            <a:srgbClr val="FAFBFC"/>
+          </a:solidFill>
+          <a:ln>
+            <a:noFill/>
+          </a:ln>
+          <a:effectLst/>
+        </p:spPr>
+        <p:style>
+          <a:lnRef idx="1">
+            <a:schemeClr val="accent1"/>
+          </a:lnRef>
+          <a:fillRef idx="3">
+            <a:schemeClr val="accent1"/>
+          </a:fillRef>
+          <a:effectRef idx="2">
+            <a:schemeClr val="accent1"/>
+          </a:effectRef>
+          <a:fontRef idx="minor">
+            <a:schemeClr val="lt1"/>
+          </a:fontRef>
+        </p:style>
+        <p:txBody>
+          <a:bodyPr rtlCol="0" anchor="ctr"/>
+          <a:lstStyle/>
+          <a:p>
+            <a:pPr algn="ctr"/>
+          </a:p>
+        </p:txBody>
+      </p:sp>
+      <p:sp>
+        <p:nvSpPr>
+          <p:cNvPr id="3" name="TextBox 2"/>
+          <p:cNvSpPr txBox="1"/>
+          <p:nvPr/>
+        </p:nvSpPr>
+        <p:spPr>
+          <a:xfrm>
+            <a:off x="402336" y="301752"/>
+            <a:ext cx="8348472" cy="795528"/>
+          </a:xfrm>
+          <a:prstGeom prst="rect">
+            <a:avLst/>
+          </a:prstGeom>
+          <a:noFill/>
+        </p:spPr>
+        <p:txBody>
+          <a:bodyPr wrap="square">
+            <a:spAutoFit/>
+          </a:bodyPr>
+          <a:lstStyle/>
+          <a:p>
+            <a:r>
+              <a:rPr sz="2800" b="1">
+                <a:solidFill>
+                  <a:srgbClr val="0F0F0F"/>
+                </a:solidFill>
+                <a:latin typeface="Fira Sans"/>
+              </a:rPr>
+              <a:t>Síntesis</a:t>
+            </a:r>
+          </a:p>
+        </p:txBody>
+      </p:sp>
+      <p:sp>
+        <p:nvSpPr>
+          <p:cNvPr id="4" name="TextBox 3"/>
+          <p:cNvSpPr txBox="1"/>
+          <p:nvPr/>
+        </p:nvSpPr>
+        <p:spPr>
+          <a:xfrm>
+            <a:off x="704088" y="1353312"/>
+            <a:ext cx="7744968" cy="3300984"/>
+          </a:xfrm>
+          <a:prstGeom prst="rect">
+            <a:avLst/>
+          </a:prstGeom>
+          <a:noFill/>
+        </p:spPr>
+        <p:txBody>
+          <a:bodyPr wrap="square">
+            <a:spAutoFit/>
+          </a:bodyPr>
+          <a:lstStyle/>
+          <a:p>
+            <a:pPr>
+              <a:lnSpc>
+                <a:spcPct val="112000"/>
+              </a:lnSpc>
+              <a:spcAft>
+                <a:spcPts val="900"/>
+              </a:spcAft>
+            </a:pPr>
+            <a:r>
+              <a:rPr sz="1800" b="1">
+                <a:solidFill>
+                  <a:srgbClr val="E0A437"/>
+                </a:solidFill>
+                <a:latin typeface="Fira Sans"/>
+              </a:rPr>
+              <a:t>▸ </a:t>
+            </a:r>
+            <a:r>
+              <a:rPr sz="1800" b="0">
+                <a:solidFill>
+                  <a:srgbClr val="000000"/>
+                </a:solidFill>
+                <a:latin typeface="Fira Sans"/>
+              </a:rPr>
+              <a:t>El análisis bivariado se elige según el par de tipos: scatter y correlación, groupby y boxplot, o tabla de contingencia.</a:t>
+            </a:r>
+          </a:p>
+          <a:p>
+            <a:pPr>
+              <a:lnSpc>
+                <a:spcPct val="112000"/>
+              </a:lnSpc>
+              <a:spcAft>
+                <a:spcPts val="900"/>
+              </a:spcAft>
+            </a:pPr>
+            <a:r>
+              <a:rPr sz="1800" b="1">
+                <a:solidFill>
+                  <a:srgbClr val="E0A437"/>
+                </a:solidFill>
+                <a:latin typeface="Fira Sans"/>
+              </a:rPr>
+              <a:t>▸ </a:t>
+            </a:r>
+            <a:r>
+              <a:rPr sz="1800" b="0">
+                <a:solidFill>
+                  <a:srgbClr val="000000"/>
+                </a:solidFill>
+                <a:latin typeface="Fira Sans"/>
+              </a:rPr>
+              <a:t>Pearson para relaciones lineales; Spearman cuando hay atípicos o curvas. Y siempre graficar: Anscombe.</a:t>
+            </a:r>
+          </a:p>
+          <a:p>
+            <a:pPr>
+              <a:lnSpc>
+                <a:spcPct val="112000"/>
+              </a:lnSpc>
+              <a:spcAft>
+                <a:spcPts val="900"/>
+              </a:spcAft>
+            </a:pPr>
+            <a:r>
+              <a:rPr sz="1800" b="1">
+                <a:solidFill>
+                  <a:srgbClr val="E0A437"/>
+                </a:solidFill>
+                <a:latin typeface="Fira Sans"/>
+              </a:rPr>
+              <a:t>▸ </a:t>
+            </a:r>
+            <a:r>
+              <a:rPr sz="1800" b="0">
+                <a:solidFill>
+                  <a:srgbClr val="000000"/>
+                </a:solidFill>
+                <a:latin typeface="Fira Sans"/>
+              </a:rPr>
+              <a:t>Correlación no es causalidad: reportamos asociación.</a:t>
+            </a:r>
+          </a:p>
+          <a:p>
+            <a:pPr>
+              <a:lnSpc>
+                <a:spcPct val="112000"/>
+              </a:lnSpc>
+              <a:spcAft>
+                <a:spcPts val="900"/>
+              </a:spcAft>
+            </a:pPr>
+            <a:r>
+              <a:rPr sz="1800" b="1">
+                <a:solidFill>
+                  <a:srgbClr val="E0A437"/>
+                </a:solidFill>
+                <a:latin typeface="Fira Sans"/>
+              </a:rPr>
+              <a:t>▸ </a:t>
+            </a:r>
+            <a:r>
+              <a:rPr sz="1800" b="0">
+                <a:solidFill>
+                  <a:srgbClr val="000000"/>
+                </a:solidFill>
+                <a:latin typeface="Fira Sans"/>
+              </a:rPr>
+              <a:t>La regresión es el primer modelo: una función que resume, predice y deja residuos que diagnostican.</a:t>
+            </a:r>
+          </a:p>
+          <a:p>
+            <a:pPr>
+              <a:lnSpc>
+                <a:spcPct val="112000"/>
+              </a:lnSpc>
+              <a:spcAft>
+                <a:spcPts val="900"/>
+              </a:spcAft>
+            </a:pPr>
+            <a:r>
+              <a:rPr sz="1800" b="1">
+                <a:solidFill>
+                  <a:srgbClr val="E0A437"/>
+                </a:solidFill>
+                <a:latin typeface="Fira Sans"/>
+              </a:rPr>
+              <a:t>▸ </a:t>
+            </a:r>
+            <a:r>
+              <a:rPr sz="1800" b="1">
+                <a:solidFill>
+                  <a:srgbClr val="1D3557"/>
+                </a:solidFill>
+                <a:latin typeface="Fira Sans"/>
+              </a:rPr>
+              <a:t>Todo lo de hoy es exactamente lo que el primer EDA del proyecto debe mostrar (entrega: lunes 15).</a:t>
+            </a:r>
+          </a:p>
+        </p:txBody>
+      </p:sp>
+    </p:spTree>
+  </p:cSld>
+  <p:clrMapOvr>
+    <a:masterClrMapping/>
+  </p:clrMapOvr>
+</p:sld>
+</file>
+
+<file path=ppt/slides/slide45.xml><?xml version="1.0" encoding="utf-8"?>
+<p:sld xmlns:a="http://schemas.openxmlformats.org/drawingml/2006/main" xmlns:p="http://schemas.openxmlformats.org/presentationml/2006/main" xmlns:r="http://schemas.openxmlformats.org/officeDocument/2006/relationships">
+  <p:cSld>
+    <p:spTree>
+      <p:nvGrpSpPr>
+        <p:cNvPr id="1" name=""/>
+        <p:cNvGrpSpPr/>
+        <p:nvPr/>
+      </p:nvGrpSpPr>
+      <p:grpSpPr/>
+      <p:sp>
+        <p:nvSpPr>
+          <p:cNvPr id="2" name="Rectangle 1"/>
+          <p:cNvSpPr/>
+          <p:nvPr/>
+        </p:nvSpPr>
+        <p:spPr>
+          <a:xfrm>
+            <a:off x="0" y="0"/>
+            <a:ext cx="9144000" cy="5138928"/>
+          </a:xfrm>
+          <a:prstGeom prst="rect">
+            <a:avLst/>
+          </a:prstGeom>
+          <a:solidFill>
+            <a:srgbClr val="FAFBFC"/>
+          </a:solidFill>
+          <a:ln>
+            <a:noFill/>
+          </a:ln>
+          <a:effectLst/>
+        </p:spPr>
+        <p:style>
+          <a:lnRef idx="1">
+            <a:schemeClr val="accent1"/>
+          </a:lnRef>
+          <a:fillRef idx="3">
+            <a:schemeClr val="accent1"/>
+          </a:fillRef>
+          <a:effectRef idx="2">
+            <a:schemeClr val="accent1"/>
+          </a:effectRef>
+          <a:fontRef idx="minor">
+            <a:schemeClr val="lt1"/>
+          </a:fontRef>
+        </p:style>
+        <p:txBody>
+          <a:bodyPr rtlCol="0" anchor="ctr"/>
+          <a:lstStyle/>
+          <a:p>
+            <a:pPr algn="ctr"/>
+          </a:p>
+        </p:txBody>
+      </p:sp>
+      <p:sp>
+        <p:nvSpPr>
+          <p:cNvPr id="3" name="TextBox 2"/>
+          <p:cNvSpPr txBox="1"/>
+          <p:nvPr/>
+        </p:nvSpPr>
+        <p:spPr>
+          <a:xfrm>
+            <a:off x="402336" y="301752"/>
+            <a:ext cx="8348472" cy="795528"/>
+          </a:xfrm>
+          <a:prstGeom prst="rect">
+            <a:avLst/>
+          </a:prstGeom>
+          <a:noFill/>
+        </p:spPr>
+        <p:txBody>
+          <a:bodyPr wrap="square">
+            <a:spAutoFit/>
+          </a:bodyPr>
+          <a:lstStyle/>
+          <a:p>
+            <a:r>
+              <a:rPr sz="2800" b="1">
+                <a:solidFill>
+                  <a:srgbClr val="0F0F0F"/>
+                </a:solidFill>
+                <a:latin typeface="Fira Sans"/>
+              </a:rPr>
+              <a:t>Próxima clase</a:t>
+            </a:r>
+          </a:p>
+        </p:txBody>
+      </p:sp>
+      <p:sp>
+        <p:nvSpPr>
+          <p:cNvPr id="4" name="TextBox 3"/>
+          <p:cNvSpPr txBox="1"/>
+          <p:nvPr/>
+        </p:nvSpPr>
+        <p:spPr>
+          <a:xfrm>
+            <a:off x="704088" y="1353312"/>
+            <a:ext cx="7744968" cy="3300984"/>
+          </a:xfrm>
+          <a:prstGeom prst="rect">
+            <a:avLst/>
+          </a:prstGeom>
+          <a:noFill/>
+        </p:spPr>
+        <p:txBody>
+          <a:bodyPr wrap="square">
+            <a:spAutoFit/>
+          </a:bodyPr>
+          <a:lstStyle/>
+          <a:p>
+            <a:pPr>
+              <a:lnSpc>
+                <a:spcPct val="112000"/>
+              </a:lnSpc>
+              <a:spcAft>
+                <a:spcPts val="900"/>
+              </a:spcAft>
+            </a:pPr>
+            <a:r>
+              <a:rPr sz="1800" b="1">
+                <a:solidFill>
+                  <a:srgbClr val="E0A437"/>
+                </a:solidFill>
+                <a:latin typeface="Fira Sans"/>
+              </a:rPr>
+              <a:t>▸ </a:t>
+            </a:r>
+            <a:r>
+              <a:rPr sz="1800" b="1">
+                <a:solidFill>
+                  <a:srgbClr val="1D3557"/>
+                </a:solidFill>
+                <a:latin typeface="Fira Sans"/>
+              </a:rPr>
+              <a:t>Jueves 3 de septiembre: presentaciones breves de las ideas de proyecto (5 minutos por equipo, sin nota).</a:t>
+            </a:r>
+          </a:p>
+          <a:p>
+            <a:pPr>
+              <a:lnSpc>
+                <a:spcPct val="112000"/>
+              </a:lnSpc>
+              <a:spcAft>
+                <a:spcPts val="900"/>
+              </a:spcAft>
+            </a:pPr>
+            <a:r>
+              <a:rPr sz="1800" b="1">
+                <a:solidFill>
+                  <a:srgbClr val="E0A437"/>
+                </a:solidFill>
+                <a:latin typeface="Fira Sans"/>
+              </a:rPr>
+              <a:t>▸ </a:t>
+            </a:r>
+            <a:r>
+              <a:rPr sz="1800" b="0">
+                <a:solidFill>
+                  <a:srgbClr val="000000"/>
+                </a:solidFill>
+                <a:latin typeface="Fira Sans"/>
+              </a:rPr>
+              <a:t>Después: fundamentos de probabilidad, la base para la inferencia de las clases siguientes.</a:t>
+            </a:r>
+          </a:p>
+          <a:p>
+            <a:pPr>
+              <a:lnSpc>
+                <a:spcPct val="112000"/>
+              </a:lnSpc>
+              <a:spcAft>
+                <a:spcPts val="900"/>
+              </a:spcAft>
+            </a:pPr>
+            <a:r>
+              <a:rPr sz="1800" b="1">
+                <a:solidFill>
+                  <a:srgbClr val="E0A437"/>
+                </a:solidFill>
+                <a:latin typeface="Fira Sans"/>
+              </a:rPr>
+              <a:t>▸ </a:t>
+            </a:r>
+            <a:r>
+              <a:rPr sz="1800" b="0">
+                <a:solidFill>
+                  <a:srgbClr val="000000"/>
+                </a:solidFill>
+                <a:latin typeface="Fira Sans"/>
+              </a:rPr>
+              <a:t>Se publica la rúbrica del primer análisis exploratorio.</a:t>
+            </a:r>
+          </a:p>
+          <a:p>
+            <a:pPr>
+              <a:lnSpc>
+                <a:spcPct val="112000"/>
+              </a:lnSpc>
+              <a:spcAft>
+                <a:spcPts val="900"/>
+              </a:spcAft>
+            </a:pPr>
+            <a:r>
+              <a:rPr sz="1800" b="1">
+                <a:solidFill>
+                  <a:srgbClr val="E0A437"/>
+                </a:solidFill>
+                <a:latin typeface="Fira Sans"/>
+              </a:rPr>
+              <a:t>▸ </a:t>
+            </a:r>
+            <a:r>
+              <a:rPr sz="1800" b="0">
+                <a:solidFill>
+                  <a:srgbClr val="000000"/>
+                </a:solidFill>
+                <a:latin typeface="Fira Sans"/>
+              </a:rPr>
+              <a:t>Recuerden: la formulación se entrega el lunes 7 por el aula virtual.</a:t>
+            </a:r>
+          </a:p>
+        </p:txBody>
+      </p:sp>
+    </p:spTree>
+  </p:cSld>
+  <p:clrMapOvr>
+    <a:masterClrMapping/>
+  </p:clrMapOvr>
+</p:sld>
+</file>
+
+<file path=ppt/slides/slide46.xml><?xml version="1.0" encoding="utf-8"?>
 <p:sld xmlns:a="http://schemas.openxmlformats.org/drawingml/2006/main" xmlns:p="http://schemas.openxmlformats.org/presentationml/2006/main" xmlns:r="http://schemas.openxmlformats.org/officeDocument/2006/relationships">
   <p:cSld>
     <p:spTree>

</xml_diff>

<commit_message>
Clase 3: leyenda de simbolos en todas las formulas (Pearson, Spearman, OLS y ponderada), ppt y notebook
Co-Authored-By: Claude Fable 5 <noreply@anthropic.com>
</commit_message>
<xml_diff>
--- a/presentaciones/clase03_eda_bivariado.pptx
+++ b/presentaciones/clase03_eda_bivariado.pptx
@@ -4546,7 +4546,7 @@
                 </a:solidFill>
                 <a:latin typeface="Fira Sans"/>
               </a:rPr>
-              <a:t>Cada variable se ordena por separado y cada valor recibe su posición; d compara las posiciones de una misma comuna. Con la fórmula de los rangos, cinco comunas bastan para calcular un Spearman a mano.</a:t>
+              <a:t>Cada variable se ordena por separado y cada valor recibe su posición. En la fórmula: di es la diferencia de rangos de la comuna i, y n el número de casos. Cinco comunas bastan para calcular un Spearman a mano.</a:t>
             </a:r>
           </a:p>
         </p:txBody>
@@ -6887,7 +6887,7 @@
         <p:spPr>
           <a:xfrm>
             <a:off x="1417319" y="1143000"/>
-            <a:ext cx="6309360" cy="2525498"/>
+            <a:ext cx="6309360" cy="2544952"/>
           </a:xfrm>
           <a:prstGeom prst="rect">
             <a:avLst/>
@@ -11451,7 +11451,7 @@
         <p:spPr>
           <a:xfrm>
             <a:off x="1417319" y="1143000"/>
-            <a:ext cx="6309360" cy="2846242"/>
+            <a:ext cx="6309360" cy="2880672"/>
           </a:xfrm>
           <a:prstGeom prst="rect">
             <a:avLst/>

</xml_diff>

<commit_message>
Clase 3: usar directamente la distancia oficial de DistanciaViaje, sin reproducirla
Co-Authored-By: Claude Fable 5 <noreply@anthropic.com>
</commit_message>
<xml_diff>
--- a/presentaciones/clase03_eda_bivariado.pptx
+++ b/presentaciones/clase03_eda_bivariado.pptx
@@ -4700,7 +4700,7 @@
                 </a:solidFill>
                 <a:latin typeface="Fira Sans"/>
               </a:rPr>
-              <a:t>Reemplazar cada valor por su posición en el orden endereza las curvas monótonas y desarma los atípicos. En Pandas: corr(method="spearman"). En la EOD, distancia y duración dan 0,54 con Pearson y 0,70 con Spearman: la diferencia delata curvatura y atípicos.</a:t>
+              <a:t>Reemplazar cada valor por su posición en el orden endereza las curvas monótonas y desarma los atípicos. En Pandas: corr(method="spearman"). En la EOD, distancia y duración dan 0,57 con Pearson y 0,76 con Spearman: la diferencia delata curvatura y atípicos.</a:t>
             </a:r>
           </a:p>
         </p:txBody>
@@ -9330,7 +9330,7 @@
                 </a:solidFill>
                 <a:latin typeface="Fira Sans"/>
               </a:rPr>
-              <a:t>Crear variables nuevas desde las existentes (resúmenes por comuna, una distancia desde coordenadas) es el feature engineering: la materia prima de los modelos.</a:t>
+              <a:t>Crear variables nuevas desde las existentes, como los resúmenes por comuna, es el feature engineering: la materia prima de los modelos.</a:t>
             </a:r>
           </a:p>
           <a:p>
@@ -9540,7 +9540,7 @@
                 </a:solidFill>
                 <a:latin typeface="Fira Sans"/>
               </a:rPr>
-              <a:t>Con todos los puntos sólidos, el scatter se satura y miente. Los remedios: transparencia (alpha), muestreo, o hexbin, donde el color cuenta los viajes (la distancia viene en DistanciaViaje.csv; el notebook la reproduce desde las coordenadas para validarla).</a:t>
+              <a:t>Con todos los puntos sólidos, el scatter se satura y miente. Los remedios: transparencia (alpha), muestreo, o hexbin, donde el color cuenta los viajes (la distancia viene en la tabla DistanciaViaje.csv; sus −1 son faltantes disfrazados).</a:t>
             </a:r>
           </a:p>
         </p:txBody>

</xml_diff>

<commit_message>
Clase 3: escala de r en grilla con subtitulos, codigo de rank() y recreo movido a la mitad real
Co-Authored-By: Claude Fable 5 <noreply@anthropic.com>
</commit_message>
<xml_diff>
--- a/presentaciones/clase03_eda_bivariado.pptx
+++ b/presentaciones/clase03_eda_bivariado.pptx
@@ -51,6 +51,7 @@
     <p:sldId id="299" r:id="rId50"/>
     <p:sldId id="300" r:id="rId51"/>
     <p:sldId id="301" r:id="rId52"/>
+    <p:sldId id="302" r:id="rId53"/>
   </p:sldIdLst>
   <p:sldSz cx="9144000" cy="5138928" type="screen4x3"/>
   <p:notesSz cx="6858000" cy="9144000"/>
@@ -3643,8 +3644,8 @@
         </p:blipFill>
         <p:spPr>
           <a:xfrm>
-            <a:off x="1417319" y="1143000"/>
-            <a:ext cx="6309360" cy="1572703"/>
+            <a:off x="1824750" y="1143000"/>
+            <a:ext cx="5494498" cy="3154680"/>
           </a:xfrm>
           <a:prstGeom prst="rect">
             <a:avLst/>
@@ -4642,35 +4643,114 @@
                 </a:solidFill>
                 <a:latin typeface="Fira Sans"/>
               </a:rPr>
-              <a:t>Spearman: la correlación de los rangos</a:t>
-            </a:r>
-          </a:p>
-        </p:txBody>
-      </p:sp>
-      <p:pic>
-        <p:nvPicPr>
-          <p:cNvPr id="4" name="Picture 3" descr="c3_12_spearman_rangos.png"/>
-          <p:cNvPicPr>
-            <a:picLocks noChangeAspect="1"/>
-          </p:cNvPicPr>
-          <p:nvPr/>
-        </p:nvPicPr>
-        <p:blipFill>
-          <a:blip r:embed="rId2"/>
-          <a:stretch>
-            <a:fillRect/>
-          </a:stretch>
-        </p:blipFill>
-        <p:spPr>
-          <a:xfrm>
-            <a:off x="1417319" y="1143000"/>
-            <a:ext cx="6309360" cy="2733680"/>
-          </a:xfrm>
-          <a:prstGeom prst="rect">
-            <a:avLst/>
-          </a:prstGeom>
-        </p:spPr>
-      </p:pic>
+              <a:t>Los rangos en Pandas: rank()</a:t>
+            </a:r>
+          </a:p>
+        </p:txBody>
+      </p:sp>
+      <p:sp>
+        <p:nvSpPr>
+          <p:cNvPr id="4" name="Rectangle 3"/>
+          <p:cNvSpPr/>
+          <p:nvPr/>
+        </p:nvSpPr>
+        <p:spPr>
+          <a:xfrm>
+            <a:off x="704088" y="1280160"/>
+            <a:ext cx="7744968" cy="2880360"/>
+          </a:xfrm>
+          <a:prstGeom prst="rect">
+            <a:avLst/>
+          </a:prstGeom>
+          <a:solidFill>
+            <a:srgbClr val="F0F2F5"/>
+          </a:solidFill>
+          <a:ln>
+            <a:solidFill>
+              <a:srgbClr val="D8DDE3"/>
+            </a:solidFill>
+          </a:ln>
+          <a:effectLst/>
+        </p:spPr>
+        <p:style>
+          <a:lnRef idx="1">
+            <a:schemeClr val="accent1"/>
+          </a:lnRef>
+          <a:fillRef idx="3">
+            <a:schemeClr val="accent1"/>
+          </a:fillRef>
+          <a:effectRef idx="2">
+            <a:schemeClr val="accent1"/>
+          </a:effectRef>
+          <a:fontRef idx="minor">
+            <a:schemeClr val="lt1"/>
+          </a:fontRef>
+        </p:style>
+        <p:txBody>
+          <a:bodyPr rtlCol="0" anchor="ctr" wrap="square" lIns="228600" tIns="137160"/>
+          <a:lstStyle/>
+          <a:p>
+            <a:pPr/>
+            <a:r>
+              <a:rPr sz="1500" b="0">
+                <a:solidFill>
+                  <a:srgbClr val="1D3557"/>
+                </a:solidFill>
+                <a:latin typeface="Menlo"/>
+              </a:rPr>
+              <a:t># rank() ordena la columna y asigna posiciones: 1 el menor</a:t>
+            </a:r>
+          </a:p>
+          <a:p>
+            <a:pPr/>
+            <a:r>
+              <a:rPr sz="1500" b="0">
+                <a:solidFill>
+                  <a:srgbClr val="1D3557"/>
+                </a:solidFill>
+                <a:latin typeface="Menlo"/>
+              </a:rPr>
+              <a:t>cinco["rango_ingreso"] = cinco["ingreso"].rank()</a:t>
+            </a:r>
+          </a:p>
+          <a:p>
+            <a:pPr/>
+            <a:r>
+              <a:rPr sz="1500" b="0">
+                <a:solidFill>
+                  <a:srgbClr val="1D3557"/>
+                </a:solidFill>
+                <a:latin typeface="Menlo"/>
+              </a:rPr>
+              <a:t>cinco["rango_duracion"] = cinco["duracion"].rank()</a:t>
+            </a:r>
+          </a:p>
+          <a:p>
+            <a:pPr/>
+            <a:r>
+              <a:rPr sz="1500" b="0">
+                <a:solidFill>
+                  <a:srgbClr val="1D3557"/>
+                </a:solidFill>
+                <a:latin typeface="Menlo"/>
+              </a:rPr>
+              <a:t/>
+            </a:r>
+          </a:p>
+          <a:p>
+            <a:pPr/>
+            <a:r>
+              <a:rPr sz="1500" b="0">
+                <a:solidFill>
+                  <a:srgbClr val="1D3557"/>
+                </a:solidFill>
+                <a:latin typeface="Menlo"/>
+              </a:rPr>
+              <a:t>cinco[["Comuna", "rango_ingreso", "rango_duracion"]]</a:t>
+            </a:r>
+          </a:p>
+        </p:txBody>
+      </p:sp>
       <p:sp>
         <p:nvSpPr>
           <p:cNvPr id="5" name="TextBox 4"/>
@@ -4679,8 +4759,8 @@
         </p:nvSpPr>
         <p:spPr>
           <a:xfrm>
-            <a:off x="704088" y="4434840"/>
-            <a:ext cx="7744968" cy="457200"/>
+            <a:off x="704088" y="4389120"/>
+            <a:ext cx="7744968" cy="1097280"/>
           </a:xfrm>
           <a:prstGeom prst="rect">
             <a:avLst/>
@@ -4693,14 +4773,31 @@
           </a:bodyPr>
           <a:lstStyle/>
           <a:p>
-            <a:r>
-              <a:rPr sz="1300" b="0">
-                <a:solidFill>
-                  <a:srgbClr val="333333"/>
-                </a:solidFill>
-                <a:latin typeface="Fira Sans"/>
-              </a:rPr>
-              <a:t>Reemplazar cada valor por su posición en el orden endereza las curvas monótonas y desarma los atípicos. En Pandas: corr(method="spearman"). En la EOD, distancia y duración dan 0,57 con Pearson y 0,76 con Spearman: la diferencia delata curvatura y atípicos.</a:t>
+            <a:pPr>
+              <a:lnSpc>
+                <a:spcPct val="112000"/>
+              </a:lnSpc>
+              <a:spcAft>
+                <a:spcPts val="900"/>
+              </a:spcAft>
+            </a:pPr>
+            <a:r>
+              <a:rPr sz="1600" b="1">
+                <a:solidFill>
+                  <a:srgbClr val="E0A437"/>
+                </a:solidFill>
+                <a:latin typeface="Fira Sans"/>
+              </a:rPr>
+              <a:t>▸ </a:t>
+            </a:r>
+            <a:r>
+              <a:rPr sz="1600" b="0">
+                <a:solidFill>
+                  <a:srgbClr val="000000"/>
+                </a:solidFill>
+                <a:latin typeface="Fira Sans"/>
+              </a:rPr>
+              <a:t>Con los rangos listos, Spearman es el Pearson de esas dos columnas nuevas: corr(method="spearman") hace todo el proceso de una vez.</a:t>
             </a:r>
           </a:p>
         </p:txBody>
@@ -4796,14 +4893,14 @@
                 </a:solidFill>
                 <a:latin typeface="Fira Sans"/>
               </a:rPr>
-              <a:t>Correlación no es causalidad</a:t>
+              <a:t>Spearman: la correlación de los rangos</a:t>
             </a:r>
           </a:p>
         </p:txBody>
       </p:sp>
       <p:pic>
         <p:nvPicPr>
-          <p:cNvPr id="4" name="Picture 3" descr="c3_13_causalidad.png"/>
+          <p:cNvPr id="4" name="Picture 3" descr="c3_12_spearman_rangos.png"/>
           <p:cNvPicPr>
             <a:picLocks noChangeAspect="1"/>
           </p:cNvPicPr>
@@ -4818,7 +4915,7 @@
         <p:spPr>
           <a:xfrm>
             <a:off x="1417319" y="1143000"/>
-            <a:ext cx="6309360" cy="2884949"/>
+            <a:ext cx="6309360" cy="2733680"/>
           </a:xfrm>
           <a:prstGeom prst="rect">
             <a:avLst/>
@@ -4854,7 +4951,7 @@
                 </a:solidFill>
                 <a:latin typeface="Fira Sans"/>
               </a:rPr>
-              <a:t>Que dos variables se muevan juntas no dice que una cause a la otra: puede haber una tercera moviendo a ambas. Con datos observacionales reportamos asociación (recuerden las preguntas reparadas de la clase 2).</a:t>
+              <a:t>Reemplazar cada valor por su posición en el orden endereza las curvas monótonas y desarma los atípicos. En Pandas: corr(method="spearman"). En la EOD, distancia y duración dan 0,57 con Pearson y 0,76 con Spearman: la diferencia delata curvatura y atípicos.</a:t>
             </a:r>
           </a:p>
         </p:txBody>
@@ -4892,7 +4989,7 @@
             <a:avLst/>
           </a:prstGeom>
           <a:solidFill>
-            <a:srgbClr val="1D3557"/>
+            <a:srgbClr val="FAFBFC"/>
           </a:solidFill>
           <a:ln>
             <a:noFill/>
@@ -4929,8 +5026,8 @@
         </p:nvSpPr>
         <p:spPr>
           <a:xfrm>
-            <a:off x="603504" y="1847088"/>
-            <a:ext cx="7946136" cy="1399032"/>
+            <a:off x="402336" y="301752"/>
+            <a:ext cx="8348472" cy="795528"/>
           </a:xfrm>
           <a:prstGeom prst="rect">
             <a:avLst/>
@@ -4944,24 +5041,71 @@
           <a:lstStyle/>
           <a:p>
             <a:r>
-              <a:rPr sz="3400" b="1">
-                <a:solidFill>
-                  <a:srgbClr val="FFFFFF"/>
-                </a:solidFill>
-                <a:latin typeface="Fira Sans"/>
-              </a:rPr>
-              <a:t>Recreo</a:t>
-            </a:r>
-          </a:p>
-          <a:p>
-            <a:r>
-              <a:rPr sz="1800" b="0">
-                <a:solidFill>
-                  <a:srgbClr val="E0A437"/>
-                </a:solidFill>
-                <a:latin typeface="Fira Sans"/>
-              </a:rPr>
-              <a:t>10 minutos</a:t>
+              <a:rPr sz="2800" b="1">
+                <a:solidFill>
+                  <a:srgbClr val="0F0F0F"/>
+                </a:solidFill>
+                <a:latin typeface="Fira Sans"/>
+              </a:rPr>
+              <a:t>Correlación no es causalidad</a:t>
+            </a:r>
+          </a:p>
+        </p:txBody>
+      </p:sp>
+      <p:pic>
+        <p:nvPicPr>
+          <p:cNvPr id="4" name="Picture 3" descr="c3_13_causalidad.png"/>
+          <p:cNvPicPr>
+            <a:picLocks noChangeAspect="1"/>
+          </p:cNvPicPr>
+          <p:nvPr/>
+        </p:nvPicPr>
+        <p:blipFill>
+          <a:blip r:embed="rId2"/>
+          <a:stretch>
+            <a:fillRect/>
+          </a:stretch>
+        </p:blipFill>
+        <p:spPr>
+          <a:xfrm>
+            <a:off x="1417319" y="1143000"/>
+            <a:ext cx="6309360" cy="2884949"/>
+          </a:xfrm>
+          <a:prstGeom prst="rect">
+            <a:avLst/>
+          </a:prstGeom>
+        </p:spPr>
+      </p:pic>
+      <p:sp>
+        <p:nvSpPr>
+          <p:cNvPr id="5" name="TextBox 4"/>
+          <p:cNvSpPr txBox="1"/>
+          <p:nvPr/>
+        </p:nvSpPr>
+        <p:spPr>
+          <a:xfrm>
+            <a:off x="704088" y="4434840"/>
+            <a:ext cx="7744968" cy="457200"/>
+          </a:xfrm>
+          <a:prstGeom prst="rect">
+            <a:avLst/>
+          </a:prstGeom>
+          <a:noFill/>
+        </p:spPr>
+        <p:txBody>
+          <a:bodyPr wrap="square">
+            <a:spAutoFit/>
+          </a:bodyPr>
+          <a:lstStyle/>
+          <a:p>
+            <a:r>
+              <a:rPr sz="1300" b="0">
+                <a:solidFill>
+                  <a:srgbClr val="333333"/>
+                </a:solidFill>
+                <a:latin typeface="Fira Sans"/>
+              </a:rPr>
+              <a:t>Que dos variables se muevan juntas no dice que una cause a la otra: puede haber una tercera moviendo a ambas. Con datos observacionales reportamos asociación (recuerden las preguntas reparadas de la clase 2).</a:t>
             </a:r>
           </a:p>
         </p:txBody>
@@ -6009,7 +6153,7 @@
                 </a:solidFill>
                 <a:latin typeface="Fira Sans"/>
               </a:rPr>
-              <a:t>Grupos y tablas de contingencia</a:t>
+              <a:t>Recreo</a:t>
             </a:r>
           </a:p>
           <a:p>
@@ -6020,7 +6164,7 @@
                 </a:solidFill>
                 <a:latin typeface="Fira Sans"/>
               </a:rPr>
-              <a:t>Cuando una de las dos variables es categórica</a:t>
+              <a:t>10 minutos</a:t>
             </a:r>
           </a:p>
         </p:txBody>
@@ -6058,7 +6202,7 @@
             <a:avLst/>
           </a:prstGeom>
           <a:solidFill>
-            <a:srgbClr val="FAFBFC"/>
+            <a:srgbClr val="1D3557"/>
           </a:solidFill>
           <a:ln>
             <a:noFill/>
@@ -6095,8 +6239,8 @@
         </p:nvSpPr>
         <p:spPr>
           <a:xfrm>
-            <a:off x="402336" y="301752"/>
-            <a:ext cx="8348472" cy="795528"/>
+            <a:off x="603504" y="1847088"/>
+            <a:ext cx="7946136" cy="1399032"/>
           </a:xfrm>
           <a:prstGeom prst="rect">
             <a:avLst/>
@@ -6110,71 +6254,24 @@
           <a:lstStyle/>
           <a:p>
             <a:r>
-              <a:rPr sz="2800" b="1">
-                <a:solidFill>
-                  <a:srgbClr val="0F0F0F"/>
-                </a:solidFill>
-                <a:latin typeface="Fira Sans"/>
-              </a:rPr>
-              <a:t>groupby: partir, aplicar, juntar</a:t>
-            </a:r>
-          </a:p>
-        </p:txBody>
-      </p:sp>
-      <p:pic>
-        <p:nvPicPr>
-          <p:cNvPr id="4" name="Picture 3" descr="c3_14_groupby.png"/>
-          <p:cNvPicPr>
-            <a:picLocks noChangeAspect="1"/>
-          </p:cNvPicPr>
-          <p:nvPr/>
-        </p:nvPicPr>
-        <p:blipFill>
-          <a:blip r:embed="rId2"/>
-          <a:stretch>
-            <a:fillRect/>
-          </a:stretch>
-        </p:blipFill>
-        <p:spPr>
-          <a:xfrm>
-            <a:off x="1417319" y="1143000"/>
-            <a:ext cx="6309360" cy="2480026"/>
-          </a:xfrm>
-          <a:prstGeom prst="rect">
-            <a:avLst/>
-          </a:prstGeom>
-        </p:spPr>
-      </p:pic>
-      <p:sp>
-        <p:nvSpPr>
-          <p:cNvPr id="5" name="TextBox 4"/>
-          <p:cNvSpPr txBox="1"/>
-          <p:nvPr/>
-        </p:nvSpPr>
-        <p:spPr>
-          <a:xfrm>
-            <a:off x="704088" y="4434840"/>
-            <a:ext cx="7744968" cy="457200"/>
-          </a:xfrm>
-          <a:prstGeom prst="rect">
-            <a:avLst/>
-          </a:prstGeom>
-          <a:noFill/>
-        </p:spPr>
-        <p:txBody>
-          <a:bodyPr wrap="square">
-            <a:spAutoFit/>
-          </a:bodyPr>
-          <a:lstStyle/>
-          <a:p>
-            <a:r>
-              <a:rPr sz="1300" b="0">
-                <a:solidFill>
-                  <a:srgbClr val="333333"/>
-                </a:solidFill>
-                <a:latin typeface="Fira Sans"/>
-              </a:rPr>
-              <a:t>La versión numérica del boxplot por grupo: la tabla se parte por categoría, cada parte recibe el resumen y los resultados se juntan.</a:t>
+              <a:rPr sz="3400" b="1">
+                <a:solidFill>
+                  <a:srgbClr val="FFFFFF"/>
+                </a:solidFill>
+                <a:latin typeface="Fira Sans"/>
+              </a:rPr>
+              <a:t>Grupos y tablas de contingencia</a:t>
+            </a:r>
+          </a:p>
+          <a:p>
+            <a:r>
+              <a:rPr sz="1800" b="0">
+                <a:solidFill>
+                  <a:srgbClr val="E0A437"/>
+                </a:solidFill>
+                <a:latin typeface="Fira Sans"/>
+              </a:rPr>
+              <a:t>Cuando una de las dos variables es categórica</a:t>
             </a:r>
           </a:p>
         </p:txBody>
@@ -6270,102 +6367,35 @@
                 </a:solidFill>
                 <a:latin typeface="Fira Sans"/>
               </a:rPr>
-              <a:t>La media por grupo: groupby</a:t>
-            </a:r>
-          </a:p>
-        </p:txBody>
-      </p:sp>
-      <p:sp>
-        <p:nvSpPr>
-          <p:cNvPr id="4" name="Rectangle 3"/>
-          <p:cNvSpPr/>
-          <p:nvPr/>
-        </p:nvSpPr>
-        <p:spPr>
-          <a:xfrm>
-            <a:off x="704088" y="1280160"/>
-            <a:ext cx="7744968" cy="2377440"/>
-          </a:xfrm>
-          <a:prstGeom prst="rect">
-            <a:avLst/>
-          </a:prstGeom>
-          <a:solidFill>
-            <a:srgbClr val="F0F2F5"/>
-          </a:solidFill>
-          <a:ln>
-            <a:solidFill>
-              <a:srgbClr val="D8DDE3"/>
-            </a:solidFill>
-          </a:ln>
-          <a:effectLst/>
-        </p:spPr>
-        <p:style>
-          <a:lnRef idx="1">
-            <a:schemeClr val="accent1"/>
-          </a:lnRef>
-          <a:fillRef idx="3">
-            <a:schemeClr val="accent1"/>
-          </a:fillRef>
-          <a:effectRef idx="2">
-            <a:schemeClr val="accent1"/>
-          </a:effectRef>
-          <a:fontRef idx="minor">
-            <a:schemeClr val="lt1"/>
-          </a:fontRef>
-        </p:style>
-        <p:txBody>
-          <a:bodyPr rtlCol="0" anchor="ctr" wrap="square" lIns="228600" tIns="137160"/>
-          <a:lstStyle/>
-          <a:p>
-            <a:pPr/>
-            <a:r>
-              <a:rPr sz="1500" b="0">
-                <a:solidFill>
-                  <a:srgbClr val="1D3557"/>
-                </a:solidFill>
-                <a:latin typeface="Menlo"/>
-              </a:rPr>
-              <a:t>iris_df.groupby("species")["petal length (cm)"].mean()</a:t>
-            </a:r>
-          </a:p>
-          <a:p>
-            <a:pPr/>
-            <a:r>
-              <a:rPr sz="1500" b="0">
-                <a:solidFill>
-                  <a:srgbClr val="1D3557"/>
-                </a:solidFill>
-                <a:latin typeface="Menlo"/>
-              </a:rPr>
-              <a:t/>
-            </a:r>
-          </a:p>
-          <a:p>
-            <a:pPr/>
-            <a:r>
-              <a:rPr sz="1500" b="0">
-                <a:solidFill>
-                  <a:srgbClr val="1D3557"/>
-                </a:solidFill>
-                <a:latin typeface="Menlo"/>
-              </a:rPr>
-              <a:t># El mismo resumen que construimos a mano con loc y el for,</a:t>
-            </a:r>
-          </a:p>
-          <a:p>
-            <a:pPr/>
-            <a:r>
-              <a:rPr sz="1500" b="0">
-                <a:solidFill>
-                  <a:srgbClr val="1D3557"/>
-                </a:solidFill>
-                <a:latin typeface="Menlo"/>
-              </a:rPr>
-              <a:t># ahora en una línea</a:t>
-            </a:r>
-          </a:p>
-        </p:txBody>
-      </p:sp>
+              <a:t>groupby: partir, aplicar, juntar</a:t>
+            </a:r>
+          </a:p>
+        </p:txBody>
+      </p:sp>
+      <p:pic>
+        <p:nvPicPr>
+          <p:cNvPr id="4" name="Picture 3" descr="c3_14_groupby.png"/>
+          <p:cNvPicPr>
+            <a:picLocks noChangeAspect="1"/>
+          </p:cNvPicPr>
+          <p:nvPr/>
+        </p:nvPicPr>
+        <p:blipFill>
+          <a:blip r:embed="rId2"/>
+          <a:stretch>
+            <a:fillRect/>
+          </a:stretch>
+        </p:blipFill>
+        <p:spPr>
+          <a:xfrm>
+            <a:off x="1417319" y="1143000"/>
+            <a:ext cx="6309360" cy="2480026"/>
+          </a:xfrm>
+          <a:prstGeom prst="rect">
+            <a:avLst/>
+          </a:prstGeom>
+        </p:spPr>
+      </p:pic>
       <p:sp>
         <p:nvSpPr>
           <p:cNvPr id="5" name="TextBox 4"/>
@@ -6374,8 +6404,8 @@
         </p:nvSpPr>
         <p:spPr>
           <a:xfrm>
-            <a:off x="704088" y="3886200"/>
-            <a:ext cx="7744968" cy="1097280"/>
+            <a:off x="704088" y="4434840"/>
+            <a:ext cx="7744968" cy="457200"/>
           </a:xfrm>
           <a:prstGeom prst="rect">
             <a:avLst/>
@@ -6388,31 +6418,14 @@
           </a:bodyPr>
           <a:lstStyle/>
           <a:p>
-            <a:pPr>
-              <a:lnSpc>
-                <a:spcPct val="112000"/>
-              </a:lnSpc>
-              <a:spcAft>
-                <a:spcPts val="900"/>
-              </a:spcAft>
-            </a:pPr>
-            <a:r>
-              <a:rPr sz="1600" b="1">
-                <a:solidFill>
-                  <a:srgbClr val="E0A437"/>
-                </a:solidFill>
-                <a:latin typeface="Fira Sans"/>
-              </a:rPr>
-              <a:t>▸ </a:t>
-            </a:r>
-            <a:r>
-              <a:rPr sz="1600" b="0">
-                <a:solidFill>
-                  <a:srgbClr val="000000"/>
-                </a:solidFill>
-                <a:latin typeface="Fira Sans"/>
-              </a:rPr>
-              <a:t>groupby parte la tabla por categoría, aplica el resumen a cada parte y junta los resultados: 1,46 / 4,26 / 5,55 cm. Es la versión numérica del boxplot por grupo.</a:t>
+            <a:r>
+              <a:rPr sz="1300" b="0">
+                <a:solidFill>
+                  <a:srgbClr val="333333"/>
+                </a:solidFill>
+                <a:latin typeface="Fira Sans"/>
+              </a:rPr>
+              <a:t>La versión numérica del boxplot por grupo: la tabla se parte por categoría, cada parte recibe el resumen y los resultados se juntan.</a:t>
             </a:r>
           </a:p>
         </p:txBody>
@@ -6508,7 +6521,7 @@
                 </a:solidFill>
                 <a:latin typeface="Fira Sans"/>
               </a:rPr>
-              <a:t>Dos categóricas: la tabla de contingencia</a:t>
+              <a:t>La media por grupo: groupby</a:t>
             </a:r>
           </a:p>
         </p:txBody>
@@ -6522,7 +6535,7 @@
         <p:spPr>
           <a:xfrm>
             <a:off x="704088" y="1280160"/>
-            <a:ext cx="7744968" cy="2880360"/>
+            <a:ext cx="7744968" cy="2377440"/>
           </a:xfrm>
           <a:prstGeom prst="rect">
             <a:avLst/>
@@ -6563,7 +6576,7 @@
                 </a:solidFill>
                 <a:latin typeface="Menlo"/>
               </a:rPr>
-              <a:t>pd.crosstab(datos["Sexo"], datos["ModoAgrupado"],</a:t>
+              <a:t>iris_df.groupby("species")["petal length (cm)"].mean()</a:t>
             </a:r>
           </a:p>
           <a:p>
@@ -6575,7 +6588,7 @@
                 </a:solidFill>
                 <a:latin typeface="Menlo"/>
               </a:rPr>
-              <a:t>            normalize="index")</a:t>
+              <a:t/>
             </a:r>
           </a:p>
           <a:p>
@@ -6587,7 +6600,7 @@
                 </a:solidFill>
                 <a:latin typeface="Menlo"/>
               </a:rPr>
-              <a:t># Para la ciudad: sumar factores en vez de contar viajes</a:t>
+              <a:t># El mismo resumen que construimos a mano con loc y el for,</a:t>
             </a:r>
           </a:p>
           <a:p>
@@ -6599,19 +6612,7 @@
                 </a:solidFill>
                 <a:latin typeface="Menlo"/>
               </a:rPr>
-              <a:t>datos.pivot_table(values="Factor", index="Sexo",</a:t>
-            </a:r>
-          </a:p>
-          <a:p>
-            <a:pPr/>
-            <a:r>
-              <a:rPr sz="1500" b="0">
-                <a:solidFill>
-                  <a:srgbClr val="1D3557"/>
-                </a:solidFill>
-                <a:latin typeface="Menlo"/>
-              </a:rPr>
-              <a:t>                  columns="ModoAgrupado", aggfunc="sum")</a:t>
+              <a:t># ahora en una línea</a:t>
             </a:r>
           </a:p>
         </p:txBody>
@@ -6624,7 +6625,7 @@
         </p:nvSpPr>
         <p:spPr>
           <a:xfrm>
-            <a:off x="704088" y="4389120"/>
+            <a:off x="704088" y="3886200"/>
             <a:ext cx="7744968" cy="1097280"/>
           </a:xfrm>
           <a:prstGeom prst="rect">
@@ -6662,7 +6663,7 @@
                 </a:solidFill>
                 <a:latin typeface="Fira Sans"/>
               </a:rPr>
-              <a:t>Ponderado por factor, en día laboral: las mujeres caminan más (40% contra 27%) y los hombres usan más el auto (28% contra 19%).</a:t>
+              <a:t>groupby parte la tabla por categoría, aplica el resumen a cada parte y junta los resultados: 1,46 / 4,26 / 5,55 cm. Es la versión numérica del boxplot por grupo.</a:t>
             </a:r>
           </a:p>
         </p:txBody>
@@ -6700,7 +6701,7 @@
             <a:avLst/>
           </a:prstGeom>
           <a:solidFill>
-            <a:srgbClr val="1D3557"/>
+            <a:srgbClr val="FAFBFC"/>
           </a:solidFill>
           <a:ln>
             <a:noFill/>
@@ -6737,8 +6738,8 @@
         </p:nvSpPr>
         <p:spPr>
           <a:xfrm>
-            <a:off x="603504" y="1847088"/>
-            <a:ext cx="7946136" cy="1399032"/>
+            <a:off x="402336" y="301752"/>
+            <a:ext cx="8348472" cy="795528"/>
           </a:xfrm>
           <a:prstGeom prst="rect">
             <a:avLst/>
@@ -6752,24 +6753,167 @@
           <a:lstStyle/>
           <a:p>
             <a:r>
-              <a:rPr sz="3400" b="1">
-                <a:solidFill>
-                  <a:srgbClr val="FFFFFF"/>
-                </a:solidFill>
-                <a:latin typeface="Fira Sans"/>
-              </a:rPr>
-              <a:t>La primera regresión</a:t>
-            </a:r>
-          </a:p>
-          <a:p>
-            <a:r>
-              <a:rPr sz="1800" b="0">
+              <a:rPr sz="2800" b="1">
+                <a:solidFill>
+                  <a:srgbClr val="0F0F0F"/>
+                </a:solidFill>
+                <a:latin typeface="Fira Sans"/>
+              </a:rPr>
+              <a:t>Dos categóricas: la tabla de contingencia</a:t>
+            </a:r>
+          </a:p>
+        </p:txBody>
+      </p:sp>
+      <p:sp>
+        <p:nvSpPr>
+          <p:cNvPr id="4" name="Rectangle 3"/>
+          <p:cNvSpPr/>
+          <p:nvPr/>
+        </p:nvSpPr>
+        <p:spPr>
+          <a:xfrm>
+            <a:off x="704088" y="1280160"/>
+            <a:ext cx="7744968" cy="2880360"/>
+          </a:xfrm>
+          <a:prstGeom prst="rect">
+            <a:avLst/>
+          </a:prstGeom>
+          <a:solidFill>
+            <a:srgbClr val="F0F2F5"/>
+          </a:solidFill>
+          <a:ln>
+            <a:solidFill>
+              <a:srgbClr val="D8DDE3"/>
+            </a:solidFill>
+          </a:ln>
+          <a:effectLst/>
+        </p:spPr>
+        <p:style>
+          <a:lnRef idx="1">
+            <a:schemeClr val="accent1"/>
+          </a:lnRef>
+          <a:fillRef idx="3">
+            <a:schemeClr val="accent1"/>
+          </a:fillRef>
+          <a:effectRef idx="2">
+            <a:schemeClr val="accent1"/>
+          </a:effectRef>
+          <a:fontRef idx="minor">
+            <a:schemeClr val="lt1"/>
+          </a:fontRef>
+        </p:style>
+        <p:txBody>
+          <a:bodyPr rtlCol="0" anchor="ctr" wrap="square" lIns="228600" tIns="137160"/>
+          <a:lstStyle/>
+          <a:p>
+            <a:pPr/>
+            <a:r>
+              <a:rPr sz="1500" b="0">
+                <a:solidFill>
+                  <a:srgbClr val="1D3557"/>
+                </a:solidFill>
+                <a:latin typeface="Menlo"/>
+              </a:rPr>
+              <a:t>pd.crosstab(datos["Sexo"], datos["ModoAgrupado"],</a:t>
+            </a:r>
+          </a:p>
+          <a:p>
+            <a:pPr/>
+            <a:r>
+              <a:rPr sz="1500" b="0">
+                <a:solidFill>
+                  <a:srgbClr val="1D3557"/>
+                </a:solidFill>
+                <a:latin typeface="Menlo"/>
+              </a:rPr>
+              <a:t>            normalize="index")</a:t>
+            </a:r>
+          </a:p>
+          <a:p>
+            <a:pPr/>
+            <a:r>
+              <a:rPr sz="1500" b="0">
+                <a:solidFill>
+                  <a:srgbClr val="1D3557"/>
+                </a:solidFill>
+                <a:latin typeface="Menlo"/>
+              </a:rPr>
+              <a:t># Para la ciudad: sumar factores en vez de contar viajes</a:t>
+            </a:r>
+          </a:p>
+          <a:p>
+            <a:pPr/>
+            <a:r>
+              <a:rPr sz="1500" b="0">
+                <a:solidFill>
+                  <a:srgbClr val="1D3557"/>
+                </a:solidFill>
+                <a:latin typeface="Menlo"/>
+              </a:rPr>
+              <a:t>datos.pivot_table(values="Factor", index="Sexo",</a:t>
+            </a:r>
+          </a:p>
+          <a:p>
+            <a:pPr/>
+            <a:r>
+              <a:rPr sz="1500" b="0">
+                <a:solidFill>
+                  <a:srgbClr val="1D3557"/>
+                </a:solidFill>
+                <a:latin typeface="Menlo"/>
+              </a:rPr>
+              <a:t>                  columns="ModoAgrupado", aggfunc="sum")</a:t>
+            </a:r>
+          </a:p>
+        </p:txBody>
+      </p:sp>
+      <p:sp>
+        <p:nvSpPr>
+          <p:cNvPr id="5" name="TextBox 4"/>
+          <p:cNvSpPr txBox="1"/>
+          <p:nvPr/>
+        </p:nvSpPr>
+        <p:spPr>
+          <a:xfrm>
+            <a:off x="704088" y="4389120"/>
+            <a:ext cx="7744968" cy="1097280"/>
+          </a:xfrm>
+          <a:prstGeom prst="rect">
+            <a:avLst/>
+          </a:prstGeom>
+          <a:noFill/>
+        </p:spPr>
+        <p:txBody>
+          <a:bodyPr wrap="square">
+            <a:spAutoFit/>
+          </a:bodyPr>
+          <a:lstStyle/>
+          <a:p>
+            <a:pPr>
+              <a:lnSpc>
+                <a:spcPct val="112000"/>
+              </a:lnSpc>
+              <a:spcAft>
+                <a:spcPts val="900"/>
+              </a:spcAft>
+            </a:pPr>
+            <a:r>
+              <a:rPr sz="1600" b="1">
                 <a:solidFill>
                   <a:srgbClr val="E0A437"/>
                 </a:solidFill>
                 <a:latin typeface="Fira Sans"/>
               </a:rPr>
-              <a:t>El primer modelo del diplomado</a:t>
+              <a:t>▸ </a:t>
+            </a:r>
+            <a:r>
+              <a:rPr sz="1600" b="0">
+                <a:solidFill>
+                  <a:srgbClr val="000000"/>
+                </a:solidFill>
+                <a:latin typeface="Fira Sans"/>
+              </a:rPr>
+              <a:t>Ponderado por factor, en día laboral: las mujeres caminan más (40% contra 27%) y los hombres usan más el auto (28% contra 19%).</a:t>
             </a:r>
           </a:p>
         </p:txBody>
@@ -6807,7 +6951,7 @@
             <a:avLst/>
           </a:prstGeom>
           <a:solidFill>
-            <a:srgbClr val="FAFBFC"/>
+            <a:srgbClr val="1D3557"/>
           </a:solidFill>
           <a:ln>
             <a:noFill/>
@@ -6844,8 +6988,8 @@
         </p:nvSpPr>
         <p:spPr>
           <a:xfrm>
-            <a:off x="402336" y="301752"/>
-            <a:ext cx="8348472" cy="795528"/>
+            <a:off x="603504" y="1847088"/>
+            <a:ext cx="7946136" cy="1399032"/>
           </a:xfrm>
           <a:prstGeom prst="rect">
             <a:avLst/>
@@ -6859,71 +7003,24 @@
           <a:lstStyle/>
           <a:p>
             <a:r>
-              <a:rPr sz="2800" b="1">
-                <a:solidFill>
-                  <a:srgbClr val="0F0F0F"/>
-                </a:solidFill>
-                <a:latin typeface="Fira Sans"/>
-              </a:rPr>
-              <a:t>Mínimos cuadrados</a:t>
-            </a:r>
-          </a:p>
-        </p:txBody>
-      </p:sp>
-      <p:pic>
-        <p:nvPicPr>
-          <p:cNvPr id="4" name="Picture 3" descr="c3_15_residuos.png"/>
-          <p:cNvPicPr>
-            <a:picLocks noChangeAspect="1"/>
-          </p:cNvPicPr>
-          <p:nvPr/>
-        </p:nvPicPr>
-        <p:blipFill>
-          <a:blip r:embed="rId2"/>
-          <a:stretch>
-            <a:fillRect/>
-          </a:stretch>
-        </p:blipFill>
-        <p:spPr>
-          <a:xfrm>
-            <a:off x="1417319" y="1143000"/>
-            <a:ext cx="6309360" cy="2544952"/>
-          </a:xfrm>
-          <a:prstGeom prst="rect">
-            <a:avLst/>
-          </a:prstGeom>
-        </p:spPr>
-      </p:pic>
-      <p:sp>
-        <p:nvSpPr>
-          <p:cNvPr id="5" name="TextBox 4"/>
-          <p:cNvSpPr txBox="1"/>
-          <p:nvPr/>
-        </p:nvSpPr>
-        <p:spPr>
-          <a:xfrm>
-            <a:off x="704088" y="4434840"/>
-            <a:ext cx="7744968" cy="457200"/>
-          </a:xfrm>
-          <a:prstGeom prst="rect">
-            <a:avLst/>
-          </a:prstGeom>
-          <a:noFill/>
-        </p:spPr>
-        <p:txBody>
-          <a:bodyPr wrap="square">
-            <a:spAutoFit/>
-          </a:bodyPr>
-          <a:lstStyle/>
-          <a:p>
-            <a:r>
-              <a:rPr sz="1300" b="0">
-                <a:solidFill>
-                  <a:srgbClr val="333333"/>
-                </a:solidFill>
-                <a:latin typeface="Fira Sans"/>
-              </a:rPr>
-              <a:t>La correlación mide la asociación; la regresión la dibuja: la recta que deja la menor suma de errores al cuadrado. La pendiente dice cuánto cambia y por cada unidad de x. Hoy es un primer contacto; en las clases 6 y 7 la profundizamos.</a:t>
+              <a:rPr sz="3400" b="1">
+                <a:solidFill>
+                  <a:srgbClr val="FFFFFF"/>
+                </a:solidFill>
+                <a:latin typeface="Fira Sans"/>
+              </a:rPr>
+              <a:t>La primera regresión</a:t>
+            </a:r>
+          </a:p>
+          <a:p>
+            <a:r>
+              <a:rPr sz="1800" b="0">
+                <a:solidFill>
+                  <a:srgbClr val="E0A437"/>
+                </a:solidFill>
+                <a:latin typeface="Fira Sans"/>
+              </a:rPr>
+              <a:t>El primer modelo del diplomado</a:t>
             </a:r>
           </a:p>
         </p:txBody>
@@ -7250,14 +7347,14 @@
                 </a:solidFill>
                 <a:latin typeface="Fira Sans"/>
               </a:rPr>
-              <a:t>Las fórmulas de la recta</a:t>
+              <a:t>Mínimos cuadrados</a:t>
             </a:r>
           </a:p>
         </p:txBody>
       </p:sp>
       <p:pic>
         <p:nvPicPr>
-          <p:cNvPr id="4" name="Picture 3" descr="c3_21_formulas_recta.png"/>
+          <p:cNvPr id="4" name="Picture 3" descr="c3_15_residuos.png"/>
           <p:cNvPicPr>
             <a:picLocks noChangeAspect="1"/>
           </p:cNvPicPr>
@@ -7272,7 +7369,7 @@
         <p:spPr>
           <a:xfrm>
             <a:off x="1417319" y="1143000"/>
-            <a:ext cx="6309360" cy="2245514"/>
+            <a:ext cx="6309360" cy="2544952"/>
           </a:xfrm>
           <a:prstGeom prst="rect">
             <a:avLst/>
@@ -7308,7 +7405,7 @@
                 </a:solidFill>
                 <a:latin typeface="Fira Sans"/>
               </a:rPr>
-              <a:t>El método se llama mínimos cuadrados ordinarios (OLS): np.polyfit implementa exactamente esta fórmula. En las clases 6 y 7 lo harán scikit-learn y statsmodels, con diagnósticos e inferencia.</a:t>
+              <a:t>La correlación mide la asociación; la regresión la dibuja: la recta que deja la menor suma de errores al cuadrado. La pendiente dice cuánto cambia y por cada unidad de x. Hoy es un primer contacto; en las clases 6 y 7 la profundizamos.</a:t>
             </a:r>
           </a:p>
         </p:txBody>
@@ -7404,14 +7501,14 @@
                 </a:solidFill>
                 <a:latin typeface="Fira Sans"/>
               </a:rPr>
-              <a:t>Pendiente e intercepto, dibujados</a:t>
+              <a:t>Las fórmulas de la recta</a:t>
             </a:r>
           </a:p>
         </p:txBody>
       </p:sp>
       <p:pic>
         <p:nvPicPr>
-          <p:cNvPr id="4" name="Picture 3" descr="c3_23_pendiente_intercepto.png"/>
+          <p:cNvPr id="4" name="Picture 3" descr="c3_21_formulas_recta.png"/>
           <p:cNvPicPr>
             <a:picLocks noChangeAspect="1"/>
           </p:cNvPicPr>
@@ -7425,8 +7522,8 @@
         </p:blipFill>
         <p:spPr>
           <a:xfrm>
-            <a:off x="1715735" y="1143000"/>
-            <a:ext cx="5712528" cy="3154680"/>
+            <a:off x="1417319" y="1143000"/>
+            <a:ext cx="6309360" cy="2245514"/>
           </a:xfrm>
           <a:prstGeom prst="rect">
             <a:avLst/>
@@ -7462,7 +7559,7 @@
                 </a:solidFill>
                 <a:latin typeface="Fira Sans"/>
               </a:rPr>
-              <a:t>El intercepto es donde la recta corta el eje: el valor de y cuando x es 0. La pendiente es cuánto sube y por cada unidad de x. En nuestra recta: 38,3 minutos de base y −4,8 por cada millón de ingreso.</a:t>
+              <a:t>El método se llama mínimos cuadrados ordinarios (OLS): np.polyfit implementa exactamente esta fórmula. En las clases 6 y 7 lo harán scikit-learn y statsmodels, con diagnósticos e inferencia.</a:t>
             </a:r>
           </a:p>
         </p:txBody>
@@ -7558,14 +7655,14 @@
                 </a:solidFill>
                 <a:latin typeface="Fira Sans"/>
               </a:rPr>
-              <a:t>La recta: ingreso y duración</a:t>
+              <a:t>Pendiente e intercepto, dibujados</a:t>
             </a:r>
           </a:p>
         </p:txBody>
       </p:sp>
       <p:pic>
         <p:nvPicPr>
-          <p:cNvPr id="4" name="Picture 3" descr="c3_18_ingreso_duracion_recta.png"/>
+          <p:cNvPr id="4" name="Picture 3" descr="c3_23_pendiente_intercepto.png"/>
           <p:cNvPicPr>
             <a:picLocks noChangeAspect="1"/>
           </p:cNvPicPr>
@@ -7579,8 +7676,8 @@
         </p:blipFill>
         <p:spPr>
           <a:xfrm>
-            <a:off x="2107331" y="1143000"/>
-            <a:ext cx="4929336" cy="3154679"/>
+            <a:off x="1715735" y="1143000"/>
+            <a:ext cx="5712528" cy="3154680"/>
           </a:xfrm>
           <a:prstGeom prst="rect">
             <a:avLst/>
@@ -7616,7 +7713,7 @@
                 </a:solidFill>
                 <a:latin typeface="Fira Sans"/>
               </a:rPr>
-              <a:t>duración = 38,3 − 4,8 · ingreso (ponderada por factor): por cada millón adicional, la duración media baja casi 5 minutos. Y r² = 0,12: la recta captura el 12% de la variación; la asociación es real pero moderada, y así se reporta.</a:t>
+              <a:t>El intercepto es donde la recta corta el eje: el valor de y cuando x es 0. La pendiente es cuánto sube y por cada unidad de x. En nuestra recta: 38,3 minutos de base y −4,8 por cada millón de ingreso.</a:t>
             </a:r>
           </a:p>
         </p:txBody>
@@ -7712,114 +7809,35 @@
                 </a:solidFill>
                 <a:latin typeface="Fira Sans"/>
               </a:rPr>
-              <a:t>La recta en NumPy</a:t>
-            </a:r>
-          </a:p>
-        </p:txBody>
-      </p:sp>
-      <p:sp>
-        <p:nvSpPr>
-          <p:cNvPr id="4" name="Rectangle 3"/>
-          <p:cNvSpPr/>
-          <p:nvPr/>
-        </p:nvSpPr>
-        <p:spPr>
-          <a:xfrm>
-            <a:off x="704088" y="1280160"/>
-            <a:ext cx="7744968" cy="2880360"/>
-          </a:xfrm>
-          <a:prstGeom prst="rect">
-            <a:avLst/>
-          </a:prstGeom>
-          <a:solidFill>
-            <a:srgbClr val="F0F2F5"/>
-          </a:solidFill>
-          <a:ln>
-            <a:solidFill>
-              <a:srgbClr val="D8DDE3"/>
-            </a:solidFill>
-          </a:ln>
-          <a:effectLst/>
-        </p:spPr>
-        <p:style>
-          <a:lnRef idx="1">
-            <a:schemeClr val="accent1"/>
-          </a:lnRef>
-          <a:fillRef idx="3">
-            <a:schemeClr val="accent1"/>
-          </a:fillRef>
-          <a:effectRef idx="2">
-            <a:schemeClr val="accent1"/>
-          </a:effectRef>
-          <a:fontRef idx="minor">
-            <a:schemeClr val="lt1"/>
-          </a:fontRef>
-        </p:style>
-        <p:txBody>
-          <a:bodyPr rtlCol="0" anchor="ctr" wrap="square" lIns="228600" tIns="137160"/>
-          <a:lstStyle/>
-          <a:p>
-            <a:pPr/>
-            <a:r>
-              <a:rPr sz="1500" b="0">
-                <a:solidFill>
-                  <a:srgbClr val="1D3557"/>
-                </a:solidFill>
-                <a:latin typeface="Menlo"/>
-              </a:rPr>
-              <a:t>pendiente, intercepto = np.polyfit(por_comuna["ingreso"],</a:t>
-            </a:r>
-          </a:p>
-          <a:p>
-            <a:pPr/>
-            <a:r>
-              <a:rPr sz="1500" b="0">
-                <a:solidFill>
-                  <a:srgbClr val="1D3557"/>
-                </a:solidFill>
-                <a:latin typeface="Menlo"/>
-              </a:rPr>
-              <a:t>                                   por_comuna["duracion"], 1)</a:t>
-            </a:r>
-          </a:p>
-          <a:p>
-            <a:pPr/>
-            <a:r>
-              <a:rPr sz="1500" b="0">
-                <a:solidFill>
-                  <a:srgbClr val="1D3557"/>
-                </a:solidFill>
-                <a:latin typeface="Menlo"/>
-              </a:rPr>
-              <a:t/>
-            </a:r>
-          </a:p>
-          <a:p>
-            <a:pPr/>
-            <a:r>
-              <a:rPr sz="1500" b="0">
-                <a:solidFill>
-                  <a:srgbClr val="1D3557"/>
-                </a:solidFill>
-                <a:latin typeface="Menlo"/>
-              </a:rPr>
-              <a:t># La recta evaluada, para dibujarla sobre el scatter</a:t>
-            </a:r>
-          </a:p>
-          <a:p>
-            <a:pPr/>
-            <a:r>
-              <a:rPr sz="1500" b="0">
-                <a:solidFill>
-                  <a:srgbClr val="1D3557"/>
-                </a:solidFill>
-                <a:latin typeface="Menlo"/>
-              </a:rPr>
-              <a:t>ax.plot(x, intercepto + pendiente * x)</a:t>
-            </a:r>
-          </a:p>
-        </p:txBody>
-      </p:sp>
+              <a:t>La recta: ingreso y duración</a:t>
+            </a:r>
+          </a:p>
+        </p:txBody>
+      </p:sp>
+      <p:pic>
+        <p:nvPicPr>
+          <p:cNvPr id="4" name="Picture 3" descr="c3_18_ingreso_duracion_recta.png"/>
+          <p:cNvPicPr>
+            <a:picLocks noChangeAspect="1"/>
+          </p:cNvPicPr>
+          <p:nvPr/>
+        </p:nvPicPr>
+        <p:blipFill>
+          <a:blip r:embed="rId2"/>
+          <a:stretch>
+            <a:fillRect/>
+          </a:stretch>
+        </p:blipFill>
+        <p:spPr>
+          <a:xfrm>
+            <a:off x="2107331" y="1143000"/>
+            <a:ext cx="4929336" cy="3154679"/>
+          </a:xfrm>
+          <a:prstGeom prst="rect">
+            <a:avLst/>
+          </a:prstGeom>
+        </p:spPr>
+      </p:pic>
       <p:sp>
         <p:nvSpPr>
           <p:cNvPr id="5" name="TextBox 4"/>
@@ -7828,8 +7846,8 @@
         </p:nvSpPr>
         <p:spPr>
           <a:xfrm>
-            <a:off x="704088" y="4389120"/>
-            <a:ext cx="7744968" cy="1097280"/>
+            <a:off x="704088" y="4434840"/>
+            <a:ext cx="7744968" cy="457200"/>
           </a:xfrm>
           <a:prstGeom prst="rect">
             <a:avLst/>
@@ -7842,31 +7860,14 @@
           </a:bodyPr>
           <a:lstStyle/>
           <a:p>
-            <a:pPr>
-              <a:lnSpc>
-                <a:spcPct val="112000"/>
-              </a:lnSpc>
-              <a:spcAft>
-                <a:spcPts val="900"/>
-              </a:spcAft>
-            </a:pPr>
-            <a:r>
-              <a:rPr sz="1600" b="1">
-                <a:solidFill>
-                  <a:srgbClr val="E0A437"/>
-                </a:solidFill>
-                <a:latin typeface="Fira Sans"/>
-              </a:rPr>
-              <a:t>▸ </a:t>
-            </a:r>
-            <a:r>
-              <a:rPr sz="1600" b="0">
-                <a:solidFill>
-                  <a:srgbClr val="000000"/>
-                </a:solidFill>
-                <a:latin typeface="Fira Sans"/>
-              </a:rPr>
-              <a:t>polyfit ajusta un polinomio por mínimos cuadrados; el 1 pide grado 1, una recta. En las clases 6 y 7 usaremos herramientas con más diagnósticos.</a:t>
+            <a:r>
+              <a:rPr sz="1300" b="0">
+                <a:solidFill>
+                  <a:srgbClr val="333333"/>
+                </a:solidFill>
+                <a:latin typeface="Fira Sans"/>
+              </a:rPr>
+              <a:t>duración = 38,3 − 4,8 · ingreso (ponderada por factor): por cada millón adicional, la duración media baja casi 5 minutos. Y r² = 0,12: la recta captura el 12% de la variación; la asociación es real pero moderada, y así se reporta.</a:t>
             </a:r>
           </a:p>
         </p:txBody>
@@ -7962,7 +7963,7 @@
                 </a:solidFill>
                 <a:latin typeface="Fira Sans"/>
               </a:rPr>
-              <a:t>Usar la recta: predecir y medir residuos</a:t>
+              <a:t>La recta en NumPy</a:t>
             </a:r>
           </a:p>
         </p:txBody>
@@ -8017,7 +8018,7 @@
                 </a:solidFill>
                 <a:latin typeface="Menlo"/>
               </a:rPr>
-              <a:t>prediccion = intercepto + pendiente * ingreso</a:t>
+              <a:t>pendiente, intercepto = np.polyfit(por_comuna["ingreso"],</a:t>
             </a:r>
           </a:p>
           <a:p>
@@ -8029,7 +8030,7 @@
                 </a:solidFill>
                 <a:latin typeface="Menlo"/>
               </a:rPr>
-              <a:t>residuo = duracion - prediccion</a:t>
+              <a:t>                                   por_comuna["duracion"], 1)</a:t>
             </a:r>
           </a:p>
           <a:p>
@@ -8053,7 +8054,7 @@
                 </a:solidFill>
                 <a:latin typeface="Menlo"/>
               </a:rPr>
-              <a:t># ¿Qué comunas viajan más de lo que su ingreso predice?</a:t>
+              <a:t># La recta evaluada, para dibujarla sobre el scatter</a:t>
             </a:r>
           </a:p>
           <a:p>
@@ -8065,7 +8066,7 @@
                 </a:solidFill>
                 <a:latin typeface="Menlo"/>
               </a:rPr>
-              <a:t>por_comuna.nlargest(5, "residuo")</a:t>
+              <a:t>ax.plot(x, intercepto + pendiente * x)</a:t>
             </a:r>
           </a:p>
         </p:txBody>
@@ -8116,7 +8117,7 @@
                 </a:solidFill>
                 <a:latin typeface="Fira Sans"/>
               </a:rPr>
-              <a:t>La Pintana viaja 13 minutos más de lo predicho y Santiago 7 menos: el residuo revela periferia y centralidad. ¿Azar? La clase 5 responde.</a:t>
+              <a:t>polyfit ajusta un polinomio por mínimos cuadrados; el 1 pide grado 1, una recta. En las clases 6 y 7 usaremos herramientas con más diagnósticos.</a:t>
             </a:r>
           </a:p>
         </p:txBody>
@@ -8212,7 +8213,7 @@
                 </a:solidFill>
                 <a:latin typeface="Fira Sans"/>
               </a:rPr>
-              <a:t>El impacto de sacar una fila</a:t>
+              <a:t>Usar la recta: predecir y medir residuos</a:t>
             </a:r>
           </a:p>
         </p:txBody>
@@ -8267,7 +8268,7 @@
                 </a:solidFill>
                 <a:latin typeface="Menlo"/>
               </a:rPr>
-              <a:t>sin_lb = por_comuna[por_comuna["Comuna"] != "LO BARNECHEA"]</a:t>
+              <a:t>prediccion = intercepto + pendiente * ingreso</a:t>
             </a:r>
           </a:p>
           <a:p>
@@ -8279,6 +8280,18 @@
                 </a:solidFill>
                 <a:latin typeface="Menlo"/>
               </a:rPr>
+              <a:t>residuo = duracion - prediccion</a:t>
+            </a:r>
+          </a:p>
+          <a:p>
+            <a:pPr/>
+            <a:r>
+              <a:rPr sz="1500" b="0">
+                <a:solidFill>
+                  <a:srgbClr val="1D3557"/>
+                </a:solidFill>
+                <a:latin typeface="Menlo"/>
+              </a:rPr>
               <a:t/>
             </a:r>
           </a:p>
@@ -8291,7 +8304,7 @@
                 </a:solidFill>
                 <a:latin typeface="Menlo"/>
               </a:rPr>
-              <a:t># Todo se recalcula sin la fila, y se compara</a:t>
+              <a:t># ¿Qué comunas viajan más de lo que su ingreso predice?</a:t>
             </a:r>
           </a:p>
           <a:p>
@@ -8303,19 +8316,7 @@
                 </a:solidFill>
                 <a:latin typeface="Menlo"/>
               </a:rPr>
-              <a:t>sin_lb["ingreso"].corr(sin_lb["duracion"])</a:t>
-            </a:r>
-          </a:p>
-          <a:p>
-            <a:pPr/>
-            <a:r>
-              <a:rPr sz="1500" b="0">
-                <a:solidFill>
-                  <a:srgbClr val="1D3557"/>
-                </a:solidFill>
-                <a:latin typeface="Menlo"/>
-              </a:rPr>
-              <a:t>np.polyfit(sin_lb["ingreso"] / 1e6, sin_lb["duracion"], 1)</a:t>
+              <a:t>por_comuna.nlargest(5, "residuo")</a:t>
             </a:r>
           </a:p>
         </p:txBody>
@@ -8366,7 +8367,7 @@
                 </a:solidFill>
                 <a:latin typeface="Fira Sans"/>
               </a:rPr>
-              <a:t>Sacar 1 comuna de 45 no mueve r (−0,34) pero cambia la pendiente en un quinto (−4,8 a −5,8): el impacto se mide con y sin, sobre todos los resúmenes en uso.</a:t>
+              <a:t>La Pintana viaja 13 minutos más de lo predicho y Santiago 7 menos: el residuo revela periferia y centralidad. ¿Azar? La clase 5 responde.</a:t>
             </a:r>
           </a:p>
         </p:txBody>
@@ -8462,35 +8463,114 @@
                 </a:solidFill>
                 <a:latin typeface="Fira Sans"/>
               </a:rPr>
-              <a:t>Las fórmulas, con factor de expansión</a:t>
-            </a:r>
-          </a:p>
-        </p:txBody>
-      </p:sp>
-      <p:pic>
-        <p:nvPicPr>
-          <p:cNvPr id="4" name="Picture 3" descr="c3_22_formulas_ponderada.png"/>
-          <p:cNvPicPr>
-            <a:picLocks noChangeAspect="1"/>
-          </p:cNvPicPr>
-          <p:nvPr/>
-        </p:nvPicPr>
-        <p:blipFill>
-          <a:blip r:embed="rId2"/>
-          <a:stretch>
-            <a:fillRect/>
-          </a:stretch>
-        </p:blipFill>
-        <p:spPr>
-          <a:xfrm>
-            <a:off x="1417319" y="1143000"/>
-            <a:ext cx="6309360" cy="2245514"/>
-          </a:xfrm>
-          <a:prstGeom prst="rect">
-            <a:avLst/>
-          </a:prstGeom>
-        </p:spPr>
-      </p:pic>
+              <a:t>El impacto de sacar una fila</a:t>
+            </a:r>
+          </a:p>
+        </p:txBody>
+      </p:sp>
+      <p:sp>
+        <p:nvSpPr>
+          <p:cNvPr id="4" name="Rectangle 3"/>
+          <p:cNvSpPr/>
+          <p:nvPr/>
+        </p:nvSpPr>
+        <p:spPr>
+          <a:xfrm>
+            <a:off x="704088" y="1280160"/>
+            <a:ext cx="7744968" cy="2880360"/>
+          </a:xfrm>
+          <a:prstGeom prst="rect">
+            <a:avLst/>
+          </a:prstGeom>
+          <a:solidFill>
+            <a:srgbClr val="F0F2F5"/>
+          </a:solidFill>
+          <a:ln>
+            <a:solidFill>
+              <a:srgbClr val="D8DDE3"/>
+            </a:solidFill>
+          </a:ln>
+          <a:effectLst/>
+        </p:spPr>
+        <p:style>
+          <a:lnRef idx="1">
+            <a:schemeClr val="accent1"/>
+          </a:lnRef>
+          <a:fillRef idx="3">
+            <a:schemeClr val="accent1"/>
+          </a:fillRef>
+          <a:effectRef idx="2">
+            <a:schemeClr val="accent1"/>
+          </a:effectRef>
+          <a:fontRef idx="minor">
+            <a:schemeClr val="lt1"/>
+          </a:fontRef>
+        </p:style>
+        <p:txBody>
+          <a:bodyPr rtlCol="0" anchor="ctr" wrap="square" lIns="228600" tIns="137160"/>
+          <a:lstStyle/>
+          <a:p>
+            <a:pPr/>
+            <a:r>
+              <a:rPr sz="1500" b="0">
+                <a:solidFill>
+                  <a:srgbClr val="1D3557"/>
+                </a:solidFill>
+                <a:latin typeface="Menlo"/>
+              </a:rPr>
+              <a:t>sin_lb = por_comuna[por_comuna["Comuna"] != "LO BARNECHEA"]</a:t>
+            </a:r>
+          </a:p>
+          <a:p>
+            <a:pPr/>
+            <a:r>
+              <a:rPr sz="1500" b="0">
+                <a:solidFill>
+                  <a:srgbClr val="1D3557"/>
+                </a:solidFill>
+                <a:latin typeface="Menlo"/>
+              </a:rPr>
+              <a:t/>
+            </a:r>
+          </a:p>
+          <a:p>
+            <a:pPr/>
+            <a:r>
+              <a:rPr sz="1500" b="0">
+                <a:solidFill>
+                  <a:srgbClr val="1D3557"/>
+                </a:solidFill>
+                <a:latin typeface="Menlo"/>
+              </a:rPr>
+              <a:t># Todo se recalcula sin la fila, y se compara</a:t>
+            </a:r>
+          </a:p>
+          <a:p>
+            <a:pPr/>
+            <a:r>
+              <a:rPr sz="1500" b="0">
+                <a:solidFill>
+                  <a:srgbClr val="1D3557"/>
+                </a:solidFill>
+                <a:latin typeface="Menlo"/>
+              </a:rPr>
+              <a:t>sin_lb["ingreso"].corr(sin_lb["duracion"])</a:t>
+            </a:r>
+          </a:p>
+          <a:p>
+            <a:pPr/>
+            <a:r>
+              <a:rPr sz="1500" b="0">
+                <a:solidFill>
+                  <a:srgbClr val="1D3557"/>
+                </a:solidFill>
+                <a:latin typeface="Menlo"/>
+              </a:rPr>
+              <a:t>np.polyfit(sin_lb["ingreso"] / 1e6, sin_lb["duracion"], 1)</a:t>
+            </a:r>
+          </a:p>
+        </p:txBody>
+      </p:sp>
       <p:sp>
         <p:nvSpPr>
           <p:cNvPr id="5" name="TextBox 4"/>
@@ -8499,8 +8579,8 @@
         </p:nvSpPr>
         <p:spPr>
           <a:xfrm>
-            <a:off x="704088" y="4434840"/>
-            <a:ext cx="7744968" cy="457200"/>
+            <a:off x="704088" y="4389120"/>
+            <a:ext cx="7744968" cy="1097280"/>
           </a:xfrm>
           <a:prstGeom prst="rect">
             <a:avLst/>
@@ -8513,14 +8593,31 @@
           </a:bodyPr>
           <a:lstStyle/>
           <a:p>
-            <a:r>
-              <a:rPr sz="1300" b="0">
-                <a:solidFill>
-                  <a:srgbClr val="333333"/>
-                </a:solidFill>
-                <a:latin typeface="Fira Sans"/>
-              </a:rPr>
-              <a:t>La misma recta de mínimos cuadrados, con cada término pesado por su factor: es la que usa el modelo que sigue, y en statsmodels se llama WLS (weighted least squares).</a:t>
+            <a:pPr>
+              <a:lnSpc>
+                <a:spcPct val="112000"/>
+              </a:lnSpc>
+              <a:spcAft>
+                <a:spcPts val="900"/>
+              </a:spcAft>
+            </a:pPr>
+            <a:r>
+              <a:rPr sz="1600" b="1">
+                <a:solidFill>
+                  <a:srgbClr val="E0A437"/>
+                </a:solidFill>
+                <a:latin typeface="Fira Sans"/>
+              </a:rPr>
+              <a:t>▸ </a:t>
+            </a:r>
+            <a:r>
+              <a:rPr sz="1600" b="0">
+                <a:solidFill>
+                  <a:srgbClr val="000000"/>
+                </a:solidFill>
+                <a:latin typeface="Fira Sans"/>
+              </a:rPr>
+              <a:t>Sacar 1 comuna de 45 no mueve r (−0,34) pero cambia la pendiente en un quinto (−4,8 a −5,8): el impacto se mide con y sin, sobre todos los resúmenes en uso.</a:t>
             </a:r>
           </a:p>
         </p:txBody>
@@ -8616,114 +8713,35 @@
                 </a:solidFill>
                 <a:latin typeface="Fira Sans"/>
               </a:rPr>
-              <a:t>Otro modelo: la motorización del hogar</a:t>
-            </a:r>
-          </a:p>
-        </p:txBody>
-      </p:sp>
-      <p:sp>
-        <p:nvSpPr>
-          <p:cNvPr id="4" name="Rectangle 3"/>
-          <p:cNvSpPr/>
-          <p:nvPr/>
-        </p:nvSpPr>
-        <p:spPr>
-          <a:xfrm>
-            <a:off x="704088" y="1280160"/>
-            <a:ext cx="7744968" cy="2880360"/>
-          </a:xfrm>
-          <a:prstGeom prst="rect">
-            <a:avLst/>
-          </a:prstGeom>
-          <a:solidFill>
-            <a:srgbClr val="F0F2F5"/>
-          </a:solidFill>
-          <a:ln>
-            <a:solidFill>
-              <a:srgbClr val="D8DDE3"/>
-            </a:solidFill>
-          </a:ln>
-          <a:effectLst/>
-        </p:spPr>
-        <p:style>
-          <a:lnRef idx="1">
-            <a:schemeClr val="accent1"/>
-          </a:lnRef>
-          <a:fillRef idx="3">
-            <a:schemeClr val="accent1"/>
-          </a:fillRef>
-          <a:effectRef idx="2">
-            <a:schemeClr val="accent1"/>
-          </a:effectRef>
-          <a:fontRef idx="minor">
-            <a:schemeClr val="lt1"/>
-          </a:fontRef>
-        </p:style>
-        <p:txBody>
-          <a:bodyPr rtlCol="0" anchor="ctr" wrap="square" lIns="228600" tIns="137160"/>
-          <a:lstStyle/>
-          <a:p>
-            <a:pPr/>
-            <a:r>
-              <a:rPr sz="1500" b="0">
-                <a:solidFill>
-                  <a:srgbClr val="1D3557"/>
-                </a:solidFill>
-                <a:latin typeface="Menlo"/>
-              </a:rPr>
-              <a:t>x = h["IngresoHogar"] / 1e6</a:t>
-            </a:r>
-          </a:p>
-          <a:p>
-            <a:pPr/>
-            <a:r>
-              <a:rPr sz="1500" b="0">
-                <a:solidFill>
-                  <a:srgbClr val="1D3557"/>
-                </a:solidFill>
-                <a:latin typeface="Menlo"/>
-              </a:rPr>
-              <a:t>y, w = h["NumVeh"], h["Factor"]</a:t>
-            </a:r>
-          </a:p>
-          <a:p>
-            <a:pPr/>
-            <a:r>
-              <a:rPr sz="1500" b="0">
-                <a:solidFill>
-                  <a:srgbClr val="1D3557"/>
-                </a:solidFill>
-                <a:latin typeface="Menlo"/>
-              </a:rPr>
-              <a:t/>
-            </a:r>
-          </a:p>
-          <a:p>
-            <a:pPr/>
-            <a:r>
-              <a:rPr sz="1500" b="0">
-                <a:solidFill>
-                  <a:srgbClr val="1D3557"/>
-                </a:solidFill>
-                <a:latin typeface="Menlo"/>
-              </a:rPr>
-              <a:t># La fórmula de la pendiente ponderada, tal cual</a:t>
-            </a:r>
-          </a:p>
-          <a:p>
-            <a:pPr/>
-            <a:r>
-              <a:rPr sz="1500" b="0">
-                <a:solidFill>
-                  <a:srgbClr val="1D3557"/>
-                </a:solidFill>
-                <a:latin typeface="Menlo"/>
-              </a:rPr>
-              <a:t>b = (w*(x - xw)*(y - yw)).sum() / (w*(x - xw)**2).sum()</a:t>
-            </a:r>
-          </a:p>
-        </p:txBody>
-      </p:sp>
+              <a:t>Las fórmulas, con factor de expansión</a:t>
+            </a:r>
+          </a:p>
+        </p:txBody>
+      </p:sp>
+      <p:pic>
+        <p:nvPicPr>
+          <p:cNvPr id="4" name="Picture 3" descr="c3_22_formulas_ponderada.png"/>
+          <p:cNvPicPr>
+            <a:picLocks noChangeAspect="1"/>
+          </p:cNvPicPr>
+          <p:nvPr/>
+        </p:nvPicPr>
+        <p:blipFill>
+          <a:blip r:embed="rId2"/>
+          <a:stretch>
+            <a:fillRect/>
+          </a:stretch>
+        </p:blipFill>
+        <p:spPr>
+          <a:xfrm>
+            <a:off x="1417319" y="1143000"/>
+            <a:ext cx="6309360" cy="2245514"/>
+          </a:xfrm>
+          <a:prstGeom prst="rect">
+            <a:avLst/>
+          </a:prstGeom>
+        </p:spPr>
+      </p:pic>
       <p:sp>
         <p:nvSpPr>
           <p:cNvPr id="5" name="TextBox 4"/>
@@ -8732,8 +8750,8 @@
         </p:nvSpPr>
         <p:spPr>
           <a:xfrm>
-            <a:off x="704088" y="4389120"/>
-            <a:ext cx="7744968" cy="1097280"/>
+            <a:off x="704088" y="4434840"/>
+            <a:ext cx="7744968" cy="457200"/>
           </a:xfrm>
           <a:prstGeom prst="rect">
             <a:avLst/>
@@ -8746,31 +8764,14 @@
           </a:bodyPr>
           <a:lstStyle/>
           <a:p>
-            <a:pPr>
-              <a:lnSpc>
-                <a:spcPct val="112000"/>
-              </a:lnSpc>
-              <a:spcAft>
-                <a:spcPts val="900"/>
-              </a:spcAft>
-            </a:pPr>
-            <a:r>
-              <a:rPr sz="1600" b="1">
-                <a:solidFill>
-                  <a:srgbClr val="E0A437"/>
-                </a:solidFill>
-                <a:latin typeface="Fira Sans"/>
-              </a:rPr>
-              <a:t>▸ </a:t>
-            </a:r>
-            <a:r>
-              <a:rPr sz="1600" b="0">
-                <a:solidFill>
-                  <a:srgbClr val="000000"/>
-                </a:solidFill>
-                <a:latin typeface="Fira Sans"/>
-              </a:rPr>
-              <a:t>18.264 hogares reales, ponderados por su factor: vehículos = 0,20 + 0,50 · ingreso. Medio vehículo más por cada millón.</a:t>
+            <a:r>
+              <a:rPr sz="1300" b="0">
+                <a:solidFill>
+                  <a:srgbClr val="333333"/>
+                </a:solidFill>
+                <a:latin typeface="Fira Sans"/>
+              </a:rPr>
+              <a:t>La misma recta de mínimos cuadrados, con cada término pesado por su factor: es la que usa el modelo que sigue, y en statsmodels se llama WLS (weighted least squares).</a:t>
             </a:r>
           </a:p>
         </p:txBody>
@@ -8866,7 +8867,7 @@
                 </a:solidFill>
                 <a:latin typeface="Fira Sans"/>
               </a:rPr>
-              <a:t>Sacar atípicos de la variable a predecir</a:t>
+              <a:t>Otro modelo: la motorización del hogar</a:t>
             </a:r>
           </a:p>
         </p:txBody>
@@ -8921,7 +8922,7 @@
                 </a:solidFill>
                 <a:latin typeface="Menlo"/>
               </a:rPr>
-              <a:t>q1, q3 = h["NumVeh"].quantile([0.25, 0.75])</a:t>
+              <a:t>x = h["IngresoHogar"] / 1e6</a:t>
             </a:r>
           </a:p>
           <a:p>
@@ -8933,7 +8934,7 @@
                 </a:solidFill>
                 <a:latin typeface="Menlo"/>
               </a:rPr>
-              <a:t>sin_atipicos = h[h["NumVeh"] &lt;= q3 + 1.5 * (q3 - q1)]</a:t>
+              <a:t>y, w = h["NumVeh"], h["Factor"]</a:t>
             </a:r>
           </a:p>
           <a:p>
@@ -8957,7 +8958,7 @@
                 </a:solidFill>
                 <a:latin typeface="Menlo"/>
               </a:rPr>
-              <a:t># El mismo modelo, sin los hogares de 3 autos o más</a:t>
+              <a:t># La fórmula de la pendiente ponderada, tal cual</a:t>
             </a:r>
           </a:p>
           <a:p>
@@ -8969,7 +8970,7 @@
                 </a:solidFill>
                 <a:latin typeface="Menlo"/>
               </a:rPr>
-              <a:t>np.polyfit(sin_atipicos["IngresoHogar"] / 1e6, sin_atipicos["NumVeh"], 1)</a:t>
+              <a:t>b = (w*(x - xw)*(y - yw)).sum() / (w*(x - xw)**2).sum()</a:t>
             </a:r>
           </a:p>
         </p:txBody>
@@ -9020,7 +9021,7 @@
                 </a:solidFill>
                 <a:latin typeface="Fira Sans"/>
               </a:rPr>
-              <a:t>Sacar 236 hogares aplana la pendiente ponderada (0,50 a 0,44): no eran errores, eran la señal. Los atípicos de y se investigan; se eliminan solo por dominio.</a:t>
+              <a:t>18.264 hogares reales, ponderados por su factor: vehículos = 0,20 + 0,50 · ingreso. Medio vehículo más por cada millón.</a:t>
             </a:r>
           </a:p>
         </p:txBody>
@@ -9058,7 +9059,7 @@
             <a:avLst/>
           </a:prstGeom>
           <a:solidFill>
-            <a:srgbClr val="1D3557"/>
+            <a:srgbClr val="FAFBFC"/>
           </a:solidFill>
           <a:ln>
             <a:noFill/>
@@ -9095,8 +9096,8 @@
         </p:nvSpPr>
         <p:spPr>
           <a:xfrm>
-            <a:off x="603504" y="1847088"/>
-            <a:ext cx="7946136" cy="1399032"/>
+            <a:off x="402336" y="301752"/>
+            <a:ext cx="8348472" cy="795528"/>
           </a:xfrm>
           <a:prstGeom prst="rect">
             <a:avLst/>
@@ -9110,24 +9111,167 @@
           <a:lstStyle/>
           <a:p>
             <a:r>
-              <a:rPr sz="3400" b="1">
-                <a:solidFill>
-                  <a:srgbClr val="FFFFFF"/>
-                </a:solidFill>
-                <a:latin typeface="Fira Sans"/>
-              </a:rPr>
-              <a:t>Buenas prácticas de visualización</a:t>
-            </a:r>
-          </a:p>
-          <a:p>
-            <a:r>
-              <a:rPr sz="1800" b="0">
+              <a:rPr sz="2800" b="1">
+                <a:solidFill>
+                  <a:srgbClr val="0F0F0F"/>
+                </a:solidFill>
+                <a:latin typeface="Fira Sans"/>
+              </a:rPr>
+              <a:t>Sacar atípicos de la variable a predecir</a:t>
+            </a:r>
+          </a:p>
+        </p:txBody>
+      </p:sp>
+      <p:sp>
+        <p:nvSpPr>
+          <p:cNvPr id="4" name="Rectangle 3"/>
+          <p:cNvSpPr/>
+          <p:nvPr/>
+        </p:nvSpPr>
+        <p:spPr>
+          <a:xfrm>
+            <a:off x="704088" y="1280160"/>
+            <a:ext cx="7744968" cy="2880360"/>
+          </a:xfrm>
+          <a:prstGeom prst="rect">
+            <a:avLst/>
+          </a:prstGeom>
+          <a:solidFill>
+            <a:srgbClr val="F0F2F5"/>
+          </a:solidFill>
+          <a:ln>
+            <a:solidFill>
+              <a:srgbClr val="D8DDE3"/>
+            </a:solidFill>
+          </a:ln>
+          <a:effectLst/>
+        </p:spPr>
+        <p:style>
+          <a:lnRef idx="1">
+            <a:schemeClr val="accent1"/>
+          </a:lnRef>
+          <a:fillRef idx="3">
+            <a:schemeClr val="accent1"/>
+          </a:fillRef>
+          <a:effectRef idx="2">
+            <a:schemeClr val="accent1"/>
+          </a:effectRef>
+          <a:fontRef idx="minor">
+            <a:schemeClr val="lt1"/>
+          </a:fontRef>
+        </p:style>
+        <p:txBody>
+          <a:bodyPr rtlCol="0" anchor="ctr" wrap="square" lIns="228600" tIns="137160"/>
+          <a:lstStyle/>
+          <a:p>
+            <a:pPr/>
+            <a:r>
+              <a:rPr sz="1500" b="0">
+                <a:solidFill>
+                  <a:srgbClr val="1D3557"/>
+                </a:solidFill>
+                <a:latin typeface="Menlo"/>
+              </a:rPr>
+              <a:t>q1, q3 = h["NumVeh"].quantile([0.25, 0.75])</a:t>
+            </a:r>
+          </a:p>
+          <a:p>
+            <a:pPr/>
+            <a:r>
+              <a:rPr sz="1500" b="0">
+                <a:solidFill>
+                  <a:srgbClr val="1D3557"/>
+                </a:solidFill>
+                <a:latin typeface="Menlo"/>
+              </a:rPr>
+              <a:t>sin_atipicos = h[h["NumVeh"] &lt;= q3 + 1.5 * (q3 - q1)]</a:t>
+            </a:r>
+          </a:p>
+          <a:p>
+            <a:pPr/>
+            <a:r>
+              <a:rPr sz="1500" b="0">
+                <a:solidFill>
+                  <a:srgbClr val="1D3557"/>
+                </a:solidFill>
+                <a:latin typeface="Menlo"/>
+              </a:rPr>
+              <a:t/>
+            </a:r>
+          </a:p>
+          <a:p>
+            <a:pPr/>
+            <a:r>
+              <a:rPr sz="1500" b="0">
+                <a:solidFill>
+                  <a:srgbClr val="1D3557"/>
+                </a:solidFill>
+                <a:latin typeface="Menlo"/>
+              </a:rPr>
+              <a:t># El mismo modelo, sin los hogares de 3 autos o más</a:t>
+            </a:r>
+          </a:p>
+          <a:p>
+            <a:pPr/>
+            <a:r>
+              <a:rPr sz="1500" b="0">
+                <a:solidFill>
+                  <a:srgbClr val="1D3557"/>
+                </a:solidFill>
+                <a:latin typeface="Menlo"/>
+              </a:rPr>
+              <a:t>np.polyfit(sin_atipicos["IngresoHogar"] / 1e6, sin_atipicos["NumVeh"], 1)</a:t>
+            </a:r>
+          </a:p>
+        </p:txBody>
+      </p:sp>
+      <p:sp>
+        <p:nvSpPr>
+          <p:cNvPr id="5" name="TextBox 4"/>
+          <p:cNvSpPr txBox="1"/>
+          <p:nvPr/>
+        </p:nvSpPr>
+        <p:spPr>
+          <a:xfrm>
+            <a:off x="704088" y="4389120"/>
+            <a:ext cx="7744968" cy="1097280"/>
+          </a:xfrm>
+          <a:prstGeom prst="rect">
+            <a:avLst/>
+          </a:prstGeom>
+          <a:noFill/>
+        </p:spPr>
+        <p:txBody>
+          <a:bodyPr wrap="square">
+            <a:spAutoFit/>
+          </a:bodyPr>
+          <a:lstStyle/>
+          <a:p>
+            <a:pPr>
+              <a:lnSpc>
+                <a:spcPct val="112000"/>
+              </a:lnSpc>
+              <a:spcAft>
+                <a:spcPts val="900"/>
+              </a:spcAft>
+            </a:pPr>
+            <a:r>
+              <a:rPr sz="1600" b="1">
                 <a:solidFill>
                   <a:srgbClr val="E0A437"/>
                 </a:solidFill>
                 <a:latin typeface="Fira Sans"/>
               </a:rPr>
-              <a:t>Que el gráfico diga la verdad y se entienda</a:t>
+              <a:t>▸ </a:t>
+            </a:r>
+            <a:r>
+              <a:rPr sz="1600" b="0">
+                <a:solidFill>
+                  <a:srgbClr val="000000"/>
+                </a:solidFill>
+                <a:latin typeface="Fira Sans"/>
+              </a:rPr>
+              <a:t>Sacar 236 hogares aplana la pendiente ponderada (0,50 a 0,44): no eran errores, eran la señal. Los atípicos de y se investigan; se eliminan solo por dominio.</a:t>
             </a:r>
           </a:p>
         </p:txBody>
@@ -9424,7 +9568,7 @@
             <a:avLst/>
           </a:prstGeom>
           <a:solidFill>
-            <a:srgbClr val="FAFBFC"/>
+            <a:srgbClr val="1D3557"/>
           </a:solidFill>
           <a:ln>
             <a:noFill/>
@@ -9461,8 +9605,8 @@
         </p:nvSpPr>
         <p:spPr>
           <a:xfrm>
-            <a:off x="402336" y="301752"/>
-            <a:ext cx="8348472" cy="795528"/>
+            <a:off x="603504" y="1847088"/>
+            <a:ext cx="7946136" cy="1399032"/>
           </a:xfrm>
           <a:prstGeom prst="rect">
             <a:avLst/>
@@ -9476,71 +9620,24 @@
           <a:lstStyle/>
           <a:p>
             <a:r>
-              <a:rPr sz="2800" b="1">
-                <a:solidFill>
-                  <a:srgbClr val="0F0F0F"/>
-                </a:solidFill>
-                <a:latin typeface="Fira Sans"/>
-              </a:rPr>
-              <a:t>Graficar 90 mil puntos: overplotting</a:t>
-            </a:r>
-          </a:p>
-        </p:txBody>
-      </p:sp>
-      <p:pic>
-        <p:nvPicPr>
-          <p:cNvPr id="4" name="Picture 3" descr="c3_08_overplotting.png"/>
-          <p:cNvPicPr>
-            <a:picLocks noChangeAspect="1"/>
-          </p:cNvPicPr>
-          <p:nvPr/>
-        </p:nvPicPr>
-        <p:blipFill>
-          <a:blip r:embed="rId2"/>
-          <a:stretch>
-            <a:fillRect/>
-          </a:stretch>
-        </p:blipFill>
-        <p:spPr>
-          <a:xfrm>
-            <a:off x="1417319" y="1143000"/>
-            <a:ext cx="6309360" cy="1913950"/>
-          </a:xfrm>
-          <a:prstGeom prst="rect">
-            <a:avLst/>
-          </a:prstGeom>
-        </p:spPr>
-      </p:pic>
-      <p:sp>
-        <p:nvSpPr>
-          <p:cNvPr id="5" name="TextBox 4"/>
-          <p:cNvSpPr txBox="1"/>
-          <p:nvPr/>
-        </p:nvSpPr>
-        <p:spPr>
-          <a:xfrm>
-            <a:off x="704088" y="4434840"/>
-            <a:ext cx="7744968" cy="457200"/>
-          </a:xfrm>
-          <a:prstGeom prst="rect">
-            <a:avLst/>
-          </a:prstGeom>
-          <a:noFill/>
-        </p:spPr>
-        <p:txBody>
-          <a:bodyPr wrap="square">
-            <a:spAutoFit/>
-          </a:bodyPr>
-          <a:lstStyle/>
-          <a:p>
-            <a:r>
-              <a:rPr sz="1300" b="0">
-                <a:solidFill>
-                  <a:srgbClr val="333333"/>
-                </a:solidFill>
-                <a:latin typeface="Fira Sans"/>
-              </a:rPr>
-              <a:t>Con todos los puntos sólidos, el scatter se satura y miente. Los remedios: transparencia (alpha), muestreo, o hexbin, donde el color cuenta los viajes (la distancia viene en la tabla DistanciaViaje.csv; sus −1 son faltantes disfrazados).</a:t>
+              <a:rPr sz="3400" b="1">
+                <a:solidFill>
+                  <a:srgbClr val="FFFFFF"/>
+                </a:solidFill>
+                <a:latin typeface="Fira Sans"/>
+              </a:rPr>
+              <a:t>Buenas prácticas de visualización</a:t>
+            </a:r>
+          </a:p>
+          <a:p>
+            <a:r>
+              <a:rPr sz="1800" b="0">
+                <a:solidFill>
+                  <a:srgbClr val="E0A437"/>
+                </a:solidFill>
+                <a:latin typeface="Fira Sans"/>
+              </a:rPr>
+              <a:t>Que el gráfico diga la verdad y se entienda</a:t>
             </a:r>
           </a:p>
         </p:txBody>
@@ -9636,14 +9733,14 @@
                 </a:solidFill>
                 <a:latin typeface="Fira Sans"/>
               </a:rPr>
-              <a:t>Cuándo usar escala logarítmica</a:t>
+              <a:t>Graficar 90 mil puntos: overplotting</a:t>
             </a:r>
           </a:p>
         </p:txBody>
       </p:sp>
       <p:pic>
         <p:nvPicPr>
-          <p:cNvPr id="4" name="Picture 3" descr="c3_10_escala_log.png"/>
+          <p:cNvPr id="4" name="Picture 3" descr="c3_08_overplotting.png"/>
           <p:cNvPicPr>
             <a:picLocks noChangeAspect="1"/>
           </p:cNvPicPr>
@@ -9658,7 +9755,7 @@
         <p:spPr>
           <a:xfrm>
             <a:off x="1417319" y="1143000"/>
-            <a:ext cx="6309360" cy="2432846"/>
+            <a:ext cx="6309360" cy="1913950"/>
           </a:xfrm>
           <a:prstGeom prst="rect">
             <a:avLst/>
@@ -9694,7 +9791,7 @@
                 </a:solidFill>
                 <a:latin typeface="Fira Sans"/>
               </a:rPr>
-              <a:t>Con colas largas como el ingreso, la escala lineal aplasta el 99% de los datos contra el borde; la logarítmica reparte el espacio y la forma aparece.</a:t>
+              <a:t>Con todos los puntos sólidos, el scatter se satura y miente. Los remedios: transparencia (alpha), muestreo, o hexbin, donde el color cuenta los viajes (la distancia viene en la tabla DistanciaViaje.csv; sus −1 son faltantes disfrazados).</a:t>
             </a:r>
           </a:p>
         </p:txBody>
@@ -9790,14 +9887,14 @@
                 </a:solidFill>
                 <a:latin typeface="Fira Sans"/>
               </a:rPr>
-              <a:t>El mismo gráfico, dos veces</a:t>
+              <a:t>Cuándo usar escala logarítmica</a:t>
             </a:r>
           </a:p>
         </p:txBody>
       </p:sp>
       <p:pic>
         <p:nvPicPr>
-          <p:cNvPr id="4" name="Picture 3" descr="c3_16_mal_buen_grafico.png"/>
+          <p:cNvPr id="4" name="Picture 3" descr="c3_10_escala_log.png"/>
           <p:cNvPicPr>
             <a:picLocks noChangeAspect="1"/>
           </p:cNvPicPr>
@@ -9812,7 +9909,7 @@
         <p:spPr>
           <a:xfrm>
             <a:off x="1417319" y="1143000"/>
-            <a:ext cx="6309360" cy="2447822"/>
+            <a:ext cx="6309360" cy="2432846"/>
           </a:xfrm>
           <a:prstGeom prst="rect">
             <a:avLst/>
@@ -9848,7 +9945,7 @@
                 </a:solidFill>
                 <a:latin typeface="Fira Sans"/>
               </a:rPr>
-              <a:t>Los mismos 30 mil viajes: sin rotular y saturado, contra rotulado, con transparencia y con el hallazgo en el título.</a:t>
+              <a:t>Con colas largas como el ingreso, la escala lineal aplasta el 99% de los datos contra el borde; la logarítmica reparte el espacio y la forma aparece.</a:t>
             </a:r>
           </a:p>
         </p:txBody>
@@ -9944,21 +10041,45 @@
                 </a:solidFill>
                 <a:latin typeface="Fira Sans"/>
               </a:rPr>
-              <a:t>Checklist del buen gráfico</a:t>
-            </a:r>
-          </a:p>
-        </p:txBody>
-      </p:sp>
-      <p:sp>
-        <p:nvSpPr>
-          <p:cNvPr id="4" name="TextBox 3"/>
+              <a:t>El mismo gráfico, dos veces</a:t>
+            </a:r>
+          </a:p>
+        </p:txBody>
+      </p:sp>
+      <p:pic>
+        <p:nvPicPr>
+          <p:cNvPr id="4" name="Picture 3" descr="c3_16_mal_buen_grafico.png"/>
+          <p:cNvPicPr>
+            <a:picLocks noChangeAspect="1"/>
+          </p:cNvPicPr>
+          <p:nvPr/>
+        </p:nvPicPr>
+        <p:blipFill>
+          <a:blip r:embed="rId2"/>
+          <a:stretch>
+            <a:fillRect/>
+          </a:stretch>
+        </p:blipFill>
+        <p:spPr>
+          <a:xfrm>
+            <a:off x="1417319" y="1143000"/>
+            <a:ext cx="6309360" cy="2447822"/>
+          </a:xfrm>
+          <a:prstGeom prst="rect">
+            <a:avLst/>
+          </a:prstGeom>
+        </p:spPr>
+      </p:pic>
+      <p:sp>
+        <p:nvSpPr>
+          <p:cNvPr id="5" name="TextBox 4"/>
           <p:cNvSpPr txBox="1"/>
           <p:nvPr/>
         </p:nvSpPr>
         <p:spPr>
           <a:xfrm>
-            <a:off x="704088" y="1353312"/>
-            <a:ext cx="7744968" cy="3300984"/>
+            <a:off x="704088" y="4434840"/>
+            <a:ext cx="7744968" cy="457200"/>
           </a:xfrm>
           <a:prstGeom prst="rect">
             <a:avLst/>
@@ -9971,143 +10092,14 @@
           </a:bodyPr>
           <a:lstStyle/>
           <a:p>
-            <a:pPr>
-              <a:lnSpc>
-                <a:spcPct val="112000"/>
-              </a:lnSpc>
-              <a:spcAft>
-                <a:spcPts val="900"/>
-              </a:spcAft>
-            </a:pPr>
-            <a:r>
-              <a:rPr sz="1800" b="1">
-                <a:solidFill>
-                  <a:srgbClr val="E0A437"/>
-                </a:solidFill>
-                <a:latin typeface="Fira Sans"/>
-              </a:rPr>
-              <a:t>▸ </a:t>
-            </a:r>
-            <a:r>
-              <a:rPr sz="1800" b="0">
-                <a:solidFill>
-                  <a:srgbClr val="000000"/>
-                </a:solidFill>
-                <a:latin typeface="Fira Sans"/>
-              </a:rPr>
-              <a:t>Título que diga el hallazgo, no solo las variables.</a:t>
-            </a:r>
-          </a:p>
-          <a:p>
-            <a:pPr>
-              <a:lnSpc>
-                <a:spcPct val="112000"/>
-              </a:lnSpc>
-              <a:spcAft>
-                <a:spcPts val="900"/>
-              </a:spcAft>
-            </a:pPr>
-            <a:r>
-              <a:rPr sz="1800" b="1">
-                <a:solidFill>
-                  <a:srgbClr val="E0A437"/>
-                </a:solidFill>
-                <a:latin typeface="Fira Sans"/>
-              </a:rPr>
-              <a:t>▸ </a:t>
-            </a:r>
-            <a:r>
-              <a:rPr sz="1800" b="0">
-                <a:solidFill>
-                  <a:srgbClr val="000000"/>
-                </a:solidFill>
-                <a:latin typeface="Fira Sans"/>
-              </a:rPr>
-              <a:t>Ejes con nombre y unidad; ejes que parten de cero en gráficos de barras.</a:t>
-            </a:r>
-          </a:p>
-          <a:p>
-            <a:pPr>
-              <a:lnSpc>
-                <a:spcPct val="112000"/>
-              </a:lnSpc>
-              <a:spcAft>
-                <a:spcPts val="900"/>
-              </a:spcAft>
-            </a:pPr>
-            <a:r>
-              <a:rPr sz="1800" b="1">
-                <a:solidFill>
-                  <a:srgbClr val="E0A437"/>
-                </a:solidFill>
-                <a:latin typeface="Fira Sans"/>
-              </a:rPr>
-              <a:t>▸ </a:t>
-            </a:r>
-            <a:r>
-              <a:rPr sz="1800" b="0">
-                <a:solidFill>
-                  <a:srgbClr val="000000"/>
-                </a:solidFill>
-                <a:latin typeface="Fira Sans"/>
-              </a:rPr>
-              <a:t>Muchos puntos: alpha, muestreo o hexbin.</a:t>
-            </a:r>
-          </a:p>
-          <a:p>
-            <a:pPr>
-              <a:lnSpc>
-                <a:spcPct val="112000"/>
-              </a:lnSpc>
-              <a:spcAft>
-                <a:spcPts val="900"/>
-              </a:spcAft>
-            </a:pPr>
-            <a:r>
-              <a:rPr sz="1800" b="1">
-                <a:solidFill>
-                  <a:srgbClr val="E0A437"/>
-                </a:solidFill>
-                <a:latin typeface="Fira Sans"/>
-              </a:rPr>
-              <a:t>▸ </a:t>
-            </a:r>
-            <a:r>
-              <a:rPr sz="1800" b="0">
-                <a:solidFill>
-                  <a:srgbClr val="000000"/>
-                </a:solidFill>
-                <a:latin typeface="Fira Sans"/>
-              </a:rPr>
-              <a:t>Colas largas: escala logarítmica o eje recortado, declarándolo.</a:t>
-            </a:r>
-          </a:p>
-          <a:p>
-            <a:pPr>
-              <a:lnSpc>
-                <a:spcPct val="112000"/>
-              </a:lnSpc>
-              <a:spcAft>
-                <a:spcPts val="900"/>
-              </a:spcAft>
-            </a:pPr>
-            <a:r>
-              <a:rPr sz="1800" b="1">
-                <a:solidFill>
-                  <a:srgbClr val="E0A437"/>
-                </a:solidFill>
-                <a:latin typeface="Fira Sans"/>
-              </a:rPr>
-              <a:t>▸ </a:t>
-            </a:r>
-            <a:r>
-              <a:rPr sz="1800" b="1">
-                <a:solidFill>
-                  <a:srgbClr val="1D3557"/>
-                </a:solidFill>
-                <a:latin typeface="Fira Sans"/>
-              </a:rPr>
-              <a:t>El gráfico se corrige igual que el código: se itera hasta que un tercero lo entienda sin explicación oral.</a:t>
+            <a:r>
+              <a:rPr sz="1300" b="0">
+                <a:solidFill>
+                  <a:srgbClr val="333333"/>
+                </a:solidFill>
+                <a:latin typeface="Fira Sans"/>
+              </a:rPr>
+              <a:t>Los mismos 30 mil viajes: sin rotular y saturado, contra rotulado, con transparencia y con el hallazgo en el título.</a:t>
             </a:r>
           </a:p>
         </p:txBody>
@@ -10203,7 +10195,7 @@
                 </a:solidFill>
                 <a:latin typeface="Fira Sans"/>
               </a:rPr>
-              <a:t>Síntesis</a:t>
+              <a:t>Checklist del buen gráfico</a:t>
             </a:r>
           </a:p>
         </p:txBody>
@@ -10254,7 +10246,7 @@
                 </a:solidFill>
                 <a:latin typeface="Fira Sans"/>
               </a:rPr>
-              <a:t>El análisis bivariado se elige según el par de tipos: scatter y correlación, groupby y boxplot, o tabla de contingencia.</a:t>
+              <a:t>Título que diga el hallazgo, no solo las variables.</a:t>
             </a:r>
           </a:p>
           <a:p>
@@ -10282,7 +10274,7 @@
                 </a:solidFill>
                 <a:latin typeface="Fira Sans"/>
               </a:rPr>
-              <a:t>Pearson para relaciones lineales; Spearman cuando hay atípicos o curvas. Y siempre graficar: Anscombe.</a:t>
+              <a:t>Ejes con nombre y unidad; ejes que parten de cero en gráficos de barras.</a:t>
             </a:r>
           </a:p>
           <a:p>
@@ -10310,7 +10302,7 @@
                 </a:solidFill>
                 <a:latin typeface="Fira Sans"/>
               </a:rPr>
-              <a:t>Correlación no es causalidad: reportamos asociación.</a:t>
+              <a:t>Muchos puntos: alpha, muestreo o hexbin.</a:t>
             </a:r>
           </a:p>
           <a:p>
@@ -10338,7 +10330,7 @@
                 </a:solidFill>
                 <a:latin typeface="Fira Sans"/>
               </a:rPr>
-              <a:t>La regresión es el primer modelo: una función que resume, predice y deja residuos que diagnostican.</a:t>
+              <a:t>Colas largas: escala logarítmica o eje recortado, declarándolo.</a:t>
             </a:r>
           </a:p>
           <a:p>
@@ -10366,7 +10358,7 @@
                 </a:solidFill>
                 <a:latin typeface="Fira Sans"/>
               </a:rPr>
-              <a:t>Todo lo de hoy es exactamente lo que el primer EDA del proyecto debe mostrar (entrega: lunes 15).</a:t>
+              <a:t>El gráfico se corrige igual que el código: se itera hasta que un tercero lo entienda sin explicación oral.</a:t>
             </a:r>
           </a:p>
         </p:txBody>
@@ -10462,7 +10454,7 @@
                 </a:solidFill>
                 <a:latin typeface="Fira Sans"/>
               </a:rPr>
-              <a:t>Próxima clase</a:t>
+              <a:t>Síntesis</a:t>
             </a:r>
           </a:p>
         </p:txBody>
@@ -10507,13 +10499,13 @@
               <a:t>▸ </a:t>
             </a:r>
             <a:r>
-              <a:rPr sz="1800" b="1">
-                <a:solidFill>
-                  <a:srgbClr val="1D3557"/>
-                </a:solidFill>
-                <a:latin typeface="Fira Sans"/>
-              </a:rPr>
-              <a:t>Jueves 3 de septiembre: presentaciones breves de las ideas de proyecto (5 minutos por equipo, sin nota).</a:t>
+              <a:rPr sz="1800" b="0">
+                <a:solidFill>
+                  <a:srgbClr val="000000"/>
+                </a:solidFill>
+                <a:latin typeface="Fira Sans"/>
+              </a:rPr>
+              <a:t>El análisis bivariado se elige según el par de tipos: scatter y correlación, groupby y boxplot, o tabla de contingencia.</a:t>
             </a:r>
           </a:p>
           <a:p>
@@ -10541,7 +10533,7 @@
                 </a:solidFill>
                 <a:latin typeface="Fira Sans"/>
               </a:rPr>
-              <a:t>Después: fundamentos de probabilidad, la base para la inferencia de las clases siguientes.</a:t>
+              <a:t>Pearson para relaciones lineales; Spearman cuando hay atípicos o curvas. Y siempre graficar: Anscombe.</a:t>
             </a:r>
           </a:p>
           <a:p>
@@ -10569,7 +10561,7 @@
                 </a:solidFill>
                 <a:latin typeface="Fira Sans"/>
               </a:rPr>
-              <a:t>Se publica la rúbrica del primer análisis exploratorio.</a:t>
+              <a:t>Correlación no es causalidad: reportamos asociación.</a:t>
             </a:r>
           </a:p>
           <a:p>
@@ -10597,7 +10589,35 @@
                 </a:solidFill>
                 <a:latin typeface="Fira Sans"/>
               </a:rPr>
-              <a:t>Recuerden: la formulación se entrega el lunes 7 por el aula virtual.</a:t>
+              <a:t>La regresión es el primer modelo: una función que resume, predice y deja residuos que diagnostican.</a:t>
+            </a:r>
+          </a:p>
+          <a:p>
+            <a:pPr>
+              <a:lnSpc>
+                <a:spcPct val="112000"/>
+              </a:lnSpc>
+              <a:spcAft>
+                <a:spcPts val="900"/>
+              </a:spcAft>
+            </a:pPr>
+            <a:r>
+              <a:rPr sz="1800" b="1">
+                <a:solidFill>
+                  <a:srgbClr val="E0A437"/>
+                </a:solidFill>
+                <a:latin typeface="Fira Sans"/>
+              </a:rPr>
+              <a:t>▸ </a:t>
+            </a:r>
+            <a:r>
+              <a:rPr sz="1800" b="1">
+                <a:solidFill>
+                  <a:srgbClr val="1D3557"/>
+                </a:solidFill>
+                <a:latin typeface="Fira Sans"/>
+              </a:rPr>
+              <a:t>Todo lo de hoy es exactamente lo que el primer EDA del proyecto debe mostrar (entrega: lunes 15).</a:t>
             </a:r>
           </a:p>
         </p:txBody>
@@ -10611,6 +10631,237 @@
 </file>
 
 <file path=ppt/slides/slide46.xml><?xml version="1.0" encoding="utf-8"?>
+<p:sld xmlns:a="http://schemas.openxmlformats.org/drawingml/2006/main" xmlns:p="http://schemas.openxmlformats.org/presentationml/2006/main" xmlns:r="http://schemas.openxmlformats.org/officeDocument/2006/relationships">
+  <p:cSld>
+    <p:spTree>
+      <p:nvGrpSpPr>
+        <p:cNvPr id="1" name=""/>
+        <p:cNvGrpSpPr/>
+        <p:nvPr/>
+      </p:nvGrpSpPr>
+      <p:grpSpPr/>
+      <p:sp>
+        <p:nvSpPr>
+          <p:cNvPr id="2" name="Rectangle 1"/>
+          <p:cNvSpPr/>
+          <p:nvPr/>
+        </p:nvSpPr>
+        <p:spPr>
+          <a:xfrm>
+            <a:off x="0" y="0"/>
+            <a:ext cx="9144000" cy="5138928"/>
+          </a:xfrm>
+          <a:prstGeom prst="rect">
+            <a:avLst/>
+          </a:prstGeom>
+          <a:solidFill>
+            <a:srgbClr val="FAFBFC"/>
+          </a:solidFill>
+          <a:ln>
+            <a:noFill/>
+          </a:ln>
+          <a:effectLst/>
+        </p:spPr>
+        <p:style>
+          <a:lnRef idx="1">
+            <a:schemeClr val="accent1"/>
+          </a:lnRef>
+          <a:fillRef idx="3">
+            <a:schemeClr val="accent1"/>
+          </a:fillRef>
+          <a:effectRef idx="2">
+            <a:schemeClr val="accent1"/>
+          </a:effectRef>
+          <a:fontRef idx="minor">
+            <a:schemeClr val="lt1"/>
+          </a:fontRef>
+        </p:style>
+        <p:txBody>
+          <a:bodyPr rtlCol="0" anchor="ctr"/>
+          <a:lstStyle/>
+          <a:p>
+            <a:pPr algn="ctr"/>
+          </a:p>
+        </p:txBody>
+      </p:sp>
+      <p:sp>
+        <p:nvSpPr>
+          <p:cNvPr id="3" name="TextBox 2"/>
+          <p:cNvSpPr txBox="1"/>
+          <p:nvPr/>
+        </p:nvSpPr>
+        <p:spPr>
+          <a:xfrm>
+            <a:off x="402336" y="301752"/>
+            <a:ext cx="8348472" cy="795528"/>
+          </a:xfrm>
+          <a:prstGeom prst="rect">
+            <a:avLst/>
+          </a:prstGeom>
+          <a:noFill/>
+        </p:spPr>
+        <p:txBody>
+          <a:bodyPr wrap="square">
+            <a:spAutoFit/>
+          </a:bodyPr>
+          <a:lstStyle/>
+          <a:p>
+            <a:r>
+              <a:rPr sz="2800" b="1">
+                <a:solidFill>
+                  <a:srgbClr val="0F0F0F"/>
+                </a:solidFill>
+                <a:latin typeface="Fira Sans"/>
+              </a:rPr>
+              <a:t>Próxima clase</a:t>
+            </a:r>
+          </a:p>
+        </p:txBody>
+      </p:sp>
+      <p:sp>
+        <p:nvSpPr>
+          <p:cNvPr id="4" name="TextBox 3"/>
+          <p:cNvSpPr txBox="1"/>
+          <p:nvPr/>
+        </p:nvSpPr>
+        <p:spPr>
+          <a:xfrm>
+            <a:off x="704088" y="1353312"/>
+            <a:ext cx="7744968" cy="3300984"/>
+          </a:xfrm>
+          <a:prstGeom prst="rect">
+            <a:avLst/>
+          </a:prstGeom>
+          <a:noFill/>
+        </p:spPr>
+        <p:txBody>
+          <a:bodyPr wrap="square">
+            <a:spAutoFit/>
+          </a:bodyPr>
+          <a:lstStyle/>
+          <a:p>
+            <a:pPr>
+              <a:lnSpc>
+                <a:spcPct val="112000"/>
+              </a:lnSpc>
+              <a:spcAft>
+                <a:spcPts val="900"/>
+              </a:spcAft>
+            </a:pPr>
+            <a:r>
+              <a:rPr sz="1800" b="1">
+                <a:solidFill>
+                  <a:srgbClr val="E0A437"/>
+                </a:solidFill>
+                <a:latin typeface="Fira Sans"/>
+              </a:rPr>
+              <a:t>▸ </a:t>
+            </a:r>
+            <a:r>
+              <a:rPr sz="1800" b="1">
+                <a:solidFill>
+                  <a:srgbClr val="1D3557"/>
+                </a:solidFill>
+                <a:latin typeface="Fira Sans"/>
+              </a:rPr>
+              <a:t>Jueves 3 de septiembre: presentaciones breves de las ideas de proyecto (5 minutos por equipo, sin nota).</a:t>
+            </a:r>
+          </a:p>
+          <a:p>
+            <a:pPr>
+              <a:lnSpc>
+                <a:spcPct val="112000"/>
+              </a:lnSpc>
+              <a:spcAft>
+                <a:spcPts val="900"/>
+              </a:spcAft>
+            </a:pPr>
+            <a:r>
+              <a:rPr sz="1800" b="1">
+                <a:solidFill>
+                  <a:srgbClr val="E0A437"/>
+                </a:solidFill>
+                <a:latin typeface="Fira Sans"/>
+              </a:rPr>
+              <a:t>▸ </a:t>
+            </a:r>
+            <a:r>
+              <a:rPr sz="1800" b="0">
+                <a:solidFill>
+                  <a:srgbClr val="000000"/>
+                </a:solidFill>
+                <a:latin typeface="Fira Sans"/>
+              </a:rPr>
+              <a:t>Después: fundamentos de probabilidad, la base para la inferencia de las clases siguientes.</a:t>
+            </a:r>
+          </a:p>
+          <a:p>
+            <a:pPr>
+              <a:lnSpc>
+                <a:spcPct val="112000"/>
+              </a:lnSpc>
+              <a:spcAft>
+                <a:spcPts val="900"/>
+              </a:spcAft>
+            </a:pPr>
+            <a:r>
+              <a:rPr sz="1800" b="1">
+                <a:solidFill>
+                  <a:srgbClr val="E0A437"/>
+                </a:solidFill>
+                <a:latin typeface="Fira Sans"/>
+              </a:rPr>
+              <a:t>▸ </a:t>
+            </a:r>
+            <a:r>
+              <a:rPr sz="1800" b="0">
+                <a:solidFill>
+                  <a:srgbClr val="000000"/>
+                </a:solidFill>
+                <a:latin typeface="Fira Sans"/>
+              </a:rPr>
+              <a:t>Se publica la rúbrica del primer análisis exploratorio.</a:t>
+            </a:r>
+          </a:p>
+          <a:p>
+            <a:pPr>
+              <a:lnSpc>
+                <a:spcPct val="112000"/>
+              </a:lnSpc>
+              <a:spcAft>
+                <a:spcPts val="900"/>
+              </a:spcAft>
+            </a:pPr>
+            <a:r>
+              <a:rPr sz="1800" b="1">
+                <a:solidFill>
+                  <a:srgbClr val="E0A437"/>
+                </a:solidFill>
+                <a:latin typeface="Fira Sans"/>
+              </a:rPr>
+              <a:t>▸ </a:t>
+            </a:r>
+            <a:r>
+              <a:rPr sz="1800" b="0">
+                <a:solidFill>
+                  <a:srgbClr val="000000"/>
+                </a:solidFill>
+                <a:latin typeface="Fira Sans"/>
+              </a:rPr>
+              <a:t>Recuerden: la formulación se entrega el lunes 7 por el aula virtual.</a:t>
+            </a:r>
+          </a:p>
+        </p:txBody>
+      </p:sp>
+    </p:spTree>
+  </p:cSld>
+  <p:clrMapOvr>
+    <a:masterClrMapping/>
+  </p:clrMapOvr>
+</p:sld>
+</file>
+
+<file path=ppt/slides/slide47.xml><?xml version="1.0" encoding="utf-8"?>
 <p:sld xmlns:a="http://schemas.openxmlformats.org/drawingml/2006/main" xmlns:p="http://schemas.openxmlformats.org/presentationml/2006/main" xmlns:r="http://schemas.openxmlformats.org/officeDocument/2006/relationships">
   <p:cSld>
     <p:spTree>

</xml_diff>

<commit_message>
Clase 3: recreo al final del contenido, antes del cierre
Co-Authored-By: Claude Fable 5 <noreply@anthropic.com>
</commit_message>
<xml_diff>
--- a/presentaciones/clase03_eda_bivariado.pptx
+++ b/presentaciones/clase03_eda_bivariado.pptx
@@ -6153,7 +6153,7 @@
                 </a:solidFill>
                 <a:latin typeface="Fira Sans"/>
               </a:rPr>
-              <a:t>Recreo</a:t>
+              <a:t>Grupos y tablas de contingencia</a:t>
             </a:r>
           </a:p>
           <a:p>
@@ -6164,7 +6164,7 @@
                 </a:solidFill>
                 <a:latin typeface="Fira Sans"/>
               </a:rPr>
-              <a:t>10 minutos</a:t>
+              <a:t>Cuando una de las dos variables es categórica</a:t>
             </a:r>
           </a:p>
         </p:txBody>
@@ -6202,7 +6202,7 @@
             <a:avLst/>
           </a:prstGeom>
           <a:solidFill>
-            <a:srgbClr val="1D3557"/>
+            <a:srgbClr val="FAFBFC"/>
           </a:solidFill>
           <a:ln>
             <a:noFill/>
@@ -6239,8 +6239,8 @@
         </p:nvSpPr>
         <p:spPr>
           <a:xfrm>
-            <a:off x="603504" y="1847088"/>
-            <a:ext cx="7946136" cy="1399032"/>
+            <a:off x="402336" y="301752"/>
+            <a:ext cx="8348472" cy="795528"/>
           </a:xfrm>
           <a:prstGeom prst="rect">
             <a:avLst/>
@@ -6254,24 +6254,71 @@
           <a:lstStyle/>
           <a:p>
             <a:r>
-              <a:rPr sz="3400" b="1">
-                <a:solidFill>
-                  <a:srgbClr val="FFFFFF"/>
-                </a:solidFill>
-                <a:latin typeface="Fira Sans"/>
-              </a:rPr>
-              <a:t>Grupos y tablas de contingencia</a:t>
-            </a:r>
-          </a:p>
-          <a:p>
-            <a:r>
-              <a:rPr sz="1800" b="0">
-                <a:solidFill>
-                  <a:srgbClr val="E0A437"/>
-                </a:solidFill>
-                <a:latin typeface="Fira Sans"/>
-              </a:rPr>
-              <a:t>Cuando una de las dos variables es categórica</a:t>
+              <a:rPr sz="2800" b="1">
+                <a:solidFill>
+                  <a:srgbClr val="0F0F0F"/>
+                </a:solidFill>
+                <a:latin typeface="Fira Sans"/>
+              </a:rPr>
+              <a:t>groupby: partir, aplicar, juntar</a:t>
+            </a:r>
+          </a:p>
+        </p:txBody>
+      </p:sp>
+      <p:pic>
+        <p:nvPicPr>
+          <p:cNvPr id="4" name="Picture 3" descr="c3_14_groupby.png"/>
+          <p:cNvPicPr>
+            <a:picLocks noChangeAspect="1"/>
+          </p:cNvPicPr>
+          <p:nvPr/>
+        </p:nvPicPr>
+        <p:blipFill>
+          <a:blip r:embed="rId2"/>
+          <a:stretch>
+            <a:fillRect/>
+          </a:stretch>
+        </p:blipFill>
+        <p:spPr>
+          <a:xfrm>
+            <a:off x="1417319" y="1143000"/>
+            <a:ext cx="6309360" cy="2480026"/>
+          </a:xfrm>
+          <a:prstGeom prst="rect">
+            <a:avLst/>
+          </a:prstGeom>
+        </p:spPr>
+      </p:pic>
+      <p:sp>
+        <p:nvSpPr>
+          <p:cNvPr id="5" name="TextBox 4"/>
+          <p:cNvSpPr txBox="1"/>
+          <p:nvPr/>
+        </p:nvSpPr>
+        <p:spPr>
+          <a:xfrm>
+            <a:off x="704088" y="4434840"/>
+            <a:ext cx="7744968" cy="457200"/>
+          </a:xfrm>
+          <a:prstGeom prst="rect">
+            <a:avLst/>
+          </a:prstGeom>
+          <a:noFill/>
+        </p:spPr>
+        <p:txBody>
+          <a:bodyPr wrap="square">
+            <a:spAutoFit/>
+          </a:bodyPr>
+          <a:lstStyle/>
+          <a:p>
+            <a:r>
+              <a:rPr sz="1300" b="0">
+                <a:solidFill>
+                  <a:srgbClr val="333333"/>
+                </a:solidFill>
+                <a:latin typeface="Fira Sans"/>
+              </a:rPr>
+              <a:t>La versión numérica del boxplot por grupo: la tabla se parte por categoría, cada parte recibe el resumen y los resultados se juntan.</a:t>
             </a:r>
           </a:p>
         </p:txBody>
@@ -6367,35 +6414,102 @@
                 </a:solidFill>
                 <a:latin typeface="Fira Sans"/>
               </a:rPr>
-              <a:t>groupby: partir, aplicar, juntar</a:t>
-            </a:r>
-          </a:p>
-        </p:txBody>
-      </p:sp>
-      <p:pic>
-        <p:nvPicPr>
-          <p:cNvPr id="4" name="Picture 3" descr="c3_14_groupby.png"/>
-          <p:cNvPicPr>
-            <a:picLocks noChangeAspect="1"/>
-          </p:cNvPicPr>
-          <p:nvPr/>
-        </p:nvPicPr>
-        <p:blipFill>
-          <a:blip r:embed="rId2"/>
-          <a:stretch>
-            <a:fillRect/>
-          </a:stretch>
-        </p:blipFill>
-        <p:spPr>
-          <a:xfrm>
-            <a:off x="1417319" y="1143000"/>
-            <a:ext cx="6309360" cy="2480026"/>
-          </a:xfrm>
-          <a:prstGeom prst="rect">
-            <a:avLst/>
-          </a:prstGeom>
-        </p:spPr>
-      </p:pic>
+              <a:t>La media por grupo: groupby</a:t>
+            </a:r>
+          </a:p>
+        </p:txBody>
+      </p:sp>
+      <p:sp>
+        <p:nvSpPr>
+          <p:cNvPr id="4" name="Rectangle 3"/>
+          <p:cNvSpPr/>
+          <p:nvPr/>
+        </p:nvSpPr>
+        <p:spPr>
+          <a:xfrm>
+            <a:off x="704088" y="1280160"/>
+            <a:ext cx="7744968" cy="2377440"/>
+          </a:xfrm>
+          <a:prstGeom prst="rect">
+            <a:avLst/>
+          </a:prstGeom>
+          <a:solidFill>
+            <a:srgbClr val="F0F2F5"/>
+          </a:solidFill>
+          <a:ln>
+            <a:solidFill>
+              <a:srgbClr val="D8DDE3"/>
+            </a:solidFill>
+          </a:ln>
+          <a:effectLst/>
+        </p:spPr>
+        <p:style>
+          <a:lnRef idx="1">
+            <a:schemeClr val="accent1"/>
+          </a:lnRef>
+          <a:fillRef idx="3">
+            <a:schemeClr val="accent1"/>
+          </a:fillRef>
+          <a:effectRef idx="2">
+            <a:schemeClr val="accent1"/>
+          </a:effectRef>
+          <a:fontRef idx="minor">
+            <a:schemeClr val="lt1"/>
+          </a:fontRef>
+        </p:style>
+        <p:txBody>
+          <a:bodyPr rtlCol="0" anchor="ctr" wrap="square" lIns="228600" tIns="137160"/>
+          <a:lstStyle/>
+          <a:p>
+            <a:pPr/>
+            <a:r>
+              <a:rPr sz="1500" b="0">
+                <a:solidFill>
+                  <a:srgbClr val="1D3557"/>
+                </a:solidFill>
+                <a:latin typeface="Menlo"/>
+              </a:rPr>
+              <a:t>iris_df.groupby("species")["petal length (cm)"].mean()</a:t>
+            </a:r>
+          </a:p>
+          <a:p>
+            <a:pPr/>
+            <a:r>
+              <a:rPr sz="1500" b="0">
+                <a:solidFill>
+                  <a:srgbClr val="1D3557"/>
+                </a:solidFill>
+                <a:latin typeface="Menlo"/>
+              </a:rPr>
+              <a:t/>
+            </a:r>
+          </a:p>
+          <a:p>
+            <a:pPr/>
+            <a:r>
+              <a:rPr sz="1500" b="0">
+                <a:solidFill>
+                  <a:srgbClr val="1D3557"/>
+                </a:solidFill>
+                <a:latin typeface="Menlo"/>
+              </a:rPr>
+              <a:t># El mismo resumen que construimos a mano con loc y el for,</a:t>
+            </a:r>
+          </a:p>
+          <a:p>
+            <a:pPr/>
+            <a:r>
+              <a:rPr sz="1500" b="0">
+                <a:solidFill>
+                  <a:srgbClr val="1D3557"/>
+                </a:solidFill>
+                <a:latin typeface="Menlo"/>
+              </a:rPr>
+              <a:t># ahora en una línea</a:t>
+            </a:r>
+          </a:p>
+        </p:txBody>
+      </p:sp>
       <p:sp>
         <p:nvSpPr>
           <p:cNvPr id="5" name="TextBox 4"/>
@@ -6404,8 +6518,8 @@
         </p:nvSpPr>
         <p:spPr>
           <a:xfrm>
-            <a:off x="704088" y="4434840"/>
-            <a:ext cx="7744968" cy="457200"/>
+            <a:off x="704088" y="3886200"/>
+            <a:ext cx="7744968" cy="1097280"/>
           </a:xfrm>
           <a:prstGeom prst="rect">
             <a:avLst/>
@@ -6418,14 +6532,31 @@
           </a:bodyPr>
           <a:lstStyle/>
           <a:p>
-            <a:r>
-              <a:rPr sz="1300" b="0">
-                <a:solidFill>
-                  <a:srgbClr val="333333"/>
-                </a:solidFill>
-                <a:latin typeface="Fira Sans"/>
-              </a:rPr>
-              <a:t>La versión numérica del boxplot por grupo: la tabla se parte por categoría, cada parte recibe el resumen y los resultados se juntan.</a:t>
+            <a:pPr>
+              <a:lnSpc>
+                <a:spcPct val="112000"/>
+              </a:lnSpc>
+              <a:spcAft>
+                <a:spcPts val="900"/>
+              </a:spcAft>
+            </a:pPr>
+            <a:r>
+              <a:rPr sz="1600" b="1">
+                <a:solidFill>
+                  <a:srgbClr val="E0A437"/>
+                </a:solidFill>
+                <a:latin typeface="Fira Sans"/>
+              </a:rPr>
+              <a:t>▸ </a:t>
+            </a:r>
+            <a:r>
+              <a:rPr sz="1600" b="0">
+                <a:solidFill>
+                  <a:srgbClr val="000000"/>
+                </a:solidFill>
+                <a:latin typeface="Fira Sans"/>
+              </a:rPr>
+              <a:t>groupby parte la tabla por categoría, aplica el resumen a cada parte y junta los resultados: 1,46 / 4,26 / 5,55 cm. Es la versión numérica del boxplot por grupo.</a:t>
             </a:r>
           </a:p>
         </p:txBody>
@@ -6521,7 +6652,7 @@
                 </a:solidFill>
                 <a:latin typeface="Fira Sans"/>
               </a:rPr>
-              <a:t>La media por grupo: groupby</a:t>
+              <a:t>Dos categóricas: la tabla de contingencia</a:t>
             </a:r>
           </a:p>
         </p:txBody>
@@ -6535,7 +6666,7 @@
         <p:spPr>
           <a:xfrm>
             <a:off x="704088" y="1280160"/>
-            <a:ext cx="7744968" cy="2377440"/>
+            <a:ext cx="7744968" cy="2880360"/>
           </a:xfrm>
           <a:prstGeom prst="rect">
             <a:avLst/>
@@ -6576,7 +6707,7 @@
                 </a:solidFill>
                 <a:latin typeface="Menlo"/>
               </a:rPr>
-              <a:t>iris_df.groupby("species")["petal length (cm)"].mean()</a:t>
+              <a:t>pd.crosstab(datos["Sexo"], datos["ModoAgrupado"],</a:t>
             </a:r>
           </a:p>
           <a:p>
@@ -6588,7 +6719,7 @@
                 </a:solidFill>
                 <a:latin typeface="Menlo"/>
               </a:rPr>
-              <a:t/>
+              <a:t>            normalize="index")</a:t>
             </a:r>
           </a:p>
           <a:p>
@@ -6600,7 +6731,7 @@
                 </a:solidFill>
                 <a:latin typeface="Menlo"/>
               </a:rPr>
-              <a:t># El mismo resumen que construimos a mano con loc y el for,</a:t>
+              <a:t># Para la ciudad: sumar factores en vez de contar viajes</a:t>
             </a:r>
           </a:p>
           <a:p>
@@ -6612,7 +6743,19 @@
                 </a:solidFill>
                 <a:latin typeface="Menlo"/>
               </a:rPr>
-              <a:t># ahora en una línea</a:t>
+              <a:t>datos.pivot_table(values="Factor", index="Sexo",</a:t>
+            </a:r>
+          </a:p>
+          <a:p>
+            <a:pPr/>
+            <a:r>
+              <a:rPr sz="1500" b="0">
+                <a:solidFill>
+                  <a:srgbClr val="1D3557"/>
+                </a:solidFill>
+                <a:latin typeface="Menlo"/>
+              </a:rPr>
+              <a:t>                  columns="ModoAgrupado", aggfunc="sum")</a:t>
             </a:r>
           </a:p>
         </p:txBody>
@@ -6625,7 +6768,7 @@
         </p:nvSpPr>
         <p:spPr>
           <a:xfrm>
-            <a:off x="704088" y="3886200"/>
+            <a:off x="704088" y="4389120"/>
             <a:ext cx="7744968" cy="1097280"/>
           </a:xfrm>
           <a:prstGeom prst="rect">
@@ -6663,7 +6806,7 @@
                 </a:solidFill>
                 <a:latin typeface="Fira Sans"/>
               </a:rPr>
-              <a:t>groupby parte la tabla por categoría, aplica el resumen a cada parte y junta los resultados: 1,46 / 4,26 / 5,55 cm. Es la versión numérica del boxplot por grupo.</a:t>
+              <a:t>Ponderado por factor, en día laboral: las mujeres caminan más (40% contra 27%) y los hombres usan más el auto (28% contra 19%).</a:t>
             </a:r>
           </a:p>
         </p:txBody>
@@ -6701,7 +6844,7 @@
             <a:avLst/>
           </a:prstGeom>
           <a:solidFill>
-            <a:srgbClr val="FAFBFC"/>
+            <a:srgbClr val="1D3557"/>
           </a:solidFill>
           <a:ln>
             <a:noFill/>
@@ -6738,8 +6881,8 @@
         </p:nvSpPr>
         <p:spPr>
           <a:xfrm>
-            <a:off x="402336" y="301752"/>
-            <a:ext cx="8348472" cy="795528"/>
+            <a:off x="603504" y="1847088"/>
+            <a:ext cx="7946136" cy="1399032"/>
           </a:xfrm>
           <a:prstGeom prst="rect">
             <a:avLst/>
@@ -6753,167 +6896,24 @@
           <a:lstStyle/>
           <a:p>
             <a:r>
-              <a:rPr sz="2800" b="1">
-                <a:solidFill>
-                  <a:srgbClr val="0F0F0F"/>
-                </a:solidFill>
-                <a:latin typeface="Fira Sans"/>
-              </a:rPr>
-              <a:t>Dos categóricas: la tabla de contingencia</a:t>
-            </a:r>
-          </a:p>
-        </p:txBody>
-      </p:sp>
-      <p:sp>
-        <p:nvSpPr>
-          <p:cNvPr id="4" name="Rectangle 3"/>
-          <p:cNvSpPr/>
-          <p:nvPr/>
-        </p:nvSpPr>
-        <p:spPr>
-          <a:xfrm>
-            <a:off x="704088" y="1280160"/>
-            <a:ext cx="7744968" cy="2880360"/>
-          </a:xfrm>
-          <a:prstGeom prst="rect">
-            <a:avLst/>
-          </a:prstGeom>
-          <a:solidFill>
-            <a:srgbClr val="F0F2F5"/>
-          </a:solidFill>
-          <a:ln>
-            <a:solidFill>
-              <a:srgbClr val="D8DDE3"/>
-            </a:solidFill>
-          </a:ln>
-          <a:effectLst/>
-        </p:spPr>
-        <p:style>
-          <a:lnRef idx="1">
-            <a:schemeClr val="accent1"/>
-          </a:lnRef>
-          <a:fillRef idx="3">
-            <a:schemeClr val="accent1"/>
-          </a:fillRef>
-          <a:effectRef idx="2">
-            <a:schemeClr val="accent1"/>
-          </a:effectRef>
-          <a:fontRef idx="minor">
-            <a:schemeClr val="lt1"/>
-          </a:fontRef>
-        </p:style>
-        <p:txBody>
-          <a:bodyPr rtlCol="0" anchor="ctr" wrap="square" lIns="228600" tIns="137160"/>
-          <a:lstStyle/>
-          <a:p>
-            <a:pPr/>
-            <a:r>
-              <a:rPr sz="1500" b="0">
-                <a:solidFill>
-                  <a:srgbClr val="1D3557"/>
-                </a:solidFill>
-                <a:latin typeface="Menlo"/>
-              </a:rPr>
-              <a:t>pd.crosstab(datos["Sexo"], datos["ModoAgrupado"],</a:t>
-            </a:r>
-          </a:p>
-          <a:p>
-            <a:pPr/>
-            <a:r>
-              <a:rPr sz="1500" b="0">
-                <a:solidFill>
-                  <a:srgbClr val="1D3557"/>
-                </a:solidFill>
-                <a:latin typeface="Menlo"/>
-              </a:rPr>
-              <a:t>            normalize="index")</a:t>
-            </a:r>
-          </a:p>
-          <a:p>
-            <a:pPr/>
-            <a:r>
-              <a:rPr sz="1500" b="0">
-                <a:solidFill>
-                  <a:srgbClr val="1D3557"/>
-                </a:solidFill>
-                <a:latin typeface="Menlo"/>
-              </a:rPr>
-              <a:t># Para la ciudad: sumar factores en vez de contar viajes</a:t>
-            </a:r>
-          </a:p>
-          <a:p>
-            <a:pPr/>
-            <a:r>
-              <a:rPr sz="1500" b="0">
-                <a:solidFill>
-                  <a:srgbClr val="1D3557"/>
-                </a:solidFill>
-                <a:latin typeface="Menlo"/>
-              </a:rPr>
-              <a:t>datos.pivot_table(values="Factor", index="Sexo",</a:t>
-            </a:r>
-          </a:p>
-          <a:p>
-            <a:pPr/>
-            <a:r>
-              <a:rPr sz="1500" b="0">
-                <a:solidFill>
-                  <a:srgbClr val="1D3557"/>
-                </a:solidFill>
-                <a:latin typeface="Menlo"/>
-              </a:rPr>
-              <a:t>                  columns="ModoAgrupado", aggfunc="sum")</a:t>
-            </a:r>
-          </a:p>
-        </p:txBody>
-      </p:sp>
-      <p:sp>
-        <p:nvSpPr>
-          <p:cNvPr id="5" name="TextBox 4"/>
-          <p:cNvSpPr txBox="1"/>
-          <p:nvPr/>
-        </p:nvSpPr>
-        <p:spPr>
-          <a:xfrm>
-            <a:off x="704088" y="4389120"/>
-            <a:ext cx="7744968" cy="1097280"/>
-          </a:xfrm>
-          <a:prstGeom prst="rect">
-            <a:avLst/>
-          </a:prstGeom>
-          <a:noFill/>
-        </p:spPr>
-        <p:txBody>
-          <a:bodyPr wrap="square">
-            <a:spAutoFit/>
-          </a:bodyPr>
-          <a:lstStyle/>
-          <a:p>
-            <a:pPr>
-              <a:lnSpc>
-                <a:spcPct val="112000"/>
-              </a:lnSpc>
-              <a:spcAft>
-                <a:spcPts val="900"/>
-              </a:spcAft>
-            </a:pPr>
-            <a:r>
-              <a:rPr sz="1600" b="1">
+              <a:rPr sz="3400" b="1">
+                <a:solidFill>
+                  <a:srgbClr val="FFFFFF"/>
+                </a:solidFill>
+                <a:latin typeface="Fira Sans"/>
+              </a:rPr>
+              <a:t>La primera regresión</a:t>
+            </a:r>
+          </a:p>
+          <a:p>
+            <a:r>
+              <a:rPr sz="1800" b="0">
                 <a:solidFill>
                   <a:srgbClr val="E0A437"/>
                 </a:solidFill>
                 <a:latin typeface="Fira Sans"/>
               </a:rPr>
-              <a:t>▸ </a:t>
-            </a:r>
-            <a:r>
-              <a:rPr sz="1600" b="0">
-                <a:solidFill>
-                  <a:srgbClr val="000000"/>
-                </a:solidFill>
-                <a:latin typeface="Fira Sans"/>
-              </a:rPr>
-              <a:t>Ponderado por factor, en día laboral: las mujeres caminan más (40% contra 27%) y los hombres usan más el auto (28% contra 19%).</a:t>
+              <a:t>El primer modelo del diplomado</a:t>
             </a:r>
           </a:p>
         </p:txBody>
@@ -6951,7 +6951,7 @@
             <a:avLst/>
           </a:prstGeom>
           <a:solidFill>
-            <a:srgbClr val="1D3557"/>
+            <a:srgbClr val="FAFBFC"/>
           </a:solidFill>
           <a:ln>
             <a:noFill/>
@@ -6988,8 +6988,8 @@
         </p:nvSpPr>
         <p:spPr>
           <a:xfrm>
-            <a:off x="603504" y="1847088"/>
-            <a:ext cx="7946136" cy="1399032"/>
+            <a:off x="402336" y="301752"/>
+            <a:ext cx="8348472" cy="795528"/>
           </a:xfrm>
           <a:prstGeom prst="rect">
             <a:avLst/>
@@ -7003,24 +7003,71 @@
           <a:lstStyle/>
           <a:p>
             <a:r>
-              <a:rPr sz="3400" b="1">
-                <a:solidFill>
-                  <a:srgbClr val="FFFFFF"/>
-                </a:solidFill>
-                <a:latin typeface="Fira Sans"/>
-              </a:rPr>
-              <a:t>La primera regresión</a:t>
-            </a:r>
-          </a:p>
-          <a:p>
-            <a:r>
-              <a:rPr sz="1800" b="0">
-                <a:solidFill>
-                  <a:srgbClr val="E0A437"/>
-                </a:solidFill>
-                <a:latin typeface="Fira Sans"/>
-              </a:rPr>
-              <a:t>El primer modelo del diplomado</a:t>
+              <a:rPr sz="2800" b="1">
+                <a:solidFill>
+                  <a:srgbClr val="0F0F0F"/>
+                </a:solidFill>
+                <a:latin typeface="Fira Sans"/>
+              </a:rPr>
+              <a:t>Mínimos cuadrados</a:t>
+            </a:r>
+          </a:p>
+        </p:txBody>
+      </p:sp>
+      <p:pic>
+        <p:nvPicPr>
+          <p:cNvPr id="4" name="Picture 3" descr="c3_15_residuos.png"/>
+          <p:cNvPicPr>
+            <a:picLocks noChangeAspect="1"/>
+          </p:cNvPicPr>
+          <p:nvPr/>
+        </p:nvPicPr>
+        <p:blipFill>
+          <a:blip r:embed="rId2"/>
+          <a:stretch>
+            <a:fillRect/>
+          </a:stretch>
+        </p:blipFill>
+        <p:spPr>
+          <a:xfrm>
+            <a:off x="1417319" y="1143000"/>
+            <a:ext cx="6309360" cy="2544952"/>
+          </a:xfrm>
+          <a:prstGeom prst="rect">
+            <a:avLst/>
+          </a:prstGeom>
+        </p:spPr>
+      </p:pic>
+      <p:sp>
+        <p:nvSpPr>
+          <p:cNvPr id="5" name="TextBox 4"/>
+          <p:cNvSpPr txBox="1"/>
+          <p:nvPr/>
+        </p:nvSpPr>
+        <p:spPr>
+          <a:xfrm>
+            <a:off x="704088" y="4434840"/>
+            <a:ext cx="7744968" cy="457200"/>
+          </a:xfrm>
+          <a:prstGeom prst="rect">
+            <a:avLst/>
+          </a:prstGeom>
+          <a:noFill/>
+        </p:spPr>
+        <p:txBody>
+          <a:bodyPr wrap="square">
+            <a:spAutoFit/>
+          </a:bodyPr>
+          <a:lstStyle/>
+          <a:p>
+            <a:r>
+              <a:rPr sz="1300" b="0">
+                <a:solidFill>
+                  <a:srgbClr val="333333"/>
+                </a:solidFill>
+                <a:latin typeface="Fira Sans"/>
+              </a:rPr>
+              <a:t>La correlación mide la asociación; la regresión la dibuja: la recta que deja la menor suma de errores al cuadrado. La pendiente dice cuánto cambia y por cada unidad de x. Hoy es un primer contacto; en las clases 6 y 7 la profundizamos.</a:t>
             </a:r>
           </a:p>
         </p:txBody>
@@ -7347,14 +7394,14 @@
                 </a:solidFill>
                 <a:latin typeface="Fira Sans"/>
               </a:rPr>
-              <a:t>Mínimos cuadrados</a:t>
+              <a:t>Las fórmulas de la recta</a:t>
             </a:r>
           </a:p>
         </p:txBody>
       </p:sp>
       <p:pic>
         <p:nvPicPr>
-          <p:cNvPr id="4" name="Picture 3" descr="c3_15_residuos.png"/>
+          <p:cNvPr id="4" name="Picture 3" descr="c3_21_formulas_recta.png"/>
           <p:cNvPicPr>
             <a:picLocks noChangeAspect="1"/>
           </p:cNvPicPr>
@@ -7369,7 +7416,7 @@
         <p:spPr>
           <a:xfrm>
             <a:off x="1417319" y="1143000"/>
-            <a:ext cx="6309360" cy="2544952"/>
+            <a:ext cx="6309360" cy="2245514"/>
           </a:xfrm>
           <a:prstGeom prst="rect">
             <a:avLst/>
@@ -7405,7 +7452,7 @@
                 </a:solidFill>
                 <a:latin typeface="Fira Sans"/>
               </a:rPr>
-              <a:t>La correlación mide la asociación; la regresión la dibuja: la recta que deja la menor suma de errores al cuadrado. La pendiente dice cuánto cambia y por cada unidad de x. Hoy es un primer contacto; en las clases 6 y 7 la profundizamos.</a:t>
+              <a:t>El método se llama mínimos cuadrados ordinarios (OLS): np.polyfit implementa exactamente esta fórmula. En las clases 6 y 7 lo harán scikit-learn y statsmodels, con diagnósticos e inferencia.</a:t>
             </a:r>
           </a:p>
         </p:txBody>
@@ -7501,14 +7548,14 @@
                 </a:solidFill>
                 <a:latin typeface="Fira Sans"/>
               </a:rPr>
-              <a:t>Las fórmulas de la recta</a:t>
+              <a:t>Pendiente e intercepto, dibujados</a:t>
             </a:r>
           </a:p>
         </p:txBody>
       </p:sp>
       <p:pic>
         <p:nvPicPr>
-          <p:cNvPr id="4" name="Picture 3" descr="c3_21_formulas_recta.png"/>
+          <p:cNvPr id="4" name="Picture 3" descr="c3_23_pendiente_intercepto.png"/>
           <p:cNvPicPr>
             <a:picLocks noChangeAspect="1"/>
           </p:cNvPicPr>
@@ -7522,8 +7569,8 @@
         </p:blipFill>
         <p:spPr>
           <a:xfrm>
-            <a:off x="1417319" y="1143000"/>
-            <a:ext cx="6309360" cy="2245514"/>
+            <a:off x="1715735" y="1143000"/>
+            <a:ext cx="5712528" cy="3154680"/>
           </a:xfrm>
           <a:prstGeom prst="rect">
             <a:avLst/>
@@ -7559,7 +7606,7 @@
                 </a:solidFill>
                 <a:latin typeface="Fira Sans"/>
               </a:rPr>
-              <a:t>El método se llama mínimos cuadrados ordinarios (OLS): np.polyfit implementa exactamente esta fórmula. En las clases 6 y 7 lo harán scikit-learn y statsmodels, con diagnósticos e inferencia.</a:t>
+              <a:t>El intercepto es donde la recta corta el eje: el valor de y cuando x es 0. La pendiente es cuánto sube y por cada unidad de x. En nuestra recta: 38,3 minutos de base y −4,8 por cada millón de ingreso.</a:t>
             </a:r>
           </a:p>
         </p:txBody>
@@ -7655,14 +7702,14 @@
                 </a:solidFill>
                 <a:latin typeface="Fira Sans"/>
               </a:rPr>
-              <a:t>Pendiente e intercepto, dibujados</a:t>
+              <a:t>La recta: ingreso y duración</a:t>
             </a:r>
           </a:p>
         </p:txBody>
       </p:sp>
       <p:pic>
         <p:nvPicPr>
-          <p:cNvPr id="4" name="Picture 3" descr="c3_23_pendiente_intercepto.png"/>
+          <p:cNvPr id="4" name="Picture 3" descr="c3_18_ingreso_duracion_recta.png"/>
           <p:cNvPicPr>
             <a:picLocks noChangeAspect="1"/>
           </p:cNvPicPr>
@@ -7676,8 +7723,8 @@
         </p:blipFill>
         <p:spPr>
           <a:xfrm>
-            <a:off x="1715735" y="1143000"/>
-            <a:ext cx="5712528" cy="3154680"/>
+            <a:off x="2107331" y="1143000"/>
+            <a:ext cx="4929336" cy="3154679"/>
           </a:xfrm>
           <a:prstGeom prst="rect">
             <a:avLst/>
@@ -7713,7 +7760,7 @@
                 </a:solidFill>
                 <a:latin typeface="Fira Sans"/>
               </a:rPr>
-              <a:t>El intercepto es donde la recta corta el eje: el valor de y cuando x es 0. La pendiente es cuánto sube y por cada unidad de x. En nuestra recta: 38,3 minutos de base y −4,8 por cada millón de ingreso.</a:t>
+              <a:t>duración = 38,3 − 4,8 · ingreso (ponderada por factor): por cada millón adicional, la duración media baja casi 5 minutos. Y r² = 0,12: la recta captura el 12% de la variación; la asociación es real pero moderada, y así se reporta.</a:t>
             </a:r>
           </a:p>
         </p:txBody>
@@ -7809,35 +7856,114 @@
                 </a:solidFill>
                 <a:latin typeface="Fira Sans"/>
               </a:rPr>
-              <a:t>La recta: ingreso y duración</a:t>
-            </a:r>
-          </a:p>
-        </p:txBody>
-      </p:sp>
-      <p:pic>
-        <p:nvPicPr>
-          <p:cNvPr id="4" name="Picture 3" descr="c3_18_ingreso_duracion_recta.png"/>
-          <p:cNvPicPr>
-            <a:picLocks noChangeAspect="1"/>
-          </p:cNvPicPr>
-          <p:nvPr/>
-        </p:nvPicPr>
-        <p:blipFill>
-          <a:blip r:embed="rId2"/>
-          <a:stretch>
-            <a:fillRect/>
-          </a:stretch>
-        </p:blipFill>
-        <p:spPr>
-          <a:xfrm>
-            <a:off x="2107331" y="1143000"/>
-            <a:ext cx="4929336" cy="3154679"/>
-          </a:xfrm>
-          <a:prstGeom prst="rect">
-            <a:avLst/>
-          </a:prstGeom>
-        </p:spPr>
-      </p:pic>
+              <a:t>La recta en NumPy</a:t>
+            </a:r>
+          </a:p>
+        </p:txBody>
+      </p:sp>
+      <p:sp>
+        <p:nvSpPr>
+          <p:cNvPr id="4" name="Rectangle 3"/>
+          <p:cNvSpPr/>
+          <p:nvPr/>
+        </p:nvSpPr>
+        <p:spPr>
+          <a:xfrm>
+            <a:off x="704088" y="1280160"/>
+            <a:ext cx="7744968" cy="2880360"/>
+          </a:xfrm>
+          <a:prstGeom prst="rect">
+            <a:avLst/>
+          </a:prstGeom>
+          <a:solidFill>
+            <a:srgbClr val="F0F2F5"/>
+          </a:solidFill>
+          <a:ln>
+            <a:solidFill>
+              <a:srgbClr val="D8DDE3"/>
+            </a:solidFill>
+          </a:ln>
+          <a:effectLst/>
+        </p:spPr>
+        <p:style>
+          <a:lnRef idx="1">
+            <a:schemeClr val="accent1"/>
+          </a:lnRef>
+          <a:fillRef idx="3">
+            <a:schemeClr val="accent1"/>
+          </a:fillRef>
+          <a:effectRef idx="2">
+            <a:schemeClr val="accent1"/>
+          </a:effectRef>
+          <a:fontRef idx="minor">
+            <a:schemeClr val="lt1"/>
+          </a:fontRef>
+        </p:style>
+        <p:txBody>
+          <a:bodyPr rtlCol="0" anchor="ctr" wrap="square" lIns="228600" tIns="137160"/>
+          <a:lstStyle/>
+          <a:p>
+            <a:pPr/>
+            <a:r>
+              <a:rPr sz="1500" b="0">
+                <a:solidFill>
+                  <a:srgbClr val="1D3557"/>
+                </a:solidFill>
+                <a:latin typeface="Menlo"/>
+              </a:rPr>
+              <a:t>pendiente, intercepto = np.polyfit(por_comuna["ingreso"],</a:t>
+            </a:r>
+          </a:p>
+          <a:p>
+            <a:pPr/>
+            <a:r>
+              <a:rPr sz="1500" b="0">
+                <a:solidFill>
+                  <a:srgbClr val="1D3557"/>
+                </a:solidFill>
+                <a:latin typeface="Menlo"/>
+              </a:rPr>
+              <a:t>                                   por_comuna["duracion"], 1)</a:t>
+            </a:r>
+          </a:p>
+          <a:p>
+            <a:pPr/>
+            <a:r>
+              <a:rPr sz="1500" b="0">
+                <a:solidFill>
+                  <a:srgbClr val="1D3557"/>
+                </a:solidFill>
+                <a:latin typeface="Menlo"/>
+              </a:rPr>
+              <a:t/>
+            </a:r>
+          </a:p>
+          <a:p>
+            <a:pPr/>
+            <a:r>
+              <a:rPr sz="1500" b="0">
+                <a:solidFill>
+                  <a:srgbClr val="1D3557"/>
+                </a:solidFill>
+                <a:latin typeface="Menlo"/>
+              </a:rPr>
+              <a:t># La recta evaluada, para dibujarla sobre el scatter</a:t>
+            </a:r>
+          </a:p>
+          <a:p>
+            <a:pPr/>
+            <a:r>
+              <a:rPr sz="1500" b="0">
+                <a:solidFill>
+                  <a:srgbClr val="1D3557"/>
+                </a:solidFill>
+                <a:latin typeface="Menlo"/>
+              </a:rPr>
+              <a:t>ax.plot(x, intercepto + pendiente * x)</a:t>
+            </a:r>
+          </a:p>
+        </p:txBody>
+      </p:sp>
       <p:sp>
         <p:nvSpPr>
           <p:cNvPr id="5" name="TextBox 4"/>
@@ -7846,8 +7972,8 @@
         </p:nvSpPr>
         <p:spPr>
           <a:xfrm>
-            <a:off x="704088" y="4434840"/>
-            <a:ext cx="7744968" cy="457200"/>
+            <a:off x="704088" y="4389120"/>
+            <a:ext cx="7744968" cy="1097280"/>
           </a:xfrm>
           <a:prstGeom prst="rect">
             <a:avLst/>
@@ -7860,14 +7986,31 @@
           </a:bodyPr>
           <a:lstStyle/>
           <a:p>
-            <a:r>
-              <a:rPr sz="1300" b="0">
-                <a:solidFill>
-                  <a:srgbClr val="333333"/>
-                </a:solidFill>
-                <a:latin typeface="Fira Sans"/>
-              </a:rPr>
-              <a:t>duración = 38,3 − 4,8 · ingreso (ponderada por factor): por cada millón adicional, la duración media baja casi 5 minutos. Y r² = 0,12: la recta captura el 12% de la variación; la asociación es real pero moderada, y así se reporta.</a:t>
+            <a:pPr>
+              <a:lnSpc>
+                <a:spcPct val="112000"/>
+              </a:lnSpc>
+              <a:spcAft>
+                <a:spcPts val="900"/>
+              </a:spcAft>
+            </a:pPr>
+            <a:r>
+              <a:rPr sz="1600" b="1">
+                <a:solidFill>
+                  <a:srgbClr val="E0A437"/>
+                </a:solidFill>
+                <a:latin typeface="Fira Sans"/>
+              </a:rPr>
+              <a:t>▸ </a:t>
+            </a:r>
+            <a:r>
+              <a:rPr sz="1600" b="0">
+                <a:solidFill>
+                  <a:srgbClr val="000000"/>
+                </a:solidFill>
+                <a:latin typeface="Fira Sans"/>
+              </a:rPr>
+              <a:t>polyfit ajusta un polinomio por mínimos cuadrados; el 1 pide grado 1, una recta. En las clases 6 y 7 usaremos herramientas con más diagnósticos.</a:t>
             </a:r>
           </a:p>
         </p:txBody>
@@ -7963,7 +8106,7 @@
                 </a:solidFill>
                 <a:latin typeface="Fira Sans"/>
               </a:rPr>
-              <a:t>La recta en NumPy</a:t>
+              <a:t>Usar la recta: predecir y medir residuos</a:t>
             </a:r>
           </a:p>
         </p:txBody>
@@ -8018,7 +8161,7 @@
                 </a:solidFill>
                 <a:latin typeface="Menlo"/>
               </a:rPr>
-              <a:t>pendiente, intercepto = np.polyfit(por_comuna["ingreso"],</a:t>
+              <a:t>prediccion = intercepto + pendiente * ingreso</a:t>
             </a:r>
           </a:p>
           <a:p>
@@ -8030,7 +8173,7 @@
                 </a:solidFill>
                 <a:latin typeface="Menlo"/>
               </a:rPr>
-              <a:t>                                   por_comuna["duracion"], 1)</a:t>
+              <a:t>residuo = duracion - prediccion</a:t>
             </a:r>
           </a:p>
           <a:p>
@@ -8054,7 +8197,7 @@
                 </a:solidFill>
                 <a:latin typeface="Menlo"/>
               </a:rPr>
-              <a:t># La recta evaluada, para dibujarla sobre el scatter</a:t>
+              <a:t># ¿Qué comunas viajan más de lo que su ingreso predice?</a:t>
             </a:r>
           </a:p>
           <a:p>
@@ -8066,7 +8209,7 @@
                 </a:solidFill>
                 <a:latin typeface="Menlo"/>
               </a:rPr>
-              <a:t>ax.plot(x, intercepto + pendiente * x)</a:t>
+              <a:t>por_comuna.nlargest(5, "residuo")</a:t>
             </a:r>
           </a:p>
         </p:txBody>
@@ -8117,7 +8260,7 @@
                 </a:solidFill>
                 <a:latin typeface="Fira Sans"/>
               </a:rPr>
-              <a:t>polyfit ajusta un polinomio por mínimos cuadrados; el 1 pide grado 1, una recta. En las clases 6 y 7 usaremos herramientas con más diagnósticos.</a:t>
+              <a:t>La Pintana viaja 13 minutos más de lo predicho y Santiago 7 menos: el residuo revela periferia y centralidad. ¿Azar? La clase 5 responde.</a:t>
             </a:r>
           </a:p>
         </p:txBody>
@@ -8213,7 +8356,7 @@
                 </a:solidFill>
                 <a:latin typeface="Fira Sans"/>
               </a:rPr>
-              <a:t>Usar la recta: predecir y medir residuos</a:t>
+              <a:t>El impacto de sacar una fila</a:t>
             </a:r>
           </a:p>
         </p:txBody>
@@ -8268,7 +8411,7 @@
                 </a:solidFill>
                 <a:latin typeface="Menlo"/>
               </a:rPr>
-              <a:t>prediccion = intercepto + pendiente * ingreso</a:t>
+              <a:t>sin_lb = por_comuna[por_comuna["Comuna"] != "LO BARNECHEA"]</a:t>
             </a:r>
           </a:p>
           <a:p>
@@ -8280,7 +8423,7 @@
                 </a:solidFill>
                 <a:latin typeface="Menlo"/>
               </a:rPr>
-              <a:t>residuo = duracion - prediccion</a:t>
+              <a:t/>
             </a:r>
           </a:p>
           <a:p>
@@ -8292,7 +8435,7 @@
                 </a:solidFill>
                 <a:latin typeface="Menlo"/>
               </a:rPr>
-              <a:t/>
+              <a:t># Todo se recalcula sin la fila, y se compara</a:t>
             </a:r>
           </a:p>
           <a:p>
@@ -8304,7 +8447,7 @@
                 </a:solidFill>
                 <a:latin typeface="Menlo"/>
               </a:rPr>
-              <a:t># ¿Qué comunas viajan más de lo que su ingreso predice?</a:t>
+              <a:t>sin_lb["ingreso"].corr(sin_lb["duracion"])</a:t>
             </a:r>
           </a:p>
           <a:p>
@@ -8316,7 +8459,7 @@
                 </a:solidFill>
                 <a:latin typeface="Menlo"/>
               </a:rPr>
-              <a:t>por_comuna.nlargest(5, "residuo")</a:t>
+              <a:t>np.polyfit(sin_lb["ingreso"] / 1e6, sin_lb["duracion"], 1)</a:t>
             </a:r>
           </a:p>
         </p:txBody>
@@ -8367,7 +8510,7 @@
                 </a:solidFill>
                 <a:latin typeface="Fira Sans"/>
               </a:rPr>
-              <a:t>La Pintana viaja 13 minutos más de lo predicho y Santiago 7 menos: el residuo revela periferia y centralidad. ¿Azar? La clase 5 responde.</a:t>
+              <a:t>Sacar 1 comuna de 45 no mueve r (−0,34) pero cambia la pendiente en un quinto (−4,8 a −5,8): el impacto se mide con y sin, sobre todos los resúmenes en uso.</a:t>
             </a:r>
           </a:p>
         </p:txBody>
@@ -8463,114 +8606,35 @@
                 </a:solidFill>
                 <a:latin typeface="Fira Sans"/>
               </a:rPr>
-              <a:t>El impacto de sacar una fila</a:t>
-            </a:r>
-          </a:p>
-        </p:txBody>
-      </p:sp>
-      <p:sp>
-        <p:nvSpPr>
-          <p:cNvPr id="4" name="Rectangle 3"/>
-          <p:cNvSpPr/>
-          <p:nvPr/>
-        </p:nvSpPr>
-        <p:spPr>
-          <a:xfrm>
-            <a:off x="704088" y="1280160"/>
-            <a:ext cx="7744968" cy="2880360"/>
-          </a:xfrm>
-          <a:prstGeom prst="rect">
-            <a:avLst/>
-          </a:prstGeom>
-          <a:solidFill>
-            <a:srgbClr val="F0F2F5"/>
-          </a:solidFill>
-          <a:ln>
-            <a:solidFill>
-              <a:srgbClr val="D8DDE3"/>
-            </a:solidFill>
-          </a:ln>
-          <a:effectLst/>
-        </p:spPr>
-        <p:style>
-          <a:lnRef idx="1">
-            <a:schemeClr val="accent1"/>
-          </a:lnRef>
-          <a:fillRef idx="3">
-            <a:schemeClr val="accent1"/>
-          </a:fillRef>
-          <a:effectRef idx="2">
-            <a:schemeClr val="accent1"/>
-          </a:effectRef>
-          <a:fontRef idx="minor">
-            <a:schemeClr val="lt1"/>
-          </a:fontRef>
-        </p:style>
-        <p:txBody>
-          <a:bodyPr rtlCol="0" anchor="ctr" wrap="square" lIns="228600" tIns="137160"/>
-          <a:lstStyle/>
-          <a:p>
-            <a:pPr/>
-            <a:r>
-              <a:rPr sz="1500" b="0">
-                <a:solidFill>
-                  <a:srgbClr val="1D3557"/>
-                </a:solidFill>
-                <a:latin typeface="Menlo"/>
-              </a:rPr>
-              <a:t>sin_lb = por_comuna[por_comuna["Comuna"] != "LO BARNECHEA"]</a:t>
-            </a:r>
-          </a:p>
-          <a:p>
-            <a:pPr/>
-            <a:r>
-              <a:rPr sz="1500" b="0">
-                <a:solidFill>
-                  <a:srgbClr val="1D3557"/>
-                </a:solidFill>
-                <a:latin typeface="Menlo"/>
-              </a:rPr>
-              <a:t/>
-            </a:r>
-          </a:p>
-          <a:p>
-            <a:pPr/>
-            <a:r>
-              <a:rPr sz="1500" b="0">
-                <a:solidFill>
-                  <a:srgbClr val="1D3557"/>
-                </a:solidFill>
-                <a:latin typeface="Menlo"/>
-              </a:rPr>
-              <a:t># Todo se recalcula sin la fila, y se compara</a:t>
-            </a:r>
-          </a:p>
-          <a:p>
-            <a:pPr/>
-            <a:r>
-              <a:rPr sz="1500" b="0">
-                <a:solidFill>
-                  <a:srgbClr val="1D3557"/>
-                </a:solidFill>
-                <a:latin typeface="Menlo"/>
-              </a:rPr>
-              <a:t>sin_lb["ingreso"].corr(sin_lb["duracion"])</a:t>
-            </a:r>
-          </a:p>
-          <a:p>
-            <a:pPr/>
-            <a:r>
-              <a:rPr sz="1500" b="0">
-                <a:solidFill>
-                  <a:srgbClr val="1D3557"/>
-                </a:solidFill>
-                <a:latin typeface="Menlo"/>
-              </a:rPr>
-              <a:t>np.polyfit(sin_lb["ingreso"] / 1e6, sin_lb["duracion"], 1)</a:t>
-            </a:r>
-          </a:p>
-        </p:txBody>
-      </p:sp>
+              <a:t>Las fórmulas, con factor de expansión</a:t>
+            </a:r>
+          </a:p>
+        </p:txBody>
+      </p:sp>
+      <p:pic>
+        <p:nvPicPr>
+          <p:cNvPr id="4" name="Picture 3" descr="c3_22_formulas_ponderada.png"/>
+          <p:cNvPicPr>
+            <a:picLocks noChangeAspect="1"/>
+          </p:cNvPicPr>
+          <p:nvPr/>
+        </p:nvPicPr>
+        <p:blipFill>
+          <a:blip r:embed="rId2"/>
+          <a:stretch>
+            <a:fillRect/>
+          </a:stretch>
+        </p:blipFill>
+        <p:spPr>
+          <a:xfrm>
+            <a:off x="1417319" y="1143000"/>
+            <a:ext cx="6309360" cy="2245514"/>
+          </a:xfrm>
+          <a:prstGeom prst="rect">
+            <a:avLst/>
+          </a:prstGeom>
+        </p:spPr>
+      </p:pic>
       <p:sp>
         <p:nvSpPr>
           <p:cNvPr id="5" name="TextBox 4"/>
@@ -8579,8 +8643,8 @@
         </p:nvSpPr>
         <p:spPr>
           <a:xfrm>
-            <a:off x="704088" y="4389120"/>
-            <a:ext cx="7744968" cy="1097280"/>
+            <a:off x="704088" y="4434840"/>
+            <a:ext cx="7744968" cy="457200"/>
           </a:xfrm>
           <a:prstGeom prst="rect">
             <a:avLst/>
@@ -8593,31 +8657,14 @@
           </a:bodyPr>
           <a:lstStyle/>
           <a:p>
-            <a:pPr>
-              <a:lnSpc>
-                <a:spcPct val="112000"/>
-              </a:lnSpc>
-              <a:spcAft>
-                <a:spcPts val="900"/>
-              </a:spcAft>
-            </a:pPr>
-            <a:r>
-              <a:rPr sz="1600" b="1">
-                <a:solidFill>
-                  <a:srgbClr val="E0A437"/>
-                </a:solidFill>
-                <a:latin typeface="Fira Sans"/>
-              </a:rPr>
-              <a:t>▸ </a:t>
-            </a:r>
-            <a:r>
-              <a:rPr sz="1600" b="0">
-                <a:solidFill>
-                  <a:srgbClr val="000000"/>
-                </a:solidFill>
-                <a:latin typeface="Fira Sans"/>
-              </a:rPr>
-              <a:t>Sacar 1 comuna de 45 no mueve r (−0,34) pero cambia la pendiente en un quinto (−4,8 a −5,8): el impacto se mide con y sin, sobre todos los resúmenes en uso.</a:t>
+            <a:r>
+              <a:rPr sz="1300" b="0">
+                <a:solidFill>
+                  <a:srgbClr val="333333"/>
+                </a:solidFill>
+                <a:latin typeface="Fira Sans"/>
+              </a:rPr>
+              <a:t>La misma recta de mínimos cuadrados, con cada término pesado por su factor: es la que usa el modelo que sigue, y en statsmodels se llama WLS (weighted least squares).</a:t>
             </a:r>
           </a:p>
         </p:txBody>
@@ -8713,35 +8760,114 @@
                 </a:solidFill>
                 <a:latin typeface="Fira Sans"/>
               </a:rPr>
-              <a:t>Las fórmulas, con factor de expansión</a:t>
-            </a:r>
-          </a:p>
-        </p:txBody>
-      </p:sp>
-      <p:pic>
-        <p:nvPicPr>
-          <p:cNvPr id="4" name="Picture 3" descr="c3_22_formulas_ponderada.png"/>
-          <p:cNvPicPr>
-            <a:picLocks noChangeAspect="1"/>
-          </p:cNvPicPr>
-          <p:nvPr/>
-        </p:nvPicPr>
-        <p:blipFill>
-          <a:blip r:embed="rId2"/>
-          <a:stretch>
-            <a:fillRect/>
-          </a:stretch>
-        </p:blipFill>
-        <p:spPr>
-          <a:xfrm>
-            <a:off x="1417319" y="1143000"/>
-            <a:ext cx="6309360" cy="2245514"/>
-          </a:xfrm>
-          <a:prstGeom prst="rect">
-            <a:avLst/>
-          </a:prstGeom>
-        </p:spPr>
-      </p:pic>
+              <a:t>Otro modelo: la motorización del hogar</a:t>
+            </a:r>
+          </a:p>
+        </p:txBody>
+      </p:sp>
+      <p:sp>
+        <p:nvSpPr>
+          <p:cNvPr id="4" name="Rectangle 3"/>
+          <p:cNvSpPr/>
+          <p:nvPr/>
+        </p:nvSpPr>
+        <p:spPr>
+          <a:xfrm>
+            <a:off x="704088" y="1280160"/>
+            <a:ext cx="7744968" cy="2880360"/>
+          </a:xfrm>
+          <a:prstGeom prst="rect">
+            <a:avLst/>
+          </a:prstGeom>
+          <a:solidFill>
+            <a:srgbClr val="F0F2F5"/>
+          </a:solidFill>
+          <a:ln>
+            <a:solidFill>
+              <a:srgbClr val="D8DDE3"/>
+            </a:solidFill>
+          </a:ln>
+          <a:effectLst/>
+        </p:spPr>
+        <p:style>
+          <a:lnRef idx="1">
+            <a:schemeClr val="accent1"/>
+          </a:lnRef>
+          <a:fillRef idx="3">
+            <a:schemeClr val="accent1"/>
+          </a:fillRef>
+          <a:effectRef idx="2">
+            <a:schemeClr val="accent1"/>
+          </a:effectRef>
+          <a:fontRef idx="minor">
+            <a:schemeClr val="lt1"/>
+          </a:fontRef>
+        </p:style>
+        <p:txBody>
+          <a:bodyPr rtlCol="0" anchor="ctr" wrap="square" lIns="228600" tIns="137160"/>
+          <a:lstStyle/>
+          <a:p>
+            <a:pPr/>
+            <a:r>
+              <a:rPr sz="1500" b="0">
+                <a:solidFill>
+                  <a:srgbClr val="1D3557"/>
+                </a:solidFill>
+                <a:latin typeface="Menlo"/>
+              </a:rPr>
+              <a:t>x = h["IngresoHogar"] / 1e6</a:t>
+            </a:r>
+          </a:p>
+          <a:p>
+            <a:pPr/>
+            <a:r>
+              <a:rPr sz="1500" b="0">
+                <a:solidFill>
+                  <a:srgbClr val="1D3557"/>
+                </a:solidFill>
+                <a:latin typeface="Menlo"/>
+              </a:rPr>
+              <a:t>y, w = h["NumVeh"], h["Factor"]</a:t>
+            </a:r>
+          </a:p>
+          <a:p>
+            <a:pPr/>
+            <a:r>
+              <a:rPr sz="1500" b="0">
+                <a:solidFill>
+                  <a:srgbClr val="1D3557"/>
+                </a:solidFill>
+                <a:latin typeface="Menlo"/>
+              </a:rPr>
+              <a:t/>
+            </a:r>
+          </a:p>
+          <a:p>
+            <a:pPr/>
+            <a:r>
+              <a:rPr sz="1500" b="0">
+                <a:solidFill>
+                  <a:srgbClr val="1D3557"/>
+                </a:solidFill>
+                <a:latin typeface="Menlo"/>
+              </a:rPr>
+              <a:t># La fórmula de la pendiente ponderada, tal cual</a:t>
+            </a:r>
+          </a:p>
+          <a:p>
+            <a:pPr/>
+            <a:r>
+              <a:rPr sz="1500" b="0">
+                <a:solidFill>
+                  <a:srgbClr val="1D3557"/>
+                </a:solidFill>
+                <a:latin typeface="Menlo"/>
+              </a:rPr>
+              <a:t>b = (w*(x - xw)*(y - yw)).sum() / (w*(x - xw)**2).sum()</a:t>
+            </a:r>
+          </a:p>
+        </p:txBody>
+      </p:sp>
       <p:sp>
         <p:nvSpPr>
           <p:cNvPr id="5" name="TextBox 4"/>
@@ -8750,8 +8876,8 @@
         </p:nvSpPr>
         <p:spPr>
           <a:xfrm>
-            <a:off x="704088" y="4434840"/>
-            <a:ext cx="7744968" cy="457200"/>
+            <a:off x="704088" y="4389120"/>
+            <a:ext cx="7744968" cy="1097280"/>
           </a:xfrm>
           <a:prstGeom prst="rect">
             <a:avLst/>
@@ -8764,14 +8890,31 @@
           </a:bodyPr>
           <a:lstStyle/>
           <a:p>
-            <a:r>
-              <a:rPr sz="1300" b="0">
-                <a:solidFill>
-                  <a:srgbClr val="333333"/>
-                </a:solidFill>
-                <a:latin typeface="Fira Sans"/>
-              </a:rPr>
-              <a:t>La misma recta de mínimos cuadrados, con cada término pesado por su factor: es la que usa el modelo que sigue, y en statsmodels se llama WLS (weighted least squares).</a:t>
+            <a:pPr>
+              <a:lnSpc>
+                <a:spcPct val="112000"/>
+              </a:lnSpc>
+              <a:spcAft>
+                <a:spcPts val="900"/>
+              </a:spcAft>
+            </a:pPr>
+            <a:r>
+              <a:rPr sz="1600" b="1">
+                <a:solidFill>
+                  <a:srgbClr val="E0A437"/>
+                </a:solidFill>
+                <a:latin typeface="Fira Sans"/>
+              </a:rPr>
+              <a:t>▸ </a:t>
+            </a:r>
+            <a:r>
+              <a:rPr sz="1600" b="0">
+                <a:solidFill>
+                  <a:srgbClr val="000000"/>
+                </a:solidFill>
+                <a:latin typeface="Fira Sans"/>
+              </a:rPr>
+              <a:t>18.264 hogares reales, ponderados por su factor: vehículos = 0,20 + 0,50 · ingreso. Medio vehículo más por cada millón.</a:t>
             </a:r>
           </a:p>
         </p:txBody>
@@ -8867,7 +9010,7 @@
                 </a:solidFill>
                 <a:latin typeface="Fira Sans"/>
               </a:rPr>
-              <a:t>Otro modelo: la motorización del hogar</a:t>
+              <a:t>Sacar atípicos de la variable a predecir</a:t>
             </a:r>
           </a:p>
         </p:txBody>
@@ -8922,7 +9065,7 @@
                 </a:solidFill>
                 <a:latin typeface="Menlo"/>
               </a:rPr>
-              <a:t>x = h["IngresoHogar"] / 1e6</a:t>
+              <a:t>q1, q3 = h["NumVeh"].quantile([0.25, 0.75])</a:t>
             </a:r>
           </a:p>
           <a:p>
@@ -8934,7 +9077,7 @@
                 </a:solidFill>
                 <a:latin typeface="Menlo"/>
               </a:rPr>
-              <a:t>y, w = h["NumVeh"], h["Factor"]</a:t>
+              <a:t>sin_atipicos = h[h["NumVeh"] &lt;= q3 + 1.5 * (q3 - q1)]</a:t>
             </a:r>
           </a:p>
           <a:p>
@@ -8958,7 +9101,7 @@
                 </a:solidFill>
                 <a:latin typeface="Menlo"/>
               </a:rPr>
-              <a:t># La fórmula de la pendiente ponderada, tal cual</a:t>
+              <a:t># El mismo modelo, sin los hogares de 3 autos o más</a:t>
             </a:r>
           </a:p>
           <a:p>
@@ -8970,7 +9113,7 @@
                 </a:solidFill>
                 <a:latin typeface="Menlo"/>
               </a:rPr>
-              <a:t>b = (w*(x - xw)*(y - yw)).sum() / (w*(x - xw)**2).sum()</a:t>
+              <a:t>np.polyfit(sin_atipicos["IngresoHogar"] / 1e6, sin_atipicos["NumVeh"], 1)</a:t>
             </a:r>
           </a:p>
         </p:txBody>
@@ -9021,7 +9164,7 @@
                 </a:solidFill>
                 <a:latin typeface="Fira Sans"/>
               </a:rPr>
-              <a:t>18.264 hogares reales, ponderados por su factor: vehículos = 0,20 + 0,50 · ingreso. Medio vehículo más por cada millón.</a:t>
+              <a:t>Sacar 236 hogares aplana la pendiente ponderada (0,50 a 0,44): no eran errores, eran la señal. Los atípicos de y se investigan; se eliminan solo por dominio.</a:t>
             </a:r>
           </a:p>
         </p:txBody>
@@ -9059,7 +9202,7 @@
             <a:avLst/>
           </a:prstGeom>
           <a:solidFill>
-            <a:srgbClr val="FAFBFC"/>
+            <a:srgbClr val="1D3557"/>
           </a:solidFill>
           <a:ln>
             <a:noFill/>
@@ -9096,8 +9239,8 @@
         </p:nvSpPr>
         <p:spPr>
           <a:xfrm>
-            <a:off x="402336" y="301752"/>
-            <a:ext cx="8348472" cy="795528"/>
+            <a:off x="603504" y="1847088"/>
+            <a:ext cx="7946136" cy="1399032"/>
           </a:xfrm>
           <a:prstGeom prst="rect">
             <a:avLst/>
@@ -9111,167 +9254,24 @@
           <a:lstStyle/>
           <a:p>
             <a:r>
-              <a:rPr sz="2800" b="1">
-                <a:solidFill>
-                  <a:srgbClr val="0F0F0F"/>
-                </a:solidFill>
-                <a:latin typeface="Fira Sans"/>
-              </a:rPr>
-              <a:t>Sacar atípicos de la variable a predecir</a:t>
-            </a:r>
-          </a:p>
-        </p:txBody>
-      </p:sp>
-      <p:sp>
-        <p:nvSpPr>
-          <p:cNvPr id="4" name="Rectangle 3"/>
-          <p:cNvSpPr/>
-          <p:nvPr/>
-        </p:nvSpPr>
-        <p:spPr>
-          <a:xfrm>
-            <a:off x="704088" y="1280160"/>
-            <a:ext cx="7744968" cy="2880360"/>
-          </a:xfrm>
-          <a:prstGeom prst="rect">
-            <a:avLst/>
-          </a:prstGeom>
-          <a:solidFill>
-            <a:srgbClr val="F0F2F5"/>
-          </a:solidFill>
-          <a:ln>
-            <a:solidFill>
-              <a:srgbClr val="D8DDE3"/>
-            </a:solidFill>
-          </a:ln>
-          <a:effectLst/>
-        </p:spPr>
-        <p:style>
-          <a:lnRef idx="1">
-            <a:schemeClr val="accent1"/>
-          </a:lnRef>
-          <a:fillRef idx="3">
-            <a:schemeClr val="accent1"/>
-          </a:fillRef>
-          <a:effectRef idx="2">
-            <a:schemeClr val="accent1"/>
-          </a:effectRef>
-          <a:fontRef idx="minor">
-            <a:schemeClr val="lt1"/>
-          </a:fontRef>
-        </p:style>
-        <p:txBody>
-          <a:bodyPr rtlCol="0" anchor="ctr" wrap="square" lIns="228600" tIns="137160"/>
-          <a:lstStyle/>
-          <a:p>
-            <a:pPr/>
-            <a:r>
-              <a:rPr sz="1500" b="0">
-                <a:solidFill>
-                  <a:srgbClr val="1D3557"/>
-                </a:solidFill>
-                <a:latin typeface="Menlo"/>
-              </a:rPr>
-              <a:t>q1, q3 = h["NumVeh"].quantile([0.25, 0.75])</a:t>
-            </a:r>
-          </a:p>
-          <a:p>
-            <a:pPr/>
-            <a:r>
-              <a:rPr sz="1500" b="0">
-                <a:solidFill>
-                  <a:srgbClr val="1D3557"/>
-                </a:solidFill>
-                <a:latin typeface="Menlo"/>
-              </a:rPr>
-              <a:t>sin_atipicos = h[h["NumVeh"] &lt;= q3 + 1.5 * (q3 - q1)]</a:t>
-            </a:r>
-          </a:p>
-          <a:p>
-            <a:pPr/>
-            <a:r>
-              <a:rPr sz="1500" b="0">
-                <a:solidFill>
-                  <a:srgbClr val="1D3557"/>
-                </a:solidFill>
-                <a:latin typeface="Menlo"/>
-              </a:rPr>
-              <a:t/>
-            </a:r>
-          </a:p>
-          <a:p>
-            <a:pPr/>
-            <a:r>
-              <a:rPr sz="1500" b="0">
-                <a:solidFill>
-                  <a:srgbClr val="1D3557"/>
-                </a:solidFill>
-                <a:latin typeface="Menlo"/>
-              </a:rPr>
-              <a:t># El mismo modelo, sin los hogares de 3 autos o más</a:t>
-            </a:r>
-          </a:p>
-          <a:p>
-            <a:pPr/>
-            <a:r>
-              <a:rPr sz="1500" b="0">
-                <a:solidFill>
-                  <a:srgbClr val="1D3557"/>
-                </a:solidFill>
-                <a:latin typeface="Menlo"/>
-              </a:rPr>
-              <a:t>np.polyfit(sin_atipicos["IngresoHogar"] / 1e6, sin_atipicos["NumVeh"], 1)</a:t>
-            </a:r>
-          </a:p>
-        </p:txBody>
-      </p:sp>
-      <p:sp>
-        <p:nvSpPr>
-          <p:cNvPr id="5" name="TextBox 4"/>
-          <p:cNvSpPr txBox="1"/>
-          <p:nvPr/>
-        </p:nvSpPr>
-        <p:spPr>
-          <a:xfrm>
-            <a:off x="704088" y="4389120"/>
-            <a:ext cx="7744968" cy="1097280"/>
-          </a:xfrm>
-          <a:prstGeom prst="rect">
-            <a:avLst/>
-          </a:prstGeom>
-          <a:noFill/>
-        </p:spPr>
-        <p:txBody>
-          <a:bodyPr wrap="square">
-            <a:spAutoFit/>
-          </a:bodyPr>
-          <a:lstStyle/>
-          <a:p>
-            <a:pPr>
-              <a:lnSpc>
-                <a:spcPct val="112000"/>
-              </a:lnSpc>
-              <a:spcAft>
-                <a:spcPts val="900"/>
-              </a:spcAft>
-            </a:pPr>
-            <a:r>
-              <a:rPr sz="1600" b="1">
+              <a:rPr sz="3400" b="1">
+                <a:solidFill>
+                  <a:srgbClr val="FFFFFF"/>
+                </a:solidFill>
+                <a:latin typeface="Fira Sans"/>
+              </a:rPr>
+              <a:t>Buenas prácticas de visualización</a:t>
+            </a:r>
+          </a:p>
+          <a:p>
+            <a:r>
+              <a:rPr sz="1800" b="0">
                 <a:solidFill>
                   <a:srgbClr val="E0A437"/>
                 </a:solidFill>
                 <a:latin typeface="Fira Sans"/>
               </a:rPr>
-              <a:t>▸ </a:t>
-            </a:r>
-            <a:r>
-              <a:rPr sz="1600" b="0">
-                <a:solidFill>
-                  <a:srgbClr val="000000"/>
-                </a:solidFill>
-                <a:latin typeface="Fira Sans"/>
-              </a:rPr>
-              <a:t>Sacar 236 hogares aplana la pendiente ponderada (0,50 a 0,44): no eran errores, eran la señal. Los atípicos de y se investigan; se eliminan solo por dominio.</a:t>
+              <a:t>Que el gráfico diga la verdad y se entienda</a:t>
             </a:r>
           </a:p>
         </p:txBody>
@@ -9568,7 +9568,7 @@
             <a:avLst/>
           </a:prstGeom>
           <a:solidFill>
-            <a:srgbClr val="1D3557"/>
+            <a:srgbClr val="FAFBFC"/>
           </a:solidFill>
           <a:ln>
             <a:noFill/>
@@ -9605,8 +9605,8 @@
         </p:nvSpPr>
         <p:spPr>
           <a:xfrm>
-            <a:off x="603504" y="1847088"/>
-            <a:ext cx="7946136" cy="1399032"/>
+            <a:off x="402336" y="301752"/>
+            <a:ext cx="8348472" cy="795528"/>
           </a:xfrm>
           <a:prstGeom prst="rect">
             <a:avLst/>
@@ -9620,24 +9620,71 @@
           <a:lstStyle/>
           <a:p>
             <a:r>
-              <a:rPr sz="3400" b="1">
-                <a:solidFill>
-                  <a:srgbClr val="FFFFFF"/>
-                </a:solidFill>
-                <a:latin typeface="Fira Sans"/>
-              </a:rPr>
-              <a:t>Buenas prácticas de visualización</a:t>
-            </a:r>
-          </a:p>
-          <a:p>
-            <a:r>
-              <a:rPr sz="1800" b="0">
-                <a:solidFill>
-                  <a:srgbClr val="E0A437"/>
-                </a:solidFill>
-                <a:latin typeface="Fira Sans"/>
-              </a:rPr>
-              <a:t>Que el gráfico diga la verdad y se entienda</a:t>
+              <a:rPr sz="2800" b="1">
+                <a:solidFill>
+                  <a:srgbClr val="0F0F0F"/>
+                </a:solidFill>
+                <a:latin typeface="Fira Sans"/>
+              </a:rPr>
+              <a:t>Graficar 90 mil puntos: overplotting</a:t>
+            </a:r>
+          </a:p>
+        </p:txBody>
+      </p:sp>
+      <p:pic>
+        <p:nvPicPr>
+          <p:cNvPr id="4" name="Picture 3" descr="c3_08_overplotting.png"/>
+          <p:cNvPicPr>
+            <a:picLocks noChangeAspect="1"/>
+          </p:cNvPicPr>
+          <p:nvPr/>
+        </p:nvPicPr>
+        <p:blipFill>
+          <a:blip r:embed="rId2"/>
+          <a:stretch>
+            <a:fillRect/>
+          </a:stretch>
+        </p:blipFill>
+        <p:spPr>
+          <a:xfrm>
+            <a:off x="1417319" y="1143000"/>
+            <a:ext cx="6309360" cy="1913950"/>
+          </a:xfrm>
+          <a:prstGeom prst="rect">
+            <a:avLst/>
+          </a:prstGeom>
+        </p:spPr>
+      </p:pic>
+      <p:sp>
+        <p:nvSpPr>
+          <p:cNvPr id="5" name="TextBox 4"/>
+          <p:cNvSpPr txBox="1"/>
+          <p:nvPr/>
+        </p:nvSpPr>
+        <p:spPr>
+          <a:xfrm>
+            <a:off x="704088" y="4434840"/>
+            <a:ext cx="7744968" cy="457200"/>
+          </a:xfrm>
+          <a:prstGeom prst="rect">
+            <a:avLst/>
+          </a:prstGeom>
+          <a:noFill/>
+        </p:spPr>
+        <p:txBody>
+          <a:bodyPr wrap="square">
+            <a:spAutoFit/>
+          </a:bodyPr>
+          <a:lstStyle/>
+          <a:p>
+            <a:r>
+              <a:rPr sz="1300" b="0">
+                <a:solidFill>
+                  <a:srgbClr val="333333"/>
+                </a:solidFill>
+                <a:latin typeface="Fira Sans"/>
+              </a:rPr>
+              <a:t>Con todos los puntos sólidos, el scatter se satura y miente. Los remedios: transparencia (alpha), muestreo, o hexbin, donde el color cuenta los viajes (la distancia viene en la tabla DistanciaViaje.csv; sus −1 son faltantes disfrazados).</a:t>
             </a:r>
           </a:p>
         </p:txBody>
@@ -9733,14 +9780,14 @@
                 </a:solidFill>
                 <a:latin typeface="Fira Sans"/>
               </a:rPr>
-              <a:t>Graficar 90 mil puntos: overplotting</a:t>
+              <a:t>Cuándo usar escala logarítmica</a:t>
             </a:r>
           </a:p>
         </p:txBody>
       </p:sp>
       <p:pic>
         <p:nvPicPr>
-          <p:cNvPr id="4" name="Picture 3" descr="c3_08_overplotting.png"/>
+          <p:cNvPr id="4" name="Picture 3" descr="c3_10_escala_log.png"/>
           <p:cNvPicPr>
             <a:picLocks noChangeAspect="1"/>
           </p:cNvPicPr>
@@ -9755,7 +9802,7 @@
         <p:spPr>
           <a:xfrm>
             <a:off x="1417319" y="1143000"/>
-            <a:ext cx="6309360" cy="1913950"/>
+            <a:ext cx="6309360" cy="2432846"/>
           </a:xfrm>
           <a:prstGeom prst="rect">
             <a:avLst/>
@@ -9791,7 +9838,7 @@
                 </a:solidFill>
                 <a:latin typeface="Fira Sans"/>
               </a:rPr>
-              <a:t>Con todos los puntos sólidos, el scatter se satura y miente. Los remedios: transparencia (alpha), muestreo, o hexbin, donde el color cuenta los viajes (la distancia viene en la tabla DistanciaViaje.csv; sus −1 son faltantes disfrazados).</a:t>
+              <a:t>Con colas largas como el ingreso, la escala lineal aplasta el 99% de los datos contra el borde; la logarítmica reparte el espacio y la forma aparece.</a:t>
             </a:r>
           </a:p>
         </p:txBody>
@@ -9887,14 +9934,14 @@
                 </a:solidFill>
                 <a:latin typeface="Fira Sans"/>
               </a:rPr>
-              <a:t>Cuándo usar escala logarítmica</a:t>
+              <a:t>El mismo gráfico, dos veces</a:t>
             </a:r>
           </a:p>
         </p:txBody>
       </p:sp>
       <p:pic>
         <p:nvPicPr>
-          <p:cNvPr id="4" name="Picture 3" descr="c3_10_escala_log.png"/>
+          <p:cNvPr id="4" name="Picture 3" descr="c3_16_mal_buen_grafico.png"/>
           <p:cNvPicPr>
             <a:picLocks noChangeAspect="1"/>
           </p:cNvPicPr>
@@ -9909,7 +9956,7 @@
         <p:spPr>
           <a:xfrm>
             <a:off x="1417319" y="1143000"/>
-            <a:ext cx="6309360" cy="2432846"/>
+            <a:ext cx="6309360" cy="2447822"/>
           </a:xfrm>
           <a:prstGeom prst="rect">
             <a:avLst/>
@@ -9945,7 +9992,7 @@
                 </a:solidFill>
                 <a:latin typeface="Fira Sans"/>
               </a:rPr>
-              <a:t>Con colas largas como el ingreso, la escala lineal aplasta el 99% de los datos contra el borde; la logarítmica reparte el espacio y la forma aparece.</a:t>
+              <a:t>Los mismos 30 mil viajes: sin rotular y saturado, contra rotulado, con transparencia y con el hallazgo en el título.</a:t>
             </a:r>
           </a:p>
         </p:txBody>
@@ -10041,45 +10088,21 @@
                 </a:solidFill>
                 <a:latin typeface="Fira Sans"/>
               </a:rPr>
-              <a:t>El mismo gráfico, dos veces</a:t>
-            </a:r>
-          </a:p>
-        </p:txBody>
-      </p:sp>
-      <p:pic>
-        <p:nvPicPr>
-          <p:cNvPr id="4" name="Picture 3" descr="c3_16_mal_buen_grafico.png"/>
-          <p:cNvPicPr>
-            <a:picLocks noChangeAspect="1"/>
-          </p:cNvPicPr>
-          <p:nvPr/>
-        </p:nvPicPr>
-        <p:blipFill>
-          <a:blip r:embed="rId2"/>
-          <a:stretch>
-            <a:fillRect/>
-          </a:stretch>
-        </p:blipFill>
-        <p:spPr>
-          <a:xfrm>
-            <a:off x="1417319" y="1143000"/>
-            <a:ext cx="6309360" cy="2447822"/>
-          </a:xfrm>
-          <a:prstGeom prst="rect">
-            <a:avLst/>
-          </a:prstGeom>
-        </p:spPr>
-      </p:pic>
-      <p:sp>
-        <p:nvSpPr>
-          <p:cNvPr id="5" name="TextBox 4"/>
+              <a:t>Checklist del buen gráfico</a:t>
+            </a:r>
+          </a:p>
+        </p:txBody>
+      </p:sp>
+      <p:sp>
+        <p:nvSpPr>
+          <p:cNvPr id="4" name="TextBox 3"/>
           <p:cNvSpPr txBox="1"/>
           <p:nvPr/>
         </p:nvSpPr>
         <p:spPr>
           <a:xfrm>
-            <a:off x="704088" y="4434840"/>
-            <a:ext cx="7744968" cy="457200"/>
+            <a:off x="704088" y="1353312"/>
+            <a:ext cx="7744968" cy="3300984"/>
           </a:xfrm>
           <a:prstGeom prst="rect">
             <a:avLst/>
@@ -10092,14 +10115,143 @@
           </a:bodyPr>
           <a:lstStyle/>
           <a:p>
-            <a:r>
-              <a:rPr sz="1300" b="0">
-                <a:solidFill>
-                  <a:srgbClr val="333333"/>
-                </a:solidFill>
-                <a:latin typeface="Fira Sans"/>
-              </a:rPr>
-              <a:t>Los mismos 30 mil viajes: sin rotular y saturado, contra rotulado, con transparencia y con el hallazgo en el título.</a:t>
+            <a:pPr>
+              <a:lnSpc>
+                <a:spcPct val="112000"/>
+              </a:lnSpc>
+              <a:spcAft>
+                <a:spcPts val="900"/>
+              </a:spcAft>
+            </a:pPr>
+            <a:r>
+              <a:rPr sz="1800" b="1">
+                <a:solidFill>
+                  <a:srgbClr val="E0A437"/>
+                </a:solidFill>
+                <a:latin typeface="Fira Sans"/>
+              </a:rPr>
+              <a:t>▸ </a:t>
+            </a:r>
+            <a:r>
+              <a:rPr sz="1800" b="0">
+                <a:solidFill>
+                  <a:srgbClr val="000000"/>
+                </a:solidFill>
+                <a:latin typeface="Fira Sans"/>
+              </a:rPr>
+              <a:t>Título que diga el hallazgo, no solo las variables.</a:t>
+            </a:r>
+          </a:p>
+          <a:p>
+            <a:pPr>
+              <a:lnSpc>
+                <a:spcPct val="112000"/>
+              </a:lnSpc>
+              <a:spcAft>
+                <a:spcPts val="900"/>
+              </a:spcAft>
+            </a:pPr>
+            <a:r>
+              <a:rPr sz="1800" b="1">
+                <a:solidFill>
+                  <a:srgbClr val="E0A437"/>
+                </a:solidFill>
+                <a:latin typeface="Fira Sans"/>
+              </a:rPr>
+              <a:t>▸ </a:t>
+            </a:r>
+            <a:r>
+              <a:rPr sz="1800" b="0">
+                <a:solidFill>
+                  <a:srgbClr val="000000"/>
+                </a:solidFill>
+                <a:latin typeface="Fira Sans"/>
+              </a:rPr>
+              <a:t>Ejes con nombre y unidad; ejes que parten de cero en gráficos de barras.</a:t>
+            </a:r>
+          </a:p>
+          <a:p>
+            <a:pPr>
+              <a:lnSpc>
+                <a:spcPct val="112000"/>
+              </a:lnSpc>
+              <a:spcAft>
+                <a:spcPts val="900"/>
+              </a:spcAft>
+            </a:pPr>
+            <a:r>
+              <a:rPr sz="1800" b="1">
+                <a:solidFill>
+                  <a:srgbClr val="E0A437"/>
+                </a:solidFill>
+                <a:latin typeface="Fira Sans"/>
+              </a:rPr>
+              <a:t>▸ </a:t>
+            </a:r>
+            <a:r>
+              <a:rPr sz="1800" b="0">
+                <a:solidFill>
+                  <a:srgbClr val="000000"/>
+                </a:solidFill>
+                <a:latin typeface="Fira Sans"/>
+              </a:rPr>
+              <a:t>Muchos puntos: alpha, muestreo o hexbin.</a:t>
+            </a:r>
+          </a:p>
+          <a:p>
+            <a:pPr>
+              <a:lnSpc>
+                <a:spcPct val="112000"/>
+              </a:lnSpc>
+              <a:spcAft>
+                <a:spcPts val="900"/>
+              </a:spcAft>
+            </a:pPr>
+            <a:r>
+              <a:rPr sz="1800" b="1">
+                <a:solidFill>
+                  <a:srgbClr val="E0A437"/>
+                </a:solidFill>
+                <a:latin typeface="Fira Sans"/>
+              </a:rPr>
+              <a:t>▸ </a:t>
+            </a:r>
+            <a:r>
+              <a:rPr sz="1800" b="0">
+                <a:solidFill>
+                  <a:srgbClr val="000000"/>
+                </a:solidFill>
+                <a:latin typeface="Fira Sans"/>
+              </a:rPr>
+              <a:t>Colas largas: escala logarítmica o eje recortado, declarándolo.</a:t>
+            </a:r>
+          </a:p>
+          <a:p>
+            <a:pPr>
+              <a:lnSpc>
+                <a:spcPct val="112000"/>
+              </a:lnSpc>
+              <a:spcAft>
+                <a:spcPts val="900"/>
+              </a:spcAft>
+            </a:pPr>
+            <a:r>
+              <a:rPr sz="1800" b="1">
+                <a:solidFill>
+                  <a:srgbClr val="E0A437"/>
+                </a:solidFill>
+                <a:latin typeface="Fira Sans"/>
+              </a:rPr>
+              <a:t>▸ </a:t>
+            </a:r>
+            <a:r>
+              <a:rPr sz="1800" b="1">
+                <a:solidFill>
+                  <a:srgbClr val="1D3557"/>
+                </a:solidFill>
+                <a:latin typeface="Fira Sans"/>
+              </a:rPr>
+              <a:t>El gráfico se corrige igual que el código: se itera hasta que un tercero lo entienda sin explicación oral.</a:t>
             </a:r>
           </a:p>
         </p:txBody>
@@ -10137,7 +10289,7 @@
             <a:avLst/>
           </a:prstGeom>
           <a:solidFill>
-            <a:srgbClr val="FAFBFC"/>
+            <a:srgbClr val="1D3557"/>
           </a:solidFill>
           <a:ln>
             <a:noFill/>
@@ -10174,8 +10326,8 @@
         </p:nvSpPr>
         <p:spPr>
           <a:xfrm>
-            <a:off x="402336" y="301752"/>
-            <a:ext cx="8348472" cy="795528"/>
+            <a:off x="603504" y="1847088"/>
+            <a:ext cx="7946136" cy="1399032"/>
           </a:xfrm>
           <a:prstGeom prst="rect">
             <a:avLst/>
@@ -10189,176 +10341,24 @@
           <a:lstStyle/>
           <a:p>
             <a:r>
-              <a:rPr sz="2800" b="1">
-                <a:solidFill>
-                  <a:srgbClr val="0F0F0F"/>
-                </a:solidFill>
-                <a:latin typeface="Fira Sans"/>
-              </a:rPr>
-              <a:t>Checklist del buen gráfico</a:t>
-            </a:r>
-          </a:p>
-        </p:txBody>
-      </p:sp>
-      <p:sp>
-        <p:nvSpPr>
-          <p:cNvPr id="4" name="TextBox 3"/>
-          <p:cNvSpPr txBox="1"/>
-          <p:nvPr/>
-        </p:nvSpPr>
-        <p:spPr>
-          <a:xfrm>
-            <a:off x="704088" y="1353312"/>
-            <a:ext cx="7744968" cy="3300984"/>
-          </a:xfrm>
-          <a:prstGeom prst="rect">
-            <a:avLst/>
-          </a:prstGeom>
-          <a:noFill/>
-        </p:spPr>
-        <p:txBody>
-          <a:bodyPr wrap="square">
-            <a:spAutoFit/>
-          </a:bodyPr>
-          <a:lstStyle/>
-          <a:p>
-            <a:pPr>
-              <a:lnSpc>
-                <a:spcPct val="112000"/>
-              </a:lnSpc>
-              <a:spcAft>
-                <a:spcPts val="900"/>
-              </a:spcAft>
-            </a:pPr>
-            <a:r>
-              <a:rPr sz="1800" b="1">
+              <a:rPr sz="3400" b="1">
+                <a:solidFill>
+                  <a:srgbClr val="FFFFFF"/>
+                </a:solidFill>
+                <a:latin typeface="Fira Sans"/>
+              </a:rPr>
+              <a:t>Recreo</a:t>
+            </a:r>
+          </a:p>
+          <a:p>
+            <a:r>
+              <a:rPr sz="1800" b="0">
                 <a:solidFill>
                   <a:srgbClr val="E0A437"/>
                 </a:solidFill>
                 <a:latin typeface="Fira Sans"/>
               </a:rPr>
-              <a:t>▸ </a:t>
-            </a:r>
-            <a:r>
-              <a:rPr sz="1800" b="0">
-                <a:solidFill>
-                  <a:srgbClr val="000000"/>
-                </a:solidFill>
-                <a:latin typeface="Fira Sans"/>
-              </a:rPr>
-              <a:t>Título que diga el hallazgo, no solo las variables.</a:t>
-            </a:r>
-          </a:p>
-          <a:p>
-            <a:pPr>
-              <a:lnSpc>
-                <a:spcPct val="112000"/>
-              </a:lnSpc>
-              <a:spcAft>
-                <a:spcPts val="900"/>
-              </a:spcAft>
-            </a:pPr>
-            <a:r>
-              <a:rPr sz="1800" b="1">
-                <a:solidFill>
-                  <a:srgbClr val="E0A437"/>
-                </a:solidFill>
-                <a:latin typeface="Fira Sans"/>
-              </a:rPr>
-              <a:t>▸ </a:t>
-            </a:r>
-            <a:r>
-              <a:rPr sz="1800" b="0">
-                <a:solidFill>
-                  <a:srgbClr val="000000"/>
-                </a:solidFill>
-                <a:latin typeface="Fira Sans"/>
-              </a:rPr>
-              <a:t>Ejes con nombre y unidad; ejes que parten de cero en gráficos de barras.</a:t>
-            </a:r>
-          </a:p>
-          <a:p>
-            <a:pPr>
-              <a:lnSpc>
-                <a:spcPct val="112000"/>
-              </a:lnSpc>
-              <a:spcAft>
-                <a:spcPts val="900"/>
-              </a:spcAft>
-            </a:pPr>
-            <a:r>
-              <a:rPr sz="1800" b="1">
-                <a:solidFill>
-                  <a:srgbClr val="E0A437"/>
-                </a:solidFill>
-                <a:latin typeface="Fira Sans"/>
-              </a:rPr>
-              <a:t>▸ </a:t>
-            </a:r>
-            <a:r>
-              <a:rPr sz="1800" b="0">
-                <a:solidFill>
-                  <a:srgbClr val="000000"/>
-                </a:solidFill>
-                <a:latin typeface="Fira Sans"/>
-              </a:rPr>
-              <a:t>Muchos puntos: alpha, muestreo o hexbin.</a:t>
-            </a:r>
-          </a:p>
-          <a:p>
-            <a:pPr>
-              <a:lnSpc>
-                <a:spcPct val="112000"/>
-              </a:lnSpc>
-              <a:spcAft>
-                <a:spcPts val="900"/>
-              </a:spcAft>
-            </a:pPr>
-            <a:r>
-              <a:rPr sz="1800" b="1">
-                <a:solidFill>
-                  <a:srgbClr val="E0A437"/>
-                </a:solidFill>
-                <a:latin typeface="Fira Sans"/>
-              </a:rPr>
-              <a:t>▸ </a:t>
-            </a:r>
-            <a:r>
-              <a:rPr sz="1800" b="0">
-                <a:solidFill>
-                  <a:srgbClr val="000000"/>
-                </a:solidFill>
-                <a:latin typeface="Fira Sans"/>
-              </a:rPr>
-              <a:t>Colas largas: escala logarítmica o eje recortado, declarándolo.</a:t>
-            </a:r>
-          </a:p>
-          <a:p>
-            <a:pPr>
-              <a:lnSpc>
-                <a:spcPct val="112000"/>
-              </a:lnSpc>
-              <a:spcAft>
-                <a:spcPts val="900"/>
-              </a:spcAft>
-            </a:pPr>
-            <a:r>
-              <a:rPr sz="1800" b="1">
-                <a:solidFill>
-                  <a:srgbClr val="E0A437"/>
-                </a:solidFill>
-                <a:latin typeface="Fira Sans"/>
-              </a:rPr>
-              <a:t>▸ </a:t>
-            </a:r>
-            <a:r>
-              <a:rPr sz="1800" b="1">
-                <a:solidFill>
-                  <a:srgbClr val="1D3557"/>
-                </a:solidFill>
-                <a:latin typeface="Fira Sans"/>
-              </a:rPr>
-              <a:t>El gráfico se corrige igual que el código: se itera hasta que un tercero lo entienda sin explicación oral.</a:t>
+              <a:t>10 minutos</a:t>
             </a:r>
           </a:p>
         </p:txBody>

</xml_diff>

<commit_message>
Clase 3: cierre con tres regresiones (km, log en x, log-log) y diapo del norte simplificada
La comparacion de modelos usa la misma regresion de statsmodels tres
veces y termina en el modelo log-log (R2 0,53), con los tres graficos
lado a lado. Se retiran dos parrafos huerfanos de versiones anteriores.

Co-Authored-By: Claude Fable 5 <noreply@anthropic.com>
</commit_message>
<xml_diff>
--- a/presentaciones/clase03_eda_bivariado.pptx
+++ b/presentaciones/clase03_eda_bivariado.pptx
@@ -9446,7 +9446,7 @@
                 </a:solidFill>
                 <a:latin typeface="Fira Sans"/>
               </a:rPr>
-              <a:t>La correlación dice qué variables prometen como predictoras; la matriz ayuda a elegirlas y a descartar redundantes.</a:t>
+              <a:t>La primera pregunta de hoy: ¿qué tan relacionadas están dos variables? Eso decide cuáles sirven para predecir.</a:t>
             </a:r>
           </a:p>
           <a:p>
@@ -9474,63 +9474,7 @@
                 </a:solidFill>
                 <a:latin typeface="Fira Sans"/>
               </a:rPr>
-              <a:t>Crear variables nuevas desde las existentes, como los resúmenes por comuna, es el feature engineering: la materia prima de los modelos.</a:t>
-            </a:r>
-          </a:p>
-          <a:p>
-            <a:pPr>
-              <a:lnSpc>
-                <a:spcPct val="112000"/>
-              </a:lnSpc>
-              <a:spcAft>
-                <a:spcPts val="900"/>
-              </a:spcAft>
-            </a:pPr>
-            <a:r>
-              <a:rPr sz="1800" b="1">
-                <a:solidFill>
-                  <a:srgbClr val="E0A437"/>
-                </a:solidFill>
-                <a:latin typeface="Fira Sans"/>
-              </a:rPr>
-              <a:t>▸ </a:t>
-            </a:r>
-            <a:r>
-              <a:rPr sz="1800" b="0">
-                <a:solidFill>
-                  <a:srgbClr val="000000"/>
-                </a:solidFill>
-                <a:latin typeface="Fira Sans"/>
-              </a:rPr>
-              <a:t>La regresión de hoy ya ES un modelo: el primero del diplomado.</a:t>
-            </a:r>
-          </a:p>
-          <a:p>
-            <a:pPr>
-              <a:lnSpc>
-                <a:spcPct val="112000"/>
-              </a:lnSpc>
-              <a:spcAft>
-                <a:spcPts val="900"/>
-              </a:spcAft>
-            </a:pPr>
-            <a:r>
-              <a:rPr sz="1800" b="1">
-                <a:solidFill>
-                  <a:srgbClr val="E0A437"/>
-                </a:solidFill>
-                <a:latin typeface="Fira Sans"/>
-              </a:rPr>
-              <a:t>▸ </a:t>
-            </a:r>
-            <a:r>
-              <a:rPr sz="1800" b="0">
-                <a:solidFill>
-                  <a:srgbClr val="000000"/>
-                </a:solidFill>
-                <a:latin typeface="Fira Sans"/>
-              </a:rPr>
-              <a:t>Sus residuos son el primer diagnóstico; la validación formal (hipótesis, valor p) llega en la clase 5.</a:t>
+              <a:t>Y hacia el final, la primera regresión: el primer modelo del diplomado.</a:t>
             </a:r>
           </a:p>
         </p:txBody>

</xml_diff>